<commit_message>
Apply reviewer fixes: colour-blind-safe figures, historical counterfactual uncertainty note, add reproduce.sh, rebuild manuscript
- Figure 2 uses plasma sequential palette; Figure 3 uses blue/vermillion colour-blind-safe diverging palette.

- Figure 3 caption/figure title note point-estimate uncertainty.

- Add top-level reproduce.sh to regenerate all results and manuscript.

- Rebuild docx, md, pptx, pdf and figures from latest results.

Co-Authored-By: Tatsuki Onishi <bougtoir@gmail.com>
</commit_message>
<xml_diff>
--- a/researcher_mobility_ode/docs/manuscript_full_article_figures.pptx
+++ b/researcher_mobility_ode/docs/manuscript_full_article_figures.pptx
@@ -3181,9 +3181,43 @@
           </a:p>
         </p:txBody>
       </p:sp>
+      <p:sp>
+        <p:nvSpPr>
+          <p:cNvPr id="3" name="Content Placeholder 2"/>
+          <p:cNvSpPr>
+            <a:spLocks noGrp="1"/>
+          </p:cNvSpPr>
+          <p:nvPr>
+            <p:ph idx="1" sz="half"/>
+          </p:nvPr>
+        </p:nvSpPr>
+        <p:spPr/>
+        <p:txBody>
+          <a:bodyPr/>
+          <a:lstStyle/>
+          <a:p/>
+        </p:txBody>
+      </p:sp>
+      <p:sp>
+        <p:nvSpPr>
+          <p:cNvPr id="4" name="Content Placeholder 3"/>
+          <p:cNvSpPr>
+            <a:spLocks noGrp="1"/>
+          </p:cNvSpPr>
+          <p:nvPr>
+            <p:ph idx="2" sz="half"/>
+          </p:nvPr>
+        </p:nvSpPr>
+        <p:spPr/>
+        <p:txBody>
+          <a:bodyPr/>
+          <a:lstStyle/>
+          <a:p/>
+        </p:txBody>
+      </p:sp>
       <p:graphicFrame>
         <p:nvGraphicFramePr>
-          <p:cNvPr id="3" name="Table 2"/>
+          <p:cNvPr id="5" name="Table 4"/>
           <p:cNvGraphicFramePr>
             <a:graphicFrameLocks noGrp="1"/>
           </p:cNvGraphicFramePr>
@@ -3342,22 +3376,22 @@
                         <a:defRPr sz="1000"/>
                       </a:pPr>
                       <a:r>
-                        <a:t>1156.27</a:t>
-                      </a:r>
-                    </a:p>
-                  </a:txBody>
-                  <a:tcPr/>
-                </a:tc>
-                <a:tc>
-                  <a:txBody>
-                    <a:bodyPr/>
-                    <a:lstStyle/>
-                    <a:p>
-                      <a:pPr>
-                        <a:defRPr sz="1000"/>
-                      </a:pPr>
-                      <a:r>
-                        <a:t>632.67</a:t>
+                        <a:t>1208.42</a:t>
+                      </a:r>
+                    </a:p>
+                  </a:txBody>
+                  <a:tcPr/>
+                </a:tc>
+                <a:tc>
+                  <a:txBody>
+                    <a:bodyPr/>
+                    <a:lstStyle/>
+                    <a:p>
+                      <a:pPr>
+                        <a:defRPr sz="1000"/>
+                      </a:pPr>
+                      <a:r>
+                        <a:t>659.04</a:t>
                       </a:r>
                     </a:p>
                   </a:txBody>
@@ -3776,22 +3810,22 @@
                         <a:defRPr sz="1000"/>
                       </a:pPr>
                       <a:r>
-                        <a:t>801.70</a:t>
-                      </a:r>
-                    </a:p>
-                  </a:txBody>
-                  <a:tcPr/>
-                </a:tc>
-                <a:tc>
-                  <a:txBody>
-                    <a:bodyPr/>
-                    <a:lstStyle/>
-                    <a:p>
-                      <a:pPr>
-                        <a:defRPr sz="1000"/>
-                      </a:pPr>
-                      <a:r>
-                        <a:t>462.03</a:t>
+                        <a:t>770.21</a:t>
+                      </a:r>
+                    </a:p>
+                  </a:txBody>
+                  <a:tcPr/>
+                </a:tc>
+                <a:tc>
+                  <a:txBody>
+                    <a:bodyPr/>
+                    <a:lstStyle/>
+                    <a:p>
+                      <a:pPr>
+                        <a:defRPr sz="1000"/>
+                      </a:pPr>
+                      <a:r>
+                        <a:t>445.87</a:t>
                       </a:r>
                     </a:p>
                   </a:txBody>
@@ -3856,9 +3890,43 @@
           </a:p>
         </p:txBody>
       </p:sp>
+      <p:sp>
+        <p:nvSpPr>
+          <p:cNvPr id="3" name="Content Placeholder 2"/>
+          <p:cNvSpPr>
+            <a:spLocks noGrp="1"/>
+          </p:cNvSpPr>
+          <p:nvPr>
+            <p:ph idx="1" sz="half"/>
+          </p:nvPr>
+        </p:nvSpPr>
+        <p:spPr/>
+        <p:txBody>
+          <a:bodyPr/>
+          <a:lstStyle/>
+          <a:p/>
+        </p:txBody>
+      </p:sp>
+      <p:sp>
+        <p:nvSpPr>
+          <p:cNvPr id="4" name="Content Placeholder 3"/>
+          <p:cNvSpPr>
+            <a:spLocks noGrp="1"/>
+          </p:cNvSpPr>
+          <p:nvPr>
+            <p:ph idx="2" sz="half"/>
+          </p:nvPr>
+        </p:nvSpPr>
+        <p:spPr/>
+        <p:txBody>
+          <a:bodyPr/>
+          <a:lstStyle/>
+          <a:p/>
+        </p:txBody>
+      </p:sp>
       <p:graphicFrame>
         <p:nvGraphicFramePr>
-          <p:cNvPr id="3" name="Table 2"/>
+          <p:cNvPr id="5" name="Table 4"/>
           <p:cNvGraphicFramePr>
             <a:graphicFrameLocks noGrp="1"/>
           </p:cNvGraphicFramePr>
@@ -4185,7 +4253,7 @@
                         <a:defRPr sz="1000"/>
                       </a:pPr>
                       <a:r>
-                        <a:t>1053.7</a:t>
+                        <a:t>1117.0</a:t>
                       </a:r>
                     </a:p>
                   </a:txBody>
@@ -4215,22 +4283,22 @@
                         <a:defRPr sz="1000"/>
                       </a:pPr>
                       <a:r>
-                        <a:t>-262.3671002430466</a:t>
-                      </a:r>
-                    </a:p>
-                  </a:txBody>
-                  <a:tcPr/>
-                </a:tc>
-                <a:tc>
-                  <a:txBody>
-                    <a:bodyPr/>
-                    <a:lstStyle/>
-                    <a:p>
-                      <a:pPr>
-                        <a:defRPr sz="1000"/>
-                      </a:pPr>
-                      <a:r>
-                        <a:t>-24.9</a:t>
+                        <a:t>-325.68763060327603</a:t>
+                      </a:r>
+                    </a:p>
+                  </a:txBody>
+                  <a:tcPr/>
+                </a:tc>
+                <a:tc>
+                  <a:txBody>
+                    <a:bodyPr/>
+                    <a:lstStyle/>
+                    <a:p>
+                      <a:pPr>
+                        <a:defRPr sz="1000"/>
+                      </a:pPr>
+                      <a:r>
+                        <a:t>-29.2</a:t>
                       </a:r>
                     </a:p>
                   </a:txBody>
@@ -4275,7 +4343,7 @@
                         <a:defRPr sz="1000"/>
                       </a:pPr>
                       <a:r>
-                        <a:t>924.6</a:t>
+                        <a:t>987.9</a:t>
                       </a:r>
                     </a:p>
                   </a:txBody>
@@ -4305,7 +4373,7 @@
                         <a:defRPr sz="1000"/>
                       </a:pPr>
                       <a:r>
-                        <a:t>-262.4</a:t>
+                        <a:t>-325.7</a:t>
                       </a:r>
                     </a:p>
                   </a:txBody>
@@ -5249,7 +5317,7 @@
                         <a:defRPr sz="1000"/>
                       </a:pPr>
                       <a:r>
-                        <a:t>806.7</a:t>
+                        <a:t>770.7</a:t>
                       </a:r>
                     </a:p>
                   </a:txBody>
@@ -5279,22 +5347,22 @@
                         <a:defRPr sz="1000"/>
                       </a:pPr>
                       <a:r>
-                        <a:t>-259.33121243301457</a:t>
-                      </a:r>
-                    </a:p>
-                  </a:txBody>
-                  <a:tcPr/>
-                </a:tc>
-                <a:tc>
-                  <a:txBody>
-                    <a:bodyPr/>
-                    <a:lstStyle/>
-                    <a:p>
-                      <a:pPr>
-                        <a:defRPr sz="1000"/>
-                      </a:pPr>
-                      <a:r>
-                        <a:t>-32.1</a:t>
+                        <a:t>-223.31831440011604</a:t>
+                      </a:r>
+                    </a:p>
+                  </a:txBody>
+                  <a:tcPr/>
+                </a:tc>
+                <a:tc>
+                  <a:txBody>
+                    <a:bodyPr/>
+                    <a:lstStyle/>
+                    <a:p>
+                      <a:pPr>
+                        <a:defRPr sz="1000"/>
+                      </a:pPr>
+                      <a:r>
+                        <a:t>-29.0</a:t>
                       </a:r>
                     </a:p>
                   </a:txBody>
@@ -5339,7 +5407,7 @@
                         <a:defRPr sz="1000"/>
                       </a:pPr>
                       <a:r>
-                        <a:t>674.2</a:t>
+                        <a:t>638.2</a:t>
                       </a:r>
                     </a:p>
                   </a:txBody>
@@ -5369,7 +5437,7 @@
                         <a:defRPr sz="1000"/>
                       </a:pPr>
                       <a:r>
-                        <a:t>-259.3</a:t>
+                        <a:t>-223.3</a:t>
                       </a:r>
                     </a:p>
                   </a:txBody>
@@ -5419,9 +5487,43 @@
           </a:p>
         </p:txBody>
       </p:sp>
+      <p:sp>
+        <p:nvSpPr>
+          <p:cNvPr id="3" name="Content Placeholder 2"/>
+          <p:cNvSpPr>
+            <a:spLocks noGrp="1"/>
+          </p:cNvSpPr>
+          <p:nvPr>
+            <p:ph idx="1" sz="half"/>
+          </p:nvPr>
+        </p:nvSpPr>
+        <p:spPr/>
+        <p:txBody>
+          <a:bodyPr/>
+          <a:lstStyle/>
+          <a:p/>
+        </p:txBody>
+      </p:sp>
+      <p:sp>
+        <p:nvSpPr>
+          <p:cNvPr id="4" name="Content Placeholder 3"/>
+          <p:cNvSpPr>
+            <a:spLocks noGrp="1"/>
+          </p:cNvSpPr>
+          <p:nvPr>
+            <p:ph idx="2" sz="half"/>
+          </p:nvPr>
+        </p:nvSpPr>
+        <p:spPr/>
+        <p:txBody>
+          <a:bodyPr/>
+          <a:lstStyle/>
+          <a:p/>
+        </p:txBody>
+      </p:sp>
       <p:graphicFrame>
         <p:nvGraphicFramePr>
-          <p:cNvPr id="3" name="Table 2"/>
+          <p:cNvPr id="5" name="Table 4"/>
           <p:cNvGraphicFramePr>
             <a:graphicFrameLocks noGrp="1"/>
           </p:cNvGraphicFramePr>
@@ -5681,22 +5783,22 @@
                         <a:defRPr sz="1000"/>
                       </a:pPr>
                       <a:r>
-                        <a:t>135.3</a:t>
-                      </a:r>
-                    </a:p>
-                  </a:txBody>
-                  <a:tcPr/>
-                </a:tc>
-                <a:tc>
-                  <a:txBody>
-                    <a:bodyPr/>
-                    <a:lstStyle/>
-                    <a:p>
-                      <a:pPr>
-                        <a:defRPr sz="1000"/>
-                      </a:pPr>
-                      <a:r>
-                        <a:t>135.3</a:t>
+                        <a:t>141.0</a:t>
+                      </a:r>
+                    </a:p>
+                  </a:txBody>
+                  <a:tcPr/>
+                </a:tc>
+                <a:tc>
+                  <a:txBody>
+                    <a:bodyPr/>
+                    <a:lstStyle/>
+                    <a:p>
+                      <a:pPr>
+                        <a:defRPr sz="1000"/>
+                      </a:pPr>
+                      <a:r>
+                        <a:t>141.0</a:t>
                       </a:r>
                     </a:p>
                   </a:txBody>
@@ -6325,22 +6427,22 @@
                         <a:defRPr sz="1000"/>
                       </a:pPr>
                       <a:r>
-                        <a:t>95.7</a:t>
-                      </a:r>
-                    </a:p>
-                  </a:txBody>
-                  <a:tcPr/>
-                </a:tc>
-                <a:tc>
-                  <a:txBody>
-                    <a:bodyPr/>
-                    <a:lstStyle/>
-                    <a:p>
-                      <a:pPr>
-                        <a:defRPr sz="1000"/>
-                      </a:pPr>
-                      <a:r>
-                        <a:t>95.7</a:t>
+                        <a:t>92.0</a:t>
+                      </a:r>
+                    </a:p>
+                  </a:txBody>
+                  <a:tcPr/>
+                </a:tc>
+                <a:tc>
+                  <a:txBody>
+                    <a:bodyPr/>
+                    <a:lstStyle/>
+                    <a:p>
+                      <a:pPr>
+                        <a:defRPr sz="1000"/>
+                      </a:pPr>
+                      <a:r>
+                        <a:t>92.0</a:t>
                       </a:r>
                     </a:p>
                   </a:txBody>
@@ -6390,9 +6492,43 @@
           </a:p>
         </p:txBody>
       </p:sp>
+      <p:sp>
+        <p:nvSpPr>
+          <p:cNvPr id="3" name="Content Placeholder 2"/>
+          <p:cNvSpPr>
+            <a:spLocks noGrp="1"/>
+          </p:cNvSpPr>
+          <p:nvPr>
+            <p:ph idx="1" sz="half"/>
+          </p:nvPr>
+        </p:nvSpPr>
+        <p:spPr/>
+        <p:txBody>
+          <a:bodyPr/>
+          <a:lstStyle/>
+          <a:p/>
+        </p:txBody>
+      </p:sp>
+      <p:sp>
+        <p:nvSpPr>
+          <p:cNvPr id="4" name="Content Placeholder 3"/>
+          <p:cNvSpPr>
+            <a:spLocks noGrp="1"/>
+          </p:cNvSpPr>
+          <p:nvPr>
+            <p:ph idx="2" sz="half"/>
+          </p:nvPr>
+        </p:nvSpPr>
+        <p:spPr/>
+        <p:txBody>
+          <a:bodyPr/>
+          <a:lstStyle/>
+          <a:p/>
+        </p:txBody>
+      </p:sp>
       <p:graphicFrame>
         <p:nvGraphicFramePr>
-          <p:cNvPr id="3" name="Table 2"/>
+          <p:cNvPr id="5" name="Table 4"/>
           <p:cNvGraphicFramePr>
             <a:graphicFrameLocks noGrp="1"/>
           </p:cNvGraphicFramePr>
@@ -6579,52 +6715,52 @@
                         <a:defRPr sz="1000"/>
                       </a:pPr>
                       <a:r>
-                        <a:t>1163</a:t>
-                      </a:r>
-                    </a:p>
-                  </a:txBody>
-                  <a:tcPr/>
-                </a:tc>
-                <a:tc>
-                  <a:txBody>
-                    <a:bodyPr/>
-                    <a:lstStyle/>
-                    <a:p>
-                      <a:pPr>
-                        <a:defRPr sz="1000"/>
-                      </a:pPr>
-                      <a:r>
-                        <a:t>[727, 4966]</a:t>
-                      </a:r>
-                    </a:p>
-                  </a:txBody>
-                  <a:tcPr/>
-                </a:tc>
-                <a:tc>
-                  <a:txBody>
-                    <a:bodyPr/>
-                    <a:lstStyle/>
-                    <a:p>
-                      <a:pPr>
-                        <a:defRPr sz="1000"/>
-                      </a:pPr>
-                      <a:r>
-                        <a:t>1461</a:t>
-                      </a:r>
-                    </a:p>
-                  </a:txBody>
-                  <a:tcPr/>
-                </a:tc>
-                <a:tc>
-                  <a:txBody>
-                    <a:bodyPr/>
-                    <a:lstStyle/>
-                    <a:p>
-                      <a:pPr>
-                        <a:defRPr sz="1000"/>
-                      </a:pPr>
-                      <a:r>
-                        <a:t>[605, 4866]</a:t>
+                        <a:t>1214</a:t>
+                      </a:r>
+                    </a:p>
+                  </a:txBody>
+                  <a:tcPr/>
+                </a:tc>
+                <a:tc>
+                  <a:txBody>
+                    <a:bodyPr/>
+                    <a:lstStyle/>
+                    <a:p>
+                      <a:pPr>
+                        <a:defRPr sz="1000"/>
+                      </a:pPr>
+                      <a:r>
+                        <a:t>[761, 5174]</a:t>
+                      </a:r>
+                    </a:p>
+                  </a:txBody>
+                  <a:tcPr/>
+                </a:tc>
+                <a:tc>
+                  <a:txBody>
+                    <a:bodyPr/>
+                    <a:lstStyle/>
+                    <a:p>
+                      <a:pPr>
+                        <a:defRPr sz="1000"/>
+                      </a:pPr>
+                      <a:r>
+                        <a:t>1532</a:t>
+                      </a:r>
+                    </a:p>
+                  </a:txBody>
+                  <a:tcPr/>
+                </a:tc>
+                <a:tc>
+                  <a:txBody>
+                    <a:bodyPr/>
+                    <a:lstStyle/>
+                    <a:p>
+                      <a:pPr>
+                        <a:defRPr sz="1000"/>
+                      </a:pPr>
+                      <a:r>
+                        <a:t>[638, 5072]</a:t>
                       </a:r>
                     </a:p>
                   </a:txBody>
@@ -7118,52 +7254,52 @@
                         <a:defRPr sz="1000"/>
                       </a:pPr>
                       <a:r>
-                        <a:t>805</a:t>
-                      </a:r>
-                    </a:p>
-                  </a:txBody>
-                  <a:tcPr/>
-                </a:tc>
-                <a:tc>
-                  <a:txBody>
-                    <a:bodyPr/>
-                    <a:lstStyle/>
-                    <a:p>
-                      <a:pPr>
-                        <a:defRPr sz="1000"/>
-                      </a:pPr>
-                      <a:r>
-                        <a:t>[428, 2620]</a:t>
-                      </a:r>
-                    </a:p>
-                  </a:txBody>
-                  <a:tcPr/>
-                </a:tc>
-                <a:tc>
-                  <a:txBody>
-                    <a:bodyPr/>
-                    <a:lstStyle/>
-                    <a:p>
-                      <a:pPr>
-                        <a:defRPr sz="1000"/>
-                      </a:pPr>
-                      <a:r>
-                        <a:t>837</a:t>
-                      </a:r>
-                    </a:p>
-                  </a:txBody>
-                  <a:tcPr/>
-                </a:tc>
-                <a:tc>
-                  <a:txBody>
-                    <a:bodyPr/>
-                    <a:lstStyle/>
-                    <a:p>
-                      <a:pPr>
-                        <a:defRPr sz="1000"/>
-                      </a:pPr>
-                      <a:r>
-                        <a:t>[343, 2542]</a:t>
+                        <a:t>775</a:t>
+                      </a:r>
+                    </a:p>
+                  </a:txBody>
+                  <a:tcPr/>
+                </a:tc>
+                <a:tc>
+                  <a:txBody>
+                    <a:bodyPr/>
+                    <a:lstStyle/>
+                    <a:p>
+                      <a:pPr>
+                        <a:defRPr sz="1000"/>
+                      </a:pPr>
+                      <a:r>
+                        <a:t>[412, 2521]</a:t>
+                      </a:r>
+                    </a:p>
+                  </a:txBody>
+                  <a:tcPr/>
+                </a:tc>
+                <a:tc>
+                  <a:txBody>
+                    <a:bodyPr/>
+                    <a:lstStyle/>
+                    <a:p>
+                      <a:pPr>
+                        <a:defRPr sz="1000"/>
+                      </a:pPr>
+                      <a:r>
+                        <a:t>831</a:t>
+                      </a:r>
+                    </a:p>
+                  </a:txBody>
+                  <a:tcPr/>
+                </a:tc>
+                <a:tc>
+                  <a:txBody>
+                    <a:bodyPr/>
+                    <a:lstStyle/>
+                    <a:p>
+                      <a:pPr>
+                        <a:defRPr sz="1000"/>
+                      </a:pPr>
+                      <a:r>
+                        <a:t>[334, 2438]</a:t>
                       </a:r>
                     </a:p>
                   </a:txBody>
@@ -7213,9 +7349,43 @@
           </a:p>
         </p:txBody>
       </p:sp>
+      <p:sp>
+        <p:nvSpPr>
+          <p:cNvPr id="3" name="Content Placeholder 2"/>
+          <p:cNvSpPr>
+            <a:spLocks noGrp="1"/>
+          </p:cNvSpPr>
+          <p:nvPr>
+            <p:ph idx="1" sz="half"/>
+          </p:nvPr>
+        </p:nvSpPr>
+        <p:spPr/>
+        <p:txBody>
+          <a:bodyPr/>
+          <a:lstStyle/>
+          <a:p/>
+        </p:txBody>
+      </p:sp>
+      <p:sp>
+        <p:nvSpPr>
+          <p:cNvPr id="4" name="Content Placeholder 3"/>
+          <p:cNvSpPr>
+            <a:spLocks noGrp="1"/>
+          </p:cNvSpPr>
+          <p:nvPr>
+            <p:ph idx="2" sz="half"/>
+          </p:nvPr>
+        </p:nvSpPr>
+        <p:spPr/>
+        <p:txBody>
+          <a:bodyPr/>
+          <a:lstStyle/>
+          <a:p/>
+        </p:txBody>
+      </p:sp>
       <p:pic>
         <p:nvPicPr>
-          <p:cNvPr id="3" name="Picture 2" descr="fig1_equilibrium_margin.png"/>
+          <p:cNvPr id="5" name="Picture 4" descr="fig1_equilibrium_margin.png"/>
           <p:cNvPicPr>
             <a:picLocks noChangeAspect="1"/>
           </p:cNvPicPr>
@@ -7239,7 +7409,7 @@
       </p:pic>
       <p:sp>
         <p:nvSpPr>
-          <p:cNvPr id="4" name="TextBox 3"/>
+          <p:cNvPr id="6" name="TextBox 5"/>
           <p:cNvSpPr txBox="1"/>
           <p:nvPr/>
         </p:nvSpPr>
@@ -7307,9 +7477,43 @@
           </a:p>
         </p:txBody>
       </p:sp>
+      <p:sp>
+        <p:nvSpPr>
+          <p:cNvPr id="3" name="Content Placeholder 2"/>
+          <p:cNvSpPr>
+            <a:spLocks noGrp="1"/>
+          </p:cNvSpPr>
+          <p:nvPr>
+            <p:ph idx="1" sz="half"/>
+          </p:nvPr>
+        </p:nvSpPr>
+        <p:spPr/>
+        <p:txBody>
+          <a:bodyPr/>
+          <a:lstStyle/>
+          <a:p/>
+        </p:txBody>
+      </p:sp>
+      <p:sp>
+        <p:nvSpPr>
+          <p:cNvPr id="4" name="Content Placeholder 3"/>
+          <p:cNvSpPr>
+            <a:spLocks noGrp="1"/>
+          </p:cNvSpPr>
+          <p:nvPr>
+            <p:ph idx="2" sz="half"/>
+          </p:nvPr>
+        </p:nvSpPr>
+        <p:spPr/>
+        <p:txBody>
+          <a:bodyPr/>
+          <a:lstStyle/>
+          <a:p/>
+        </p:txBody>
+      </p:sp>
       <p:pic>
         <p:nvPicPr>
-          <p:cNvPr id="3" name="Picture 2" descr="fig2_pnr_proximity.png"/>
+          <p:cNvPr id="5" name="Picture 4" descr="fig2_pnr_proximity.png"/>
           <p:cNvPicPr>
             <a:picLocks noChangeAspect="1"/>
           </p:cNvPicPr>
@@ -7333,7 +7537,7 @@
       </p:pic>
       <p:sp>
         <p:nvSpPr>
-          <p:cNvPr id="4" name="TextBox 3"/>
+          <p:cNvPr id="6" name="TextBox 5"/>
           <p:cNvSpPr txBox="1"/>
           <p:nvPr/>
         </p:nvSpPr>
@@ -7401,9 +7605,43 @@
           </a:p>
         </p:txBody>
       </p:sp>
+      <p:sp>
+        <p:nvSpPr>
+          <p:cNvPr id="3" name="Content Placeholder 2"/>
+          <p:cNvSpPr>
+            <a:spLocks noGrp="1"/>
+          </p:cNvSpPr>
+          <p:nvPr>
+            <p:ph idx="1" sz="half"/>
+          </p:nvPr>
+        </p:nvSpPr>
+        <p:spPr/>
+        <p:txBody>
+          <a:bodyPr/>
+          <a:lstStyle/>
+          <a:p/>
+        </p:txBody>
+      </p:sp>
+      <p:sp>
+        <p:nvSpPr>
+          <p:cNvPr id="4" name="Content Placeholder 3"/>
+          <p:cNvSpPr>
+            <a:spLocks noGrp="1"/>
+          </p:cNvSpPr>
+          <p:nvPr>
+            <p:ph idx="2" sz="half"/>
+          </p:nvPr>
+        </p:nvSpPr>
+        <p:spPr/>
+        <p:txBody>
+          <a:bodyPr/>
+          <a:lstStyle/>
+          <a:p/>
+        </p:txBody>
+      </p:sp>
       <p:pic>
         <p:nvPicPr>
-          <p:cNvPr id="3" name="Picture 2" descr="fig3_historical_margin.png"/>
+          <p:cNvPr id="5" name="Picture 4" descr="fig3_historical_margin.png"/>
           <p:cNvPicPr>
             <a:picLocks noChangeAspect="1"/>
           </p:cNvPicPr>
@@ -7427,7 +7665,7 @@
       </p:pic>
       <p:sp>
         <p:nvSpPr>
-          <p:cNvPr id="4" name="TextBox 3"/>
+          <p:cNvPr id="6" name="TextBox 5"/>
           <p:cNvSpPr txBox="1"/>
           <p:nvPr/>
         </p:nvSpPr>
@@ -7451,7 +7689,7 @@
               <a:defRPr sz="1400"/>
             </a:pPr>
             <a:r>
-              <a:t>Positive values mean the late-window rates would produce a larger safety margin if they persisted.</a:t>
+              <a:t>Positive values mean the late-window rates would produce a larger safety margin if they persisted. The comparison is across point estimates; uncertainty is substantial.</a:t>
             </a:r>
           </a:p>
         </p:txBody>
@@ -7495,9 +7733,43 @@
           </a:p>
         </p:txBody>
       </p:sp>
+      <p:sp>
+        <p:nvSpPr>
+          <p:cNvPr id="3" name="Content Placeholder 2"/>
+          <p:cNvSpPr>
+            <a:spLocks noGrp="1"/>
+          </p:cNvSpPr>
+          <p:nvPr>
+            <p:ph idx="1" sz="half"/>
+          </p:nvPr>
+        </p:nvSpPr>
+        <p:spPr/>
+        <p:txBody>
+          <a:bodyPr/>
+          <a:lstStyle/>
+          <a:p/>
+        </p:txBody>
+      </p:sp>
+      <p:sp>
+        <p:nvSpPr>
+          <p:cNvPr id="4" name="Content Placeholder 3"/>
+          <p:cNvSpPr>
+            <a:spLocks noGrp="1"/>
+          </p:cNvSpPr>
+          <p:nvPr>
+            <p:ph idx="2" sz="half"/>
+          </p:nvPr>
+        </p:nvSpPr>
+        <p:spPr/>
+        <p:txBody>
+          <a:bodyPr/>
+          <a:lstStyle/>
+          <a:p/>
+        </p:txBody>
+      </p:sp>
       <p:pic>
         <p:nvPicPr>
-          <p:cNvPr id="3" name="Picture 2" descr="fig4_bootstrap_ci.png"/>
+          <p:cNvPr id="5" name="Picture 4" descr="fig4_bootstrap_ci.png"/>
           <p:cNvPicPr>
             <a:picLocks noChangeAspect="1"/>
           </p:cNvPicPr>
@@ -7521,7 +7793,7 @@
       </p:pic>
       <p:sp>
         <p:nvSpPr>
-          <p:cNvPr id="4" name="TextBox 3"/>
+          <p:cNvPr id="6" name="TextBox 5"/>
           <p:cNvSpPr txBox="1"/>
           <p:nvPr/>
         </p:nvSpPr>
@@ -7589,9 +7861,43 @@
           </a:p>
         </p:txBody>
       </p:sp>
+      <p:sp>
+        <p:nvSpPr>
+          <p:cNvPr id="3" name="Content Placeholder 2"/>
+          <p:cNvSpPr>
+            <a:spLocks noGrp="1"/>
+          </p:cNvSpPr>
+          <p:nvPr>
+            <p:ph idx="1" sz="half"/>
+          </p:nvPr>
+        </p:nvSpPr>
+        <p:spPr/>
+        <p:txBody>
+          <a:bodyPr/>
+          <a:lstStyle/>
+          <a:p/>
+        </p:txBody>
+      </p:sp>
+      <p:sp>
+        <p:nvSpPr>
+          <p:cNvPr id="4" name="Content Placeholder 3"/>
+          <p:cNvSpPr>
+            <a:spLocks noGrp="1"/>
+          </p:cNvSpPr>
+          <p:nvPr>
+            <p:ph idx="2" sz="half"/>
+          </p:nvPr>
+        </p:nvSpPr>
+        <p:spPr/>
+        <p:txBody>
+          <a:bodyPr/>
+          <a:lstStyle/>
+          <a:p/>
+        </p:txBody>
+      </p:sp>
       <p:graphicFrame>
         <p:nvGraphicFramePr>
-          <p:cNvPr id="3" name="Table 2"/>
+          <p:cNvPr id="5" name="Table 4"/>
           <p:cNvGraphicFramePr>
             <a:graphicFrameLocks noGrp="1"/>
           </p:cNvGraphicFramePr>
@@ -7862,52 +8168,52 @@
                         <a:defRPr sz="1000"/>
                       </a:pPr>
                       <a:r>
-                        <a:t>48</a:t>
-                      </a:r>
-                    </a:p>
-                  </a:txBody>
-                  <a:tcPr/>
-                </a:tc>
-                <a:tc>
-                  <a:txBody>
-                    <a:bodyPr/>
-                    <a:lstStyle/>
-                    <a:p>
-                      <a:pPr>
-                        <a:defRPr sz="1000"/>
-                      </a:pPr>
-                      <a:r>
-                        <a:t>3840</a:t>
-                      </a:r>
-                    </a:p>
-                  </a:txBody>
-                  <a:tcPr/>
-                </a:tc>
-                <a:tc>
-                  <a:txBody>
-                    <a:bodyPr/>
-                    <a:lstStyle/>
-                    <a:p>
-                      <a:pPr>
-                        <a:defRPr sz="1000"/>
-                      </a:pPr>
-                      <a:r>
-                        <a:t>45</a:t>
-                      </a:r>
-                    </a:p>
-                  </a:txBody>
-                  <a:tcPr/>
-                </a:tc>
-                <a:tc>
-                  <a:txBody>
-                    <a:bodyPr/>
-                    <a:lstStyle/>
-                    <a:p>
-                      <a:pPr>
-                        <a:defRPr sz="1000"/>
-                      </a:pPr>
-                      <a:r>
-                        <a:t>40</a:t>
+                        <a:t>49</a:t>
+                      </a:r>
+                    </a:p>
+                  </a:txBody>
+                  <a:tcPr/>
+                </a:tc>
+                <a:tc>
+                  <a:txBody>
+                    <a:bodyPr/>
+                    <a:lstStyle/>
+                    <a:p>
+                      <a:pPr>
+                        <a:defRPr sz="1000"/>
+                      </a:pPr>
+                      <a:r>
+                        <a:t>3850</a:t>
+                      </a:r>
+                    </a:p>
+                  </a:txBody>
+                  <a:tcPr/>
+                </a:tc>
+                <a:tc>
+                  <a:txBody>
+                    <a:bodyPr/>
+                    <a:lstStyle/>
+                    <a:p>
+                      <a:pPr>
+                        <a:defRPr sz="1000"/>
+                      </a:pPr>
+                      <a:r>
+                        <a:t>46</a:t>
+                      </a:r>
+                    </a:p>
+                  </a:txBody>
+                  <a:tcPr/>
+                </a:tc>
+                <a:tc>
+                  <a:txBody>
+                    <a:bodyPr/>
+                    <a:lstStyle/>
+                    <a:p>
+                      <a:pPr>
+                        <a:defRPr sz="1000"/>
+                      </a:pPr>
+                      <a:r>
+                        <a:t>41</a:t>
                       </a:r>
                     </a:p>
                   </a:txBody>
@@ -7937,22 +8243,22 @@
                         <a:defRPr sz="1000"/>
                       </a:pPr>
                       <a:r>
-                        <a:t>2006.2</a:t>
-                      </a:r>
-                    </a:p>
-                  </a:txBody>
-                  <a:tcPr/>
-                </a:tc>
-                <a:tc>
-                  <a:txBody>
-                    <a:bodyPr/>
-                    <a:lstStyle/>
-                    <a:p>
-                      <a:pPr>
-                        <a:defRPr sz="1000"/>
-                      </a:pPr>
-                      <a:r>
-                        <a:t>22</a:t>
+                        <a:t>2006.1</a:t>
+                      </a:r>
+                    </a:p>
+                  </a:txBody>
+                  <a:tcPr/>
+                </a:tc>
+                <a:tc>
+                  <a:txBody>
+                    <a:bodyPr/>
+                    <a:lstStyle/>
+                    <a:p>
+                      <a:pPr>
+                        <a:defRPr sz="1000"/>
+                      </a:pPr>
+                      <a:r>
+                        <a:t>23</a:t>
                       </a:r>
                     </a:p>
                   </a:txBody>
@@ -8716,52 +9022,52 @@
                         <a:defRPr sz="1000"/>
                       </a:pPr>
                       <a:r>
-                        <a:t>50</a:t>
-                      </a:r>
-                    </a:p>
-                  </a:txBody>
-                  <a:tcPr/>
-                </a:tc>
-                <a:tc>
-                  <a:txBody>
-                    <a:bodyPr/>
-                    <a:lstStyle/>
-                    <a:p>
-                      <a:pPr>
-                        <a:defRPr sz="1000"/>
-                      </a:pPr>
-                      <a:r>
-                        <a:t>4220</a:t>
-                      </a:r>
-                    </a:p>
-                  </a:txBody>
-                  <a:tcPr/>
-                </a:tc>
-                <a:tc>
-                  <a:txBody>
-                    <a:bodyPr/>
-                    <a:lstStyle/>
-                    <a:p>
-                      <a:pPr>
-                        <a:defRPr sz="1000"/>
-                      </a:pPr>
-                      <a:r>
-                        <a:t>45</a:t>
-                      </a:r>
-                    </a:p>
-                  </a:txBody>
-                  <a:tcPr/>
-                </a:tc>
-                <a:tc>
-                  <a:txBody>
-                    <a:bodyPr/>
-                    <a:lstStyle/>
-                    <a:p>
-                      <a:pPr>
-                        <a:defRPr sz="1000"/>
-                      </a:pPr>
-                      <a:r>
-                        <a:t>47</a:t>
+                        <a:t>49</a:t>
+                      </a:r>
+                    </a:p>
+                  </a:txBody>
+                  <a:tcPr/>
+                </a:tc>
+                <a:tc>
+                  <a:txBody>
+                    <a:bodyPr/>
+                    <a:lstStyle/>
+                    <a:p>
+                      <a:pPr>
+                        <a:defRPr sz="1000"/>
+                      </a:pPr>
+                      <a:r>
+                        <a:t>4210</a:t>
+                      </a:r>
+                    </a:p>
+                  </a:txBody>
+                  <a:tcPr/>
+                </a:tc>
+                <a:tc>
+                  <a:txBody>
+                    <a:bodyPr/>
+                    <a:lstStyle/>
+                    <a:p>
+                      <a:pPr>
+                        <a:defRPr sz="1000"/>
+                      </a:pPr>
+                      <a:r>
+                        <a:t>44</a:t>
+                      </a:r>
+                    </a:p>
+                  </a:txBody>
+                  <a:tcPr/>
+                </a:tc>
+                <a:tc>
+                  <a:txBody>
+                    <a:bodyPr/>
+                    <a:lstStyle/>
+                    <a:p>
+                      <a:pPr>
+                        <a:defRPr sz="1000"/>
+                      </a:pPr>
+                      <a:r>
+                        <a:t>46</a:t>
                       </a:r>
                     </a:p>
                   </a:txBody>
@@ -8791,22 +9097,22 @@
                         <a:defRPr sz="1000"/>
                       </a:pPr>
                       <a:r>
-                        <a:t>2006.3</a:t>
-                      </a:r>
-                    </a:p>
-                  </a:txBody>
-                  <a:tcPr/>
-                </a:tc>
-                <a:tc>
-                  <a:txBody>
-                    <a:bodyPr/>
-                    <a:lstStyle/>
-                    <a:p>
-                      <a:pPr>
-                        <a:defRPr sz="1000"/>
-                      </a:pPr>
-                      <a:r>
-                        <a:t>18</a:t>
+                        <a:t>2006.4</a:t>
+                      </a:r>
+                    </a:p>
+                  </a:txBody>
+                  <a:tcPr/>
+                </a:tc>
+                <a:tc>
+                  <a:txBody>
+                    <a:bodyPr/>
+                    <a:lstStyle/>
+                    <a:p>
+                      <a:pPr>
+                        <a:defRPr sz="1000"/>
+                      </a:pPr>
+                      <a:r>
+                        <a:t>17</a:t>
                       </a:r>
                     </a:p>
                   </a:txBody>
@@ -8856,9 +9162,43 @@
           </a:p>
         </p:txBody>
       </p:sp>
+      <p:sp>
+        <p:nvSpPr>
+          <p:cNvPr id="3" name="Content Placeholder 2"/>
+          <p:cNvSpPr>
+            <a:spLocks noGrp="1"/>
+          </p:cNvSpPr>
+          <p:nvPr>
+            <p:ph idx="1" sz="half"/>
+          </p:nvPr>
+        </p:nvSpPr>
+        <p:spPr/>
+        <p:txBody>
+          <a:bodyPr/>
+          <a:lstStyle/>
+          <a:p/>
+        </p:txBody>
+      </p:sp>
+      <p:sp>
+        <p:nvSpPr>
+          <p:cNvPr id="4" name="Content Placeholder 3"/>
+          <p:cNvSpPr>
+            <a:spLocks noGrp="1"/>
+          </p:cNvSpPr>
+          <p:nvPr>
+            <p:ph idx="2" sz="half"/>
+          </p:nvPr>
+        </p:nvSpPr>
+        <p:spPr/>
+        <p:txBody>
+          <a:bodyPr/>
+          <a:lstStyle/>
+          <a:p/>
+        </p:txBody>
+      </p:sp>
       <p:graphicFrame>
         <p:nvGraphicFramePr>
-          <p:cNvPr id="3" name="Table 2"/>
+          <p:cNvPr id="5" name="Table 4"/>
           <p:cNvGraphicFramePr>
             <a:graphicFrameLocks noGrp="1"/>
           </p:cNvGraphicFramePr>
@@ -9129,7 +9469,7 @@
                         <a:defRPr sz="1000"/>
                       </a:pPr>
                       <a:r>
-                        <a:t>1156.27</a:t>
+                        <a:t>1208.42</a:t>
                       </a:r>
                     </a:p>
                   </a:txBody>
@@ -9159,67 +9499,67 @@
                         <a:defRPr sz="1000"/>
                       </a:pPr>
                       <a:r>
-                        <a:t>1027.20</a:t>
-                      </a:r>
-                    </a:p>
-                  </a:txBody>
-                  <a:tcPr/>
-                </a:tc>
-                <a:tc>
-                  <a:txBody>
-                    <a:bodyPr/>
-                    <a:lstStyle/>
-                    <a:p>
-                      <a:pPr>
-                        <a:defRPr sz="1000"/>
-                      </a:pPr>
-                      <a:r>
-                        <a:t>2.76</a:t>
-                      </a:r>
-                    </a:p>
-                  </a:txBody>
-                  <a:tcPr/>
-                </a:tc>
-                <a:tc>
-                  <a:txBody>
-                    <a:bodyPr/>
-                    <a:lstStyle/>
-                    <a:p>
-                      <a:pPr>
-                        <a:defRPr sz="1000"/>
-                      </a:pPr>
-                      <a:r>
-                        <a:t>0.00261</a:t>
-                      </a:r>
-                    </a:p>
-                  </a:txBody>
-                  <a:tcPr/>
-                </a:tc>
-                <a:tc>
-                  <a:txBody>
-                    <a:bodyPr/>
-                    <a:lstStyle/>
-                    <a:p>
-                      <a:pPr>
-                        <a:defRPr sz="1000"/>
-                      </a:pPr>
-                      <a:r>
-                        <a:t>0.12276</a:t>
-                      </a:r>
-                    </a:p>
-                  </a:txBody>
-                  <a:tcPr/>
-                </a:tc>
-                <a:tc>
-                  <a:txBody>
-                    <a:bodyPr/>
-                    <a:lstStyle/>
-                    <a:p>
-                      <a:pPr>
-                        <a:defRPr sz="1000"/>
-                      </a:pPr>
-                      <a:r>
-                        <a:t>0.00523</a:t>
+                        <a:t>1079.36</a:t>
+                      </a:r>
+                    </a:p>
+                  </a:txBody>
+                  <a:tcPr/>
+                </a:tc>
+                <a:tc>
+                  <a:txBody>
+                    <a:bodyPr/>
+                    <a:lstStyle/>
+                    <a:p>
+                      <a:pPr>
+                        <a:defRPr sz="1000"/>
+                      </a:pPr>
+                      <a:r>
+                        <a:t>2.82</a:t>
+                      </a:r>
+                    </a:p>
+                  </a:txBody>
+                  <a:tcPr/>
+                </a:tc>
+                <a:tc>
+                  <a:txBody>
+                    <a:bodyPr/>
+                    <a:lstStyle/>
+                    <a:p>
+                      <a:pPr>
+                        <a:defRPr sz="1000"/>
+                      </a:pPr>
+                      <a:r>
+                        <a:t>0.00255</a:t>
+                      </a:r>
+                    </a:p>
+                  </a:txBody>
+                  <a:tcPr/>
+                </a:tc>
+                <a:tc>
+                  <a:txBody>
+                    <a:bodyPr/>
+                    <a:lstStyle/>
+                    <a:p>
+                      <a:pPr>
+                        <a:defRPr sz="1000"/>
+                      </a:pPr>
+                      <a:r>
+                        <a:t>0.12532</a:t>
+                      </a:r>
+                    </a:p>
+                  </a:txBody>
+                  <a:tcPr/>
+                </a:tc>
+                <a:tc>
+                  <a:txBody>
+                    <a:bodyPr/>
+                    <a:lstStyle/>
+                    <a:p>
+                      <a:pPr>
+                        <a:defRPr sz="1000"/>
+                      </a:pPr>
+                      <a:r>
+                        <a:t>0.00510</a:t>
                       </a:r>
                     </a:p>
                   </a:txBody>
@@ -9983,7 +10323,7 @@
                         <a:defRPr sz="1000"/>
                       </a:pPr>
                       <a:r>
-                        <a:t>801.70</a:t>
+                        <a:t>770.21</a:t>
                       </a:r>
                     </a:p>
                   </a:txBody>
@@ -10013,67 +10353,67 @@
                         <a:defRPr sz="1000"/>
                       </a:pPr>
                       <a:r>
-                        <a:t>669.21</a:t>
-                      </a:r>
-                    </a:p>
-                  </a:txBody>
-                  <a:tcPr/>
-                </a:tc>
-                <a:tc>
-                  <a:txBody>
-                    <a:bodyPr/>
-                    <a:lstStyle/>
-                    <a:p>
-                      <a:pPr>
-                        <a:defRPr sz="1000"/>
-                      </a:pPr>
-                      <a:r>
-                        <a:t>2.83</a:t>
-                      </a:r>
-                    </a:p>
-                  </a:txBody>
-                  <a:tcPr/>
-                </a:tc>
-                <a:tc>
-                  <a:txBody>
-                    <a:bodyPr/>
-                    <a:lstStyle/>
-                    <a:p>
-                      <a:pPr>
-                        <a:defRPr sz="1000"/>
-                      </a:pPr>
-                      <a:r>
-                        <a:t>0.00396</a:t>
-                      </a:r>
-                    </a:p>
-                  </a:txBody>
-                  <a:tcPr/>
-                </a:tc>
-                <a:tc>
-                  <a:txBody>
-                    <a:bodyPr/>
-                    <a:lstStyle/>
-                    <a:p>
-                      <a:pPr>
-                        <a:defRPr sz="1000"/>
-                      </a:pPr>
-                      <a:r>
-                        <a:t>0.10504</a:t>
-                      </a:r>
-                    </a:p>
-                  </a:txBody>
-                  <a:tcPr/>
-                </a:tc>
-                <a:tc>
-                  <a:txBody>
-                    <a:bodyPr/>
-                    <a:lstStyle/>
-                    <a:p>
-                      <a:pPr>
-                        <a:defRPr sz="1000"/>
-                      </a:pPr>
-                      <a:r>
-                        <a:t>0.00791</a:t>
+                        <a:t>637.71</a:t>
+                      </a:r>
+                    </a:p>
+                  </a:txBody>
+                  <a:tcPr/>
+                </a:tc>
+                <a:tc>
+                  <a:txBody>
+                    <a:bodyPr/>
+                    <a:lstStyle/>
+                    <a:p>
+                      <a:pPr>
+                        <a:defRPr sz="1000"/>
+                      </a:pPr>
+                      <a:r>
+                        <a:t>2.77</a:t>
+                      </a:r>
+                    </a:p>
+                  </a:txBody>
+                  <a:tcPr/>
+                </a:tc>
+                <a:tc>
+                  <a:txBody>
+                    <a:bodyPr/>
+                    <a:lstStyle/>
+                    <a:p>
+                      <a:pPr>
+                        <a:defRPr sz="1000"/>
+                      </a:pPr>
+                      <a:r>
+                        <a:t>0.00404</a:t>
+                      </a:r>
+                    </a:p>
+                  </a:txBody>
+                  <a:tcPr/>
+                </a:tc>
+                <a:tc>
+                  <a:txBody>
+                    <a:bodyPr/>
+                    <a:lstStyle/>
+                    <a:p>
+                      <a:pPr>
+                        <a:defRPr sz="1000"/>
+                      </a:pPr>
+                      <a:r>
+                        <a:t>0.10294</a:t>
+                      </a:r>
+                    </a:p>
+                  </a:txBody>
+                  <a:tcPr/>
+                </a:tc>
+                <a:tc>
+                  <a:txBody>
+                    <a:bodyPr/>
+                    <a:lstStyle/>
+                    <a:p>
+                      <a:pPr>
+                        <a:defRPr sz="1000"/>
+                      </a:pPr>
+                      <a:r>
+                        <a:t>0.00808</a:t>
                       </a:r>
                     </a:p>
                   </a:txBody>
@@ -10123,9 +10463,43 @@
           </a:p>
         </p:txBody>
       </p:sp>
+      <p:sp>
+        <p:nvSpPr>
+          <p:cNvPr id="3" name="Content Placeholder 2"/>
+          <p:cNvSpPr>
+            <a:spLocks noGrp="1"/>
+          </p:cNvSpPr>
+          <p:nvPr>
+            <p:ph idx="1" sz="half"/>
+          </p:nvPr>
+        </p:nvSpPr>
+        <p:spPr/>
+        <p:txBody>
+          <a:bodyPr/>
+          <a:lstStyle/>
+          <a:p/>
+        </p:txBody>
+      </p:sp>
+      <p:sp>
+        <p:nvSpPr>
+          <p:cNvPr id="4" name="Content Placeholder 3"/>
+          <p:cNvSpPr>
+            <a:spLocks noGrp="1"/>
+          </p:cNvSpPr>
+          <p:nvPr>
+            <p:ph idx="2" sz="half"/>
+          </p:nvPr>
+        </p:nvSpPr>
+        <p:spPr/>
+        <p:txBody>
+          <a:bodyPr/>
+          <a:lstStyle/>
+          <a:p/>
+        </p:txBody>
+      </p:sp>
       <p:graphicFrame>
         <p:nvGraphicFramePr>
-          <p:cNvPr id="3" name="Table 2"/>
+          <p:cNvPr id="5" name="Table 4"/>
           <p:cNvGraphicFramePr>
             <a:graphicFrameLocks noGrp="1"/>
           </p:cNvGraphicFramePr>
@@ -10383,7 +10757,7 @@
                         <a:defRPr sz="1000"/>
                       </a:pPr>
                       <a:r>
-                        <a:t>-2.100</a:t>
+                        <a:t>-2.096</a:t>
                       </a:r>
                     </a:p>
                   </a:txBody>
@@ -10413,7 +10787,7 @@
                         <a:defRPr sz="1000"/>
                       </a:pPr>
                       <a:r>
-                        <a:t>0.067</a:t>
+                        <a:t>0.066</a:t>
                       </a:r>
                     </a:p>
                   </a:txBody>
@@ -10443,7 +10817,7 @@
                         <a:defRPr sz="1000"/>
                       </a:pPr>
                       <a:r>
-                        <a:t>0.047</a:t>
+                        <a:t>0.044</a:t>
                       </a:r>
                     </a:p>
                   </a:txBody>
@@ -11132,7 +11506,7 @@
                         <a:defRPr sz="1000"/>
                       </a:pPr>
                       <a:r>
-                        <a:t>-2.126</a:t>
+                        <a:t>-2.124</a:t>
                       </a:r>
                     </a:p>
                   </a:txBody>
@@ -11162,7 +11536,7 @@
                         <a:defRPr sz="1000"/>
                       </a:pPr>
                       <a:r>
-                        <a:t>0.087</a:t>
+                        <a:t>0.089</a:t>
                       </a:r>
                     </a:p>
                   </a:txBody>
@@ -11192,7 +11566,7 @@
                         <a:defRPr sz="1000"/>
                       </a:pPr>
                       <a:r>
-                        <a:t>0.066</a:t>
+                        <a:t>0.063</a:t>
                       </a:r>
                     </a:p>
                   </a:txBody>
@@ -11242,9 +11616,43 @@
           </a:p>
         </p:txBody>
       </p:sp>
+      <p:sp>
+        <p:nvSpPr>
+          <p:cNvPr id="3" name="Content Placeholder 2"/>
+          <p:cNvSpPr>
+            <a:spLocks noGrp="1"/>
+          </p:cNvSpPr>
+          <p:nvPr>
+            <p:ph idx="1" sz="half"/>
+          </p:nvPr>
+        </p:nvSpPr>
+        <p:spPr/>
+        <p:txBody>
+          <a:bodyPr/>
+          <a:lstStyle/>
+          <a:p/>
+        </p:txBody>
+      </p:sp>
+      <p:sp>
+        <p:nvSpPr>
+          <p:cNvPr id="4" name="Content Placeholder 3"/>
+          <p:cNvSpPr>
+            <a:spLocks noGrp="1"/>
+          </p:cNvSpPr>
+          <p:nvPr>
+            <p:ph idx="2" sz="half"/>
+          </p:nvPr>
+        </p:nvSpPr>
+        <p:spPr/>
+        <p:txBody>
+          <a:bodyPr/>
+          <a:lstStyle/>
+          <a:p/>
+        </p:txBody>
+      </p:sp>
       <p:graphicFrame>
         <p:nvGraphicFramePr>
-          <p:cNvPr id="3" name="Table 2"/>
+          <p:cNvPr id="5" name="Table 4"/>
           <p:cNvGraphicFramePr>
             <a:graphicFrameLocks noGrp="1"/>
           </p:cNvGraphicFramePr>
@@ -11581,37 +11989,37 @@
                         <a:defRPr sz="1000"/>
                       </a:pPr>
                       <a:r>
-                        <a:t>2.8304</a:t>
-                      </a:r>
-                    </a:p>
-                  </a:txBody>
-                  <a:tcPr/>
-                </a:tc>
-                <a:tc>
-                  <a:txBody>
-                    <a:bodyPr/>
-                    <a:lstStyle/>
-                    <a:p>
-                      <a:pPr>
-                        <a:defRPr sz="1000"/>
-                      </a:pPr>
-                      <a:r>
-                        <a:t>0.165</a:t>
-                      </a:r>
-                    </a:p>
-                  </a:txBody>
-                  <a:tcPr/>
-                </a:tc>
-                <a:tc>
-                  <a:txBody>
-                    <a:bodyPr/>
-                    <a:lstStyle/>
-                    <a:p>
-                      <a:pPr>
-                        <a:defRPr sz="1000"/>
-                      </a:pPr>
-                      <a:r>
-                        <a:t>0.835</a:t>
+                        <a:t>2.7692</a:t>
+                      </a:r>
+                    </a:p>
+                  </a:txBody>
+                  <a:tcPr/>
+                </a:tc>
+                <a:tc>
+                  <a:txBody>
+                    <a:bodyPr/>
+                    <a:lstStyle/>
+                    <a:p>
+                      <a:pPr>
+                        <a:defRPr sz="1000"/>
+                      </a:pPr>
+                      <a:r>
+                        <a:t>0.172</a:t>
+                      </a:r>
+                    </a:p>
+                  </a:txBody>
+                  <a:tcPr/>
+                </a:tc>
+                <a:tc>
+                  <a:txBody>
+                    <a:bodyPr/>
+                    <a:lstStyle/>
+                    <a:p>
+                      <a:pPr>
+                        <a:defRPr sz="1000"/>
+                      </a:pPr>
+                      <a:r>
+                        <a:t>0.828</a:t>
                       </a:r>
                     </a:p>
                   </a:txBody>
@@ -11812,7 +12220,7 @@
                         <a:defRPr sz="1000"/>
                       </a:pPr>
                       <a:r>
-                        <a:t>Continental Europe</a:t>
+                        <a:t>Other Western</a:t>
                       </a:r>
                     </a:p>
                   </a:txBody>
@@ -11857,37 +12265,37 @@
                         <a:defRPr sz="1000"/>
                       </a:pPr>
                       <a:r>
-                        <a:t>2.7634</a:t>
-                      </a:r>
-                    </a:p>
-                  </a:txBody>
-                  <a:tcPr/>
-                </a:tc>
-                <a:tc>
-                  <a:txBody>
-                    <a:bodyPr/>
-                    <a:lstStyle/>
-                    <a:p>
-                      <a:pPr>
-                        <a:defRPr sz="1000"/>
-                      </a:pPr>
-                      <a:r>
-                        <a:t>0.112</a:t>
-                      </a:r>
-                    </a:p>
-                  </a:txBody>
-                  <a:tcPr/>
-                </a:tc>
-                <a:tc>
-                  <a:txBody>
-                    <a:bodyPr/>
-                    <a:lstStyle/>
-                    <a:p>
-                      <a:pPr>
-                        <a:defRPr sz="1000"/>
-                      </a:pPr>
-                      <a:r>
-                        <a:t>0.888</a:t>
+                        <a:t>0.8723</a:t>
+                      </a:r>
+                    </a:p>
+                  </a:txBody>
+                  <a:tcPr/>
+                </a:tc>
+                <a:tc>
+                  <a:txBody>
+                    <a:bodyPr/>
+                    <a:lstStyle/>
+                    <a:p>
+                      <a:pPr>
+                        <a:defRPr sz="1000"/>
+                      </a:pPr>
+                      <a:r>
+                        <a:t>0.111</a:t>
+                      </a:r>
+                    </a:p>
+                  </a:txBody>
+                  <a:tcPr/>
+                </a:tc>
+                <a:tc>
+                  <a:txBody>
+                    <a:bodyPr/>
+                    <a:lstStyle/>
+                    <a:p>
+                      <a:pPr>
+                        <a:defRPr sz="1000"/>
+                      </a:pPr>
+                      <a:r>
+                        <a:t>0.889</a:t>
                       </a:r>
                     </a:p>
                   </a:txBody>
@@ -11904,7 +12312,7 @@
                         <a:defRPr sz="1000"/>
                       </a:pPr>
                       <a:r>
-                        <a:t>Other Western</a:t>
+                        <a:t>Continental Europe</a:t>
                       </a:r>
                     </a:p>
                   </a:txBody>
@@ -11949,37 +12357,37 @@
                         <a:defRPr sz="1000"/>
                       </a:pPr>
                       <a:r>
-                        <a:t>0.8723</a:t>
-                      </a:r>
-                    </a:p>
-                  </a:txBody>
-                  <a:tcPr/>
-                </a:tc>
-                <a:tc>
-                  <a:txBody>
-                    <a:bodyPr/>
-                    <a:lstStyle/>
-                    <a:p>
-                      <a:pPr>
-                        <a:defRPr sz="1000"/>
-                      </a:pPr>
-                      <a:r>
-                        <a:t>0.111</a:t>
-                      </a:r>
-                    </a:p>
-                  </a:txBody>
-                  <a:tcPr/>
-                </a:tc>
-                <a:tc>
-                  <a:txBody>
-                    <a:bodyPr/>
-                    <a:lstStyle/>
-                    <a:p>
-                      <a:pPr>
-                        <a:defRPr sz="1000"/>
-                      </a:pPr>
-                      <a:r>
-                        <a:t>0.889</a:t>
+                        <a:t>2.8237</a:t>
+                      </a:r>
+                    </a:p>
+                  </a:txBody>
+                  <a:tcPr/>
+                </a:tc>
+                <a:tc>
+                  <a:txBody>
+                    <a:bodyPr/>
+                    <a:lstStyle/>
+                    <a:p>
+                      <a:pPr>
+                        <a:defRPr sz="1000"/>
+                      </a:pPr>
+                      <a:r>
+                        <a:t>0.107</a:t>
+                      </a:r>
+                    </a:p>
+                  </a:txBody>
+                  <a:tcPr/>
+                </a:tc>
+                <a:tc>
+                  <a:txBody>
+                    <a:bodyPr/>
+                    <a:lstStyle/>
+                    <a:p>
+                      <a:pPr>
+                        <a:defRPr sz="1000"/>
+                      </a:pPr>
+                      <a:r>
+                        <a:t>0.893</a:t>
                       </a:r>
                     </a:p>
                   </a:txBody>

</xml_diff>

<commit_message>
Fix Devin Review findings: dynamic Results/Discussion, robust policy levers, PNR bounds filtering, time-varying support guard, reproduce.sh cache gating, and cohort edit provenance
Co-Authored-By: Tatsuki Onishi <bougtoir@gmail.com>
</commit_message>
<xml_diff>
--- a/researcher_mobility_ode/docs/manuscript_full_article_figures.pptx
+++ b/researcher_mobility_ode/docs/manuscript_full_article_figures.pptx
@@ -3934,7 +3934,7 @@
         </p:nvGraphicFramePr>
         <p:xfrm>
           <a:off x="457200" y="1097280"/>
-          <a:ext cx="12801600" cy="5486400"/>
+          <a:ext cx="15361919" cy="1645919"/>
         </p:xfrm>
         <a:graphic>
           <a:graphicData uri="http://schemas.openxmlformats.org/drawingml/2006/table">
@@ -3943,18 +3943,20 @@
                 <a:tableStyleId>{5C22544A-7EE6-4342-B048-85BDC9FD1C3A}</a:tableStyleId>
               </a:tblPr>
               <a:tblGrid>
-                <a:gridCol w="1280160"/>
-                <a:gridCol w="1280160"/>
-                <a:gridCol w="1280160"/>
-                <a:gridCol w="1280160"/>
-                <a:gridCol w="1280160"/>
-                <a:gridCol w="1280160"/>
-                <a:gridCol w="1280160"/>
-                <a:gridCol w="1280160"/>
-                <a:gridCol w="1280160"/>
-                <a:gridCol w="1280160"/>
+                <a:gridCol w="1280159"/>
+                <a:gridCol w="1280159"/>
+                <a:gridCol w="1280159"/>
+                <a:gridCol w="1280159"/>
+                <a:gridCol w="1280159"/>
+                <a:gridCol w="1280159"/>
+                <a:gridCol w="1280159"/>
+                <a:gridCol w="1280159"/>
+                <a:gridCol w="1280159"/>
+                <a:gridCol w="1280159"/>
+                <a:gridCol w="1280159"/>
+                <a:gridCol w="1280170"/>
               </a:tblGrid>
-              <a:tr h="548640">
+              <a:tr h="548639">
                 <a:tc>
                   <a:txBody>
                     <a:bodyPr/>
@@ -3973,6 +3975,30 @@
                     <a:lstStyle/>
                     <a:p>
                       <a:r>
+                        <a:t>n_early</a:t>
+                      </a:r>
+                    </a:p>
+                  </a:txBody>
+                  <a:tcPr/>
+                </a:tc>
+                <a:tc>
+                  <a:txBody>
+                    <a:bodyPr/>
+                    <a:lstStyle/>
+                    <a:p>
+                      <a:r>
+                        <a:t>n_late</a:t>
+                      </a:r>
+                    </a:p>
+                  </a:txBody>
+                  <a:tcPr/>
+                </a:tc>
+                <a:tc>
+                  <a:txBody>
+                    <a:bodyPr/>
+                    <a:lstStyle/>
+                    <a:p>
+                      <a:r>
                         <a:t>T early</a:t>
                       </a:r>
                     </a:p>
@@ -4076,1071 +4102,189 @@
                   <a:tcPr/>
                 </a:tc>
               </a:tr>
-              <a:tr h="548640">
-                <a:tc>
-                  <a:txBody>
-                    <a:bodyPr/>
-                    <a:lstStyle/>
-                    <a:p>
-                      <a:pPr>
-                        <a:defRPr sz="1000"/>
-                      </a:pPr>
-                      <a:r>
-                        <a:t>Anglosphere ex-US</a:t>
-                      </a:r>
-                    </a:p>
-                  </a:txBody>
-                  <a:tcPr/>
-                </a:tc>
-                <a:tc>
-                  <a:txBody>
-                    <a:bodyPr/>
-                    <a:lstStyle/>
-                    <a:p>
-                      <a:pPr>
-                        <a:defRPr sz="1000"/>
-                      </a:pPr>
-                      <a:r>
-                        <a:t>699.2</a:t>
-                      </a:r>
-                    </a:p>
-                  </a:txBody>
-                  <a:tcPr/>
-                </a:tc>
-                <a:tc>
-                  <a:txBody>
-                    <a:bodyPr/>
-                    <a:lstStyle/>
-                    <a:p>
-                      <a:pPr>
-                        <a:defRPr sz="1000"/>
-                      </a:pPr>
-                      <a:r>
-                        <a:t>250.1</a:t>
-                      </a:r>
-                    </a:p>
-                  </a:txBody>
-                  <a:tcPr/>
-                </a:tc>
-                <a:tc>
-                  <a:txBody>
-                    <a:bodyPr/>
-                    <a:lstStyle/>
-                    <a:p>
-                      <a:pPr>
-                        <a:defRPr sz="1000"/>
-                      </a:pPr>
-                      <a:r>
-                        <a:t>-449.1613272646298</a:t>
-                      </a:r>
-                    </a:p>
-                  </a:txBody>
-                  <a:tcPr/>
-                </a:tc>
-                <a:tc>
-                  <a:txBody>
-                    <a:bodyPr/>
-                    <a:lstStyle/>
-                    <a:p>
-                      <a:pPr>
-                        <a:defRPr sz="1000"/>
-                      </a:pPr>
-                      <a:r>
-                        <a:t>-64.2</a:t>
-                      </a:r>
-                    </a:p>
-                  </a:txBody>
-                  <a:tcPr/>
-                </a:tc>
-                <a:tc>
-                  <a:txBody>
-                    <a:bodyPr/>
-                    <a:lstStyle/>
-                    <a:p>
-                      <a:pPr>
-                        <a:defRPr sz="1000"/>
-                      </a:pPr>
-                      <a:r>
-                        <a:t>119.77848101265822</a:t>
-                      </a:r>
-                    </a:p>
-                  </a:txBody>
-                  <a:tcPr/>
-                </a:tc>
-                <a:tc>
-                  <a:txBody>
-                    <a:bodyPr/>
-                    <a:lstStyle/>
-                    <a:p>
-                      <a:pPr>
-                        <a:defRPr sz="1000"/>
-                      </a:pPr>
-                      <a:r>
-                        <a:t>119.77848101265822</a:t>
-                      </a:r>
-                    </a:p>
-                  </a:txBody>
-                  <a:tcPr/>
-                </a:tc>
-                <a:tc>
-                  <a:txBody>
-                    <a:bodyPr/>
-                    <a:lstStyle/>
-                    <a:p>
-                      <a:pPr>
-                        <a:defRPr sz="1000"/>
-                      </a:pPr>
-                      <a:r>
-                        <a:t>579.5</a:t>
-                      </a:r>
-                    </a:p>
-                  </a:txBody>
-                  <a:tcPr/>
-                </a:tc>
-                <a:tc>
-                  <a:txBody>
-                    <a:bodyPr/>
-                    <a:lstStyle/>
-                    <a:p>
-                      <a:pPr>
-                        <a:defRPr sz="1000"/>
-                      </a:pPr>
-                      <a:r>
-                        <a:t>130.3</a:t>
-                      </a:r>
-                    </a:p>
-                  </a:txBody>
-                  <a:tcPr/>
-                </a:tc>
-                <a:tc>
-                  <a:txBody>
-                    <a:bodyPr/>
-                    <a:lstStyle/>
-                    <a:p>
-                      <a:pPr>
-                        <a:defRPr sz="1000"/>
-                      </a:pPr>
-                      <a:r>
-                        <a:t>-449.2</a:t>
+              <a:tr h="548639">
+                <a:tc>
+                  <a:txBody>
+                    <a:bodyPr/>
+                    <a:lstStyle/>
+                    <a:p>
+                      <a:pPr>
+                        <a:defRPr sz="1000"/>
+                      </a:pPr>
+                      <a:r>
+                        <a:t>Continental Europe</a:t>
+                      </a:r>
+                    </a:p>
+                  </a:txBody>
+                  <a:tcPr/>
+                </a:tc>
+                <a:tc>
+                  <a:txBody>
+                    <a:bodyPr/>
+                    <a:lstStyle/>
+                    <a:p>
+                      <a:pPr>
+                        <a:defRPr sz="1000"/>
+                      </a:pPr>
+                      <a:r>
+                        <a:t>38</a:t>
+                      </a:r>
+                    </a:p>
+                  </a:txBody>
+                  <a:tcPr/>
+                </a:tc>
+                <a:tc>
+                  <a:txBody>
+                    <a:bodyPr/>
+                    <a:lstStyle/>
+                    <a:p>
+                      <a:pPr>
+                        <a:defRPr sz="1000"/>
+                      </a:pPr>
+                      <a:r>
+                        <a:t>11</a:t>
+                      </a:r>
+                    </a:p>
+                  </a:txBody>
+                  <a:tcPr/>
+                </a:tc>
+                <a:tc>
+                  <a:txBody>
+                    <a:bodyPr/>
+                    <a:lstStyle/>
+                    <a:p>
+                      <a:pPr>
+                        <a:defRPr sz="1000"/>
+                      </a:pPr>
+                      <a:r>
+                        <a:t>1117.0</a:t>
+                      </a:r>
+                    </a:p>
+                  </a:txBody>
+                  <a:tcPr/>
+                </a:tc>
+                <a:tc>
+                  <a:txBody>
+                    <a:bodyPr/>
+                    <a:lstStyle/>
+                    <a:p>
+                      <a:pPr>
+                        <a:defRPr sz="1000"/>
+                      </a:pPr>
+                      <a:r>
+                        <a:t>791.3</a:t>
+                      </a:r>
+                    </a:p>
+                  </a:txBody>
+                  <a:tcPr/>
+                </a:tc>
+                <a:tc>
+                  <a:txBody>
+                    <a:bodyPr/>
+                    <a:lstStyle/>
+                    <a:p>
+                      <a:pPr>
+                        <a:defRPr sz="1000"/>
+                      </a:pPr>
+                      <a:r>
+                        <a:t>-325.68763060327603</a:t>
+                      </a:r>
+                    </a:p>
+                  </a:txBody>
+                  <a:tcPr/>
+                </a:tc>
+                <a:tc>
+                  <a:txBody>
+                    <a:bodyPr/>
+                    <a:lstStyle/>
+                    <a:p>
+                      <a:pPr>
+                        <a:defRPr sz="1000"/>
+                      </a:pPr>
+                      <a:r>
+                        <a:t>-29.2</a:t>
+                      </a:r>
+                    </a:p>
+                  </a:txBody>
+                  <a:tcPr/>
+                </a:tc>
+                <a:tc>
+                  <a:txBody>
+                    <a:bodyPr/>
+                    <a:lstStyle/>
+                    <a:p>
+                      <a:pPr>
+                        <a:defRPr sz="1000"/>
+                      </a:pPr>
+                      <a:r>
+                        <a:t>129.0692124105012</a:t>
+                      </a:r>
+                    </a:p>
+                  </a:txBody>
+                  <a:tcPr/>
+                </a:tc>
+                <a:tc>
+                  <a:txBody>
+                    <a:bodyPr/>
+                    <a:lstStyle/>
+                    <a:p>
+                      <a:pPr>
+                        <a:defRPr sz="1000"/>
+                      </a:pPr>
+                      <a:r>
+                        <a:t>129.0692124105012</a:t>
+                      </a:r>
+                    </a:p>
+                  </a:txBody>
+                  <a:tcPr/>
+                </a:tc>
+                <a:tc>
+                  <a:txBody>
+                    <a:bodyPr/>
+                    <a:lstStyle/>
+                    <a:p>
+                      <a:pPr>
+                        <a:defRPr sz="1000"/>
+                      </a:pPr>
+                      <a:r>
+                        <a:t>987.9</a:t>
+                      </a:r>
+                    </a:p>
+                  </a:txBody>
+                  <a:tcPr/>
+                </a:tc>
+                <a:tc>
+                  <a:txBody>
+                    <a:bodyPr/>
+                    <a:lstStyle/>
+                    <a:p>
+                      <a:pPr>
+                        <a:defRPr sz="1000"/>
+                      </a:pPr>
+                      <a:r>
+                        <a:t>662.2</a:t>
+                      </a:r>
+                    </a:p>
+                  </a:txBody>
+                  <a:tcPr/>
+                </a:tc>
+                <a:tc>
+                  <a:txBody>
+                    <a:bodyPr/>
+                    <a:lstStyle/>
+                    <a:p>
+                      <a:pPr>
+                        <a:defRPr sz="1000"/>
+                      </a:pPr>
+                      <a:r>
+                        <a:t>-325.7</a:t>
                       </a:r>
                     </a:p>
                   </a:txBody>
                   <a:tcPr/>
                 </a:tc>
               </a:tr>
-              <a:tr h="548640">
-                <a:tc>
-                  <a:txBody>
-                    <a:bodyPr/>
-                    <a:lstStyle/>
-                    <a:p>
-                      <a:pPr>
-                        <a:defRPr sz="1000"/>
-                      </a:pPr>
-                      <a:r>
-                        <a:t>Continental Europe</a:t>
-                      </a:r>
-                    </a:p>
-                  </a:txBody>
-                  <a:tcPr/>
-                </a:tc>
-                <a:tc>
-                  <a:txBody>
-                    <a:bodyPr/>
-                    <a:lstStyle/>
-                    <a:p>
-                      <a:pPr>
-                        <a:defRPr sz="1000"/>
-                      </a:pPr>
-                      <a:r>
-                        <a:t>1117.0</a:t>
-                      </a:r>
-                    </a:p>
-                  </a:txBody>
-                  <a:tcPr/>
-                </a:tc>
-                <a:tc>
-                  <a:txBody>
-                    <a:bodyPr/>
-                    <a:lstStyle/>
-                    <a:p>
-                      <a:pPr>
-                        <a:defRPr sz="1000"/>
-                      </a:pPr>
-                      <a:r>
-                        <a:t>791.3</a:t>
-                      </a:r>
-                    </a:p>
-                  </a:txBody>
-                  <a:tcPr/>
-                </a:tc>
-                <a:tc>
-                  <a:txBody>
-                    <a:bodyPr/>
-                    <a:lstStyle/>
-                    <a:p>
-                      <a:pPr>
-                        <a:defRPr sz="1000"/>
-                      </a:pPr>
-                      <a:r>
-                        <a:t>-325.68763060327603</a:t>
-                      </a:r>
-                    </a:p>
-                  </a:txBody>
-                  <a:tcPr/>
-                </a:tc>
-                <a:tc>
-                  <a:txBody>
-                    <a:bodyPr/>
-                    <a:lstStyle/>
-                    <a:p>
-                      <a:pPr>
-                        <a:defRPr sz="1000"/>
-                      </a:pPr>
-                      <a:r>
-                        <a:t>-29.2</a:t>
-                      </a:r>
-                    </a:p>
-                  </a:txBody>
-                  <a:tcPr/>
-                </a:tc>
-                <a:tc>
-                  <a:txBody>
-                    <a:bodyPr/>
-                    <a:lstStyle/>
-                    <a:p>
-                      <a:pPr>
-                        <a:defRPr sz="1000"/>
-                      </a:pPr>
-                      <a:r>
-                        <a:t>129.0692124105012</a:t>
-                      </a:r>
-                    </a:p>
-                  </a:txBody>
-                  <a:tcPr/>
-                </a:tc>
-                <a:tc>
-                  <a:txBody>
-                    <a:bodyPr/>
-                    <a:lstStyle/>
-                    <a:p>
-                      <a:pPr>
-                        <a:defRPr sz="1000"/>
-                      </a:pPr>
-                      <a:r>
-                        <a:t>129.0692124105012</a:t>
-                      </a:r>
-                    </a:p>
-                  </a:txBody>
-                  <a:tcPr/>
-                </a:tc>
-                <a:tc>
-                  <a:txBody>
-                    <a:bodyPr/>
-                    <a:lstStyle/>
-                    <a:p>
-                      <a:pPr>
-                        <a:defRPr sz="1000"/>
-                      </a:pPr>
-                      <a:r>
-                        <a:t>987.9</a:t>
-                      </a:r>
-                    </a:p>
-                  </a:txBody>
-                  <a:tcPr/>
-                </a:tc>
-                <a:tc>
-                  <a:txBody>
-                    <a:bodyPr/>
-                    <a:lstStyle/>
-                    <a:p>
-                      <a:pPr>
-                        <a:defRPr sz="1000"/>
-                      </a:pPr>
-                      <a:r>
-                        <a:t>662.2</a:t>
-                      </a:r>
-                    </a:p>
-                  </a:txBody>
-                  <a:tcPr/>
-                </a:tc>
-                <a:tc>
-                  <a:txBody>
-                    <a:bodyPr/>
-                    <a:lstStyle/>
-                    <a:p>
-                      <a:pPr>
-                        <a:defRPr sz="1000"/>
-                      </a:pPr>
-                      <a:r>
-                        <a:t>-325.7</a:t>
-                      </a:r>
-                    </a:p>
-                  </a:txBody>
-                  <a:tcPr/>
-                </a:tc>
-              </a:tr>
-              <a:tr h="548640">
-                <a:tc>
-                  <a:txBody>
-                    <a:bodyPr/>
-                    <a:lstStyle/>
-                    <a:p>
-                      <a:pPr>
-                        <a:defRPr sz="1000"/>
-                      </a:pPr>
-                      <a:r>
-                        <a:t>Hindu</a:t>
-                      </a:r>
-                    </a:p>
-                  </a:txBody>
-                  <a:tcPr/>
-                </a:tc>
-                <a:tc>
-                  <a:txBody>
-                    <a:bodyPr/>
-                    <a:lstStyle/>
-                    <a:p>
-                      <a:pPr>
-                        <a:defRPr sz="1000"/>
-                      </a:pPr>
-                      <a:r>
-                        <a:t>902.2</a:t>
-                      </a:r>
-                    </a:p>
-                  </a:txBody>
-                  <a:tcPr/>
-                </a:tc>
-                <a:tc>
-                  <a:txBody>
-                    <a:bodyPr/>
-                    <a:lstStyle/>
-                    <a:p>
-                      <a:pPr>
-                        <a:defRPr sz="1000"/>
-                      </a:pPr>
-                      <a:r>
-                        <a:t>608.4</a:t>
-                      </a:r>
-                    </a:p>
-                  </a:txBody>
-                  <a:tcPr/>
-                </a:tc>
-                <a:tc>
-                  <a:txBody>
-                    <a:bodyPr/>
-                    <a:lstStyle/>
-                    <a:p>
-                      <a:pPr>
-                        <a:defRPr sz="1000"/>
-                      </a:pPr>
-                      <a:r>
-                        <a:t>-293.7374997320797</a:t>
-                      </a:r>
-                    </a:p>
-                  </a:txBody>
-                  <a:tcPr/>
-                </a:tc>
-                <a:tc>
-                  <a:txBody>
-                    <a:bodyPr/>
-                    <a:lstStyle/>
-                    <a:p>
-                      <a:pPr>
-                        <a:defRPr sz="1000"/>
-                      </a:pPr>
-                      <a:r>
-                        <a:t>-32.6</a:t>
-                      </a:r>
-                    </a:p>
-                  </a:txBody>
-                  <a:tcPr/>
-                </a:tc>
-                <a:tc>
-                  <a:txBody>
-                    <a:bodyPr/>
-                    <a:lstStyle/>
-                    <a:p>
-                      <a:pPr>
-                        <a:defRPr sz="1000"/>
-                      </a:pPr>
-                      <a:r>
-                        <a:t>66.04072398190046</a:t>
-                      </a:r>
-                    </a:p>
-                  </a:txBody>
-                  <a:tcPr/>
-                </a:tc>
-                <a:tc>
-                  <a:txBody>
-                    <a:bodyPr/>
-                    <a:lstStyle/>
-                    <a:p>
-                      <a:pPr>
-                        <a:defRPr sz="1000"/>
-                      </a:pPr>
-                      <a:r>
-                        <a:t>66.04072398190046</a:t>
-                      </a:r>
-                    </a:p>
-                  </a:txBody>
-                  <a:tcPr/>
-                </a:tc>
-                <a:tc>
-                  <a:txBody>
-                    <a:bodyPr/>
-                    <a:lstStyle/>
-                    <a:p>
-                      <a:pPr>
-                        <a:defRPr sz="1000"/>
-                      </a:pPr>
-                      <a:r>
-                        <a:t>836.1</a:t>
-                      </a:r>
-                    </a:p>
-                  </a:txBody>
-                  <a:tcPr/>
-                </a:tc>
-                <a:tc>
-                  <a:txBody>
-                    <a:bodyPr/>
-                    <a:lstStyle/>
-                    <a:p>
-                      <a:pPr>
-                        <a:defRPr sz="1000"/>
-                      </a:pPr>
-                      <a:r>
-                        <a:t>542.4</a:t>
-                      </a:r>
-                    </a:p>
-                  </a:txBody>
-                  <a:tcPr/>
-                </a:tc>
-                <a:tc>
-                  <a:txBody>
-                    <a:bodyPr/>
-                    <a:lstStyle/>
-                    <a:p>
-                      <a:pPr>
-                        <a:defRPr sz="1000"/>
-                      </a:pPr>
-                      <a:r>
-                        <a:t>-293.7</a:t>
-                      </a:r>
-                    </a:p>
-                  </a:txBody>
-                  <a:tcPr/>
-                </a:tc>
-              </a:tr>
-              <a:tr h="548640">
-                <a:tc>
-                  <a:txBody>
-                    <a:bodyPr/>
-                    <a:lstStyle/>
-                    <a:p>
-                      <a:pPr>
-                        <a:defRPr sz="1000"/>
-                      </a:pPr>
-                      <a:r>
-                        <a:t>Islamic</a:t>
-                      </a:r>
-                    </a:p>
-                  </a:txBody>
-                  <a:tcPr/>
-                </a:tc>
-                <a:tc>
-                  <a:txBody>
-                    <a:bodyPr/>
-                    <a:lstStyle/>
-                    <a:p>
-                      <a:pPr>
-                        <a:defRPr sz="1000"/>
-                      </a:pPr>
-                      <a:r>
-                        <a:t>185.5</a:t>
-                      </a:r>
-                    </a:p>
-                  </a:txBody>
-                  <a:tcPr/>
-                </a:tc>
-                <a:tc>
-                  <a:txBody>
-                    <a:bodyPr/>
-                    <a:lstStyle/>
-                    <a:p>
-                      <a:pPr>
-                        <a:defRPr sz="1000"/>
-                      </a:pPr>
-                      <a:r>
-                        <a:t>1106.5</a:t>
-                      </a:r>
-                    </a:p>
-                  </a:txBody>
-                  <a:tcPr/>
-                </a:tc>
-                <a:tc>
-                  <a:txBody>
-                    <a:bodyPr/>
-                    <a:lstStyle/>
-                    <a:p>
-                      <a:pPr>
-                        <a:defRPr sz="1000"/>
-                      </a:pPr>
-                      <a:r>
-                        <a:t>920.941045001848</a:t>
-                      </a:r>
-                    </a:p>
-                  </a:txBody>
-                  <a:tcPr/>
-                </a:tc>
-                <a:tc>
-                  <a:txBody>
-                    <a:bodyPr/>
-                    <a:lstStyle/>
-                    <a:p>
-                      <a:pPr>
-                        <a:defRPr sz="1000"/>
-                      </a:pPr>
-                      <a:r>
-                        <a:t>496.4</a:t>
-                      </a:r>
-                    </a:p>
-                  </a:txBody>
-                  <a:tcPr/>
-                </a:tc>
-                <a:tc>
-                  <a:txBody>
-                    <a:bodyPr/>
-                    <a:lstStyle/>
-                    <a:p>
-                      <a:pPr>
-                        <a:defRPr sz="1000"/>
-                      </a:pPr>
-                      <a:r>
-                        <a:t>126.52032520325204</a:t>
-                      </a:r>
-                    </a:p>
-                  </a:txBody>
-                  <a:tcPr/>
-                </a:tc>
-                <a:tc>
-                  <a:txBody>
-                    <a:bodyPr/>
-                    <a:lstStyle/>
-                    <a:p>
-                      <a:pPr>
-                        <a:defRPr sz="1000"/>
-                      </a:pPr>
-                      <a:r>
-                        <a:t>126.52032520325204</a:t>
-                      </a:r>
-                    </a:p>
-                  </a:txBody>
-                  <a:tcPr/>
-                </a:tc>
-                <a:tc>
-                  <a:txBody>
-                    <a:bodyPr/>
-                    <a:lstStyle/>
-                    <a:p>
-                      <a:pPr>
-                        <a:defRPr sz="1000"/>
-                      </a:pPr>
-                      <a:r>
-                        <a:t>59.0</a:t>
-                      </a:r>
-                    </a:p>
-                  </a:txBody>
-                  <a:tcPr/>
-                </a:tc>
-                <a:tc>
-                  <a:txBody>
-                    <a:bodyPr/>
-                    <a:lstStyle/>
-                    <a:p>
-                      <a:pPr>
-                        <a:defRPr sz="1000"/>
-                      </a:pPr>
-                      <a:r>
-                        <a:t>979.9</a:t>
-                      </a:r>
-                    </a:p>
-                  </a:txBody>
-                  <a:tcPr/>
-                </a:tc>
-                <a:tc>
-                  <a:txBody>
-                    <a:bodyPr/>
-                    <a:lstStyle/>
-                    <a:p>
-                      <a:pPr>
-                        <a:defRPr sz="1000"/>
-                      </a:pPr>
-                      <a:r>
-                        <a:t>920.9</a:t>
-                      </a:r>
-                    </a:p>
-                  </a:txBody>
-                  <a:tcPr/>
-                </a:tc>
-              </a:tr>
-              <a:tr h="548640">
-                <a:tc>
-                  <a:txBody>
-                    <a:bodyPr/>
-                    <a:lstStyle/>
-                    <a:p>
-                      <a:pPr>
-                        <a:defRPr sz="1000"/>
-                      </a:pPr>
-                      <a:r>
-                        <a:t>Japanese</a:t>
-                      </a:r>
-                    </a:p>
-                  </a:txBody>
-                  <a:tcPr/>
-                </a:tc>
-                <a:tc>
-                  <a:txBody>
-                    <a:bodyPr/>
-                    <a:lstStyle/>
-                    <a:p>
-                      <a:pPr>
-                        <a:defRPr sz="1000"/>
-                      </a:pPr>
-                      <a:r>
-                        <a:t>184.3</a:t>
-                      </a:r>
-                    </a:p>
-                  </a:txBody>
-                  <a:tcPr/>
-                </a:tc>
-                <a:tc>
-                  <a:txBody>
-                    <a:bodyPr/>
-                    <a:lstStyle/>
-                    <a:p>
-                      <a:pPr>
-                        <a:defRPr sz="1000"/>
-                      </a:pPr>
-                      <a:r>
-                        <a:t>235.3</a:t>
-                      </a:r>
-                    </a:p>
-                  </a:txBody>
-                  <a:tcPr/>
-                </a:tc>
-                <a:tc>
-                  <a:txBody>
-                    <a:bodyPr/>
-                    <a:lstStyle/>
-                    <a:p>
-                      <a:pPr>
-                        <a:defRPr sz="1000"/>
-                      </a:pPr>
-                      <a:r>
-                        <a:t>51.038535768981774</a:t>
-                      </a:r>
-                    </a:p>
-                  </a:txBody>
-                  <a:tcPr/>
-                </a:tc>
-                <a:tc>
-                  <a:txBody>
-                    <a:bodyPr/>
-                    <a:lstStyle/>
-                    <a:p>
-                      <a:pPr>
-                        <a:defRPr sz="1000"/>
-                      </a:pPr>
-                      <a:r>
-                        <a:t>27.7</a:t>
-                      </a:r>
-                    </a:p>
-                  </a:txBody>
-                  <a:tcPr/>
-                </a:tc>
-                <a:tc>
-                  <a:txBody>
-                    <a:bodyPr/>
-                    <a:lstStyle/>
-                    <a:p>
-                      <a:pPr>
-                        <a:defRPr sz="1000"/>
-                      </a:pPr>
-                      <a:r>
-                        <a:t>50.47533632286996</a:t>
-                      </a:r>
-                    </a:p>
-                  </a:txBody>
-                  <a:tcPr/>
-                </a:tc>
-                <a:tc>
-                  <a:txBody>
-                    <a:bodyPr/>
-                    <a:lstStyle/>
-                    <a:p>
-                      <a:pPr>
-                        <a:defRPr sz="1000"/>
-                      </a:pPr>
-                      <a:r>
-                        <a:t>50.47533632286996</a:t>
-                      </a:r>
-                    </a:p>
-                  </a:txBody>
-                  <a:tcPr/>
-                </a:tc>
-                <a:tc>
-                  <a:txBody>
-                    <a:bodyPr/>
-                    <a:lstStyle/>
-                    <a:p>
-                      <a:pPr>
-                        <a:defRPr sz="1000"/>
-                      </a:pPr>
-                      <a:r>
-                        <a:t>133.8</a:t>
-                      </a:r>
-                    </a:p>
-                  </a:txBody>
-                  <a:tcPr/>
-                </a:tc>
-                <a:tc>
-                  <a:txBody>
-                    <a:bodyPr/>
-                    <a:lstStyle/>
-                    <a:p>
-                      <a:pPr>
-                        <a:defRPr sz="1000"/>
-                      </a:pPr>
-                      <a:r>
-                        <a:t>184.8</a:t>
-                      </a:r>
-                    </a:p>
-                  </a:txBody>
-                  <a:tcPr/>
-                </a:tc>
-                <a:tc>
-                  <a:txBody>
-                    <a:bodyPr/>
-                    <a:lstStyle/>
-                    <a:p>
-                      <a:pPr>
-                        <a:defRPr sz="1000"/>
-                      </a:pPr>
-                      <a:r>
-                        <a:t>51.0</a:t>
-                      </a:r>
-                    </a:p>
-                  </a:txBody>
-                  <a:tcPr/>
-                </a:tc>
-              </a:tr>
-              <a:tr h="548640">
-                <a:tc>
-                  <a:txBody>
-                    <a:bodyPr/>
-                    <a:lstStyle/>
-                    <a:p>
-                      <a:pPr>
-                        <a:defRPr sz="1000"/>
-                      </a:pPr>
-                      <a:r>
-                        <a:t>Other Civilizations</a:t>
-                      </a:r>
-                    </a:p>
-                  </a:txBody>
-                  <a:tcPr/>
-                </a:tc>
-                <a:tc>
-                  <a:txBody>
-                    <a:bodyPr/>
-                    <a:lstStyle/>
-                    <a:p>
-                      <a:pPr>
-                        <a:defRPr sz="1000"/>
-                      </a:pPr>
-                      <a:r>
-                        <a:t>164.4</a:t>
-                      </a:r>
-                    </a:p>
-                  </a:txBody>
-                  <a:tcPr/>
-                </a:tc>
-                <a:tc>
-                  <a:txBody>
-                    <a:bodyPr/>
-                    <a:lstStyle/>
-                    <a:p>
-                      <a:pPr>
-                        <a:defRPr sz="1000"/>
-                      </a:pPr>
-                      <a:r>
-                        <a:t>673.8</a:t>
-                      </a:r>
-                    </a:p>
-                  </a:txBody>
-                  <a:tcPr/>
-                </a:tc>
-                <a:tc>
-                  <a:txBody>
-                    <a:bodyPr/>
-                    <a:lstStyle/>
-                    <a:p>
-                      <a:pPr>
-                        <a:defRPr sz="1000"/>
-                      </a:pPr>
-                      <a:r>
-                        <a:t>509.3498486089304</a:t>
-                      </a:r>
-                    </a:p>
-                  </a:txBody>
-                  <a:tcPr/>
-                </a:tc>
-                <a:tc>
-                  <a:txBody>
-                    <a:bodyPr/>
-                    <a:lstStyle/>
-                    <a:p>
-                      <a:pPr>
-                        <a:defRPr sz="1000"/>
-                      </a:pPr>
-                      <a:r>
-                        <a:t>309.8</a:t>
-                      </a:r>
-                    </a:p>
-                  </a:txBody>
-                  <a:tcPr/>
-                </a:tc>
-                <a:tc>
-                  <a:txBody>
-                    <a:bodyPr/>
-                    <a:lstStyle/>
-                    <a:p>
-                      <a:pPr>
-                        <a:defRPr sz="1000"/>
-                      </a:pPr>
-                      <a:r>
-                        <a:t>104.59615384615384</a:t>
-                      </a:r>
-                    </a:p>
-                  </a:txBody>
-                  <a:tcPr/>
-                </a:tc>
-                <a:tc>
-                  <a:txBody>
-                    <a:bodyPr/>
-                    <a:lstStyle/>
-                    <a:p>
-                      <a:pPr>
-                        <a:defRPr sz="1000"/>
-                      </a:pPr>
-                      <a:r>
-                        <a:t>104.59615384615384</a:t>
-                      </a:r>
-                    </a:p>
-                  </a:txBody>
-                  <a:tcPr/>
-                </a:tc>
-                <a:tc>
-                  <a:txBody>
-                    <a:bodyPr/>
-                    <a:lstStyle/>
-                    <a:p>
-                      <a:pPr>
-                        <a:defRPr sz="1000"/>
-                      </a:pPr>
-                      <a:r>
-                        <a:t>59.8</a:t>
-                      </a:r>
-                    </a:p>
-                  </a:txBody>
-                  <a:tcPr/>
-                </a:tc>
-                <a:tc>
-                  <a:txBody>
-                    <a:bodyPr/>
-                    <a:lstStyle/>
-                    <a:p>
-                      <a:pPr>
-                        <a:defRPr sz="1000"/>
-                      </a:pPr>
-                      <a:r>
-                        <a:t>569.2</a:t>
-                      </a:r>
-                    </a:p>
-                  </a:txBody>
-                  <a:tcPr/>
-                </a:tc>
-                <a:tc>
-                  <a:txBody>
-                    <a:bodyPr/>
-                    <a:lstStyle/>
-                    <a:p>
-                      <a:pPr>
-                        <a:defRPr sz="1000"/>
-                      </a:pPr>
-                      <a:r>
-                        <a:t>509.3</a:t>
-                      </a:r>
-                    </a:p>
-                  </a:txBody>
-                  <a:tcPr/>
-                </a:tc>
-              </a:tr>
-              <a:tr h="548640">
-                <a:tc>
-                  <a:txBody>
-                    <a:bodyPr/>
-                    <a:lstStyle/>
-                    <a:p>
-                      <a:pPr>
-                        <a:defRPr sz="1000"/>
-                      </a:pPr>
-                      <a:r>
-                        <a:t>Other Western</a:t>
-                      </a:r>
-                    </a:p>
-                  </a:txBody>
-                  <a:tcPr/>
-                </a:tc>
-                <a:tc>
-                  <a:txBody>
-                    <a:bodyPr/>
-                    <a:lstStyle/>
-                    <a:p>
-                      <a:pPr>
-                        <a:defRPr sz="1000"/>
-                      </a:pPr>
-                      <a:r>
-                        <a:t>304.0</a:t>
-                      </a:r>
-                    </a:p>
-                  </a:txBody>
-                  <a:tcPr/>
-                </a:tc>
-                <a:tc>
-                  <a:txBody>
-                    <a:bodyPr/>
-                    <a:lstStyle/>
-                    <a:p>
-                      <a:pPr>
-                        <a:defRPr sz="1000"/>
-                      </a:pPr>
-                      <a:r>
-                        <a:t>239.0</a:t>
-                      </a:r>
-                    </a:p>
-                  </a:txBody>
-                  <a:tcPr/>
-                </a:tc>
-                <a:tc>
-                  <a:txBody>
-                    <a:bodyPr/>
-                    <a:lstStyle/>
-                    <a:p>
-                      <a:pPr>
-                        <a:defRPr sz="1000"/>
-                      </a:pPr>
-                      <a:r>
-                        <a:t>-65.04525966570378</a:t>
-                      </a:r>
-                    </a:p>
-                  </a:txBody>
-                  <a:tcPr/>
-                </a:tc>
-                <a:tc>
-                  <a:txBody>
-                    <a:bodyPr/>
-                    <a:lstStyle/>
-                    <a:p>
-                      <a:pPr>
-                        <a:defRPr sz="1000"/>
-                      </a:pPr>
-                      <a:r>
-                        <a:t>-21.4</a:t>
-                      </a:r>
-                    </a:p>
-                  </a:txBody>
-                  <a:tcPr/>
-                </a:tc>
-                <a:tc>
-                  <a:txBody>
-                    <a:bodyPr/>
-                    <a:lstStyle/>
-                    <a:p>
-                      <a:pPr>
-                        <a:defRPr sz="1000"/>
-                      </a:pPr>
-                      <a:r>
-                        <a:t>57.16981132075472</a:t>
-                      </a:r>
-                    </a:p>
-                  </a:txBody>
-                  <a:tcPr/>
-                </a:tc>
-                <a:tc>
-                  <a:txBody>
-                    <a:bodyPr/>
-                    <a:lstStyle/>
-                    <a:p>
-                      <a:pPr>
-                        <a:defRPr sz="1000"/>
-                      </a:pPr>
-                      <a:r>
-                        <a:t>57.16981132075472</a:t>
-                      </a:r>
-                    </a:p>
-                  </a:txBody>
-                  <a:tcPr/>
-                </a:tc>
-                <a:tc>
-                  <a:txBody>
-                    <a:bodyPr/>
-                    <a:lstStyle/>
-                    <a:p>
-                      <a:pPr>
-                        <a:defRPr sz="1000"/>
-                      </a:pPr>
-                      <a:r>
-                        <a:t>246.9</a:t>
-                      </a:r>
-                    </a:p>
-                  </a:txBody>
-                  <a:tcPr/>
-                </a:tc>
-                <a:tc>
-                  <a:txBody>
-                    <a:bodyPr/>
-                    <a:lstStyle/>
-                    <a:p>
-                      <a:pPr>
-                        <a:defRPr sz="1000"/>
-                      </a:pPr>
-                      <a:r>
-                        <a:t>181.8</a:t>
-                      </a:r>
-                    </a:p>
-                  </a:txBody>
-                  <a:tcPr/>
-                </a:tc>
-                <a:tc>
-                  <a:txBody>
-                    <a:bodyPr/>
-                    <a:lstStyle/>
-                    <a:p>
-                      <a:pPr>
-                        <a:defRPr sz="1000"/>
-                      </a:pPr>
-                      <a:r>
-                        <a:t>-65.0</a:t>
-                      </a:r>
-                    </a:p>
-                  </a:txBody>
-                  <a:tcPr/>
-                </a:tc>
-              </a:tr>
-              <a:tr h="548640">
+              <a:tr h="548641">
                 <a:tc>
                   <a:txBody>
                     <a:bodyPr/>
@@ -5165,6 +4309,36 @@
                         <a:defRPr sz="1000"/>
                       </a:pPr>
                       <a:r>
+                        <a:t>29</a:t>
+                      </a:r>
+                    </a:p>
+                  </a:txBody>
+                  <a:tcPr/>
+                </a:tc>
+                <a:tc>
+                  <a:txBody>
+                    <a:bodyPr/>
+                    <a:lstStyle/>
+                    <a:p>
+                      <a:pPr>
+                        <a:defRPr sz="1000"/>
+                      </a:pPr>
+                      <a:r>
+                        <a:t>12</a:t>
+                      </a:r>
+                    </a:p>
+                  </a:txBody>
+                  <a:tcPr/>
+                </a:tc>
+                <a:tc>
+                  <a:txBody>
+                    <a:bodyPr/>
+                    <a:lstStyle/>
+                    <a:p>
+                      <a:pPr>
+                        <a:defRPr sz="1000"/>
+                      </a:pPr>
+                      <a:r>
                         <a:t>1392.6</a:t>
                       </a:r>
                     </a:p>
@@ -5286,158 +4460,6 @@
                       </a:pPr>
                       <a:r>
                         <a:t>-456.2</a:t>
-                      </a:r>
-                    </a:p>
-                  </a:txBody>
-                  <a:tcPr/>
-                </a:tc>
-              </a:tr>
-              <a:tr h="548640">
-                <a:tc>
-                  <a:txBody>
-                    <a:bodyPr/>
-                    <a:lstStyle/>
-                    <a:p>
-                      <a:pPr>
-                        <a:defRPr sz="1000"/>
-                      </a:pPr>
-                      <a:r>
-                        <a:t>United States</a:t>
-                      </a:r>
-                    </a:p>
-                  </a:txBody>
-                  <a:tcPr/>
-                </a:tc>
-                <a:tc>
-                  <a:txBody>
-                    <a:bodyPr/>
-                    <a:lstStyle/>
-                    <a:p>
-                      <a:pPr>
-                        <a:defRPr sz="1000"/>
-                      </a:pPr>
-                      <a:r>
-                        <a:t>770.7</a:t>
-                      </a:r>
-                    </a:p>
-                  </a:txBody>
-                  <a:tcPr/>
-                </a:tc>
-                <a:tc>
-                  <a:txBody>
-                    <a:bodyPr/>
-                    <a:lstStyle/>
-                    <a:p>
-                      <a:pPr>
-                        <a:defRPr sz="1000"/>
-                      </a:pPr>
-                      <a:r>
-                        <a:t>547.3</a:t>
-                      </a:r>
-                    </a:p>
-                  </a:txBody>
-                  <a:tcPr/>
-                </a:tc>
-                <a:tc>
-                  <a:txBody>
-                    <a:bodyPr/>
-                    <a:lstStyle/>
-                    <a:p>
-                      <a:pPr>
-                        <a:defRPr sz="1000"/>
-                      </a:pPr>
-                      <a:r>
-                        <a:t>-223.31831440011604</a:t>
-                      </a:r>
-                    </a:p>
-                  </a:txBody>
-                  <a:tcPr/>
-                </a:tc>
-                <a:tc>
-                  <a:txBody>
-                    <a:bodyPr/>
-                    <a:lstStyle/>
-                    <a:p>
-                      <a:pPr>
-                        <a:defRPr sz="1000"/>
-                      </a:pPr>
-                      <a:r>
-                        <a:t>-29.0</a:t>
-                      </a:r>
-                    </a:p>
-                  </a:txBody>
-                  <a:tcPr/>
-                </a:tc>
-                <a:tc>
-                  <a:txBody>
-                    <a:bodyPr/>
-                    <a:lstStyle/>
-                    <a:p>
-                      <a:pPr>
-                        <a:defRPr sz="1000"/>
-                      </a:pPr>
-                      <a:r>
-                        <a:t>132.49329758713137</a:t>
-                      </a:r>
-                    </a:p>
-                  </a:txBody>
-                  <a:tcPr/>
-                </a:tc>
-                <a:tc>
-                  <a:txBody>
-                    <a:bodyPr/>
-                    <a:lstStyle/>
-                    <a:p>
-                      <a:pPr>
-                        <a:defRPr sz="1000"/>
-                      </a:pPr>
-                      <a:r>
-                        <a:t>132.49329758713137</a:t>
-                      </a:r>
-                    </a:p>
-                  </a:txBody>
-                  <a:tcPr/>
-                </a:tc>
-                <a:tc>
-                  <a:txBody>
-                    <a:bodyPr/>
-                    <a:lstStyle/>
-                    <a:p>
-                      <a:pPr>
-                        <a:defRPr sz="1000"/>
-                      </a:pPr>
-                      <a:r>
-                        <a:t>638.2</a:t>
-                      </a:r>
-                    </a:p>
-                  </a:txBody>
-                  <a:tcPr/>
-                </a:tc>
-                <a:tc>
-                  <a:txBody>
-                    <a:bodyPr/>
-                    <a:lstStyle/>
-                    <a:p>
-                      <a:pPr>
-                        <a:defRPr sz="1000"/>
-                      </a:pPr>
-                      <a:r>
-                        <a:t>414.8</a:t>
-                      </a:r>
-                    </a:p>
-                  </a:txBody>
-                  <a:tcPr/>
-                </a:tc>
-                <a:tc>
-                  <a:txBody>
-                    <a:bodyPr/>
-                    <a:lstStyle/>
-                    <a:p>
-                      <a:pPr>
-                        <a:defRPr sz="1000"/>
-                      </a:pPr>
-                      <a:r>
-                        <a:t>-223.3</a:t>
                       </a:r>
                     </a:p>
                   </a:txBody>

</xml_diff>

<commit_message>
Integrate annual transition-rate projection into full article manuscript
- Adds annual Methods (4.10/4.11), Results (5.6-5.8), Discussion (6.4-6.7) and updated Conclusion to the Research Policy full article. - Reuses scripts/annual_rates_projection_report.py plotting functions and results/annual/*.csv values with no hard-coded figures. - Regenerates docx, md and pptx with Figures 1-7 and Tables 1-12 cited inline. - Runs reproduce.sh end-to-end.

Co-Authored-By: Tatsuki Onishi <bougtoir@gmail.com>
</commit_message>
<xml_diff>
--- a/researcher_mobility_ode/docs/manuscript_full_article_figures.pptx
+++ b/researcher_mobility_ode/docs/manuscript_full_article_figures.pptx
@@ -18,6 +18,13 @@
     <p:sldId id="266" r:id="rId17"/>
     <p:sldId id="267" r:id="rId18"/>
     <p:sldId id="268" r:id="rId19"/>
+    <p:sldId id="269" r:id="rId20"/>
+    <p:sldId id="270" r:id="rId21"/>
+    <p:sldId id="271" r:id="rId22"/>
+    <p:sldId id="272" r:id="rId23"/>
+    <p:sldId id="273" r:id="rId24"/>
+    <p:sldId id="274" r:id="rId25"/>
+    <p:sldId id="275" r:id="rId26"/>
   </p:sldIdLst>
   <p:sldSz cx="12191695" cy="6858000" type="screen4x3"/>
   <p:notesSz cx="6858000" cy="9144000"/>
@@ -6340,6 +6347,2712 @@
 </p:sld>
 </file>
 
+<file path=ppt/slides/slide14.xml><?xml version="1.0" encoding="utf-8"?>
+<p:sld xmlns:a="http://schemas.openxmlformats.org/drawingml/2006/main" xmlns:p="http://schemas.openxmlformats.org/presentationml/2006/main" xmlns:r="http://schemas.openxmlformats.org/officeDocument/2006/relationships">
+  <p:cSld>
+    <p:spTree>
+      <p:nvGrpSpPr>
+        <p:cNvPr id="1" name=""/>
+        <p:cNvGrpSpPr/>
+        <p:nvPr/>
+      </p:nvGrpSpPr>
+      <p:grpSpPr/>
+      <p:sp>
+        <p:nvSpPr>
+          <p:cNvPr id="2" name="Title 1"/>
+          <p:cNvSpPr>
+            <a:spLocks noGrp="1"/>
+          </p:cNvSpPr>
+          <p:nvPr>
+            <p:ph type="title"/>
+          </p:nvPr>
+        </p:nvSpPr>
+        <p:spPr/>
+        <p:txBody>
+          <a:bodyPr/>
+          <a:lstStyle/>
+          <a:p>
+            <a:r>
+              <a:t>Figure 5: Annual observed and projected transition rates</a:t>
+            </a:r>
+          </a:p>
+        </p:txBody>
+      </p:sp>
+      <p:sp>
+        <p:nvSpPr>
+          <p:cNvPr id="3" name="Content Placeholder 2"/>
+          <p:cNvSpPr>
+            <a:spLocks noGrp="1"/>
+          </p:cNvSpPr>
+          <p:nvPr>
+            <p:ph idx="1" sz="half"/>
+          </p:nvPr>
+        </p:nvSpPr>
+        <p:spPr/>
+        <p:txBody>
+          <a:bodyPr/>
+          <a:lstStyle/>
+          <a:p/>
+        </p:txBody>
+      </p:sp>
+      <p:sp>
+        <p:nvSpPr>
+          <p:cNvPr id="4" name="Content Placeholder 3"/>
+          <p:cNvSpPr>
+            <a:spLocks noGrp="1"/>
+          </p:cNvSpPr>
+          <p:nvPr>
+            <p:ph idx="2" sz="half"/>
+          </p:nvPr>
+        </p:nvSpPr>
+        <p:spPr/>
+        <p:txBody>
+          <a:bodyPr/>
+          <a:lstStyle/>
+          <a:p/>
+        </p:txBody>
+      </p:sp>
+      <p:pic>
+        <p:nvPicPr>
+          <p:cNvPr id="5" name="Picture 4" descr="annual_rates_by_group.png"/>
+          <p:cNvPicPr>
+            <a:picLocks noChangeAspect="1"/>
+          </p:cNvPicPr>
+          <p:nvPr/>
+        </p:nvPicPr>
+        <p:blipFill>
+          <a:blip r:embed="rId2"/>
+          <a:stretch>
+            <a:fillRect/>
+          </a:stretch>
+        </p:blipFill>
+        <p:spPr>
+          <a:xfrm>
+            <a:off x="1371600" y="1097280"/>
+            <a:ext cx="9144000" cy="7919049"/>
+          </a:xfrm>
+          <a:prstGeom prst="rect">
+            <a:avLst/>
+          </a:prstGeom>
+        </p:spPr>
+      </p:pic>
+      <p:sp>
+        <p:nvSpPr>
+          <p:cNvPr id="6" name="TextBox 5"/>
+          <p:cNvSpPr txBox="1"/>
+          <p:nvPr/>
+        </p:nvSpPr>
+        <p:spPr>
+          <a:xfrm>
+            <a:off x="1371600" y="5486400"/>
+            <a:ext cx="9144000" cy="731520"/>
+          </a:xfrm>
+          <a:prstGeom prst="rect">
+            <a:avLst/>
+          </a:prstGeom>
+          <a:noFill/>
+        </p:spPr>
+        <p:txBody>
+          <a:bodyPr wrap="none">
+            <a:spAutoFit/>
+          </a:bodyPr>
+          <a:lstStyle/>
+          <a:p>
+            <a:pPr>
+              <a:defRPr sz="1400"/>
+            </a:pPr>
+            <a:r>
+              <a:t>Solid lines mark observed 2000-2016 rates; dashed lines mark projected 2017-2026 rates.</a:t>
+            </a:r>
+          </a:p>
+        </p:txBody>
+      </p:sp>
+    </p:spTree>
+  </p:cSld>
+  <p:clrMapOvr>
+    <a:masterClrMapping/>
+  </p:clrMapOvr>
+</p:sld>
+</file>
+
+<file path=ppt/slides/slide15.xml><?xml version="1.0" encoding="utf-8"?>
+<p:sld xmlns:a="http://schemas.openxmlformats.org/drawingml/2006/main" xmlns:p="http://schemas.openxmlformats.org/presentationml/2006/main" xmlns:r="http://schemas.openxmlformats.org/officeDocument/2006/relationships">
+  <p:cSld>
+    <p:spTree>
+      <p:nvGrpSpPr>
+        <p:cNvPr id="1" name=""/>
+        <p:cNvGrpSpPr/>
+        <p:nvPr/>
+      </p:nvGrpSpPr>
+      <p:grpSpPr/>
+      <p:sp>
+        <p:nvSpPr>
+          <p:cNvPr id="2" name="Title 1"/>
+          <p:cNvSpPr>
+            <a:spLocks noGrp="1"/>
+          </p:cNvSpPr>
+          <p:nvPr>
+            <p:ph type="title"/>
+          </p:nvPr>
+        </p:nvSpPr>
+        <p:spPr/>
+        <p:txBody>
+          <a:bodyPr/>
+          <a:lstStyle/>
+          <a:p>
+            <a:r>
+              <a:t>Figure 6: Inter-civilisation abroad author-years</a:t>
+            </a:r>
+          </a:p>
+        </p:txBody>
+      </p:sp>
+      <p:sp>
+        <p:nvSpPr>
+          <p:cNvPr id="3" name="Content Placeholder 2"/>
+          <p:cNvSpPr>
+            <a:spLocks noGrp="1"/>
+          </p:cNvSpPr>
+          <p:nvPr>
+            <p:ph idx="1" sz="half"/>
+          </p:nvPr>
+        </p:nvSpPr>
+        <p:spPr/>
+        <p:txBody>
+          <a:bodyPr/>
+          <a:lstStyle/>
+          <a:p/>
+        </p:txBody>
+      </p:sp>
+      <p:sp>
+        <p:nvSpPr>
+          <p:cNvPr id="4" name="Content Placeholder 3"/>
+          <p:cNvSpPr>
+            <a:spLocks noGrp="1"/>
+          </p:cNvSpPr>
+          <p:nvPr>
+            <p:ph idx="2" sz="half"/>
+          </p:nvPr>
+        </p:nvSpPr>
+        <p:spPr/>
+        <p:txBody>
+          <a:bodyPr/>
+          <a:lstStyle/>
+          <a:p/>
+        </p:txBody>
+      </p:sp>
+      <p:pic>
+        <p:nvPicPr>
+          <p:cNvPr id="5" name="Picture 4" descr="annual_interciv_heatmap.png"/>
+          <p:cNvPicPr>
+            <a:picLocks noChangeAspect="1"/>
+          </p:cNvPicPr>
+          <p:nvPr/>
+        </p:nvPicPr>
+        <p:blipFill>
+          <a:blip r:embed="rId2"/>
+          <a:stretch>
+            <a:fillRect/>
+          </a:stretch>
+        </p:blipFill>
+        <p:spPr>
+          <a:xfrm>
+            <a:off x="1371600" y="1097280"/>
+            <a:ext cx="9144000" cy="7643132"/>
+          </a:xfrm>
+          <a:prstGeom prst="rect">
+            <a:avLst/>
+          </a:prstGeom>
+        </p:spPr>
+      </p:pic>
+      <p:sp>
+        <p:nvSpPr>
+          <p:cNvPr id="6" name="TextBox 5"/>
+          <p:cNvSpPr txBox="1"/>
+          <p:nvPr/>
+        </p:nvSpPr>
+        <p:spPr>
+          <a:xfrm>
+            <a:off x="1371600" y="5486400"/>
+            <a:ext cx="9144000" cy="731520"/>
+          </a:xfrm>
+          <a:prstGeom prst="rect">
+            <a:avLst/>
+          </a:prstGeom>
+          <a:noFill/>
+        </p:spPr>
+        <p:txBody>
+          <a:bodyPr wrap="none">
+            <a:spAutoFit/>
+          </a:bodyPr>
+          <a:lstStyle/>
+          <a:p>
+            <a:pPr>
+              <a:defRPr sz="1400"/>
+            </a:pPr>
+            <a:r>
+              <a:t>Rows are origin civilisations; columns are destination civilisations approximated by recent_group.</a:t>
+            </a:r>
+          </a:p>
+        </p:txBody>
+      </p:sp>
+    </p:spTree>
+  </p:cSld>
+  <p:clrMapOvr>
+    <a:masterClrMapping/>
+  </p:clrMapOvr>
+</p:sld>
+</file>
+
+<file path=ppt/slides/slide16.xml><?xml version="1.0" encoding="utf-8"?>
+<p:sld xmlns:a="http://schemas.openxmlformats.org/drawingml/2006/main" xmlns:p="http://schemas.openxmlformats.org/presentationml/2006/main" xmlns:r="http://schemas.openxmlformats.org/officeDocument/2006/relationships">
+  <p:cSld>
+    <p:spTree>
+      <p:nvGrpSpPr>
+        <p:cNvPr id="1" name=""/>
+        <p:cNvGrpSpPr/>
+        <p:nvPr/>
+      </p:nvGrpSpPr>
+      <p:grpSpPr/>
+      <p:sp>
+        <p:nvSpPr>
+          <p:cNvPr id="2" name="Title 1"/>
+          <p:cNvSpPr>
+            <a:spLocks noGrp="1"/>
+          </p:cNvSpPr>
+          <p:nvPr>
+            <p:ph type="title"/>
+          </p:nvPr>
+        </p:nvSpPr>
+        <p:spPr/>
+        <p:txBody>
+          <a:bodyPr/>
+          <a:lstStyle/>
+          <a:p>
+            <a:r>
+              <a:t>Figure 7: Observed vs projected compartment counts</a:t>
+            </a:r>
+          </a:p>
+        </p:txBody>
+      </p:sp>
+      <p:sp>
+        <p:nvSpPr>
+          <p:cNvPr id="3" name="Content Placeholder 2"/>
+          <p:cNvSpPr>
+            <a:spLocks noGrp="1"/>
+          </p:cNvSpPr>
+          <p:nvPr>
+            <p:ph idx="1" sz="half"/>
+          </p:nvPr>
+        </p:nvSpPr>
+        <p:spPr/>
+        <p:txBody>
+          <a:bodyPr/>
+          <a:lstStyle/>
+          <a:p/>
+        </p:txBody>
+      </p:sp>
+      <p:sp>
+        <p:nvSpPr>
+          <p:cNvPr id="4" name="Content Placeholder 3"/>
+          <p:cNvSpPr>
+            <a:spLocks noGrp="1"/>
+          </p:cNvSpPr>
+          <p:nvPr>
+            <p:ph idx="2" sz="half"/>
+          </p:nvPr>
+        </p:nvSpPr>
+        <p:spPr/>
+        <p:txBody>
+          <a:bodyPr/>
+          <a:lstStyle/>
+          <a:p/>
+        </p:txBody>
+      </p:sp>
+      <p:pic>
+        <p:nvPicPr>
+          <p:cNvPr id="5" name="Picture 4" descr="annual_projection_vs_observed.png"/>
+          <p:cNvPicPr>
+            <a:picLocks noChangeAspect="1"/>
+          </p:cNvPicPr>
+          <p:nvPr/>
+        </p:nvPicPr>
+        <p:blipFill>
+          <a:blip r:embed="rId2"/>
+          <a:stretch>
+            <a:fillRect/>
+          </a:stretch>
+        </p:blipFill>
+        <p:spPr>
+          <a:xfrm>
+            <a:off x="1371600" y="1097280"/>
+            <a:ext cx="9144000" cy="5833374"/>
+          </a:xfrm>
+          <a:prstGeom prst="rect">
+            <a:avLst/>
+          </a:prstGeom>
+        </p:spPr>
+      </p:pic>
+      <p:sp>
+        <p:nvSpPr>
+          <p:cNvPr id="6" name="TextBox 5"/>
+          <p:cNvSpPr txBox="1"/>
+          <p:nvPr/>
+        </p:nvSpPr>
+        <p:spPr>
+          <a:xfrm>
+            <a:off x="1371600" y="5486400"/>
+            <a:ext cx="9144000" cy="731520"/>
+          </a:xfrm>
+          <a:prstGeom prst="rect">
+            <a:avLst/>
+          </a:prstGeom>
+          <a:noFill/>
+        </p:spPr>
+        <p:txBody>
+          <a:bodyPr wrap="none">
+            <a:spAutoFit/>
+          </a:bodyPr>
+          <a:lstStyle/>
+          <a:p>
+            <a:pPr>
+              <a:defRPr sz="1400"/>
+            </a:pPr>
+            <a:r>
+              <a:t>Solid lines are observed counts; dashed lines are 2017-2026 projections. The vertical dotted line is 2016.</a:t>
+            </a:r>
+          </a:p>
+        </p:txBody>
+      </p:sp>
+    </p:spTree>
+  </p:cSld>
+  <p:clrMapOvr>
+    <a:masterClrMapping/>
+  </p:clrMapOvr>
+</p:sld>
+</file>
+
+<file path=ppt/slides/slide17.xml><?xml version="1.0" encoding="utf-8"?>
+<p:sld xmlns:a="http://schemas.openxmlformats.org/drawingml/2006/main" xmlns:p="http://schemas.openxmlformats.org/presentationml/2006/main" xmlns:r="http://schemas.openxmlformats.org/officeDocument/2006/relationships">
+  <p:cSld>
+    <p:spTree>
+      <p:nvGrpSpPr>
+        <p:cNvPr id="1" name=""/>
+        <p:cNvGrpSpPr/>
+        <p:nvPr/>
+      </p:nvGrpSpPr>
+      <p:grpSpPr/>
+      <p:sp>
+        <p:nvSpPr>
+          <p:cNvPr id="2" name="Title 1"/>
+          <p:cNvSpPr>
+            <a:spLocks noGrp="1"/>
+          </p:cNvSpPr>
+          <p:nvPr>
+            <p:ph type="title"/>
+          </p:nvPr>
+        </p:nvSpPr>
+        <p:spPr/>
+        <p:txBody>
+          <a:bodyPr/>
+          <a:lstStyle/>
+          <a:p>
+            <a:r>
+              <a:t>Table 9: Mean observed annual transition rates, 2000-2016</a:t>
+            </a:r>
+          </a:p>
+        </p:txBody>
+      </p:sp>
+      <p:sp>
+        <p:nvSpPr>
+          <p:cNvPr id="3" name="Content Placeholder 2"/>
+          <p:cNvSpPr>
+            <a:spLocks noGrp="1"/>
+          </p:cNvSpPr>
+          <p:nvPr>
+            <p:ph idx="1" sz="half"/>
+          </p:nvPr>
+        </p:nvSpPr>
+        <p:spPr/>
+        <p:txBody>
+          <a:bodyPr/>
+          <a:lstStyle/>
+          <a:p/>
+        </p:txBody>
+      </p:sp>
+      <p:sp>
+        <p:nvSpPr>
+          <p:cNvPr id="4" name="Content Placeholder 3"/>
+          <p:cNvSpPr>
+            <a:spLocks noGrp="1"/>
+          </p:cNvSpPr>
+          <p:nvPr>
+            <p:ph idx="2" sz="half"/>
+          </p:nvPr>
+        </p:nvSpPr>
+        <p:spPr/>
+        <p:txBody>
+          <a:bodyPr/>
+          <a:lstStyle/>
+          <a:p/>
+        </p:txBody>
+      </p:sp>
+      <p:graphicFrame>
+        <p:nvGraphicFramePr>
+          <p:cNvPr id="5" name="Table 4"/>
+          <p:cNvGraphicFramePr>
+            <a:graphicFrameLocks noGrp="1"/>
+          </p:cNvGraphicFramePr>
+          <p:nvPr/>
+        </p:nvGraphicFramePr>
+        <p:xfrm>
+          <a:off x="457200" y="1097280"/>
+          <a:ext cx="8961119" cy="5486400"/>
+        </p:xfrm>
+        <a:graphic>
+          <a:graphicData uri="http://schemas.openxmlformats.org/drawingml/2006/table">
+            <a:tbl>
+              <a:tblPr firstRow="1" bandRow="1">
+                <a:tableStyleId>{5C22544A-7EE6-4342-B048-85BDC9FD1C3A}</a:tableStyleId>
+              </a:tblPr>
+              <a:tblGrid>
+                <a:gridCol w="1280159"/>
+                <a:gridCol w="1280159"/>
+                <a:gridCol w="1280159"/>
+                <a:gridCol w="1280159"/>
+                <a:gridCol w="1280159"/>
+                <a:gridCol w="1280159"/>
+                <a:gridCol w="1280165"/>
+              </a:tblGrid>
+              <a:tr h="548640">
+                <a:tc>
+                  <a:txBody>
+                    <a:bodyPr/>
+                    <a:lstStyle/>
+                    <a:p>
+                      <a:r>
+                        <a:t>Group</a:t>
+                      </a:r>
+                    </a:p>
+                  </a:txBody>
+                  <a:tcPr/>
+                </a:tc>
+                <a:tc>
+                  <a:txBody>
+                    <a:bodyPr/>
+                    <a:lstStyle/>
+                    <a:p>
+                      <a:r>
+                        <a:t>α</a:t>
+                      </a:r>
+                    </a:p>
+                  </a:txBody>
+                  <a:tcPr/>
+                </a:tc>
+                <a:tc>
+                  <a:txBody>
+                    <a:bodyPr/>
+                    <a:lstStyle/>
+                    <a:p>
+                      <a:r>
+                        <a:t>β</a:t>
+                      </a:r>
+                    </a:p>
+                  </a:txBody>
+                  <a:tcPr/>
+                </a:tc>
+                <a:tc>
+                  <a:txBody>
+                    <a:bodyPr/>
+                    <a:lstStyle/>
+                    <a:p>
+                      <a:r>
+                        <a:t>h_D</a:t>
+                      </a:r>
+                    </a:p>
+                  </a:txBody>
+                  <a:tcPr/>
+                </a:tc>
+                <a:tc>
+                  <a:txBody>
+                    <a:bodyPr/>
+                    <a:lstStyle/>
+                    <a:p>
+                      <a:r>
+                        <a:t>p_D</a:t>
+                      </a:r>
+                    </a:p>
+                  </a:txBody>
+                  <a:tcPr/>
+                </a:tc>
+                <a:tc>
+                  <a:txBody>
+                    <a:bodyPr/>
+                    <a:lstStyle/>
+                    <a:p>
+                      <a:r>
+                        <a:t>d</a:t>
+                      </a:r>
+                    </a:p>
+                  </a:txBody>
+                  <a:tcPr/>
+                </a:tc>
+                <a:tc>
+                  <a:txBody>
+                    <a:bodyPr/>
+                    <a:lstStyle/>
+                    <a:p>
+                      <a:r>
+                        <a:t>I_total</a:t>
+                      </a:r>
+                    </a:p>
+                  </a:txBody>
+                  <a:tcPr/>
+                </a:tc>
+              </a:tr>
+              <a:tr h="548640">
+                <a:tc>
+                  <a:txBody>
+                    <a:bodyPr/>
+                    <a:lstStyle/>
+                    <a:p>
+                      <a:pPr>
+                        <a:defRPr sz="1000"/>
+                      </a:pPr>
+                      <a:r>
+                        <a:t>Anglosphere ex-US</a:t>
+                      </a:r>
+                    </a:p>
+                  </a:txBody>
+                  <a:tcPr/>
+                </a:tc>
+                <a:tc>
+                  <a:txBody>
+                    <a:bodyPr/>
+                    <a:lstStyle/>
+                    <a:p>
+                      <a:pPr>
+                        <a:defRPr sz="1000"/>
+                      </a:pPr>
+                      <a:r>
+                        <a:t>0.1129176379176379</a:t>
+                      </a:r>
+                    </a:p>
+                  </a:txBody>
+                  <a:tcPr/>
+                </a:tc>
+                <a:tc>
+                  <a:txBody>
+                    <a:bodyPr/>
+                    <a:lstStyle/>
+                    <a:p>
+                      <a:pPr>
+                        <a:defRPr sz="1000"/>
+                      </a:pPr>
+                      <a:r>
+                        <a:t>0.15173091365625077</a:t>
+                      </a:r>
+                    </a:p>
+                  </a:txBody>
+                  <a:tcPr/>
+                </a:tc>
+                <a:tc>
+                  <a:txBody>
+                    <a:bodyPr/>
+                    <a:lstStyle/>
+                    <a:p>
+                      <a:pPr>
+                        <a:defRPr sz="1000"/>
+                      </a:pPr>
+                      <a:r>
+                        <a:t>0.1417249417249417</a:t>
+                      </a:r>
+                    </a:p>
+                  </a:txBody>
+                  <a:tcPr/>
+                </a:tc>
+                <a:tc>
+                  <a:txBody>
+                    <a:bodyPr/>
+                    <a:lstStyle/>
+                    <a:p>
+                      <a:pPr>
+                        <a:defRPr sz="1000"/>
+                      </a:pPr>
+                      <a:r>
+                        <a:t>0.06086050415316485</a:t>
+                      </a:r>
+                    </a:p>
+                  </a:txBody>
+                  <a:tcPr/>
+                </a:tc>
+                <a:tc>
+                  <a:txBody>
+                    <a:bodyPr/>
+                    <a:lstStyle/>
+                    <a:p>
+                      <a:pPr>
+                        <a:defRPr sz="1000"/>
+                      </a:pPr>
+                      <a:r>
+                        <a:t>0.043972244494452827</a:t>
+                      </a:r>
+                    </a:p>
+                  </a:txBody>
+                  <a:tcPr/>
+                </a:tc>
+                <a:tc>
+                  <a:txBody>
+                    <a:bodyPr/>
+                    <a:lstStyle/>
+                    <a:p>
+                      <a:pPr>
+                        <a:defRPr sz="1000"/>
+                      </a:pPr>
+                      <a:r>
+                        <a:t>2.076923076923077</a:t>
+                      </a:r>
+                    </a:p>
+                  </a:txBody>
+                  <a:tcPr/>
+                </a:tc>
+              </a:tr>
+              <a:tr h="548640">
+                <a:tc>
+                  <a:txBody>
+                    <a:bodyPr/>
+                    <a:lstStyle/>
+                    <a:p>
+                      <a:pPr>
+                        <a:defRPr sz="1000"/>
+                      </a:pPr>
+                      <a:r>
+                        <a:t>Continental Europe</a:t>
+                      </a:r>
+                    </a:p>
+                  </a:txBody>
+                  <a:tcPr/>
+                </a:tc>
+                <a:tc>
+                  <a:txBody>
+                    <a:bodyPr/>
+                    <a:lstStyle/>
+                    <a:p>
+                      <a:pPr>
+                        <a:defRPr sz="1000"/>
+                      </a:pPr>
+                      <a:r>
+                        <a:t>0.047545598762704575</a:t>
+                      </a:r>
+                    </a:p>
+                  </a:txBody>
+                  <a:tcPr/>
+                </a:tc>
+                <a:tc>
+                  <a:txBody>
+                    <a:bodyPr/>
+                    <a:lstStyle/>
+                    <a:p>
+                      <a:pPr>
+                        <a:defRPr sz="1000"/>
+                      </a:pPr>
+                      <a:r>
+                        <a:t>0.13902267736763677</a:t>
+                      </a:r>
+                    </a:p>
+                  </a:txBody>
+                  <a:tcPr/>
+                </a:tc>
+                <a:tc>
+                  <a:txBody>
+                    <a:bodyPr/>
+                    <a:lstStyle/>
+                    <a:p>
+                      <a:pPr>
+                        <a:defRPr sz="1000"/>
+                      </a:pPr>
+                      <a:r>
+                        <a:t>0.12181336418611399</a:t>
+                      </a:r>
+                    </a:p>
+                  </a:txBody>
+                  <a:tcPr/>
+                </a:tc>
+                <a:tc>
+                  <a:txBody>
+                    <a:bodyPr/>
+                    <a:lstStyle/>
+                    <a:p>
+                      <a:pPr>
+                        <a:defRPr sz="1000"/>
+                      </a:pPr>
+                      <a:r>
+                        <a:t>0.06799587647162213</a:t>
+                      </a:r>
+                    </a:p>
+                  </a:txBody>
+                  <a:tcPr/>
+                </a:tc>
+                <a:tc>
+                  <a:txBody>
+                    <a:bodyPr/>
+                    <a:lstStyle/>
+                    <a:p>
+                      <a:pPr>
+                        <a:defRPr sz="1000"/>
+                      </a:pPr>
+                      <a:r>
+                        <a:t>0.0300192911404828</a:t>
+                      </a:r>
+                    </a:p>
+                  </a:txBody>
+                  <a:tcPr/>
+                </a:tc>
+                <a:tc>
+                  <a:txBody>
+                    <a:bodyPr/>
+                    <a:lstStyle/>
+                    <a:p>
+                      <a:pPr>
+                        <a:defRPr sz="1000"/>
+                      </a:pPr>
+                      <a:r>
+                        <a:t>3.0625</a:t>
+                      </a:r>
+                    </a:p>
+                  </a:txBody>
+                  <a:tcPr/>
+                </a:tc>
+              </a:tr>
+              <a:tr h="548640">
+                <a:tc>
+                  <a:txBody>
+                    <a:bodyPr/>
+                    <a:lstStyle/>
+                    <a:p>
+                      <a:pPr>
+                        <a:defRPr sz="1000"/>
+                      </a:pPr>
+                      <a:r>
+                        <a:t>Hindu</a:t>
+                      </a:r>
+                    </a:p>
+                  </a:txBody>
+                  <a:tcPr/>
+                </a:tc>
+                <a:tc>
+                  <a:txBody>
+                    <a:bodyPr/>
+                    <a:lstStyle/>
+                    <a:p>
+                      <a:pPr>
+                        <a:defRPr sz="1000"/>
+                      </a:pPr>
+                      <a:r>
+                        <a:t>0.06396181707275748</a:t>
+                      </a:r>
+                    </a:p>
+                  </a:txBody>
+                  <a:tcPr/>
+                </a:tc>
+                <a:tc>
+                  <a:txBody>
+                    <a:bodyPr/>
+                    <a:lstStyle/>
+                    <a:p>
+                      <a:pPr>
+                        <a:defRPr sz="1000"/>
+                      </a:pPr>
+                      <a:r>
+                        <a:t>0.18984126984126978</a:t>
+                      </a:r>
+                    </a:p>
+                  </a:txBody>
+                  <a:tcPr/>
+                </a:tc>
+                <a:tc>
+                  <a:txBody>
+                    <a:bodyPr/>
+                    <a:lstStyle/>
+                    <a:p>
+                      <a:pPr>
+                        <a:defRPr sz="1000"/>
+                      </a:pPr>
+                      <a:r>
+                        <a:t>0.13046281630447018</a:t>
+                      </a:r>
+                    </a:p>
+                  </a:txBody>
+                  <a:tcPr/>
+                </a:tc>
+                <a:tc>
+                  <a:txBody>
+                    <a:bodyPr/>
+                    <a:lstStyle/>
+                    <a:p>
+                      <a:pPr>
+                        <a:defRPr sz="1000"/>
+                      </a:pPr>
+                      <a:r>
+                        <a:t>0.07486960638957495</a:t>
+                      </a:r>
+                    </a:p>
+                  </a:txBody>
+                  <a:tcPr/>
+                </a:tc>
+                <a:tc>
+                  <a:txBody>
+                    <a:bodyPr/>
+                    <a:lstStyle/>
+                    <a:p>
+                      <a:pPr>
+                        <a:defRPr sz="1000"/>
+                      </a:pPr>
+                      <a:r>
+                        <a:t>0.05741241221177246</a:t>
+                      </a:r>
+                    </a:p>
+                  </a:txBody>
+                  <a:tcPr/>
+                </a:tc>
+                <a:tc>
+                  <a:txBody>
+                    <a:bodyPr/>
+                    <a:lstStyle/>
+                    <a:p>
+                      <a:pPr>
+                        <a:defRPr sz="1000"/>
+                      </a:pPr>
+                      <a:r>
+                        <a:t>1.7333333333333334</a:t>
+                      </a:r>
+                    </a:p>
+                  </a:txBody>
+                  <a:tcPr/>
+                </a:tc>
+              </a:tr>
+              <a:tr h="548640">
+                <a:tc>
+                  <a:txBody>
+                    <a:bodyPr/>
+                    <a:lstStyle/>
+                    <a:p>
+                      <a:pPr>
+                        <a:defRPr sz="1000"/>
+                      </a:pPr>
+                      <a:r>
+                        <a:t>Islamic</a:t>
+                      </a:r>
+                    </a:p>
+                  </a:txBody>
+                  <a:tcPr/>
+                </a:tc>
+                <a:tc>
+                  <a:txBody>
+                    <a:bodyPr/>
+                    <a:lstStyle/>
+                    <a:p>
+                      <a:pPr>
+                        <a:defRPr sz="1000"/>
+                      </a:pPr>
+                      <a:r>
+                        <a:t>0.08205568021963228</a:t>
+                      </a:r>
+                    </a:p>
+                  </a:txBody>
+                  <a:tcPr/>
+                </a:tc>
+                <a:tc>
+                  <a:txBody>
+                    <a:bodyPr/>
+                    <a:lstStyle/>
+                    <a:p>
+                      <a:pPr>
+                        <a:defRPr sz="1000"/>
+                      </a:pPr>
+                      <a:r>
+                        <a:t>0.29100529100529093</a:t>
+                      </a:r>
+                    </a:p>
+                  </a:txBody>
+                  <a:tcPr/>
+                </a:tc>
+                <a:tc>
+                  <a:txBody>
+                    <a:bodyPr/>
+                    <a:lstStyle/>
+                    <a:p>
+                      <a:pPr>
+                        <a:defRPr sz="1000"/>
+                      </a:pPr>
+                      <a:r>
+                        <a:t>0.1326110541617339</a:t>
+                      </a:r>
+                    </a:p>
+                  </a:txBody>
+                  <a:tcPr/>
+                </a:tc>
+                <a:tc>
+                  <a:txBody>
+                    <a:bodyPr/>
+                    <a:lstStyle/>
+                    <a:p>
+                      <a:pPr>
+                        <a:defRPr sz="1000"/>
+                      </a:pPr>
+                      <a:r>
+                        <a:t>0.07790892074769187</a:t>
+                      </a:r>
+                    </a:p>
+                  </a:txBody>
+                  <a:tcPr/>
+                </a:tc>
+                <a:tc>
+                  <a:txBody>
+                    <a:bodyPr/>
+                    <a:lstStyle/>
+                    <a:p>
+                      <a:pPr>
+                        <a:defRPr sz="1000"/>
+                      </a:pPr>
+                      <a:r>
+                        <a:t>0.15885368948496636</a:t>
+                      </a:r>
+                    </a:p>
+                  </a:txBody>
+                  <a:tcPr/>
+                </a:tc>
+                <a:tc>
+                  <a:txBody>
+                    <a:bodyPr/>
+                    <a:lstStyle/>
+                    <a:p>
+                      <a:pPr>
+                        <a:defRPr sz="1000"/>
+                      </a:pPr>
+                      <a:r>
+                        <a:t>2.2222222222222223</a:t>
+                      </a:r>
+                    </a:p>
+                  </a:txBody>
+                  <a:tcPr/>
+                </a:tc>
+              </a:tr>
+              <a:tr h="548640">
+                <a:tc>
+                  <a:txBody>
+                    <a:bodyPr/>
+                    <a:lstStyle/>
+                    <a:p>
+                      <a:pPr>
+                        <a:defRPr sz="1000"/>
+                      </a:pPr>
+                      <a:r>
+                        <a:t>Japanese</a:t>
+                      </a:r>
+                    </a:p>
+                  </a:txBody>
+                  <a:tcPr/>
+                </a:tc>
+                <a:tc>
+                  <a:txBody>
+                    <a:bodyPr/>
+                    <a:lstStyle/>
+                    <a:p>
+                      <a:pPr>
+                        <a:defRPr sz="1000"/>
+                      </a:pPr>
+                      <a:r>
+                        <a:t>0.05340135985824978</a:t>
+                      </a:r>
+                    </a:p>
+                  </a:txBody>
+                  <a:tcPr/>
+                </a:tc>
+                <a:tc>
+                  <a:txBody>
+                    <a:bodyPr/>
+                    <a:lstStyle/>
+                    <a:p>
+                      <a:pPr>
+                        <a:defRPr sz="1000"/>
+                      </a:pPr>
+                      <a:r>
+                        <a:t>0.3333333333333333</a:t>
+                      </a:r>
+                    </a:p>
+                  </a:txBody>
+                  <a:tcPr/>
+                </a:tc>
+                <a:tc>
+                  <a:txBody>
+                    <a:bodyPr/>
+                    <a:lstStyle/>
+                    <a:p>
+                      <a:pPr>
+                        <a:defRPr sz="1000"/>
+                      </a:pPr>
+                      <a:r>
+                        <a:t>0.10170404247700691</a:t>
+                      </a:r>
+                    </a:p>
+                  </a:txBody>
+                  <a:tcPr/>
+                </a:tc>
+                <a:tc>
+                  <a:txBody>
+                    <a:bodyPr/>
+                    <a:lstStyle/>
+                    <a:p>
+                      <a:pPr>
+                        <a:defRPr sz="1000"/>
+                      </a:pPr>
+                      <a:r>
+                        <a:t>0.072498564486719</a:t>
+                      </a:r>
+                    </a:p>
+                  </a:txBody>
+                  <a:tcPr/>
+                </a:tc>
+                <a:tc>
+                  <a:txBody>
+                    <a:bodyPr/>
+                    <a:lstStyle/>
+                    <a:p>
+                      <a:pPr>
+                        <a:defRPr sz="1000"/>
+                      </a:pPr>
+                      <a:r>
+                        <a:t>0.05831801893653609</a:t>
+                      </a:r>
+                    </a:p>
+                  </a:txBody>
+                  <a:tcPr/>
+                </a:tc>
+                <a:tc>
+                  <a:txBody>
+                    <a:bodyPr/>
+                    <a:lstStyle/>
+                    <a:p>
+                      <a:pPr>
+                        <a:defRPr sz="1000"/>
+                      </a:pPr>
+                      <a:r>
+                        <a:t>2.0</a:t>
+                      </a:r>
+                    </a:p>
+                  </a:txBody>
+                  <a:tcPr/>
+                </a:tc>
+              </a:tr>
+              <a:tr h="548640">
+                <a:tc>
+                  <a:txBody>
+                    <a:bodyPr/>
+                    <a:lstStyle/>
+                    <a:p>
+                      <a:pPr>
+                        <a:defRPr sz="1000"/>
+                      </a:pPr>
+                      <a:r>
+                        <a:t>Other Civilizations</a:t>
+                      </a:r>
+                    </a:p>
+                  </a:txBody>
+                  <a:tcPr/>
+                </a:tc>
+                <a:tc>
+                  <a:txBody>
+                    <a:bodyPr/>
+                    <a:lstStyle/>
+                    <a:p>
+                      <a:pPr>
+                        <a:defRPr sz="1000"/>
+                      </a:pPr>
+                      <a:r>
+                        <a:t>0.09591154459575511</a:t>
+                      </a:r>
+                    </a:p>
+                  </a:txBody>
+                  <a:tcPr/>
+                </a:tc>
+                <a:tc>
+                  <a:txBody>
+                    <a:bodyPr/>
+                    <a:lstStyle/>
+                    <a:p>
+                      <a:pPr>
+                        <a:defRPr sz="1000"/>
+                      </a:pPr>
+                      <a:r>
+                        <a:t>0.24004884004884006</a:t>
+                      </a:r>
+                    </a:p>
+                  </a:txBody>
+                  <a:tcPr/>
+                </a:tc>
+                <a:tc>
+                  <a:txBody>
+                    <a:bodyPr/>
+                    <a:lstStyle/>
+                    <a:p>
+                      <a:pPr>
+                        <a:defRPr sz="1000"/>
+                      </a:pPr>
+                      <a:r>
+                        <a:t>0.1285588680325522</a:t>
+                      </a:r>
+                    </a:p>
+                  </a:txBody>
+                  <a:tcPr/>
+                </a:tc>
+                <a:tc>
+                  <a:txBody>
+                    <a:bodyPr/>
+                    <a:lstStyle/>
+                    <a:p>
+                      <a:pPr>
+                        <a:defRPr sz="1000"/>
+                      </a:pPr>
+                      <a:r>
+                        <a:t>0.08731763592444705</a:t>
+                      </a:r>
+                    </a:p>
+                  </a:txBody>
+                  <a:tcPr/>
+                </a:tc>
+                <a:tc>
+                  <a:txBody>
+                    <a:bodyPr/>
+                    <a:lstStyle/>
+                    <a:p>
+                      <a:pPr>
+                        <a:defRPr sz="1000"/>
+                      </a:pPr>
+                      <a:r>
+                        <a:t>0.08593809508349504</a:t>
+                      </a:r>
+                    </a:p>
+                  </a:txBody>
+                  <a:tcPr/>
+                </a:tc>
+                <a:tc>
+                  <a:txBody>
+                    <a:bodyPr/>
+                    <a:lstStyle/>
+                    <a:p>
+                      <a:pPr>
+                        <a:defRPr sz="1000"/>
+                      </a:pPr>
+                      <a:r>
+                        <a:t>1.6666666666666667</a:t>
+                      </a:r>
+                    </a:p>
+                  </a:txBody>
+                  <a:tcPr/>
+                </a:tc>
+              </a:tr>
+              <a:tr h="548640">
+                <a:tc>
+                  <a:txBody>
+                    <a:bodyPr/>
+                    <a:lstStyle/>
+                    <a:p>
+                      <a:pPr>
+                        <a:defRPr sz="1000"/>
+                      </a:pPr>
+                      <a:r>
+                        <a:t>Other Western</a:t>
+                      </a:r>
+                    </a:p>
+                  </a:txBody>
+                  <a:tcPr/>
+                </a:tc>
+                <a:tc>
+                  <a:txBody>
+                    <a:bodyPr/>
+                    <a:lstStyle/>
+                    <a:p>
+                      <a:pPr>
+                        <a:defRPr sz="1000"/>
+                      </a:pPr>
+                      <a:r>
+                        <a:t>0.09078955232801385</a:t>
+                      </a:r>
+                    </a:p>
+                  </a:txBody>
+                  <a:tcPr/>
+                </a:tc>
+                <a:tc>
+                  <a:txBody>
+                    <a:bodyPr/>
+                    <a:lstStyle/>
+                    <a:p>
+                      <a:pPr>
+                        <a:defRPr sz="1000"/>
+                      </a:pPr>
+                      <a:r>
+                        <a:t>0.21396825396825397</a:t>
+                      </a:r>
+                    </a:p>
+                  </a:txBody>
+                  <a:tcPr/>
+                </a:tc>
+                <a:tc>
+                  <a:txBody>
+                    <a:bodyPr/>
+                    <a:lstStyle/>
+                    <a:p>
+                      <a:pPr>
+                        <a:defRPr sz="1000"/>
+                      </a:pPr>
+                      <a:r>
+                        <a:t>0.19933058394596853</a:t>
+                      </a:r>
+                    </a:p>
+                  </a:txBody>
+                  <a:tcPr/>
+                </a:tc>
+                <a:tc>
+                  <a:txBody>
+                    <a:bodyPr/>
+                    <a:lstStyle/>
+                    <a:p>
+                      <a:pPr>
+                        <a:defRPr sz="1000"/>
+                      </a:pPr>
+                      <a:r>
+                        <a:t>0.06507524037958819</a:t>
+                      </a:r>
+                    </a:p>
+                  </a:txBody>
+                  <a:tcPr/>
+                </a:tc>
+                <a:tc>
+                  <a:txBody>
+                    <a:bodyPr/>
+                    <a:lstStyle/>
+                    <a:p>
+                      <a:pPr>
+                        <a:defRPr sz="1000"/>
+                      </a:pPr>
+                      <a:r>
+                        <a:t>0.0881659023795685</a:t>
+                      </a:r>
+                    </a:p>
+                  </a:txBody>
+                  <a:tcPr/>
+                </a:tc>
+                <a:tc>
+                  <a:txBody>
+                    <a:bodyPr/>
+                    <a:lstStyle/>
+                    <a:p>
+                      <a:pPr>
+                        <a:defRPr sz="1000"/>
+                      </a:pPr>
+                      <a:r>
+                        <a:t>1.6666666666666667</a:t>
+                      </a:r>
+                    </a:p>
+                  </a:txBody>
+                  <a:tcPr/>
+                </a:tc>
+              </a:tr>
+              <a:tr h="548640">
+                <a:tc>
+                  <a:txBody>
+                    <a:bodyPr/>
+                    <a:lstStyle/>
+                    <a:p>
+                      <a:pPr>
+                        <a:defRPr sz="1000"/>
+                      </a:pPr>
+                      <a:r>
+                        <a:t>Sinic</a:t>
+                      </a:r>
+                    </a:p>
+                  </a:txBody>
+                  <a:tcPr/>
+                </a:tc>
+                <a:tc>
+                  <a:txBody>
+                    <a:bodyPr/>
+                    <a:lstStyle/>
+                    <a:p>
+                      <a:pPr>
+                        <a:defRPr sz="1000"/>
+                      </a:pPr>
+                      <a:r>
+                        <a:t>0.04506616990458503</a:t>
+                      </a:r>
+                    </a:p>
+                  </a:txBody>
+                  <a:tcPr/>
+                </a:tc>
+                <a:tc>
+                  <a:txBody>
+                    <a:bodyPr/>
+                    <a:lstStyle/>
+                    <a:p>
+                      <a:pPr>
+                        <a:defRPr sz="1000"/>
+                      </a:pPr>
+                      <a:r>
+                        <a:t>0.20043186340764194</a:t>
+                      </a:r>
+                    </a:p>
+                  </a:txBody>
+                  <a:tcPr/>
+                </a:tc>
+                <a:tc>
+                  <a:txBody>
+                    <a:bodyPr/>
+                    <a:lstStyle/>
+                    <a:p>
+                      <a:pPr>
+                        <a:defRPr sz="1000"/>
+                      </a:pPr>
+                      <a:r>
+                        <a:t>0.08705484019374365</a:t>
+                      </a:r>
+                    </a:p>
+                  </a:txBody>
+                  <a:tcPr/>
+                </a:tc>
+                <a:tc>
+                  <a:txBody>
+                    <a:bodyPr/>
+                    <a:lstStyle/>
+                    <a:p>
+                      <a:pPr>
+                        <a:defRPr sz="1000"/>
+                      </a:pPr>
+                      <a:r>
+                        <a:t>0.05182305235562991</a:t>
+                      </a:r>
+                    </a:p>
+                  </a:txBody>
+                  <a:tcPr/>
+                </a:tc>
+                <a:tc>
+                  <a:txBody>
+                    <a:bodyPr/>
+                    <a:lstStyle/>
+                    <a:p>
+                      <a:pPr>
+                        <a:defRPr sz="1000"/>
+                      </a:pPr>
+                      <a:r>
+                        <a:t>0.036227248090891374</a:t>
+                      </a:r>
+                    </a:p>
+                  </a:txBody>
+                  <a:tcPr/>
+                </a:tc>
+                <a:tc>
+                  <a:txBody>
+                    <a:bodyPr/>
+                    <a:lstStyle/>
+                    <a:p>
+                      <a:pPr>
+                        <a:defRPr sz="1000"/>
+                      </a:pPr>
+                      <a:r>
+                        <a:t>2.5625</a:t>
+                      </a:r>
+                    </a:p>
+                  </a:txBody>
+                  <a:tcPr/>
+                </a:tc>
+              </a:tr>
+              <a:tr h="548640">
+                <a:tc>
+                  <a:txBody>
+                    <a:bodyPr/>
+                    <a:lstStyle/>
+                    <a:p>
+                      <a:pPr>
+                        <a:defRPr sz="1000"/>
+                      </a:pPr>
+                      <a:r>
+                        <a:t>United States</a:t>
+                      </a:r>
+                    </a:p>
+                  </a:txBody>
+                  <a:tcPr/>
+                </a:tc>
+                <a:tc>
+                  <a:txBody>
+                    <a:bodyPr/>
+                    <a:lstStyle/>
+                    <a:p>
+                      <a:pPr>
+                        <a:defRPr sz="1000"/>
+                      </a:pPr>
+                      <a:r>
+                        <a:t>0.0691164519185129</a:t>
+                      </a:r>
+                    </a:p>
+                  </a:txBody>
+                  <a:tcPr/>
+                </a:tc>
+                <a:tc>
+                  <a:txBody>
+                    <a:bodyPr/>
+                    <a:lstStyle/>
+                    <a:p>
+                      <a:pPr>
+                        <a:defRPr sz="1000"/>
+                      </a:pPr>
+                      <a:r>
+                        <a:t>0.16127421339903422</a:t>
+                      </a:r>
+                    </a:p>
+                  </a:txBody>
+                  <a:tcPr/>
+                </a:tc>
+                <a:tc>
+                  <a:txBody>
+                    <a:bodyPr/>
+                    <a:lstStyle/>
+                    <a:p>
+                      <a:pPr>
+                        <a:defRPr sz="1000"/>
+                      </a:pPr>
+                      <a:r>
+                        <a:t>0.15765794688955578</a:t>
+                      </a:r>
+                    </a:p>
+                  </a:txBody>
+                  <a:tcPr/>
+                </a:tc>
+                <a:tc>
+                  <a:txBody>
+                    <a:bodyPr/>
+                    <a:lstStyle/>
+                    <a:p>
+                      <a:pPr>
+                        <a:defRPr sz="1000"/>
+                      </a:pPr>
+                      <a:r>
+                        <a:t>0.04848176699156801</a:t>
+                      </a:r>
+                    </a:p>
+                  </a:txBody>
+                  <a:tcPr/>
+                </a:tc>
+                <a:tc>
+                  <a:txBody>
+                    <a:bodyPr/>
+                    <a:lstStyle/>
+                    <a:p>
+                      <a:pPr>
+                        <a:defRPr sz="1000"/>
+                      </a:pPr>
+                      <a:r>
+                        <a:t>0.027229516859262524</a:t>
+                      </a:r>
+                    </a:p>
+                  </a:txBody>
+                  <a:tcPr/>
+                </a:tc>
+                <a:tc>
+                  <a:txBody>
+                    <a:bodyPr/>
+                    <a:lstStyle/>
+                    <a:p>
+                      <a:pPr>
+                        <a:defRPr sz="1000"/>
+                      </a:pPr>
+                      <a:r>
+                        <a:t>2.8823529411764706</a:t>
+                      </a:r>
+                    </a:p>
+                  </a:txBody>
+                  <a:tcPr/>
+                </a:tc>
+              </a:tr>
+            </a:tbl>
+          </a:graphicData>
+        </a:graphic>
+      </p:graphicFrame>
+    </p:spTree>
+  </p:cSld>
+  <p:clrMapOvr>
+    <a:masterClrMapping/>
+  </p:clrMapOvr>
+</p:sld>
+</file>
+
+<file path=ppt/slides/slide18.xml><?xml version="1.0" encoding="utf-8"?>
+<p:sld xmlns:a="http://schemas.openxmlformats.org/drawingml/2006/main" xmlns:p="http://schemas.openxmlformats.org/presentationml/2006/main" xmlns:r="http://schemas.openxmlformats.org/officeDocument/2006/relationships">
+  <p:cSld>
+    <p:spTree>
+      <p:nvGrpSpPr>
+        <p:cNvPr id="1" name=""/>
+        <p:cNvGrpSpPr/>
+        <p:nvPr/>
+      </p:nvGrpSpPr>
+      <p:grpSpPr/>
+      <p:sp>
+        <p:nvSpPr>
+          <p:cNvPr id="2" name="Title 1"/>
+          <p:cNvSpPr>
+            <a:spLocks noGrp="1"/>
+          </p:cNvSpPr>
+          <p:nvPr>
+            <p:ph type="title"/>
+          </p:nvPr>
+        </p:nvSpPr>
+        <p:spPr/>
+        <p:txBody>
+          <a:bodyPr/>
+          <a:lstStyle/>
+          <a:p>
+            <a:r>
+              <a:t>Table 10: Top origin-destination abroad author-year pairs</a:t>
+            </a:r>
+          </a:p>
+        </p:txBody>
+      </p:sp>
+      <p:sp>
+        <p:nvSpPr>
+          <p:cNvPr id="3" name="Content Placeholder 2"/>
+          <p:cNvSpPr>
+            <a:spLocks noGrp="1"/>
+          </p:cNvSpPr>
+          <p:nvPr>
+            <p:ph idx="1" sz="half"/>
+          </p:nvPr>
+        </p:nvSpPr>
+        <p:spPr/>
+        <p:txBody>
+          <a:bodyPr/>
+          <a:lstStyle/>
+          <a:p/>
+        </p:txBody>
+      </p:sp>
+      <p:sp>
+        <p:nvSpPr>
+          <p:cNvPr id="4" name="Content Placeholder 3"/>
+          <p:cNvSpPr>
+            <a:spLocks noGrp="1"/>
+          </p:cNvSpPr>
+          <p:nvPr>
+            <p:ph idx="2" sz="half"/>
+          </p:nvPr>
+        </p:nvSpPr>
+        <p:spPr/>
+        <p:txBody>
+          <a:bodyPr/>
+          <a:lstStyle/>
+          <a:p/>
+        </p:txBody>
+      </p:sp>
+      <p:graphicFrame>
+        <p:nvGraphicFramePr>
+          <p:cNvPr id="5" name="Table 4"/>
+          <p:cNvGraphicFramePr>
+            <a:graphicFrameLocks noGrp="1"/>
+          </p:cNvGraphicFramePr>
+          <p:nvPr/>
+        </p:nvGraphicFramePr>
+        <p:xfrm>
+          <a:off x="457200" y="1097280"/>
+          <a:ext cx="5486400" cy="6035040"/>
+        </p:xfrm>
+        <a:graphic>
+          <a:graphicData uri="http://schemas.openxmlformats.org/drawingml/2006/table">
+            <a:tbl>
+              <a:tblPr firstRow="1" bandRow="1">
+                <a:tableStyleId>{5C22544A-7EE6-4342-B048-85BDC9FD1C3A}</a:tableStyleId>
+              </a:tblPr>
+              <a:tblGrid>
+                <a:gridCol w="1828800"/>
+                <a:gridCol w="1828800"/>
+                <a:gridCol w="1828800"/>
+              </a:tblGrid>
+              <a:tr h="548640">
+                <a:tc>
+                  <a:txBody>
+                    <a:bodyPr/>
+                    <a:lstStyle/>
+                    <a:p>
+                      <a:r>
+                        <a:t>Origin</a:t>
+                      </a:r>
+                    </a:p>
+                  </a:txBody>
+                  <a:tcPr/>
+                </a:tc>
+                <a:tc>
+                  <a:txBody>
+                    <a:bodyPr/>
+                    <a:lstStyle/>
+                    <a:p>
+                      <a:r>
+                        <a:t>Destination</a:t>
+                      </a:r>
+                    </a:p>
+                  </a:txBody>
+                  <a:tcPr/>
+                </a:tc>
+                <a:tc>
+                  <a:txBody>
+                    <a:bodyPr/>
+                    <a:lstStyle/>
+                    <a:p>
+                      <a:r>
+                        <a:t>Author-years</a:t>
+                      </a:r>
+                    </a:p>
+                  </a:txBody>
+                  <a:tcPr/>
+                </a:tc>
+              </a:tr>
+              <a:tr h="548640">
+                <a:tc>
+                  <a:txBody>
+                    <a:bodyPr/>
+                    <a:lstStyle/>
+                    <a:p>
+                      <a:pPr>
+                        <a:defRPr sz="1000"/>
+                      </a:pPr>
+                      <a:r>
+                        <a:t>Continental Europe</a:t>
+                      </a:r>
+                    </a:p>
+                  </a:txBody>
+                  <a:tcPr/>
+                </a:tc>
+                <a:tc>
+                  <a:txBody>
+                    <a:bodyPr/>
+                    <a:lstStyle/>
+                    <a:p>
+                      <a:pPr>
+                        <a:defRPr sz="1000"/>
+                      </a:pPr>
+                      <a:r>
+                        <a:t>Continental Europe</a:t>
+                      </a:r>
+                    </a:p>
+                  </a:txBody>
+                  <a:tcPr/>
+                </a:tc>
+                <a:tc>
+                  <a:txBody>
+                    <a:bodyPr/>
+                    <a:lstStyle/>
+                    <a:p>
+                      <a:pPr>
+                        <a:defRPr sz="1000"/>
+                      </a:pPr>
+                      <a:r>
+                        <a:t>80</a:t>
+                      </a:r>
+                    </a:p>
+                  </a:txBody>
+                  <a:tcPr/>
+                </a:tc>
+              </a:tr>
+              <a:tr h="548640">
+                <a:tc>
+                  <a:txBody>
+                    <a:bodyPr/>
+                    <a:lstStyle/>
+                    <a:p>
+                      <a:pPr>
+                        <a:defRPr sz="1000"/>
+                      </a:pPr>
+                      <a:r>
+                        <a:t>Sinic</a:t>
+                      </a:r>
+                    </a:p>
+                  </a:txBody>
+                  <a:tcPr/>
+                </a:tc>
+                <a:tc>
+                  <a:txBody>
+                    <a:bodyPr/>
+                    <a:lstStyle/>
+                    <a:p>
+                      <a:pPr>
+                        <a:defRPr sz="1000"/>
+                      </a:pPr>
+                      <a:r>
+                        <a:t>Sinic</a:t>
+                      </a:r>
+                    </a:p>
+                  </a:txBody>
+                  <a:tcPr/>
+                </a:tc>
+                <a:tc>
+                  <a:txBody>
+                    <a:bodyPr/>
+                    <a:lstStyle/>
+                    <a:p>
+                      <a:pPr>
+                        <a:defRPr sz="1000"/>
+                      </a:pPr>
+                      <a:r>
+                        <a:t>78</a:t>
+                      </a:r>
+                    </a:p>
+                  </a:txBody>
+                  <a:tcPr/>
+                </a:tc>
+              </a:tr>
+              <a:tr h="548640">
+                <a:tc>
+                  <a:txBody>
+                    <a:bodyPr/>
+                    <a:lstStyle/>
+                    <a:p>
+                      <a:pPr>
+                        <a:defRPr sz="1000"/>
+                      </a:pPr>
+                      <a:r>
+                        <a:t>Anglosphere ex-US</a:t>
+                      </a:r>
+                    </a:p>
+                  </a:txBody>
+                  <a:tcPr/>
+                </a:tc>
+                <a:tc>
+                  <a:txBody>
+                    <a:bodyPr/>
+                    <a:lstStyle/>
+                    <a:p>
+                      <a:pPr>
+                        <a:defRPr sz="1000"/>
+                      </a:pPr>
+                      <a:r>
+                        <a:t>Continental Europe</a:t>
+                      </a:r>
+                    </a:p>
+                  </a:txBody>
+                  <a:tcPr/>
+                </a:tc>
+                <a:tc>
+                  <a:txBody>
+                    <a:bodyPr/>
+                    <a:lstStyle/>
+                    <a:p>
+                      <a:pPr>
+                        <a:defRPr sz="1000"/>
+                      </a:pPr>
+                      <a:r>
+                        <a:t>61</a:t>
+                      </a:r>
+                    </a:p>
+                  </a:txBody>
+                  <a:tcPr/>
+                </a:tc>
+              </a:tr>
+              <a:tr h="548640">
+                <a:tc>
+                  <a:txBody>
+                    <a:bodyPr/>
+                    <a:lstStyle/>
+                    <a:p>
+                      <a:pPr>
+                        <a:defRPr sz="1000"/>
+                      </a:pPr>
+                      <a:r>
+                        <a:t>Continental Europe</a:t>
+                      </a:r>
+                    </a:p>
+                  </a:txBody>
+                  <a:tcPr/>
+                </a:tc>
+                <a:tc>
+                  <a:txBody>
+                    <a:bodyPr/>
+                    <a:lstStyle/>
+                    <a:p>
+                      <a:pPr>
+                        <a:defRPr sz="1000"/>
+                      </a:pPr>
+                      <a:r>
+                        <a:t>Anglosphere ex-US</a:t>
+                      </a:r>
+                    </a:p>
+                  </a:txBody>
+                  <a:tcPr/>
+                </a:tc>
+                <a:tc>
+                  <a:txBody>
+                    <a:bodyPr/>
+                    <a:lstStyle/>
+                    <a:p>
+                      <a:pPr>
+                        <a:defRPr sz="1000"/>
+                      </a:pPr>
+                      <a:r>
+                        <a:t>60</a:t>
+                      </a:r>
+                    </a:p>
+                  </a:txBody>
+                  <a:tcPr/>
+                </a:tc>
+              </a:tr>
+              <a:tr h="548640">
+                <a:tc>
+                  <a:txBody>
+                    <a:bodyPr/>
+                    <a:lstStyle/>
+                    <a:p>
+                      <a:pPr>
+                        <a:defRPr sz="1000"/>
+                      </a:pPr>
+                      <a:r>
+                        <a:t>Anglosphere ex-US</a:t>
+                      </a:r>
+                    </a:p>
+                  </a:txBody>
+                  <a:tcPr/>
+                </a:tc>
+                <a:tc>
+                  <a:txBody>
+                    <a:bodyPr/>
+                    <a:lstStyle/>
+                    <a:p>
+                      <a:pPr>
+                        <a:defRPr sz="1000"/>
+                      </a:pPr>
+                      <a:r>
+                        <a:t>Anglosphere ex-US</a:t>
+                      </a:r>
+                    </a:p>
+                  </a:txBody>
+                  <a:tcPr/>
+                </a:tc>
+                <a:tc>
+                  <a:txBody>
+                    <a:bodyPr/>
+                    <a:lstStyle/>
+                    <a:p>
+                      <a:pPr>
+                        <a:defRPr sz="1000"/>
+                      </a:pPr>
+                      <a:r>
+                        <a:t>59</a:t>
+                      </a:r>
+                    </a:p>
+                  </a:txBody>
+                  <a:tcPr/>
+                </a:tc>
+              </a:tr>
+              <a:tr h="548640">
+                <a:tc>
+                  <a:txBody>
+                    <a:bodyPr/>
+                    <a:lstStyle/>
+                    <a:p>
+                      <a:pPr>
+                        <a:defRPr sz="1000"/>
+                      </a:pPr>
+                      <a:r>
+                        <a:t>United States</a:t>
+                      </a:r>
+                    </a:p>
+                  </a:txBody>
+                  <a:tcPr/>
+                </a:tc>
+                <a:tc>
+                  <a:txBody>
+                    <a:bodyPr/>
+                    <a:lstStyle/>
+                    <a:p>
+                      <a:pPr>
+                        <a:defRPr sz="1000"/>
+                      </a:pPr>
+                      <a:r>
+                        <a:t>Other Western</a:t>
+                      </a:r>
+                    </a:p>
+                  </a:txBody>
+                  <a:tcPr/>
+                </a:tc>
+                <a:tc>
+                  <a:txBody>
+                    <a:bodyPr/>
+                    <a:lstStyle/>
+                    <a:p>
+                      <a:pPr>
+                        <a:defRPr sz="1000"/>
+                      </a:pPr>
+                      <a:r>
+                        <a:t>52</a:t>
+                      </a:r>
+                    </a:p>
+                  </a:txBody>
+                  <a:tcPr/>
+                </a:tc>
+              </a:tr>
+              <a:tr h="548640">
+                <a:tc>
+                  <a:txBody>
+                    <a:bodyPr/>
+                    <a:lstStyle/>
+                    <a:p>
+                      <a:pPr>
+                        <a:defRPr sz="1000"/>
+                      </a:pPr>
+                      <a:r>
+                        <a:t>Hindu</a:t>
+                      </a:r>
+                    </a:p>
+                  </a:txBody>
+                  <a:tcPr/>
+                </a:tc>
+                <a:tc>
+                  <a:txBody>
+                    <a:bodyPr/>
+                    <a:lstStyle/>
+                    <a:p>
+                      <a:pPr>
+                        <a:defRPr sz="1000"/>
+                      </a:pPr>
+                      <a:r>
+                        <a:t>Hindu</a:t>
+                      </a:r>
+                    </a:p>
+                  </a:txBody>
+                  <a:tcPr/>
+                </a:tc>
+                <a:tc>
+                  <a:txBody>
+                    <a:bodyPr/>
+                    <a:lstStyle/>
+                    <a:p>
+                      <a:pPr>
+                        <a:defRPr sz="1000"/>
+                      </a:pPr>
+                      <a:r>
+                        <a:t>48</a:t>
+                      </a:r>
+                    </a:p>
+                  </a:txBody>
+                  <a:tcPr/>
+                </a:tc>
+              </a:tr>
+              <a:tr h="548640">
+                <a:tc>
+                  <a:txBody>
+                    <a:bodyPr/>
+                    <a:lstStyle/>
+                    <a:p>
+                      <a:pPr>
+                        <a:defRPr sz="1000"/>
+                      </a:pPr>
+                      <a:r>
+                        <a:t>Other Western</a:t>
+                      </a:r>
+                    </a:p>
+                  </a:txBody>
+                  <a:tcPr/>
+                </a:tc>
+                <a:tc>
+                  <a:txBody>
+                    <a:bodyPr/>
+                    <a:lstStyle/>
+                    <a:p>
+                      <a:pPr>
+                        <a:defRPr sz="1000"/>
+                      </a:pPr>
+                      <a:r>
+                        <a:t>Other Western</a:t>
+                      </a:r>
+                    </a:p>
+                  </a:txBody>
+                  <a:tcPr/>
+                </a:tc>
+                <a:tc>
+                  <a:txBody>
+                    <a:bodyPr/>
+                    <a:lstStyle/>
+                    <a:p>
+                      <a:pPr>
+                        <a:defRPr sz="1000"/>
+                      </a:pPr>
+                      <a:r>
+                        <a:t>43</a:t>
+                      </a:r>
+                    </a:p>
+                  </a:txBody>
+                  <a:tcPr/>
+                </a:tc>
+              </a:tr>
+              <a:tr h="548640">
+                <a:tc>
+                  <a:txBody>
+                    <a:bodyPr/>
+                    <a:lstStyle/>
+                    <a:p>
+                      <a:pPr>
+                        <a:defRPr sz="1000"/>
+                      </a:pPr>
+                      <a:r>
+                        <a:t>Continental Europe</a:t>
+                      </a:r>
+                    </a:p>
+                  </a:txBody>
+                  <a:tcPr/>
+                </a:tc>
+                <a:tc>
+                  <a:txBody>
+                    <a:bodyPr/>
+                    <a:lstStyle/>
+                    <a:p>
+                      <a:pPr>
+                        <a:defRPr sz="1000"/>
+                      </a:pPr>
+                      <a:r>
+                        <a:t>Other Western</a:t>
+                      </a:r>
+                    </a:p>
+                  </a:txBody>
+                  <a:tcPr/>
+                </a:tc>
+                <a:tc>
+                  <a:txBody>
+                    <a:bodyPr/>
+                    <a:lstStyle/>
+                    <a:p>
+                      <a:pPr>
+                        <a:defRPr sz="1000"/>
+                      </a:pPr>
+                      <a:r>
+                        <a:t>40</a:t>
+                      </a:r>
+                    </a:p>
+                  </a:txBody>
+                  <a:tcPr/>
+                </a:tc>
+              </a:tr>
+              <a:tr h="548640">
+                <a:tc>
+                  <a:txBody>
+                    <a:bodyPr/>
+                    <a:lstStyle/>
+                    <a:p>
+                      <a:pPr>
+                        <a:defRPr sz="1000"/>
+                      </a:pPr>
+                      <a:r>
+                        <a:t>United States</a:t>
+                      </a:r>
+                    </a:p>
+                  </a:txBody>
+                  <a:tcPr/>
+                </a:tc>
+                <a:tc>
+                  <a:txBody>
+                    <a:bodyPr/>
+                    <a:lstStyle/>
+                    <a:p>
+                      <a:pPr>
+                        <a:defRPr sz="1000"/>
+                      </a:pPr>
+                      <a:r>
+                        <a:t>Continental Europe</a:t>
+                      </a:r>
+                    </a:p>
+                  </a:txBody>
+                  <a:tcPr/>
+                </a:tc>
+                <a:tc>
+                  <a:txBody>
+                    <a:bodyPr/>
+                    <a:lstStyle/>
+                    <a:p>
+                      <a:pPr>
+                        <a:defRPr sz="1000"/>
+                      </a:pPr>
+                      <a:r>
+                        <a:t>38</a:t>
+                      </a:r>
+                    </a:p>
+                  </a:txBody>
+                  <a:tcPr/>
+                </a:tc>
+              </a:tr>
+            </a:tbl>
+          </a:graphicData>
+        </a:graphic>
+      </p:graphicFrame>
+    </p:spTree>
+  </p:cSld>
+  <p:clrMapOvr>
+    <a:masterClrMapping/>
+  </p:clrMapOvr>
+</p:sld>
+</file>
+
+<file path=ppt/slides/slide19.xml><?xml version="1.0" encoding="utf-8"?>
+<p:sld xmlns:a="http://schemas.openxmlformats.org/drawingml/2006/main" xmlns:p="http://schemas.openxmlformats.org/presentationml/2006/main" xmlns:r="http://schemas.openxmlformats.org/officeDocument/2006/relationships">
+  <p:cSld>
+    <p:spTree>
+      <p:nvGrpSpPr>
+        <p:cNvPr id="1" name=""/>
+        <p:cNvGrpSpPr/>
+        <p:nvPr/>
+      </p:nvGrpSpPr>
+      <p:grpSpPr/>
+      <p:sp>
+        <p:nvSpPr>
+          <p:cNvPr id="2" name="Title 1"/>
+          <p:cNvSpPr>
+            <a:spLocks noGrp="1"/>
+          </p:cNvSpPr>
+          <p:nvPr>
+            <p:ph type="title"/>
+          </p:nvPr>
+        </p:nvSpPr>
+        <p:spPr/>
+        <p:txBody>
+          <a:bodyPr/>
+          <a:lstStyle/>
+          <a:p>
+            <a:r>
+              <a:t>Table 11: Projection accuracy by civilisation, 2017-2023</a:t>
+            </a:r>
+          </a:p>
+        </p:txBody>
+      </p:sp>
+      <p:sp>
+        <p:nvSpPr>
+          <p:cNvPr id="3" name="Content Placeholder 2"/>
+          <p:cNvSpPr>
+            <a:spLocks noGrp="1"/>
+          </p:cNvSpPr>
+          <p:nvPr>
+            <p:ph idx="1" sz="half"/>
+          </p:nvPr>
+        </p:nvSpPr>
+        <p:spPr/>
+        <p:txBody>
+          <a:bodyPr/>
+          <a:lstStyle/>
+          <a:p/>
+        </p:txBody>
+      </p:sp>
+      <p:sp>
+        <p:nvSpPr>
+          <p:cNvPr id="4" name="Content Placeholder 3"/>
+          <p:cNvSpPr>
+            <a:spLocks noGrp="1"/>
+          </p:cNvSpPr>
+          <p:nvPr>
+            <p:ph idx="2" sz="half"/>
+          </p:nvPr>
+        </p:nvSpPr>
+        <p:spPr/>
+        <p:txBody>
+          <a:bodyPr/>
+          <a:lstStyle/>
+          <a:p/>
+        </p:txBody>
+      </p:sp>
+      <p:graphicFrame>
+        <p:nvGraphicFramePr>
+          <p:cNvPr id="5" name="Table 4"/>
+          <p:cNvGraphicFramePr>
+            <a:graphicFrameLocks noGrp="1"/>
+          </p:cNvGraphicFramePr>
+          <p:nvPr/>
+        </p:nvGraphicFramePr>
+        <p:xfrm>
+          <a:off x="457200" y="1097280"/>
+          <a:ext cx="6035040" cy="5486400"/>
+        </p:xfrm>
+        <a:graphic>
+          <a:graphicData uri="http://schemas.openxmlformats.org/drawingml/2006/table">
+            <a:tbl>
+              <a:tblPr firstRow="1" bandRow="1">
+                <a:tableStyleId>{5C22544A-7EE6-4342-B048-85BDC9FD1C3A}</a:tableStyleId>
+              </a:tblPr>
+              <a:tblGrid>
+                <a:gridCol w="2011680"/>
+                <a:gridCol w="2011680"/>
+                <a:gridCol w="2011680"/>
+              </a:tblGrid>
+              <a:tr h="548640">
+                <a:tc>
+                  <a:txBody>
+                    <a:bodyPr/>
+                    <a:lstStyle/>
+                    <a:p>
+                      <a:r>
+                        <a:t>Group</a:t>
+                      </a:r>
+                    </a:p>
+                  </a:txBody>
+                  <a:tcPr/>
+                </a:tc>
+                <a:tc>
+                  <a:txBody>
+                    <a:bodyPr/>
+                    <a:lstStyle/>
+                    <a:p>
+                      <a:r>
+                        <a:t>RMSE</a:t>
+                      </a:r>
+                    </a:p>
+                  </a:txBody>
+                  <a:tcPr/>
+                </a:tc>
+                <a:tc>
+                  <a:txBody>
+                    <a:bodyPr/>
+                    <a:lstStyle/>
+                    <a:p>
+                      <a:r>
+                        <a:t>MAPE</a:t>
+                      </a:r>
+                    </a:p>
+                  </a:txBody>
+                  <a:tcPr/>
+                </a:tc>
+              </a:tr>
+              <a:tr h="548640">
+                <a:tc>
+                  <a:txBody>
+                    <a:bodyPr/>
+                    <a:lstStyle/>
+                    <a:p>
+                      <a:pPr>
+                        <a:defRPr sz="1000"/>
+                      </a:pPr>
+                      <a:r>
+                        <a:t>Anglosphere ex-US</a:t>
+                      </a:r>
+                    </a:p>
+                  </a:txBody>
+                  <a:tcPr/>
+                </a:tc>
+                <a:tc>
+                  <a:txBody>
+                    <a:bodyPr/>
+                    <a:lstStyle/>
+                    <a:p>
+                      <a:pPr>
+                        <a:defRPr sz="1000"/>
+                      </a:pPr>
+                      <a:r>
+                        <a:t>1.79</a:t>
+                      </a:r>
+                    </a:p>
+                  </a:txBody>
+                  <a:tcPr/>
+                </a:tc>
+                <a:tc>
+                  <a:txBody>
+                    <a:bodyPr/>
+                    <a:lstStyle/>
+                    <a:p>
+                      <a:pPr>
+                        <a:defRPr sz="1000"/>
+                      </a:pPr>
+                      <a:r>
+                        <a:t>24.5%</a:t>
+                      </a:r>
+                    </a:p>
+                  </a:txBody>
+                  <a:tcPr/>
+                </a:tc>
+              </a:tr>
+              <a:tr h="548640">
+                <a:tc>
+                  <a:txBody>
+                    <a:bodyPr/>
+                    <a:lstStyle/>
+                    <a:p>
+                      <a:pPr>
+                        <a:defRPr sz="1000"/>
+                      </a:pPr>
+                      <a:r>
+                        <a:t>Continental Europe</a:t>
+                      </a:r>
+                    </a:p>
+                  </a:txBody>
+                  <a:tcPr/>
+                </a:tc>
+                <a:tc>
+                  <a:txBody>
+                    <a:bodyPr/>
+                    <a:lstStyle/>
+                    <a:p>
+                      <a:pPr>
+                        <a:defRPr sz="1000"/>
+                      </a:pPr>
+                      <a:r>
+                        <a:t>2.12</a:t>
+                      </a:r>
+                    </a:p>
+                  </a:txBody>
+                  <a:tcPr/>
+                </a:tc>
+                <a:tc>
+                  <a:txBody>
+                    <a:bodyPr/>
+                    <a:lstStyle/>
+                    <a:p>
+                      <a:pPr>
+                        <a:defRPr sz="1000"/>
+                      </a:pPr>
+                      <a:r>
+                        <a:t>28.5%</a:t>
+                      </a:r>
+                    </a:p>
+                  </a:txBody>
+                  <a:tcPr/>
+                </a:tc>
+              </a:tr>
+              <a:tr h="548640">
+                <a:tc>
+                  <a:txBody>
+                    <a:bodyPr/>
+                    <a:lstStyle/>
+                    <a:p>
+                      <a:pPr>
+                        <a:defRPr sz="1000"/>
+                      </a:pPr>
+                      <a:r>
+                        <a:t>Hindu</a:t>
+                      </a:r>
+                    </a:p>
+                  </a:txBody>
+                  <a:tcPr/>
+                </a:tc>
+                <a:tc>
+                  <a:txBody>
+                    <a:bodyPr/>
+                    <a:lstStyle/>
+                    <a:p>
+                      <a:pPr>
+                        <a:defRPr sz="1000"/>
+                      </a:pPr>
+                      <a:r>
+                        <a:t>1.56</a:t>
+                      </a:r>
+                    </a:p>
+                  </a:txBody>
+                  <a:tcPr/>
+                </a:tc>
+                <a:tc>
+                  <a:txBody>
+                    <a:bodyPr/>
+                    <a:lstStyle/>
+                    <a:p>
+                      <a:pPr>
+                        <a:defRPr sz="1000"/>
+                      </a:pPr>
+                      <a:r>
+                        <a:t>30.5%</a:t>
+                      </a:r>
+                    </a:p>
+                  </a:txBody>
+                  <a:tcPr/>
+                </a:tc>
+              </a:tr>
+              <a:tr h="548640">
+                <a:tc>
+                  <a:txBody>
+                    <a:bodyPr/>
+                    <a:lstStyle/>
+                    <a:p>
+                      <a:pPr>
+                        <a:defRPr sz="1000"/>
+                      </a:pPr>
+                      <a:r>
+                        <a:t>Islamic</a:t>
+                      </a:r>
+                    </a:p>
+                  </a:txBody>
+                  <a:tcPr/>
+                </a:tc>
+                <a:tc>
+                  <a:txBody>
+                    <a:bodyPr/>
+                    <a:lstStyle/>
+                    <a:p>
+                      <a:pPr>
+                        <a:defRPr sz="1000"/>
+                      </a:pPr>
+                      <a:r>
+                        <a:t>3.05</a:t>
+                      </a:r>
+                    </a:p>
+                  </a:txBody>
+                  <a:tcPr/>
+                </a:tc>
+                <a:tc>
+                  <a:txBody>
+                    <a:bodyPr/>
+                    <a:lstStyle/>
+                    <a:p>
+                      <a:pPr>
+                        <a:defRPr sz="1000"/>
+                      </a:pPr>
+                      <a:r>
+                        <a:t>48.0%</a:t>
+                      </a:r>
+                    </a:p>
+                  </a:txBody>
+                  <a:tcPr/>
+                </a:tc>
+              </a:tr>
+              <a:tr h="548640">
+                <a:tc>
+                  <a:txBody>
+                    <a:bodyPr/>
+                    <a:lstStyle/>
+                    <a:p>
+                      <a:pPr>
+                        <a:defRPr sz="1000"/>
+                      </a:pPr>
+                      <a:r>
+                        <a:t>Japanese</a:t>
+                      </a:r>
+                    </a:p>
+                  </a:txBody>
+                  <a:tcPr/>
+                </a:tc>
+                <a:tc>
+                  <a:txBody>
+                    <a:bodyPr/>
+                    <a:lstStyle/>
+                    <a:p>
+                      <a:pPr>
+                        <a:defRPr sz="1000"/>
+                      </a:pPr>
+                      <a:r>
+                        <a:t>1.23</a:t>
+                      </a:r>
+                    </a:p>
+                  </a:txBody>
+                  <a:tcPr/>
+                </a:tc>
+                <a:tc>
+                  <a:txBody>
+                    <a:bodyPr/>
+                    <a:lstStyle/>
+                    <a:p>
+                      <a:pPr>
+                        <a:defRPr sz="1000"/>
+                      </a:pPr>
+                      <a:r>
+                        <a:t>32.3%</a:t>
+                      </a:r>
+                    </a:p>
+                  </a:txBody>
+                  <a:tcPr/>
+                </a:tc>
+              </a:tr>
+              <a:tr h="548640">
+                <a:tc>
+                  <a:txBody>
+                    <a:bodyPr/>
+                    <a:lstStyle/>
+                    <a:p>
+                      <a:pPr>
+                        <a:defRPr sz="1000"/>
+                      </a:pPr>
+                      <a:r>
+                        <a:t>Other Civilizations</a:t>
+                      </a:r>
+                    </a:p>
+                  </a:txBody>
+                  <a:tcPr/>
+                </a:tc>
+                <a:tc>
+                  <a:txBody>
+                    <a:bodyPr/>
+                    <a:lstStyle/>
+                    <a:p>
+                      <a:pPr>
+                        <a:defRPr sz="1000"/>
+                      </a:pPr>
+                      <a:r>
+                        <a:t>1.72</a:t>
+                      </a:r>
+                    </a:p>
+                  </a:txBody>
+                  <a:tcPr/>
+                </a:tc>
+                <a:tc>
+                  <a:txBody>
+                    <a:bodyPr/>
+                    <a:lstStyle/>
+                    <a:p>
+                      <a:pPr>
+                        <a:defRPr sz="1000"/>
+                      </a:pPr>
+                      <a:r>
+                        <a:t>36.7%</a:t>
+                      </a:r>
+                    </a:p>
+                  </a:txBody>
+                  <a:tcPr/>
+                </a:tc>
+              </a:tr>
+              <a:tr h="548640">
+                <a:tc>
+                  <a:txBody>
+                    <a:bodyPr/>
+                    <a:lstStyle/>
+                    <a:p>
+                      <a:pPr>
+                        <a:defRPr sz="1000"/>
+                      </a:pPr>
+                      <a:r>
+                        <a:t>Other Western</a:t>
+                      </a:r>
+                    </a:p>
+                  </a:txBody>
+                  <a:tcPr/>
+                </a:tc>
+                <a:tc>
+                  <a:txBody>
+                    <a:bodyPr/>
+                    <a:lstStyle/>
+                    <a:p>
+                      <a:pPr>
+                        <a:defRPr sz="1000"/>
+                      </a:pPr>
+                      <a:r>
+                        <a:t>2.22</a:t>
+                      </a:r>
+                    </a:p>
+                  </a:txBody>
+                  <a:tcPr/>
+                </a:tc>
+                <a:tc>
+                  <a:txBody>
+                    <a:bodyPr/>
+                    <a:lstStyle/>
+                    <a:p>
+                      <a:pPr>
+                        <a:defRPr sz="1000"/>
+                      </a:pPr>
+                      <a:r>
+                        <a:t>34.8%</a:t>
+                      </a:r>
+                    </a:p>
+                  </a:txBody>
+                  <a:tcPr/>
+                </a:tc>
+              </a:tr>
+              <a:tr h="548640">
+                <a:tc>
+                  <a:txBody>
+                    <a:bodyPr/>
+                    <a:lstStyle/>
+                    <a:p>
+                      <a:pPr>
+                        <a:defRPr sz="1000"/>
+                      </a:pPr>
+                      <a:r>
+                        <a:t>Sinic</a:t>
+                      </a:r>
+                    </a:p>
+                  </a:txBody>
+                  <a:tcPr/>
+                </a:tc>
+                <a:tc>
+                  <a:txBody>
+                    <a:bodyPr/>
+                    <a:lstStyle/>
+                    <a:p>
+                      <a:pPr>
+                        <a:defRPr sz="1000"/>
+                      </a:pPr>
+                      <a:r>
+                        <a:t>4.43</a:t>
+                      </a:r>
+                    </a:p>
+                  </a:txBody>
+                  <a:tcPr/>
+                </a:tc>
+                <a:tc>
+                  <a:txBody>
+                    <a:bodyPr/>
+                    <a:lstStyle/>
+                    <a:p>
+                      <a:pPr>
+                        <a:defRPr sz="1000"/>
+                      </a:pPr>
+                      <a:r>
+                        <a:t>54.5%</a:t>
+                      </a:r>
+                    </a:p>
+                  </a:txBody>
+                  <a:tcPr/>
+                </a:tc>
+              </a:tr>
+              <a:tr h="548640">
+                <a:tc>
+                  <a:txBody>
+                    <a:bodyPr/>
+                    <a:lstStyle/>
+                    <a:p>
+                      <a:pPr>
+                        <a:defRPr sz="1000"/>
+                      </a:pPr>
+                      <a:r>
+                        <a:t>United States</a:t>
+                      </a:r>
+                    </a:p>
+                  </a:txBody>
+                  <a:tcPr/>
+                </a:tc>
+                <a:tc>
+                  <a:txBody>
+                    <a:bodyPr/>
+                    <a:lstStyle/>
+                    <a:p>
+                      <a:pPr>
+                        <a:defRPr sz="1000"/>
+                      </a:pPr>
+                      <a:r>
+                        <a:t>3.87</a:t>
+                      </a:r>
+                    </a:p>
+                  </a:txBody>
+                  <a:tcPr/>
+                </a:tc>
+                <a:tc>
+                  <a:txBody>
+                    <a:bodyPr/>
+                    <a:lstStyle/>
+                    <a:p>
+                      <a:pPr>
+                        <a:defRPr sz="1000"/>
+                      </a:pPr>
+                      <a:r>
+                        <a:t>33.6%</a:t>
+                      </a:r>
+                    </a:p>
+                  </a:txBody>
+                  <a:tcPr/>
+                </a:tc>
+              </a:tr>
+            </a:tbl>
+          </a:graphicData>
+        </a:graphic>
+      </p:graphicFrame>
+    </p:spTree>
+  </p:cSld>
+  <p:clrMapOvr>
+    <a:masterClrMapping/>
+  </p:clrMapOvr>
+</p:sld>
+</file>
+
 <file path=ppt/slides/slide2.xml><?xml version="1.0" encoding="utf-8"?>
 <p:sld xmlns:a="http://schemas.openxmlformats.org/drawingml/2006/main" xmlns:p="http://schemas.openxmlformats.org/presentationml/2006/main" xmlns:r="http://schemas.openxmlformats.org/officeDocument/2006/relationships">
   <p:cSld>
@@ -6460,6 +9173,426 @@
           </a:p>
         </p:txBody>
       </p:sp>
+    </p:spTree>
+  </p:cSld>
+  <p:clrMapOvr>
+    <a:masterClrMapping/>
+  </p:clrMapOvr>
+</p:sld>
+</file>
+
+<file path=ppt/slides/slide20.xml><?xml version="1.0" encoding="utf-8"?>
+<p:sld xmlns:a="http://schemas.openxmlformats.org/drawingml/2006/main" xmlns:p="http://schemas.openxmlformats.org/presentationml/2006/main" xmlns:r="http://schemas.openxmlformats.org/officeDocument/2006/relationships">
+  <p:cSld>
+    <p:spTree>
+      <p:nvGrpSpPr>
+        <p:cNvPr id="1" name=""/>
+        <p:cNvGrpSpPr/>
+        <p:nvPr/>
+      </p:nvGrpSpPr>
+      <p:grpSpPr/>
+      <p:sp>
+        <p:nvSpPr>
+          <p:cNvPr id="2" name="Title 1"/>
+          <p:cNvSpPr>
+            <a:spLocks noGrp="1"/>
+          </p:cNvSpPr>
+          <p:nvPr>
+            <p:ph type="title"/>
+          </p:nvPr>
+        </p:nvSpPr>
+        <p:spPr/>
+        <p:txBody>
+          <a:bodyPr/>
+          <a:lstStyle/>
+          <a:p>
+            <a:r>
+              <a:t>Table 12: Projection accuracy by compartment, 2017-2023</a:t>
+            </a:r>
+          </a:p>
+        </p:txBody>
+      </p:sp>
+      <p:sp>
+        <p:nvSpPr>
+          <p:cNvPr id="3" name="Content Placeholder 2"/>
+          <p:cNvSpPr>
+            <a:spLocks noGrp="1"/>
+          </p:cNvSpPr>
+          <p:nvPr>
+            <p:ph idx="1" sz="half"/>
+          </p:nvPr>
+        </p:nvSpPr>
+        <p:spPr/>
+        <p:txBody>
+          <a:bodyPr/>
+          <a:lstStyle/>
+          <a:p/>
+        </p:txBody>
+      </p:sp>
+      <p:sp>
+        <p:nvSpPr>
+          <p:cNvPr id="4" name="Content Placeholder 3"/>
+          <p:cNvSpPr>
+            <a:spLocks noGrp="1"/>
+          </p:cNvSpPr>
+          <p:nvPr>
+            <p:ph idx="2" sz="half"/>
+          </p:nvPr>
+        </p:nvSpPr>
+        <p:spPr/>
+        <p:txBody>
+          <a:bodyPr/>
+          <a:lstStyle/>
+          <a:p/>
+        </p:txBody>
+      </p:sp>
+      <p:graphicFrame>
+        <p:nvGraphicFramePr>
+          <p:cNvPr id="5" name="Table 4"/>
+          <p:cNvGraphicFramePr>
+            <a:graphicFrameLocks noGrp="1"/>
+          </p:cNvGraphicFramePr>
+          <p:nvPr/>
+        </p:nvGraphicFramePr>
+        <p:xfrm>
+          <a:off x="457200" y="1097280"/>
+          <a:ext cx="6035040" cy="3840480"/>
+        </p:xfrm>
+        <a:graphic>
+          <a:graphicData uri="http://schemas.openxmlformats.org/drawingml/2006/table">
+            <a:tbl>
+              <a:tblPr firstRow="1" bandRow="1">
+                <a:tableStyleId>{5C22544A-7EE6-4342-B048-85BDC9FD1C3A}</a:tableStyleId>
+              </a:tblPr>
+              <a:tblGrid>
+                <a:gridCol w="2011680"/>
+                <a:gridCol w="2011680"/>
+                <a:gridCol w="2011680"/>
+              </a:tblGrid>
+              <a:tr h="548640">
+                <a:tc>
+                  <a:txBody>
+                    <a:bodyPr/>
+                    <a:lstStyle/>
+                    <a:p>
+                      <a:r>
+                        <a:t>Compartment</a:t>
+                      </a:r>
+                    </a:p>
+                  </a:txBody>
+                  <a:tcPr/>
+                </a:tc>
+                <a:tc>
+                  <a:txBody>
+                    <a:bodyPr/>
+                    <a:lstStyle/>
+                    <a:p>
+                      <a:r>
+                        <a:t>RMSE</a:t>
+                      </a:r>
+                    </a:p>
+                  </a:txBody>
+                  <a:tcPr/>
+                </a:tc>
+                <a:tc>
+                  <a:txBody>
+                    <a:bodyPr/>
+                    <a:lstStyle/>
+                    <a:p>
+                      <a:r>
+                        <a:t>MAPE</a:t>
+                      </a:r>
+                    </a:p>
+                  </a:txBody>
+                  <a:tcPr/>
+                </a:tc>
+              </a:tr>
+              <a:tr h="548640">
+                <a:tc>
+                  <a:txBody>
+                    <a:bodyPr/>
+                    <a:lstStyle/>
+                    <a:p>
+                      <a:pPr>
+                        <a:defRPr sz="1000"/>
+                      </a:pPr>
+                      <a:r>
+                        <a:t>A</a:t>
+                      </a:r>
+                    </a:p>
+                  </a:txBody>
+                  <a:tcPr/>
+                </a:tc>
+                <a:tc>
+                  <a:txBody>
+                    <a:bodyPr/>
+                    <a:lstStyle/>
+                    <a:p>
+                      <a:pPr>
+                        <a:defRPr sz="1000"/>
+                      </a:pPr>
+                      <a:r>
+                        <a:t>0.86</a:t>
+                      </a:r>
+                    </a:p>
+                  </a:txBody>
+                  <a:tcPr/>
+                </a:tc>
+                <a:tc>
+                  <a:txBody>
+                    <a:bodyPr/>
+                    <a:lstStyle/>
+                    <a:p>
+                      <a:pPr>
+                        <a:defRPr sz="1000"/>
+                      </a:pPr>
+                      <a:r>
+                        <a:t>55.0%</a:t>
+                      </a:r>
+                    </a:p>
+                  </a:txBody>
+                  <a:tcPr/>
+                </a:tc>
+              </a:tr>
+              <a:tr h="548640">
+                <a:tc>
+                  <a:txBody>
+                    <a:bodyPr/>
+                    <a:lstStyle/>
+                    <a:p>
+                      <a:pPr>
+                        <a:defRPr sz="1000"/>
+                      </a:pPr>
+                      <a:r>
+                        <a:t>D</a:t>
+                      </a:r>
+                    </a:p>
+                  </a:txBody>
+                  <a:tcPr/>
+                </a:tc>
+                <a:tc>
+                  <a:txBody>
+                    <a:bodyPr/>
+                    <a:lstStyle/>
+                    <a:p>
+                      <a:pPr>
+                        <a:defRPr sz="1000"/>
+                      </a:pPr>
+                      <a:r>
+                        <a:t>1.51</a:t>
+                      </a:r>
+                    </a:p>
+                  </a:txBody>
+                  <a:tcPr/>
+                </a:tc>
+                <a:tc>
+                  <a:txBody>
+                    <a:bodyPr/>
+                    <a:lstStyle/>
+                    <a:p>
+                      <a:pPr>
+                        <a:defRPr sz="1000"/>
+                      </a:pPr>
+                      <a:r>
+                        <a:t>21.1%</a:t>
+                      </a:r>
+                    </a:p>
+                  </a:txBody>
+                  <a:tcPr/>
+                </a:tc>
+              </a:tr>
+              <a:tr h="548640">
+                <a:tc>
+                  <a:txBody>
+                    <a:bodyPr/>
+                    <a:lstStyle/>
+                    <a:p>
+                      <a:pPr>
+                        <a:defRPr sz="1000"/>
+                      </a:pPr>
+                      <a:r>
+                        <a:t>H_A</a:t>
+                      </a:r>
+                    </a:p>
+                  </a:txBody>
+                  <a:tcPr/>
+                </a:tc>
+                <a:tc>
+                  <a:txBody>
+                    <a:bodyPr/>
+                    <a:lstStyle/>
+                    <a:p>
+                      <a:pPr>
+                        <a:defRPr sz="1000"/>
+                      </a:pPr>
+                      <a:r>
+                        <a:t>1.52</a:t>
+                      </a:r>
+                    </a:p>
+                  </a:txBody>
+                  <a:tcPr/>
+                </a:tc>
+                <a:tc>
+                  <a:txBody>
+                    <a:bodyPr/>
+                    <a:lstStyle/>
+                    <a:p>
+                      <a:pPr>
+                        <a:defRPr sz="1000"/>
+                      </a:pPr>
+                      <a:r>
+                        <a:t>27.6%</a:t>
+                      </a:r>
+                    </a:p>
+                  </a:txBody>
+                  <a:tcPr/>
+                </a:tc>
+              </a:tr>
+              <a:tr h="548640">
+                <a:tc>
+                  <a:txBody>
+                    <a:bodyPr/>
+                    <a:lstStyle/>
+                    <a:p>
+                      <a:pPr>
+                        <a:defRPr sz="1000"/>
+                      </a:pPr>
+                      <a:r>
+                        <a:t>H_D</a:t>
+                      </a:r>
+                    </a:p>
+                  </a:txBody>
+                  <a:tcPr/>
+                </a:tc>
+                <a:tc>
+                  <a:txBody>
+                    <a:bodyPr/>
+                    <a:lstStyle/>
+                    <a:p>
+                      <a:pPr>
+                        <a:defRPr sz="1000"/>
+                      </a:pPr>
+                      <a:r>
+                        <a:t>4.68</a:t>
+                      </a:r>
+                    </a:p>
+                  </a:txBody>
+                  <a:tcPr/>
+                </a:tc>
+                <a:tc>
+                  <a:txBody>
+                    <a:bodyPr/>
+                    <a:lstStyle/>
+                    <a:p>
+                      <a:pPr>
+                        <a:defRPr sz="1000"/>
+                      </a:pPr>
+                      <a:r>
+                        <a:t>32.3%</a:t>
+                      </a:r>
+                    </a:p>
+                  </a:txBody>
+                  <a:tcPr/>
+                </a:tc>
+              </a:tr>
+              <a:tr h="548640">
+                <a:tc>
+                  <a:txBody>
+                    <a:bodyPr/>
+                    <a:lstStyle/>
+                    <a:p>
+                      <a:pPr>
+                        <a:defRPr sz="1000"/>
+                      </a:pPr>
+                      <a:r>
+                        <a:t>P_A</a:t>
+                      </a:r>
+                    </a:p>
+                  </a:txBody>
+                  <a:tcPr/>
+                </a:tc>
+                <a:tc>
+                  <a:txBody>
+                    <a:bodyPr/>
+                    <a:lstStyle/>
+                    <a:p>
+                      <a:pPr>
+                        <a:defRPr sz="1000"/>
+                      </a:pPr>
+                      <a:r>
+                        <a:t>1.99</a:t>
+                      </a:r>
+                    </a:p>
+                  </a:txBody>
+                  <a:tcPr/>
+                </a:tc>
+                <a:tc>
+                  <a:txBody>
+                    <a:bodyPr/>
+                    <a:lstStyle/>
+                    <a:p>
+                      <a:pPr>
+                        <a:defRPr sz="1000"/>
+                      </a:pPr>
+                      <a:r>
+                        <a:t>46.9%</a:t>
+                      </a:r>
+                    </a:p>
+                  </a:txBody>
+                  <a:tcPr/>
+                </a:tc>
+              </a:tr>
+              <a:tr h="548640">
+                <a:tc>
+                  <a:txBody>
+                    <a:bodyPr/>
+                    <a:lstStyle/>
+                    <a:p>
+                      <a:pPr>
+                        <a:defRPr sz="1000"/>
+                      </a:pPr>
+                      <a:r>
+                        <a:t>P_D</a:t>
+                      </a:r>
+                    </a:p>
+                  </a:txBody>
+                  <a:tcPr/>
+                </a:tc>
+                <a:tc>
+                  <a:txBody>
+                    <a:bodyPr/>
+                    <a:lstStyle/>
+                    <a:p>
+                      <a:pPr>
+                        <a:defRPr sz="1000"/>
+                      </a:pPr>
+                      <a:r>
+                        <a:t>3.33</a:t>
+                      </a:r>
+                    </a:p>
+                  </a:txBody>
+                  <a:tcPr/>
+                </a:tc>
+                <a:tc>
+                  <a:txBody>
+                    <a:bodyPr/>
+                    <a:lstStyle/>
+                    <a:p>
+                      <a:pPr>
+                        <a:defRPr sz="1000"/>
+                      </a:pPr>
+                      <a:r>
+                        <a:t>32.7%</a:t>
+                      </a:r>
+                    </a:p>
+                  </a:txBody>
+                  <a:tcPr/>
+                </a:tc>
+              </a:tr>
+            </a:tbl>
+          </a:graphicData>
+        </a:graphic>
+      </p:graphicFrame>
     </p:spTree>
   </p:cSld>
   <p:clrMapOvr>

</xml_diff>

<commit_message>
Add T/M column and integer counts; annotate Fig1; expand diversity dead-end discussion
Co-Authored-By: Tatsuki Onishi <bougtoir@gmail.com>
</commit_message>
<xml_diff>
--- a/researcher_mobility_ode/docs/manuscript_full_article_figures.pptx
+++ b/researcher_mobility_ode/docs/manuscript_full_article_figures.pptx
@@ -3321,22 +3321,22 @@
                         <a:defRPr sz="1000"/>
                       </a:pPr>
                       <a:r>
-                        <a:t>752.12</a:t>
-                      </a:r>
-                    </a:p>
-                  </a:txBody>
-                  <a:tcPr/>
-                </a:tc>
-                <a:tc>
-                  <a:txBody>
-                    <a:bodyPr/>
-                    <a:lstStyle/>
-                    <a:p>
-                      <a:pPr>
-                        <a:defRPr sz="1000"/>
-                      </a:pPr>
-                      <a:r>
-                        <a:t>411.20</a:t>
+                        <a:t>752</a:t>
+                      </a:r>
+                    </a:p>
+                  </a:txBody>
+                  <a:tcPr/>
+                </a:tc>
+                <a:tc>
+                  <a:txBody>
+                    <a:bodyPr/>
+                    <a:lstStyle/>
+                    <a:p>
+                      <a:pPr>
+                        <a:defRPr sz="1000"/>
+                      </a:pPr>
+                      <a:r>
+                        <a:t>411</a:t>
                       </a:r>
                     </a:p>
                   </a:txBody>
@@ -3383,22 +3383,22 @@
                         <a:defRPr sz="1000"/>
                       </a:pPr>
                       <a:r>
-                        <a:t>1208.42</a:t>
-                      </a:r>
-                    </a:p>
-                  </a:txBody>
-                  <a:tcPr/>
-                </a:tc>
-                <a:tc>
-                  <a:txBody>
-                    <a:bodyPr/>
-                    <a:lstStyle/>
-                    <a:p>
-                      <a:pPr>
-                        <a:defRPr sz="1000"/>
-                      </a:pPr>
-                      <a:r>
-                        <a:t>659.04</a:t>
+                        <a:t>1208</a:t>
+                      </a:r>
+                    </a:p>
+                  </a:txBody>
+                  <a:tcPr/>
+                </a:tc>
+                <a:tc>
+                  <a:txBody>
+                    <a:bodyPr/>
+                    <a:lstStyle/>
+                    <a:p>
+                      <a:pPr>
+                        <a:defRPr sz="1000"/>
+                      </a:pPr>
+                      <a:r>
+                        <a:t>659</a:t>
                       </a:r>
                     </a:p>
                   </a:txBody>
@@ -3445,22 +3445,22 @@
                         <a:defRPr sz="1000"/>
                       </a:pPr>
                       <a:r>
-                        <a:t>1497.37</a:t>
-                      </a:r>
-                    </a:p>
-                  </a:txBody>
-                  <a:tcPr/>
-                </a:tc>
-                <a:tc>
-                  <a:txBody>
-                    <a:bodyPr/>
-                    <a:lstStyle/>
-                    <a:p>
-                      <a:pPr>
-                        <a:defRPr sz="1000"/>
-                      </a:pPr>
-                      <a:r>
-                        <a:t>781.23</a:t>
+                        <a:t>1497</a:t>
+                      </a:r>
+                    </a:p>
+                  </a:txBody>
+                  <a:tcPr/>
+                </a:tc>
+                <a:tc>
+                  <a:txBody>
+                    <a:bodyPr/>
+                    <a:lstStyle/>
+                    <a:p>
+                      <a:pPr>
+                        <a:defRPr sz="1000"/>
+                      </a:pPr>
+                      <a:r>
+                        <a:t>781</a:t>
                       </a:r>
                     </a:p>
                   </a:txBody>
@@ -3507,22 +3507,22 @@
                         <a:defRPr sz="1000"/>
                       </a:pPr>
                       <a:r>
-                        <a:t>892.42</a:t>
-                      </a:r>
-                    </a:p>
-                  </a:txBody>
-                  <a:tcPr/>
-                </a:tc>
-                <a:tc>
-                  <a:txBody>
-                    <a:bodyPr/>
-                    <a:lstStyle/>
-                    <a:p>
-                      <a:pPr>
-                        <a:defRPr sz="1000"/>
-                      </a:pPr>
-                      <a:r>
-                        <a:t>469.06</a:t>
+                        <a:t>892</a:t>
+                      </a:r>
+                    </a:p>
+                  </a:txBody>
+                  <a:tcPr/>
+                </a:tc>
+                <a:tc>
+                  <a:txBody>
+                    <a:bodyPr/>
+                    <a:lstStyle/>
+                    <a:p>
+                      <a:pPr>
+                        <a:defRPr sz="1000"/>
+                      </a:pPr>
+                      <a:r>
+                        <a:t>469</a:t>
                       </a:r>
                     </a:p>
                   </a:txBody>
@@ -3569,22 +3569,22 @@
                         <a:defRPr sz="1000"/>
                       </a:pPr>
                       <a:r>
-                        <a:t>206.81</a:t>
-                      </a:r>
-                    </a:p>
-                  </a:txBody>
-                  <a:tcPr/>
-                </a:tc>
-                <a:tc>
-                  <a:txBody>
-                    <a:bodyPr/>
-                    <a:lstStyle/>
-                    <a:p>
-                      <a:pPr>
-                        <a:defRPr sz="1000"/>
-                      </a:pPr>
-                      <a:r>
-                        <a:t>129.35</a:t>
+                        <a:t>207</a:t>
+                      </a:r>
+                    </a:p>
+                  </a:txBody>
+                  <a:tcPr/>
+                </a:tc>
+                <a:tc>
+                  <a:txBody>
+                    <a:bodyPr/>
+                    <a:lstStyle/>
+                    <a:p>
+                      <a:pPr>
+                        <a:defRPr sz="1000"/>
+                      </a:pPr>
+                      <a:r>
+                        <a:t>129</a:t>
                       </a:r>
                     </a:p>
                   </a:txBody>
@@ -3631,22 +3631,22 @@
                         <a:defRPr sz="1000"/>
                       </a:pPr>
                       <a:r>
-                        <a:t>424.70</a:t>
-                      </a:r>
-                    </a:p>
-                  </a:txBody>
-                  <a:tcPr/>
-                </a:tc>
-                <a:tc>
-                  <a:txBody>
-                    <a:bodyPr/>
-                    <a:lstStyle/>
-                    <a:p>
-                      <a:pPr>
-                        <a:defRPr sz="1000"/>
-                      </a:pPr>
-                      <a:r>
-                        <a:t>234.34</a:t>
+                        <a:t>425</a:t>
+                      </a:r>
+                    </a:p>
+                  </a:txBody>
+                  <a:tcPr/>
+                </a:tc>
+                <a:tc>
+                  <a:txBody>
+                    <a:bodyPr/>
+                    <a:lstStyle/>
+                    <a:p>
+                      <a:pPr>
+                        <a:defRPr sz="1000"/>
+                      </a:pPr>
+                      <a:r>
+                        <a:t>234</a:t>
                       </a:r>
                     </a:p>
                   </a:txBody>
@@ -3693,22 +3693,22 @@
                         <a:defRPr sz="1000"/>
                       </a:pPr>
                       <a:r>
-                        <a:t>513.12</a:t>
-                      </a:r>
-                    </a:p>
-                  </a:txBody>
-                  <a:tcPr/>
-                </a:tc>
-                <a:tc>
-                  <a:txBody>
-                    <a:bodyPr/>
-                    <a:lstStyle/>
-                    <a:p>
-                      <a:pPr>
-                        <a:defRPr sz="1000"/>
-                      </a:pPr>
-                      <a:r>
-                        <a:t>270.32</a:t>
+                        <a:t>513</a:t>
+                      </a:r>
+                    </a:p>
+                  </a:txBody>
+                  <a:tcPr/>
+                </a:tc>
+                <a:tc>
+                  <a:txBody>
+                    <a:bodyPr/>
+                    <a:lstStyle/>
+                    <a:p>
+                      <a:pPr>
+                        <a:defRPr sz="1000"/>
+                      </a:pPr>
+                      <a:r>
+                        <a:t>270</a:t>
                       </a:r>
                     </a:p>
                   </a:txBody>
@@ -3755,22 +3755,22 @@
                         <a:defRPr sz="1000"/>
                       </a:pPr>
                       <a:r>
-                        <a:t>1783.64</a:t>
-                      </a:r>
-                    </a:p>
-                  </a:txBody>
-                  <a:tcPr/>
-                </a:tc>
-                <a:tc>
-                  <a:txBody>
-                    <a:bodyPr/>
-                    <a:lstStyle/>
-                    <a:p>
-                      <a:pPr>
-                        <a:defRPr sz="1000"/>
-                      </a:pPr>
-                      <a:r>
-                        <a:t>940.82</a:t>
+                        <a:t>1784</a:t>
+                      </a:r>
+                    </a:p>
+                  </a:txBody>
+                  <a:tcPr/>
+                </a:tc>
+                <a:tc>
+                  <a:txBody>
+                    <a:bodyPr/>
+                    <a:lstStyle/>
+                    <a:p>
+                      <a:pPr>
+                        <a:defRPr sz="1000"/>
+                      </a:pPr>
+                      <a:r>
+                        <a:t>941</a:t>
                       </a:r>
                     </a:p>
                   </a:txBody>
@@ -3817,22 +3817,22 @@
                         <a:defRPr sz="1000"/>
                       </a:pPr>
                       <a:r>
-                        <a:t>770.21</a:t>
-                      </a:r>
-                    </a:p>
-                  </a:txBody>
-                  <a:tcPr/>
-                </a:tc>
-                <a:tc>
-                  <a:txBody>
-                    <a:bodyPr/>
-                    <a:lstStyle/>
-                    <a:p>
-                      <a:pPr>
-                        <a:defRPr sz="1000"/>
-                      </a:pPr>
-                      <a:r>
-                        <a:t>445.87</a:t>
+                        <a:t>770</a:t>
+                      </a:r>
+                    </a:p>
+                  </a:txBody>
+                  <a:tcPr/>
+                </a:tc>
+                <a:tc>
+                  <a:txBody>
+                    <a:bodyPr/>
+                    <a:lstStyle/>
+                    <a:p>
+                      <a:pPr>
+                        <a:defRPr sz="1000"/>
+                      </a:pPr>
+                      <a:r>
+                        <a:t>446</a:t>
                       </a:r>
                     </a:p>
                   </a:txBody>
@@ -4164,22 +4164,22 @@
                         <a:defRPr sz="1000"/>
                       </a:pPr>
                       <a:r>
-                        <a:t>1117.0</a:t>
-                      </a:r>
-                    </a:p>
-                  </a:txBody>
-                  <a:tcPr/>
-                </a:tc>
-                <a:tc>
-                  <a:txBody>
-                    <a:bodyPr/>
-                    <a:lstStyle/>
-                    <a:p>
-                      <a:pPr>
-                        <a:defRPr sz="1000"/>
-                      </a:pPr>
-                      <a:r>
-                        <a:t>791.3</a:t>
+                        <a:t>1117</a:t>
+                      </a:r>
+                    </a:p>
+                  </a:txBody>
+                  <a:tcPr/>
+                </a:tc>
+                <a:tc>
+                  <a:txBody>
+                    <a:bodyPr/>
+                    <a:lstStyle/>
+                    <a:p>
+                      <a:pPr>
+                        <a:defRPr sz="1000"/>
+                      </a:pPr>
+                      <a:r>
+                        <a:t>791</a:t>
                       </a:r>
                     </a:p>
                   </a:txBody>
@@ -4254,22 +4254,22 @@
                         <a:defRPr sz="1000"/>
                       </a:pPr>
                       <a:r>
-                        <a:t>987.9</a:t>
-                      </a:r>
-                    </a:p>
-                  </a:txBody>
-                  <a:tcPr/>
-                </a:tc>
-                <a:tc>
-                  <a:txBody>
-                    <a:bodyPr/>
-                    <a:lstStyle/>
-                    <a:p>
-                      <a:pPr>
-                        <a:defRPr sz="1000"/>
-                      </a:pPr>
-                      <a:r>
-                        <a:t>662.2</a:t>
+                        <a:t>988</a:t>
+                      </a:r>
+                    </a:p>
+                  </a:txBody>
+                  <a:tcPr/>
+                </a:tc>
+                <a:tc>
+                  <a:txBody>
+                    <a:bodyPr/>
+                    <a:lstStyle/>
+                    <a:p>
+                      <a:pPr>
+                        <a:defRPr sz="1000"/>
+                      </a:pPr>
+                      <a:r>
+                        <a:t>662</a:t>
                       </a:r>
                     </a:p>
                   </a:txBody>
@@ -4346,22 +4346,22 @@
                         <a:defRPr sz="1000"/>
                       </a:pPr>
                       <a:r>
-                        <a:t>1392.6</a:t>
-                      </a:r>
-                    </a:p>
-                  </a:txBody>
-                  <a:tcPr/>
-                </a:tc>
-                <a:tc>
-                  <a:txBody>
-                    <a:bodyPr/>
-                    <a:lstStyle/>
-                    <a:p>
-                      <a:pPr>
-                        <a:defRPr sz="1000"/>
-                      </a:pPr>
-                      <a:r>
-                        <a:t>936.4</a:t>
+                        <a:t>1393</a:t>
+                      </a:r>
+                    </a:p>
+                  </a:txBody>
+                  <a:tcPr/>
+                </a:tc>
+                <a:tc>
+                  <a:txBody>
+                    <a:bodyPr/>
+                    <a:lstStyle/>
+                    <a:p>
+                      <a:pPr>
+                        <a:defRPr sz="1000"/>
+                      </a:pPr>
+                      <a:r>
+                        <a:t>936</a:t>
                       </a:r>
                     </a:p>
                   </a:txBody>
@@ -4436,22 +4436,22 @@
                         <a:defRPr sz="1000"/>
                       </a:pPr>
                       <a:r>
-                        <a:t>1280.3</a:t>
-                      </a:r>
-                    </a:p>
-                  </a:txBody>
-                  <a:tcPr/>
-                </a:tc>
-                <a:tc>
-                  <a:txBody>
-                    <a:bodyPr/>
-                    <a:lstStyle/>
-                    <a:p>
-                      <a:pPr>
-                        <a:defRPr sz="1000"/>
-                      </a:pPr>
-                      <a:r>
-                        <a:t>824.1</a:t>
+                        <a:t>1280</a:t>
+                      </a:r>
+                    </a:p>
+                  </a:txBody>
+                  <a:tcPr/>
+                </a:tc>
+                <a:tc>
+                  <a:txBody>
+                    <a:bodyPr/>
+                    <a:lstStyle/>
+                    <a:p>
+                      <a:pPr>
+                        <a:defRPr sz="1000"/>
+                      </a:pPr>
+                      <a:r>
+                        <a:t>824</a:t>
                       </a:r>
                     </a:p>
                   </a:txBody>
@@ -4720,7 +4720,7 @@
                         <a:defRPr sz="1000"/>
                       </a:pPr>
                       <a:r>
-                        <a:t>88.9</a:t>
+                        <a:t>89</a:t>
                       </a:r>
                     </a:p>
                   </a:txBody>
@@ -4812,7 +4812,7 @@
                         <a:defRPr sz="1000"/>
                       </a:pPr>
                       <a:r>
-                        <a:t>141.0</a:t>
+                        <a:t>141</a:t>
                       </a:r>
                     </a:p>
                   </a:txBody>
@@ -4904,7 +4904,7 @@
                         <a:defRPr sz="1000"/>
                       </a:pPr>
                       <a:r>
-                        <a:t>168.3</a:t>
+                        <a:t>168</a:t>
                       </a:r>
                     </a:p>
                   </a:txBody>
@@ -4996,7 +4996,7 @@
                         <a:defRPr sz="1000"/>
                       </a:pPr>
                       <a:r>
-                        <a:t>101.2</a:t>
+                        <a:t>101</a:t>
                       </a:r>
                     </a:p>
                   </a:txBody>
@@ -5088,7 +5088,7 @@
                         <a:defRPr sz="1000"/>
                       </a:pPr>
                       <a:r>
-                        <a:t>25.8</a:t>
+                        <a:t>26</a:t>
                       </a:r>
                     </a:p>
                   </a:txBody>
@@ -5180,7 +5180,7 @@
                         <a:defRPr sz="1000"/>
                       </a:pPr>
                       <a:r>
-                        <a:t>49.4</a:t>
+                        <a:t>49</a:t>
                       </a:r>
                     </a:p>
                   </a:txBody>
@@ -5272,7 +5272,7 @@
                         <a:defRPr sz="1000"/>
                       </a:pPr>
                       <a:r>
-                        <a:t>58.3</a:t>
+                        <a:t>58</a:t>
                       </a:r>
                     </a:p>
                   </a:txBody>
@@ -5364,7 +5364,7 @@
                         <a:defRPr sz="1000"/>
                       </a:pPr>
                       <a:r>
-                        <a:t>202.6</a:t>
+                        <a:t>203</a:t>
                       </a:r>
                     </a:p>
                   </a:txBody>
@@ -5456,7 +5456,7 @@
                         <a:defRPr sz="1000"/>
                       </a:pPr>
                       <a:r>
-                        <a:t>92.0</a:t>
+                        <a:t>92</a:t>
                       </a:r>
                     </a:p>
                   </a:txBody>
@@ -9135,7 +9135,7 @@
         <p:spPr>
           <a:xfrm>
             <a:off x="1371600" y="1097280"/>
-            <a:ext cx="9144000" cy="4572000"/>
+            <a:ext cx="9144000" cy="5029200"/>
           </a:xfrm>
           <a:prstGeom prst="rect">
             <a:avLst/>
@@ -11361,7 +11361,7 @@
         </p:nvGraphicFramePr>
         <p:xfrm>
           <a:off x="457200" y="1097280"/>
-          <a:ext cx="10241280" cy="5486400"/>
+          <a:ext cx="11109960" cy="5486400"/>
         </p:xfrm>
         <a:graphic>
           <a:graphicData uri="http://schemas.openxmlformats.org/drawingml/2006/table">
@@ -11370,14 +11370,15 @@
                 <a:tableStyleId>{5C22544A-7EE6-4342-B048-85BDC9FD1C3A}</a:tableStyleId>
               </a:tblPr>
               <a:tblGrid>
-                <a:gridCol w="1280160"/>
-                <a:gridCol w="1280160"/>
-                <a:gridCol w="1280160"/>
-                <a:gridCol w="1280160"/>
-                <a:gridCol w="1280160"/>
-                <a:gridCol w="1280160"/>
-                <a:gridCol w="1280160"/>
-                <a:gridCol w="1280160"/>
+                <a:gridCol w="1234440"/>
+                <a:gridCol w="1234440"/>
+                <a:gridCol w="1234440"/>
+                <a:gridCol w="1234440"/>
+                <a:gridCol w="1234440"/>
+                <a:gridCol w="1234440"/>
+                <a:gridCol w="1234440"/>
+                <a:gridCol w="1234440"/>
+                <a:gridCol w="1234440"/>
               </a:tblGrid>
               <a:tr h="548640">
                 <a:tc>
@@ -11434,6 +11435,18 @@
                     <a:lstStyle/>
                     <a:p>
                       <a:r>
+                        <a:t>T/M</a:t>
+                      </a:r>
+                    </a:p>
+                  </a:txBody>
+                  <a:tcPr/>
+                </a:tc>
+                <a:tc>
+                  <a:txBody>
+                    <a:bodyPr/>
+                    <a:lstStyle/>
+                    <a:p>
+                      <a:r>
                         <a:t>I0</a:t>
                       </a:r>
                     </a:p>
@@ -11502,37 +11515,37 @@
                         <a:defRPr sz="1000"/>
                       </a:pPr>
                       <a:r>
-                        <a:t>752.12</a:t>
-                      </a:r>
-                    </a:p>
-                  </a:txBody>
-                  <a:tcPr/>
-                </a:tc>
-                <a:tc>
-                  <a:txBody>
-                    <a:bodyPr/>
-                    <a:lstStyle/>
-                    <a:p>
-                      <a:pPr>
-                        <a:defRPr sz="1000"/>
-                      </a:pPr>
-                      <a:r>
-                        <a:t>119.78</a:t>
-                      </a:r>
-                    </a:p>
-                  </a:txBody>
-                  <a:tcPr/>
-                </a:tc>
-                <a:tc>
-                  <a:txBody>
-                    <a:bodyPr/>
-                    <a:lstStyle/>
-                    <a:p>
-                      <a:pPr>
-                        <a:defRPr sz="1000"/>
-                      </a:pPr>
-                      <a:r>
-                        <a:t>632.34</a:t>
+                        <a:t>752</a:t>
+                      </a:r>
+                    </a:p>
+                  </a:txBody>
+                  <a:tcPr/>
+                </a:tc>
+                <a:tc>
+                  <a:txBody>
+                    <a:bodyPr/>
+                    <a:lstStyle/>
+                    <a:p>
+                      <a:pPr>
+                        <a:defRPr sz="1000"/>
+                      </a:pPr>
+                      <a:r>
+                        <a:t>120</a:t>
+                      </a:r>
+                    </a:p>
+                  </a:txBody>
+                  <a:tcPr/>
+                </a:tc>
+                <a:tc>
+                  <a:txBody>
+                    <a:bodyPr/>
+                    <a:lstStyle/>
+                    <a:p>
+                      <a:pPr>
+                        <a:defRPr sz="1000"/>
+                      </a:pPr>
+                      <a:r>
+                        <a:t>632</a:t>
                       </a:r>
                     </a:p>
                   </a:txBody>
@@ -11562,7 +11575,7 @@
                         <a:defRPr sz="1000"/>
                       </a:pPr>
                       <a:r>
-                        <a:t>0.00239</a:t>
+                        <a:t>0</a:t>
                       </a:r>
                     </a:p>
                   </a:txBody>
@@ -11593,6 +11606,21 @@
                       </a:pPr>
                       <a:r>
                         <a:t>0.00478</a:t>
+                      </a:r>
+                    </a:p>
+                  </a:txBody>
+                  <a:tcPr/>
+                </a:tc>
+                <a:tc>
+                  <a:txBody>
+                    <a:bodyPr/>
+                    <a:lstStyle/>
+                    <a:p>
+                      <a:pPr>
+                        <a:defRPr sz="1000"/>
+                      </a:pPr>
+                      <a:r>
+                        <a:t>6.27929</a:t>
                       </a:r>
                     </a:p>
                   </a:txBody>
@@ -11624,37 +11652,37 @@
                         <a:defRPr sz="1000"/>
                       </a:pPr>
                       <a:r>
-                        <a:t>1208.42</a:t>
-                      </a:r>
-                    </a:p>
-                  </a:txBody>
-                  <a:tcPr/>
-                </a:tc>
-                <a:tc>
-                  <a:txBody>
-                    <a:bodyPr/>
-                    <a:lstStyle/>
-                    <a:p>
-                      <a:pPr>
-                        <a:defRPr sz="1000"/>
-                      </a:pPr>
-                      <a:r>
-                        <a:t>129.07</a:t>
-                      </a:r>
-                    </a:p>
-                  </a:txBody>
-                  <a:tcPr/>
-                </a:tc>
-                <a:tc>
-                  <a:txBody>
-                    <a:bodyPr/>
-                    <a:lstStyle/>
-                    <a:p>
-                      <a:pPr>
-                        <a:defRPr sz="1000"/>
-                      </a:pPr>
-                      <a:r>
-                        <a:t>1079.36</a:t>
+                        <a:t>1208</a:t>
+                      </a:r>
+                    </a:p>
+                  </a:txBody>
+                  <a:tcPr/>
+                </a:tc>
+                <a:tc>
+                  <a:txBody>
+                    <a:bodyPr/>
+                    <a:lstStyle/>
+                    <a:p>
+                      <a:pPr>
+                        <a:defRPr sz="1000"/>
+                      </a:pPr>
+                      <a:r>
+                        <a:t>129</a:t>
+                      </a:r>
+                    </a:p>
+                  </a:txBody>
+                  <a:tcPr/>
+                </a:tc>
+                <a:tc>
+                  <a:txBody>
+                    <a:bodyPr/>
+                    <a:lstStyle/>
+                    <a:p>
+                      <a:pPr>
+                        <a:defRPr sz="1000"/>
+                      </a:pPr>
+                      <a:r>
+                        <a:t>1079</a:t>
                       </a:r>
                     </a:p>
                   </a:txBody>
@@ -11684,7 +11712,7 @@
                         <a:defRPr sz="1000"/>
                       </a:pPr>
                       <a:r>
-                        <a:t>0.00255</a:t>
+                        <a:t>0</a:t>
                       </a:r>
                     </a:p>
                   </a:txBody>
@@ -11715,6 +11743,21 @@
                       </a:pPr>
                       <a:r>
                         <a:t>0.00510</a:t>
+                      </a:r>
+                    </a:p>
+                  </a:txBody>
+                  <a:tcPr/>
+                </a:tc>
+                <a:tc>
+                  <a:txBody>
+                    <a:bodyPr/>
+                    <a:lstStyle/>
+                    <a:p>
+                      <a:pPr>
+                        <a:defRPr sz="1000"/>
+                      </a:pPr>
+                      <a:r>
+                        <a:t>9.36261</a:t>
                       </a:r>
                     </a:p>
                   </a:txBody>
@@ -11746,37 +11789,37 @@
                         <a:defRPr sz="1000"/>
                       </a:pPr>
                       <a:r>
-                        <a:t>1497.37</a:t>
-                      </a:r>
-                    </a:p>
-                  </a:txBody>
-                  <a:tcPr/>
-                </a:tc>
-                <a:tc>
-                  <a:txBody>
-                    <a:bodyPr/>
-                    <a:lstStyle/>
-                    <a:p>
-                      <a:pPr>
-                        <a:defRPr sz="1000"/>
-                      </a:pPr>
-                      <a:r>
-                        <a:t>66.04</a:t>
-                      </a:r>
-                    </a:p>
-                  </a:txBody>
-                  <a:tcPr/>
-                </a:tc>
-                <a:tc>
-                  <a:txBody>
-                    <a:bodyPr/>
-                    <a:lstStyle/>
-                    <a:p>
-                      <a:pPr>
-                        <a:defRPr sz="1000"/>
-                      </a:pPr>
-                      <a:r>
-                        <a:t>1431.33</a:t>
+                        <a:t>1497</a:t>
+                      </a:r>
+                    </a:p>
+                  </a:txBody>
+                  <a:tcPr/>
+                </a:tc>
+                <a:tc>
+                  <a:txBody>
+                    <a:bodyPr/>
+                    <a:lstStyle/>
+                    <a:p>
+                      <a:pPr>
+                        <a:defRPr sz="1000"/>
+                      </a:pPr>
+                      <a:r>
+                        <a:t>66</a:t>
+                      </a:r>
+                    </a:p>
+                  </a:txBody>
+                  <a:tcPr/>
+                </a:tc>
+                <a:tc>
+                  <a:txBody>
+                    <a:bodyPr/>
+                    <a:lstStyle/>
+                    <a:p>
+                      <a:pPr>
+                        <a:defRPr sz="1000"/>
+                      </a:pPr>
+                      <a:r>
+                        <a:t>1431</a:t>
                       </a:r>
                     </a:p>
                   </a:txBody>
@@ -11806,7 +11849,7 @@
                         <a:defRPr sz="1000"/>
                       </a:pPr>
                       <a:r>
-                        <a:t>0.00106</a:t>
+                        <a:t>0</a:t>
                       </a:r>
                     </a:p>
                   </a:txBody>
@@ -11837,6 +11880,21 @@
                       </a:pPr>
                       <a:r>
                         <a:t>0.00213</a:t>
+                      </a:r>
+                    </a:p>
+                  </a:txBody>
+                  <a:tcPr/>
+                </a:tc>
+                <a:tc>
+                  <a:txBody>
+                    <a:bodyPr/>
+                    <a:lstStyle/>
+                    <a:p>
+                      <a:pPr>
+                        <a:defRPr sz="1000"/>
+                      </a:pPr>
+                      <a:r>
+                        <a:t>22.67343</a:t>
                       </a:r>
                     </a:p>
                   </a:txBody>
@@ -11868,37 +11926,37 @@
                         <a:defRPr sz="1000"/>
                       </a:pPr>
                       <a:r>
-                        <a:t>892.42</a:t>
-                      </a:r>
-                    </a:p>
-                  </a:txBody>
-                  <a:tcPr/>
-                </a:tc>
-                <a:tc>
-                  <a:txBody>
-                    <a:bodyPr/>
-                    <a:lstStyle/>
-                    <a:p>
-                      <a:pPr>
-                        <a:defRPr sz="1000"/>
-                      </a:pPr>
-                      <a:r>
-                        <a:t>126.52</a:t>
-                      </a:r>
-                    </a:p>
-                  </a:txBody>
-                  <a:tcPr/>
-                </a:tc>
-                <a:tc>
-                  <a:txBody>
-                    <a:bodyPr/>
-                    <a:lstStyle/>
-                    <a:p>
-                      <a:pPr>
-                        <a:defRPr sz="1000"/>
-                      </a:pPr>
-                      <a:r>
-                        <a:t>765.89</a:t>
+                        <a:t>892</a:t>
+                      </a:r>
+                    </a:p>
+                  </a:txBody>
+                  <a:tcPr/>
+                </a:tc>
+                <a:tc>
+                  <a:txBody>
+                    <a:bodyPr/>
+                    <a:lstStyle/>
+                    <a:p>
+                      <a:pPr>
+                        <a:defRPr sz="1000"/>
+                      </a:pPr>
+                      <a:r>
+                        <a:t>127</a:t>
+                      </a:r>
+                    </a:p>
+                  </a:txBody>
+                  <a:tcPr/>
+                </a:tc>
+                <a:tc>
+                  <a:txBody>
+                    <a:bodyPr/>
+                    <a:lstStyle/>
+                    <a:p>
+                      <a:pPr>
+                        <a:defRPr sz="1000"/>
+                      </a:pPr>
+                      <a:r>
+                        <a:t>766</a:t>
                       </a:r>
                     </a:p>
                   </a:txBody>
@@ -11928,7 +11986,7 @@
                         <a:defRPr sz="1000"/>
                       </a:pPr>
                       <a:r>
-                        <a:t>0.00141</a:t>
+                        <a:t>0</a:t>
                       </a:r>
                     </a:p>
                   </a:txBody>
@@ -11959,6 +12017,21 @@
                       </a:pPr>
                       <a:r>
                         <a:t>0.00282</a:t>
+                      </a:r>
+                    </a:p>
+                  </a:txBody>
+                  <a:tcPr/>
+                </a:tc>
+                <a:tc>
+                  <a:txBody>
+                    <a:bodyPr/>
+                    <a:lstStyle/>
+                    <a:p>
+                      <a:pPr>
+                        <a:defRPr sz="1000"/>
+                      </a:pPr>
+                      <a:r>
+                        <a:t>7.05353</a:t>
                       </a:r>
                     </a:p>
                   </a:txBody>
@@ -11990,37 +12063,37 @@
                         <a:defRPr sz="1000"/>
                       </a:pPr>
                       <a:r>
-                        <a:t>206.81</a:t>
-                      </a:r>
-                    </a:p>
-                  </a:txBody>
-                  <a:tcPr/>
-                </a:tc>
-                <a:tc>
-                  <a:txBody>
-                    <a:bodyPr/>
-                    <a:lstStyle/>
-                    <a:p>
-                      <a:pPr>
-                        <a:defRPr sz="1000"/>
-                      </a:pPr>
-                      <a:r>
-                        <a:t>50.48</a:t>
-                      </a:r>
-                    </a:p>
-                  </a:txBody>
-                  <a:tcPr/>
-                </a:tc>
-                <a:tc>
-                  <a:txBody>
-                    <a:bodyPr/>
-                    <a:lstStyle/>
-                    <a:p>
-                      <a:pPr>
-                        <a:defRPr sz="1000"/>
-                      </a:pPr>
-                      <a:r>
-                        <a:t>156.33</a:t>
+                        <a:t>207</a:t>
+                      </a:r>
+                    </a:p>
+                  </a:txBody>
+                  <a:tcPr/>
+                </a:tc>
+                <a:tc>
+                  <a:txBody>
+                    <a:bodyPr/>
+                    <a:lstStyle/>
+                    <a:p>
+                      <a:pPr>
+                        <a:defRPr sz="1000"/>
+                      </a:pPr>
+                      <a:r>
+                        <a:t>50</a:t>
+                      </a:r>
+                    </a:p>
+                  </a:txBody>
+                  <a:tcPr/>
+                </a:tc>
+                <a:tc>
+                  <a:txBody>
+                    <a:bodyPr/>
+                    <a:lstStyle/>
+                    <a:p>
+                      <a:pPr>
+                        <a:defRPr sz="1000"/>
+                      </a:pPr>
+                      <a:r>
+                        <a:t>156</a:t>
                       </a:r>
                     </a:p>
                   </a:txBody>
@@ -12050,7 +12123,7 @@
                         <a:defRPr sz="1000"/>
                       </a:pPr>
                       <a:r>
-                        <a:t>0.00993</a:t>
+                        <a:t>0</a:t>
                       </a:r>
                     </a:p>
                   </a:txBody>
@@ -12081,6 +12154,21 @@
                       </a:pPr>
                       <a:r>
                         <a:t>0.01985</a:t>
+                      </a:r>
+                    </a:p>
+                  </a:txBody>
+                  <a:tcPr/>
+                </a:tc>
+                <a:tc>
+                  <a:txBody>
+                    <a:bodyPr/>
+                    <a:lstStyle/>
+                    <a:p>
+                      <a:pPr>
+                        <a:defRPr sz="1000"/>
+                      </a:pPr>
+                      <a:r>
+                        <a:t>4.09717</a:t>
                       </a:r>
                     </a:p>
                   </a:txBody>
@@ -12112,37 +12200,37 @@
                         <a:defRPr sz="1000"/>
                       </a:pPr>
                       <a:r>
-                        <a:t>424.70</a:t>
-                      </a:r>
-                    </a:p>
-                  </a:txBody>
-                  <a:tcPr/>
-                </a:tc>
-                <a:tc>
-                  <a:txBody>
-                    <a:bodyPr/>
-                    <a:lstStyle/>
-                    <a:p>
-                      <a:pPr>
-                        <a:defRPr sz="1000"/>
-                      </a:pPr>
-                      <a:r>
-                        <a:t>104.60</a:t>
-                      </a:r>
-                    </a:p>
-                  </a:txBody>
-                  <a:tcPr/>
-                </a:tc>
-                <a:tc>
-                  <a:txBody>
-                    <a:bodyPr/>
-                    <a:lstStyle/>
-                    <a:p>
-                      <a:pPr>
-                        <a:defRPr sz="1000"/>
-                      </a:pPr>
-                      <a:r>
-                        <a:t>320.10</a:t>
+                        <a:t>425</a:t>
+                      </a:r>
+                    </a:p>
+                  </a:txBody>
+                  <a:tcPr/>
+                </a:tc>
+                <a:tc>
+                  <a:txBody>
+                    <a:bodyPr/>
+                    <a:lstStyle/>
+                    <a:p>
+                      <a:pPr>
+                        <a:defRPr sz="1000"/>
+                      </a:pPr>
+                      <a:r>
+                        <a:t>105</a:t>
+                      </a:r>
+                    </a:p>
+                  </a:txBody>
+                  <a:tcPr/>
+                </a:tc>
+                <a:tc>
+                  <a:txBody>
+                    <a:bodyPr/>
+                    <a:lstStyle/>
+                    <a:p>
+                      <a:pPr>
+                        <a:defRPr sz="1000"/>
+                      </a:pPr>
+                      <a:r>
+                        <a:t>320</a:t>
                       </a:r>
                     </a:p>
                   </a:txBody>
@@ -12172,7 +12260,7 @@
                         <a:defRPr sz="1000"/>
                       </a:pPr>
                       <a:r>
-                        <a:t>0.00310</a:t>
+                        <a:t>0</a:t>
                       </a:r>
                     </a:p>
                   </a:txBody>
@@ -12203,6 +12291,21 @@
                       </a:pPr>
                       <a:r>
                         <a:t>0.00620</a:t>
+                      </a:r>
+                    </a:p>
+                  </a:txBody>
+                  <a:tcPr/>
+                </a:tc>
+                <a:tc>
+                  <a:txBody>
+                    <a:bodyPr/>
+                    <a:lstStyle/>
+                    <a:p>
+                      <a:pPr>
+                        <a:defRPr sz="1000"/>
+                      </a:pPr>
+                      <a:r>
+                        <a:t>4.06036</a:t>
                       </a:r>
                     </a:p>
                   </a:txBody>
@@ -12234,37 +12337,37 @@
                         <a:defRPr sz="1000"/>
                       </a:pPr>
                       <a:r>
-                        <a:t>513.12</a:t>
-                      </a:r>
-                    </a:p>
-                  </a:txBody>
-                  <a:tcPr/>
-                </a:tc>
-                <a:tc>
-                  <a:txBody>
-                    <a:bodyPr/>
-                    <a:lstStyle/>
-                    <a:p>
-                      <a:pPr>
-                        <a:defRPr sz="1000"/>
-                      </a:pPr>
-                      <a:r>
-                        <a:t>57.17</a:t>
-                      </a:r>
-                    </a:p>
-                  </a:txBody>
-                  <a:tcPr/>
-                </a:tc>
-                <a:tc>
-                  <a:txBody>
-                    <a:bodyPr/>
-                    <a:lstStyle/>
-                    <a:p>
-                      <a:pPr>
-                        <a:defRPr sz="1000"/>
-                      </a:pPr>
-                      <a:r>
-                        <a:t>455.95</a:t>
+                        <a:t>513</a:t>
+                      </a:r>
+                    </a:p>
+                  </a:txBody>
+                  <a:tcPr/>
+                </a:tc>
+                <a:tc>
+                  <a:txBody>
+                    <a:bodyPr/>
+                    <a:lstStyle/>
+                    <a:p>
+                      <a:pPr>
+                        <a:defRPr sz="1000"/>
+                      </a:pPr>
+                      <a:r>
+                        <a:t>57</a:t>
+                      </a:r>
+                    </a:p>
+                  </a:txBody>
+                  <a:tcPr/>
+                </a:tc>
+                <a:tc>
+                  <a:txBody>
+                    <a:bodyPr/>
+                    <a:lstStyle/>
+                    <a:p>
+                      <a:pPr>
+                        <a:defRPr sz="1000"/>
+                      </a:pPr>
+                      <a:r>
+                        <a:t>456</a:t>
                       </a:r>
                     </a:p>
                   </a:txBody>
@@ -12294,7 +12397,7 @@
                         <a:defRPr sz="1000"/>
                       </a:pPr>
                       <a:r>
-                        <a:t>0.00200</a:t>
+                        <a:t>0</a:t>
                       </a:r>
                     </a:p>
                   </a:txBody>
@@ -12325,6 +12428,21 @@
                       </a:pPr>
                       <a:r>
                         <a:t>0.00400</a:t>
+                      </a:r>
+                    </a:p>
+                  </a:txBody>
+                  <a:tcPr/>
+                </a:tc>
+                <a:tc>
+                  <a:txBody>
+                    <a:bodyPr/>
+                    <a:lstStyle/>
+                    <a:p>
+                      <a:pPr>
+                        <a:defRPr sz="1000"/>
+                      </a:pPr>
+                      <a:r>
+                        <a:t>8.97530</a:t>
                       </a:r>
                     </a:p>
                   </a:txBody>
@@ -12356,37 +12474,37 @@
                         <a:defRPr sz="1000"/>
                       </a:pPr>
                       <a:r>
-                        <a:t>1783.64</a:t>
-                      </a:r>
-                    </a:p>
-                  </a:txBody>
-                  <a:tcPr/>
-                </a:tc>
-                <a:tc>
-                  <a:txBody>
-                    <a:bodyPr/>
-                    <a:lstStyle/>
-                    <a:p>
-                      <a:pPr>
-                        <a:defRPr sz="1000"/>
-                      </a:pPr>
-                      <a:r>
-                        <a:t>112.34</a:t>
-                      </a:r>
-                    </a:p>
-                  </a:txBody>
-                  <a:tcPr/>
-                </a:tc>
-                <a:tc>
-                  <a:txBody>
-                    <a:bodyPr/>
-                    <a:lstStyle/>
-                    <a:p>
-                      <a:pPr>
-                        <a:defRPr sz="1000"/>
-                      </a:pPr>
-                      <a:r>
-                        <a:t>1671.29</a:t>
+                        <a:t>1784</a:t>
+                      </a:r>
+                    </a:p>
+                  </a:txBody>
+                  <a:tcPr/>
+                </a:tc>
+                <a:tc>
+                  <a:txBody>
+                    <a:bodyPr/>
+                    <a:lstStyle/>
+                    <a:p>
+                      <a:pPr>
+                        <a:defRPr sz="1000"/>
+                      </a:pPr>
+                      <a:r>
+                        <a:t>112</a:t>
+                      </a:r>
+                    </a:p>
+                  </a:txBody>
+                  <a:tcPr/>
+                </a:tc>
+                <a:tc>
+                  <a:txBody>
+                    <a:bodyPr/>
+                    <a:lstStyle/>
+                    <a:p>
+                      <a:pPr>
+                        <a:defRPr sz="1000"/>
+                      </a:pPr>
+                      <a:r>
+                        <a:t>1671</a:t>
                       </a:r>
                     </a:p>
                   </a:txBody>
@@ -12416,7 +12534,7 @@
                         <a:defRPr sz="1000"/>
                       </a:pPr>
                       <a:r>
-                        <a:t>0.00140</a:t>
+                        <a:t>0</a:t>
                       </a:r>
                     </a:p>
                   </a:txBody>
@@ -12447,6 +12565,21 @@
                       </a:pPr>
                       <a:r>
                         <a:t>0.00281</a:t>
+                      </a:r>
+                    </a:p>
+                  </a:txBody>
+                  <a:tcPr/>
+                </a:tc>
+                <a:tc>
+                  <a:txBody>
+                    <a:bodyPr/>
+                    <a:lstStyle/>
+                    <a:p>
+                      <a:pPr>
+                        <a:defRPr sz="1000"/>
+                      </a:pPr>
+                      <a:r>
+                        <a:t>15.87655</a:t>
                       </a:r>
                     </a:p>
                   </a:txBody>
@@ -12478,37 +12611,37 @@
                         <a:defRPr sz="1000"/>
                       </a:pPr>
                       <a:r>
-                        <a:t>770.21</a:t>
-                      </a:r>
-                    </a:p>
-                  </a:txBody>
-                  <a:tcPr/>
-                </a:tc>
-                <a:tc>
-                  <a:txBody>
-                    <a:bodyPr/>
-                    <a:lstStyle/>
-                    <a:p>
-                      <a:pPr>
-                        <a:defRPr sz="1000"/>
-                      </a:pPr>
-                      <a:r>
-                        <a:t>132.49</a:t>
-                      </a:r>
-                    </a:p>
-                  </a:txBody>
-                  <a:tcPr/>
-                </a:tc>
-                <a:tc>
-                  <a:txBody>
-                    <a:bodyPr/>
-                    <a:lstStyle/>
-                    <a:p>
-                      <a:pPr>
-                        <a:defRPr sz="1000"/>
-                      </a:pPr>
-                      <a:r>
-                        <a:t>637.71</a:t>
+                        <a:t>770</a:t>
+                      </a:r>
+                    </a:p>
+                  </a:txBody>
+                  <a:tcPr/>
+                </a:tc>
+                <a:tc>
+                  <a:txBody>
+                    <a:bodyPr/>
+                    <a:lstStyle/>
+                    <a:p>
+                      <a:pPr>
+                        <a:defRPr sz="1000"/>
+                      </a:pPr>
+                      <a:r>
+                        <a:t>132</a:t>
+                      </a:r>
+                    </a:p>
+                  </a:txBody>
+                  <a:tcPr/>
+                </a:tc>
+                <a:tc>
+                  <a:txBody>
+                    <a:bodyPr/>
+                    <a:lstStyle/>
+                    <a:p>
+                      <a:pPr>
+                        <a:defRPr sz="1000"/>
+                      </a:pPr>
+                      <a:r>
+                        <a:t>638</a:t>
                       </a:r>
                     </a:p>
                   </a:txBody>
@@ -12538,7 +12671,7 @@
                         <a:defRPr sz="1000"/>
                       </a:pPr>
                       <a:r>
-                        <a:t>0.00404</a:t>
+                        <a:t>0</a:t>
                       </a:r>
                     </a:p>
                   </a:txBody>
@@ -12569,6 +12702,21 @@
                       </a:pPr>
                       <a:r>
                         <a:t>0.00808</a:t>
+                      </a:r>
+                    </a:p>
+                  </a:txBody>
+                  <a:tcPr/>
+                </a:tc>
+                <a:tc>
+                  <a:txBody>
+                    <a:bodyPr/>
+                    <a:lstStyle/>
+                    <a:p>
+                      <a:pPr>
+                        <a:defRPr sz="1000"/>
+                      </a:pPr>
+                      <a:r>
+                        <a:t>5.81317</a:t>
                       </a:r>
                     </a:p>
                   </a:txBody>

</xml_diff>

<commit_message>
Add Japan compartment/PNR figures, mirror fig3, unify fig5/7 titles, integrate into full article
Co-Authored-By: Tatsuki Onishi <bougtoir@gmail.com>
</commit_message>
<xml_diff>
--- a/researcher_mobility_ode/docs/manuscript_full_article_figures.pptx
+++ b/researcher_mobility_ode/docs/manuscript_full_article_figures.pptx
@@ -25,6 +25,8 @@
     <p:sldId id="273" r:id="rId24"/>
     <p:sldId id="274" r:id="rId25"/>
     <p:sldId id="275" r:id="rId26"/>
+    <p:sldId id="276" r:id="rId27"/>
+    <p:sldId id="277" r:id="rId28"/>
   </p:sldIdLst>
   <p:sldSz cx="12191695" cy="6858000" type="screen4x3"/>
   <p:notesSz cx="6858000" cy="9144000"/>
@@ -6373,7 +6375,7 @@
           <a:lstStyle/>
           <a:p>
             <a:r>
-              <a:t>Figure 5: Annual observed and projected transition rates</a:t>
+              <a:t>Figure 5: Observed and projected transition rates</a:t>
             </a:r>
           </a:p>
         </p:txBody>
@@ -6757,6 +6759,262 @@
           <a:lstStyle/>
           <a:p>
             <a:r>
+              <a:t>Figure 8: Japan compartment model and cross-civilisation transition-rate ladders</a:t>
+            </a:r>
+          </a:p>
+        </p:txBody>
+      </p:sp>
+      <p:sp>
+        <p:nvSpPr>
+          <p:cNvPr id="3" name="Content Placeholder 2"/>
+          <p:cNvSpPr>
+            <a:spLocks noGrp="1"/>
+          </p:cNvSpPr>
+          <p:nvPr>
+            <p:ph idx="1" sz="half"/>
+          </p:nvPr>
+        </p:nvSpPr>
+        <p:spPr/>
+        <p:txBody>
+          <a:bodyPr/>
+          <a:lstStyle/>
+          <a:p/>
+        </p:txBody>
+      </p:sp>
+      <p:sp>
+        <p:nvSpPr>
+          <p:cNvPr id="4" name="Content Placeholder 3"/>
+          <p:cNvSpPr>
+            <a:spLocks noGrp="1"/>
+          </p:cNvSpPr>
+          <p:nvPr>
+            <p:ph idx="2" sz="half"/>
+          </p:nvPr>
+        </p:nvSpPr>
+        <p:spPr/>
+        <p:txBody>
+          <a:bodyPr/>
+          <a:lstStyle/>
+          <a:p/>
+        </p:txBody>
+      </p:sp>
+      <p:pic>
+        <p:nvPicPr>
+          <p:cNvPr id="5" name="Picture 4" descr="fig8_japan_compartment_flow.png"/>
+          <p:cNvPicPr>
+            <a:picLocks noChangeAspect="1"/>
+          </p:cNvPicPr>
+          <p:nvPr/>
+        </p:nvPicPr>
+        <p:blipFill>
+          <a:blip r:embed="rId2"/>
+          <a:stretch>
+            <a:fillRect/>
+          </a:stretch>
+        </p:blipFill>
+        <p:spPr>
+          <a:xfrm>
+            <a:off x="1371600" y="1097280"/>
+            <a:ext cx="9144000" cy="5043674"/>
+          </a:xfrm>
+          <a:prstGeom prst="rect">
+            <a:avLst/>
+          </a:prstGeom>
+        </p:spPr>
+      </p:pic>
+      <p:sp>
+        <p:nvSpPr>
+          <p:cNvPr id="6" name="TextBox 5"/>
+          <p:cNvSpPr txBox="1"/>
+          <p:nvPr/>
+        </p:nvSpPr>
+        <p:spPr>
+          <a:xfrm>
+            <a:off x="1371600" y="5486400"/>
+            <a:ext cx="9144000" cy="731520"/>
+          </a:xfrm>
+          <a:prstGeom prst="rect">
+            <a:avLst/>
+          </a:prstGeom>
+          <a:noFill/>
+        </p:spPr>
+        <p:txBody>
+          <a:bodyPr wrap="none">
+            <a:spAutoFit/>
+          </a:bodyPr>
+          <a:lstStyle/>
+          <a:p>
+            <a:pPr>
+              <a:defRPr sz="1400"/>
+            </a:pPr>
+            <a:r>
+              <a:t>Left: Japan's six compartments; right: Japan highlighted against other civilisations on each transition rate.</a:t>
+            </a:r>
+          </a:p>
+        </p:txBody>
+      </p:sp>
+    </p:spTree>
+  </p:cSld>
+  <p:clrMapOvr>
+    <a:masterClrMapping/>
+  </p:clrMapOvr>
+</p:sld>
+</file>
+
+<file path=ppt/slides/slide18.xml><?xml version="1.0" encoding="utf-8"?>
+<p:sld xmlns:a="http://schemas.openxmlformats.org/drawingml/2006/main" xmlns:p="http://schemas.openxmlformats.org/presentationml/2006/main" xmlns:r="http://schemas.openxmlformats.org/officeDocument/2006/relationships">
+  <p:cSld>
+    <p:spTree>
+      <p:nvGrpSpPr>
+        <p:cNvPr id="1" name=""/>
+        <p:cNvGrpSpPr/>
+        <p:nvPr/>
+      </p:nvGrpSpPr>
+      <p:grpSpPr/>
+      <p:sp>
+        <p:nvSpPr>
+          <p:cNvPr id="2" name="Title 1"/>
+          <p:cNvSpPr>
+            <a:spLocks noGrp="1"/>
+          </p:cNvSpPr>
+          <p:nvPr>
+            <p:ph type="title"/>
+          </p:nvPr>
+        </p:nvSpPr>
+        <p:spPr/>
+        <p:txBody>
+          <a:bodyPr/>
+          <a:lstStyle/>
+          <a:p>
+            <a:r>
+              <a:t>Figure 9: T/M safety margin versus closest PNR proximity</a:t>
+            </a:r>
+          </a:p>
+        </p:txBody>
+      </p:sp>
+      <p:sp>
+        <p:nvSpPr>
+          <p:cNvPr id="3" name="Content Placeholder 2"/>
+          <p:cNvSpPr>
+            <a:spLocks noGrp="1"/>
+          </p:cNvSpPr>
+          <p:nvPr>
+            <p:ph idx="1" sz="half"/>
+          </p:nvPr>
+        </p:nvSpPr>
+        <p:spPr/>
+        <p:txBody>
+          <a:bodyPr/>
+          <a:lstStyle/>
+          <a:p/>
+        </p:txBody>
+      </p:sp>
+      <p:sp>
+        <p:nvSpPr>
+          <p:cNvPr id="4" name="Content Placeholder 3"/>
+          <p:cNvSpPr>
+            <a:spLocks noGrp="1"/>
+          </p:cNvSpPr>
+          <p:nvPr>
+            <p:ph idx="2" sz="half"/>
+          </p:nvPr>
+        </p:nvSpPr>
+        <p:spPr/>
+        <p:txBody>
+          <a:bodyPr/>
+          <a:lstStyle/>
+          <a:p/>
+        </p:txBody>
+      </p:sp>
+      <p:pic>
+        <p:nvPicPr>
+          <p:cNvPr id="5" name="Picture 4" descr="fig9_tm_pnr_scatter.png"/>
+          <p:cNvPicPr>
+            <a:picLocks noChangeAspect="1"/>
+          </p:cNvPicPr>
+          <p:nvPr/>
+        </p:nvPicPr>
+        <p:blipFill>
+          <a:blip r:embed="rId2"/>
+          <a:stretch>
+            <a:fillRect/>
+          </a:stretch>
+        </p:blipFill>
+        <p:spPr>
+          <a:xfrm>
+            <a:off x="1371600" y="1097280"/>
+            <a:ext cx="9144000" cy="7112000"/>
+          </a:xfrm>
+          <a:prstGeom prst="rect">
+            <a:avLst/>
+          </a:prstGeom>
+        </p:spPr>
+      </p:pic>
+      <p:sp>
+        <p:nvSpPr>
+          <p:cNvPr id="6" name="TextBox 5"/>
+          <p:cNvSpPr txBox="1"/>
+          <p:nvPr/>
+        </p:nvSpPr>
+        <p:spPr>
+          <a:xfrm>
+            <a:off x="1371600" y="5486400"/>
+            <a:ext cx="9144000" cy="731520"/>
+          </a:xfrm>
+          <a:prstGeom prst="rect">
+            <a:avLst/>
+          </a:prstGeom>
+          <a:noFill/>
+        </p:spPr>
+        <p:txBody>
+          <a:bodyPr wrap="none">
+            <a:spAutoFit/>
+          </a:bodyPr>
+          <a:lstStyle/>
+          <a:p>
+            <a:pPr>
+              <a:defRPr sz="1400"/>
+            </a:pPr>
+            <a:r>
+              <a:t>Lower-left points are the most fragile. Japan is highlighted in red.</a:t>
+            </a:r>
+          </a:p>
+        </p:txBody>
+      </p:sp>
+    </p:spTree>
+  </p:cSld>
+  <p:clrMapOvr>
+    <a:masterClrMapping/>
+  </p:clrMapOvr>
+</p:sld>
+</file>
+
+<file path=ppt/slides/slide19.xml><?xml version="1.0" encoding="utf-8"?>
+<p:sld xmlns:a="http://schemas.openxmlformats.org/drawingml/2006/main" xmlns:p="http://schemas.openxmlformats.org/presentationml/2006/main" xmlns:r="http://schemas.openxmlformats.org/officeDocument/2006/relationships">
+  <p:cSld>
+    <p:spTree>
+      <p:nvGrpSpPr>
+        <p:cNvPr id="1" name=""/>
+        <p:cNvGrpSpPr/>
+        <p:nvPr/>
+      </p:nvGrpSpPr>
+      <p:grpSpPr/>
+      <p:sp>
+        <p:nvSpPr>
+          <p:cNvPr id="2" name="Title 1"/>
+          <p:cNvSpPr>
+            <a:spLocks noGrp="1"/>
+          </p:cNvSpPr>
+          <p:nvPr>
+            <p:ph type="title"/>
+          </p:nvPr>
+        </p:nvSpPr>
+        <p:spPr/>
+        <p:txBody>
+          <a:bodyPr/>
+          <a:lstStyle/>
+          <a:p>
+            <a:r>
               <a:t>Table 9: Mean observed annual transition rates, 2000-2016</a:t>
             </a:r>
           </a:p>
@@ -7866,1175 +8124,6 @@
                       </a:pPr>
                       <a:r>
                         <a:t>2.8823529411764706</a:t>
-                      </a:r>
-                    </a:p>
-                  </a:txBody>
-                  <a:tcPr/>
-                </a:tc>
-              </a:tr>
-            </a:tbl>
-          </a:graphicData>
-        </a:graphic>
-      </p:graphicFrame>
-    </p:spTree>
-  </p:cSld>
-  <p:clrMapOvr>
-    <a:masterClrMapping/>
-  </p:clrMapOvr>
-</p:sld>
-</file>
-
-<file path=ppt/slides/slide18.xml><?xml version="1.0" encoding="utf-8"?>
-<p:sld xmlns:a="http://schemas.openxmlformats.org/drawingml/2006/main" xmlns:p="http://schemas.openxmlformats.org/presentationml/2006/main" xmlns:r="http://schemas.openxmlformats.org/officeDocument/2006/relationships">
-  <p:cSld>
-    <p:spTree>
-      <p:nvGrpSpPr>
-        <p:cNvPr id="1" name=""/>
-        <p:cNvGrpSpPr/>
-        <p:nvPr/>
-      </p:nvGrpSpPr>
-      <p:grpSpPr/>
-      <p:sp>
-        <p:nvSpPr>
-          <p:cNvPr id="2" name="Title 1"/>
-          <p:cNvSpPr>
-            <a:spLocks noGrp="1"/>
-          </p:cNvSpPr>
-          <p:nvPr>
-            <p:ph type="title"/>
-          </p:nvPr>
-        </p:nvSpPr>
-        <p:spPr/>
-        <p:txBody>
-          <a:bodyPr/>
-          <a:lstStyle/>
-          <a:p>
-            <a:r>
-              <a:t>Table 10: Top origin-destination abroad author-year pairs</a:t>
-            </a:r>
-          </a:p>
-        </p:txBody>
-      </p:sp>
-      <p:sp>
-        <p:nvSpPr>
-          <p:cNvPr id="3" name="Content Placeholder 2"/>
-          <p:cNvSpPr>
-            <a:spLocks noGrp="1"/>
-          </p:cNvSpPr>
-          <p:nvPr>
-            <p:ph idx="1" sz="half"/>
-          </p:nvPr>
-        </p:nvSpPr>
-        <p:spPr/>
-        <p:txBody>
-          <a:bodyPr/>
-          <a:lstStyle/>
-          <a:p/>
-        </p:txBody>
-      </p:sp>
-      <p:sp>
-        <p:nvSpPr>
-          <p:cNvPr id="4" name="Content Placeholder 3"/>
-          <p:cNvSpPr>
-            <a:spLocks noGrp="1"/>
-          </p:cNvSpPr>
-          <p:nvPr>
-            <p:ph idx="2" sz="half"/>
-          </p:nvPr>
-        </p:nvSpPr>
-        <p:spPr/>
-        <p:txBody>
-          <a:bodyPr/>
-          <a:lstStyle/>
-          <a:p/>
-        </p:txBody>
-      </p:sp>
-      <p:graphicFrame>
-        <p:nvGraphicFramePr>
-          <p:cNvPr id="5" name="Table 4"/>
-          <p:cNvGraphicFramePr>
-            <a:graphicFrameLocks noGrp="1"/>
-          </p:cNvGraphicFramePr>
-          <p:nvPr/>
-        </p:nvGraphicFramePr>
-        <p:xfrm>
-          <a:off x="457200" y="1097280"/>
-          <a:ext cx="5486400" cy="6035040"/>
-        </p:xfrm>
-        <a:graphic>
-          <a:graphicData uri="http://schemas.openxmlformats.org/drawingml/2006/table">
-            <a:tbl>
-              <a:tblPr firstRow="1" bandRow="1">
-                <a:tableStyleId>{5C22544A-7EE6-4342-B048-85BDC9FD1C3A}</a:tableStyleId>
-              </a:tblPr>
-              <a:tblGrid>
-                <a:gridCol w="1828800"/>
-                <a:gridCol w="1828800"/>
-                <a:gridCol w="1828800"/>
-              </a:tblGrid>
-              <a:tr h="548640">
-                <a:tc>
-                  <a:txBody>
-                    <a:bodyPr/>
-                    <a:lstStyle/>
-                    <a:p>
-                      <a:r>
-                        <a:t>Origin</a:t>
-                      </a:r>
-                    </a:p>
-                  </a:txBody>
-                  <a:tcPr/>
-                </a:tc>
-                <a:tc>
-                  <a:txBody>
-                    <a:bodyPr/>
-                    <a:lstStyle/>
-                    <a:p>
-                      <a:r>
-                        <a:t>Destination</a:t>
-                      </a:r>
-                    </a:p>
-                  </a:txBody>
-                  <a:tcPr/>
-                </a:tc>
-                <a:tc>
-                  <a:txBody>
-                    <a:bodyPr/>
-                    <a:lstStyle/>
-                    <a:p>
-                      <a:r>
-                        <a:t>Author-years</a:t>
-                      </a:r>
-                    </a:p>
-                  </a:txBody>
-                  <a:tcPr/>
-                </a:tc>
-              </a:tr>
-              <a:tr h="548640">
-                <a:tc>
-                  <a:txBody>
-                    <a:bodyPr/>
-                    <a:lstStyle/>
-                    <a:p>
-                      <a:pPr>
-                        <a:defRPr sz="1000"/>
-                      </a:pPr>
-                      <a:r>
-                        <a:t>Continental Europe</a:t>
-                      </a:r>
-                    </a:p>
-                  </a:txBody>
-                  <a:tcPr/>
-                </a:tc>
-                <a:tc>
-                  <a:txBody>
-                    <a:bodyPr/>
-                    <a:lstStyle/>
-                    <a:p>
-                      <a:pPr>
-                        <a:defRPr sz="1000"/>
-                      </a:pPr>
-                      <a:r>
-                        <a:t>Continental Europe</a:t>
-                      </a:r>
-                    </a:p>
-                  </a:txBody>
-                  <a:tcPr/>
-                </a:tc>
-                <a:tc>
-                  <a:txBody>
-                    <a:bodyPr/>
-                    <a:lstStyle/>
-                    <a:p>
-                      <a:pPr>
-                        <a:defRPr sz="1000"/>
-                      </a:pPr>
-                      <a:r>
-                        <a:t>80</a:t>
-                      </a:r>
-                    </a:p>
-                  </a:txBody>
-                  <a:tcPr/>
-                </a:tc>
-              </a:tr>
-              <a:tr h="548640">
-                <a:tc>
-                  <a:txBody>
-                    <a:bodyPr/>
-                    <a:lstStyle/>
-                    <a:p>
-                      <a:pPr>
-                        <a:defRPr sz="1000"/>
-                      </a:pPr>
-                      <a:r>
-                        <a:t>Sinic</a:t>
-                      </a:r>
-                    </a:p>
-                  </a:txBody>
-                  <a:tcPr/>
-                </a:tc>
-                <a:tc>
-                  <a:txBody>
-                    <a:bodyPr/>
-                    <a:lstStyle/>
-                    <a:p>
-                      <a:pPr>
-                        <a:defRPr sz="1000"/>
-                      </a:pPr>
-                      <a:r>
-                        <a:t>Sinic</a:t>
-                      </a:r>
-                    </a:p>
-                  </a:txBody>
-                  <a:tcPr/>
-                </a:tc>
-                <a:tc>
-                  <a:txBody>
-                    <a:bodyPr/>
-                    <a:lstStyle/>
-                    <a:p>
-                      <a:pPr>
-                        <a:defRPr sz="1000"/>
-                      </a:pPr>
-                      <a:r>
-                        <a:t>78</a:t>
-                      </a:r>
-                    </a:p>
-                  </a:txBody>
-                  <a:tcPr/>
-                </a:tc>
-              </a:tr>
-              <a:tr h="548640">
-                <a:tc>
-                  <a:txBody>
-                    <a:bodyPr/>
-                    <a:lstStyle/>
-                    <a:p>
-                      <a:pPr>
-                        <a:defRPr sz="1000"/>
-                      </a:pPr>
-                      <a:r>
-                        <a:t>Anglosphere ex-US</a:t>
-                      </a:r>
-                    </a:p>
-                  </a:txBody>
-                  <a:tcPr/>
-                </a:tc>
-                <a:tc>
-                  <a:txBody>
-                    <a:bodyPr/>
-                    <a:lstStyle/>
-                    <a:p>
-                      <a:pPr>
-                        <a:defRPr sz="1000"/>
-                      </a:pPr>
-                      <a:r>
-                        <a:t>Continental Europe</a:t>
-                      </a:r>
-                    </a:p>
-                  </a:txBody>
-                  <a:tcPr/>
-                </a:tc>
-                <a:tc>
-                  <a:txBody>
-                    <a:bodyPr/>
-                    <a:lstStyle/>
-                    <a:p>
-                      <a:pPr>
-                        <a:defRPr sz="1000"/>
-                      </a:pPr>
-                      <a:r>
-                        <a:t>61</a:t>
-                      </a:r>
-                    </a:p>
-                  </a:txBody>
-                  <a:tcPr/>
-                </a:tc>
-              </a:tr>
-              <a:tr h="548640">
-                <a:tc>
-                  <a:txBody>
-                    <a:bodyPr/>
-                    <a:lstStyle/>
-                    <a:p>
-                      <a:pPr>
-                        <a:defRPr sz="1000"/>
-                      </a:pPr>
-                      <a:r>
-                        <a:t>Continental Europe</a:t>
-                      </a:r>
-                    </a:p>
-                  </a:txBody>
-                  <a:tcPr/>
-                </a:tc>
-                <a:tc>
-                  <a:txBody>
-                    <a:bodyPr/>
-                    <a:lstStyle/>
-                    <a:p>
-                      <a:pPr>
-                        <a:defRPr sz="1000"/>
-                      </a:pPr>
-                      <a:r>
-                        <a:t>Anglosphere ex-US</a:t>
-                      </a:r>
-                    </a:p>
-                  </a:txBody>
-                  <a:tcPr/>
-                </a:tc>
-                <a:tc>
-                  <a:txBody>
-                    <a:bodyPr/>
-                    <a:lstStyle/>
-                    <a:p>
-                      <a:pPr>
-                        <a:defRPr sz="1000"/>
-                      </a:pPr>
-                      <a:r>
-                        <a:t>60</a:t>
-                      </a:r>
-                    </a:p>
-                  </a:txBody>
-                  <a:tcPr/>
-                </a:tc>
-              </a:tr>
-              <a:tr h="548640">
-                <a:tc>
-                  <a:txBody>
-                    <a:bodyPr/>
-                    <a:lstStyle/>
-                    <a:p>
-                      <a:pPr>
-                        <a:defRPr sz="1000"/>
-                      </a:pPr>
-                      <a:r>
-                        <a:t>Anglosphere ex-US</a:t>
-                      </a:r>
-                    </a:p>
-                  </a:txBody>
-                  <a:tcPr/>
-                </a:tc>
-                <a:tc>
-                  <a:txBody>
-                    <a:bodyPr/>
-                    <a:lstStyle/>
-                    <a:p>
-                      <a:pPr>
-                        <a:defRPr sz="1000"/>
-                      </a:pPr>
-                      <a:r>
-                        <a:t>Anglosphere ex-US</a:t>
-                      </a:r>
-                    </a:p>
-                  </a:txBody>
-                  <a:tcPr/>
-                </a:tc>
-                <a:tc>
-                  <a:txBody>
-                    <a:bodyPr/>
-                    <a:lstStyle/>
-                    <a:p>
-                      <a:pPr>
-                        <a:defRPr sz="1000"/>
-                      </a:pPr>
-                      <a:r>
-                        <a:t>59</a:t>
-                      </a:r>
-                    </a:p>
-                  </a:txBody>
-                  <a:tcPr/>
-                </a:tc>
-              </a:tr>
-              <a:tr h="548640">
-                <a:tc>
-                  <a:txBody>
-                    <a:bodyPr/>
-                    <a:lstStyle/>
-                    <a:p>
-                      <a:pPr>
-                        <a:defRPr sz="1000"/>
-                      </a:pPr>
-                      <a:r>
-                        <a:t>United States</a:t>
-                      </a:r>
-                    </a:p>
-                  </a:txBody>
-                  <a:tcPr/>
-                </a:tc>
-                <a:tc>
-                  <a:txBody>
-                    <a:bodyPr/>
-                    <a:lstStyle/>
-                    <a:p>
-                      <a:pPr>
-                        <a:defRPr sz="1000"/>
-                      </a:pPr>
-                      <a:r>
-                        <a:t>Other Western</a:t>
-                      </a:r>
-                    </a:p>
-                  </a:txBody>
-                  <a:tcPr/>
-                </a:tc>
-                <a:tc>
-                  <a:txBody>
-                    <a:bodyPr/>
-                    <a:lstStyle/>
-                    <a:p>
-                      <a:pPr>
-                        <a:defRPr sz="1000"/>
-                      </a:pPr>
-                      <a:r>
-                        <a:t>52</a:t>
-                      </a:r>
-                    </a:p>
-                  </a:txBody>
-                  <a:tcPr/>
-                </a:tc>
-              </a:tr>
-              <a:tr h="548640">
-                <a:tc>
-                  <a:txBody>
-                    <a:bodyPr/>
-                    <a:lstStyle/>
-                    <a:p>
-                      <a:pPr>
-                        <a:defRPr sz="1000"/>
-                      </a:pPr>
-                      <a:r>
-                        <a:t>Hindu</a:t>
-                      </a:r>
-                    </a:p>
-                  </a:txBody>
-                  <a:tcPr/>
-                </a:tc>
-                <a:tc>
-                  <a:txBody>
-                    <a:bodyPr/>
-                    <a:lstStyle/>
-                    <a:p>
-                      <a:pPr>
-                        <a:defRPr sz="1000"/>
-                      </a:pPr>
-                      <a:r>
-                        <a:t>Hindu</a:t>
-                      </a:r>
-                    </a:p>
-                  </a:txBody>
-                  <a:tcPr/>
-                </a:tc>
-                <a:tc>
-                  <a:txBody>
-                    <a:bodyPr/>
-                    <a:lstStyle/>
-                    <a:p>
-                      <a:pPr>
-                        <a:defRPr sz="1000"/>
-                      </a:pPr>
-                      <a:r>
-                        <a:t>48</a:t>
-                      </a:r>
-                    </a:p>
-                  </a:txBody>
-                  <a:tcPr/>
-                </a:tc>
-              </a:tr>
-              <a:tr h="548640">
-                <a:tc>
-                  <a:txBody>
-                    <a:bodyPr/>
-                    <a:lstStyle/>
-                    <a:p>
-                      <a:pPr>
-                        <a:defRPr sz="1000"/>
-                      </a:pPr>
-                      <a:r>
-                        <a:t>Other Western</a:t>
-                      </a:r>
-                    </a:p>
-                  </a:txBody>
-                  <a:tcPr/>
-                </a:tc>
-                <a:tc>
-                  <a:txBody>
-                    <a:bodyPr/>
-                    <a:lstStyle/>
-                    <a:p>
-                      <a:pPr>
-                        <a:defRPr sz="1000"/>
-                      </a:pPr>
-                      <a:r>
-                        <a:t>Other Western</a:t>
-                      </a:r>
-                    </a:p>
-                  </a:txBody>
-                  <a:tcPr/>
-                </a:tc>
-                <a:tc>
-                  <a:txBody>
-                    <a:bodyPr/>
-                    <a:lstStyle/>
-                    <a:p>
-                      <a:pPr>
-                        <a:defRPr sz="1000"/>
-                      </a:pPr>
-                      <a:r>
-                        <a:t>43</a:t>
-                      </a:r>
-                    </a:p>
-                  </a:txBody>
-                  <a:tcPr/>
-                </a:tc>
-              </a:tr>
-              <a:tr h="548640">
-                <a:tc>
-                  <a:txBody>
-                    <a:bodyPr/>
-                    <a:lstStyle/>
-                    <a:p>
-                      <a:pPr>
-                        <a:defRPr sz="1000"/>
-                      </a:pPr>
-                      <a:r>
-                        <a:t>Continental Europe</a:t>
-                      </a:r>
-                    </a:p>
-                  </a:txBody>
-                  <a:tcPr/>
-                </a:tc>
-                <a:tc>
-                  <a:txBody>
-                    <a:bodyPr/>
-                    <a:lstStyle/>
-                    <a:p>
-                      <a:pPr>
-                        <a:defRPr sz="1000"/>
-                      </a:pPr>
-                      <a:r>
-                        <a:t>Other Western</a:t>
-                      </a:r>
-                    </a:p>
-                  </a:txBody>
-                  <a:tcPr/>
-                </a:tc>
-                <a:tc>
-                  <a:txBody>
-                    <a:bodyPr/>
-                    <a:lstStyle/>
-                    <a:p>
-                      <a:pPr>
-                        <a:defRPr sz="1000"/>
-                      </a:pPr>
-                      <a:r>
-                        <a:t>40</a:t>
-                      </a:r>
-                    </a:p>
-                  </a:txBody>
-                  <a:tcPr/>
-                </a:tc>
-              </a:tr>
-              <a:tr h="548640">
-                <a:tc>
-                  <a:txBody>
-                    <a:bodyPr/>
-                    <a:lstStyle/>
-                    <a:p>
-                      <a:pPr>
-                        <a:defRPr sz="1000"/>
-                      </a:pPr>
-                      <a:r>
-                        <a:t>United States</a:t>
-                      </a:r>
-                    </a:p>
-                  </a:txBody>
-                  <a:tcPr/>
-                </a:tc>
-                <a:tc>
-                  <a:txBody>
-                    <a:bodyPr/>
-                    <a:lstStyle/>
-                    <a:p>
-                      <a:pPr>
-                        <a:defRPr sz="1000"/>
-                      </a:pPr>
-                      <a:r>
-                        <a:t>Continental Europe</a:t>
-                      </a:r>
-                    </a:p>
-                  </a:txBody>
-                  <a:tcPr/>
-                </a:tc>
-                <a:tc>
-                  <a:txBody>
-                    <a:bodyPr/>
-                    <a:lstStyle/>
-                    <a:p>
-                      <a:pPr>
-                        <a:defRPr sz="1000"/>
-                      </a:pPr>
-                      <a:r>
-                        <a:t>38</a:t>
-                      </a:r>
-                    </a:p>
-                  </a:txBody>
-                  <a:tcPr/>
-                </a:tc>
-              </a:tr>
-            </a:tbl>
-          </a:graphicData>
-        </a:graphic>
-      </p:graphicFrame>
-    </p:spTree>
-  </p:cSld>
-  <p:clrMapOvr>
-    <a:masterClrMapping/>
-  </p:clrMapOvr>
-</p:sld>
-</file>
-
-<file path=ppt/slides/slide19.xml><?xml version="1.0" encoding="utf-8"?>
-<p:sld xmlns:a="http://schemas.openxmlformats.org/drawingml/2006/main" xmlns:p="http://schemas.openxmlformats.org/presentationml/2006/main" xmlns:r="http://schemas.openxmlformats.org/officeDocument/2006/relationships">
-  <p:cSld>
-    <p:spTree>
-      <p:nvGrpSpPr>
-        <p:cNvPr id="1" name=""/>
-        <p:cNvGrpSpPr/>
-        <p:nvPr/>
-      </p:nvGrpSpPr>
-      <p:grpSpPr/>
-      <p:sp>
-        <p:nvSpPr>
-          <p:cNvPr id="2" name="Title 1"/>
-          <p:cNvSpPr>
-            <a:spLocks noGrp="1"/>
-          </p:cNvSpPr>
-          <p:nvPr>
-            <p:ph type="title"/>
-          </p:nvPr>
-        </p:nvSpPr>
-        <p:spPr/>
-        <p:txBody>
-          <a:bodyPr/>
-          <a:lstStyle/>
-          <a:p>
-            <a:r>
-              <a:t>Table 11: Projection accuracy by civilisation, 2017-2023</a:t>
-            </a:r>
-          </a:p>
-        </p:txBody>
-      </p:sp>
-      <p:sp>
-        <p:nvSpPr>
-          <p:cNvPr id="3" name="Content Placeholder 2"/>
-          <p:cNvSpPr>
-            <a:spLocks noGrp="1"/>
-          </p:cNvSpPr>
-          <p:nvPr>
-            <p:ph idx="1" sz="half"/>
-          </p:nvPr>
-        </p:nvSpPr>
-        <p:spPr/>
-        <p:txBody>
-          <a:bodyPr/>
-          <a:lstStyle/>
-          <a:p/>
-        </p:txBody>
-      </p:sp>
-      <p:sp>
-        <p:nvSpPr>
-          <p:cNvPr id="4" name="Content Placeholder 3"/>
-          <p:cNvSpPr>
-            <a:spLocks noGrp="1"/>
-          </p:cNvSpPr>
-          <p:nvPr>
-            <p:ph idx="2" sz="half"/>
-          </p:nvPr>
-        </p:nvSpPr>
-        <p:spPr/>
-        <p:txBody>
-          <a:bodyPr/>
-          <a:lstStyle/>
-          <a:p/>
-        </p:txBody>
-      </p:sp>
-      <p:graphicFrame>
-        <p:nvGraphicFramePr>
-          <p:cNvPr id="5" name="Table 4"/>
-          <p:cNvGraphicFramePr>
-            <a:graphicFrameLocks noGrp="1"/>
-          </p:cNvGraphicFramePr>
-          <p:nvPr/>
-        </p:nvGraphicFramePr>
-        <p:xfrm>
-          <a:off x="457200" y="1097280"/>
-          <a:ext cx="6035040" cy="5486400"/>
-        </p:xfrm>
-        <a:graphic>
-          <a:graphicData uri="http://schemas.openxmlformats.org/drawingml/2006/table">
-            <a:tbl>
-              <a:tblPr firstRow="1" bandRow="1">
-                <a:tableStyleId>{5C22544A-7EE6-4342-B048-85BDC9FD1C3A}</a:tableStyleId>
-              </a:tblPr>
-              <a:tblGrid>
-                <a:gridCol w="2011680"/>
-                <a:gridCol w="2011680"/>
-                <a:gridCol w="2011680"/>
-              </a:tblGrid>
-              <a:tr h="548640">
-                <a:tc>
-                  <a:txBody>
-                    <a:bodyPr/>
-                    <a:lstStyle/>
-                    <a:p>
-                      <a:r>
-                        <a:t>Group</a:t>
-                      </a:r>
-                    </a:p>
-                  </a:txBody>
-                  <a:tcPr/>
-                </a:tc>
-                <a:tc>
-                  <a:txBody>
-                    <a:bodyPr/>
-                    <a:lstStyle/>
-                    <a:p>
-                      <a:r>
-                        <a:t>RMSE</a:t>
-                      </a:r>
-                    </a:p>
-                  </a:txBody>
-                  <a:tcPr/>
-                </a:tc>
-                <a:tc>
-                  <a:txBody>
-                    <a:bodyPr/>
-                    <a:lstStyle/>
-                    <a:p>
-                      <a:r>
-                        <a:t>MAPE</a:t>
-                      </a:r>
-                    </a:p>
-                  </a:txBody>
-                  <a:tcPr/>
-                </a:tc>
-              </a:tr>
-              <a:tr h="548640">
-                <a:tc>
-                  <a:txBody>
-                    <a:bodyPr/>
-                    <a:lstStyle/>
-                    <a:p>
-                      <a:pPr>
-                        <a:defRPr sz="1000"/>
-                      </a:pPr>
-                      <a:r>
-                        <a:t>Anglosphere ex-US</a:t>
-                      </a:r>
-                    </a:p>
-                  </a:txBody>
-                  <a:tcPr/>
-                </a:tc>
-                <a:tc>
-                  <a:txBody>
-                    <a:bodyPr/>
-                    <a:lstStyle/>
-                    <a:p>
-                      <a:pPr>
-                        <a:defRPr sz="1000"/>
-                      </a:pPr>
-                      <a:r>
-                        <a:t>1.79</a:t>
-                      </a:r>
-                    </a:p>
-                  </a:txBody>
-                  <a:tcPr/>
-                </a:tc>
-                <a:tc>
-                  <a:txBody>
-                    <a:bodyPr/>
-                    <a:lstStyle/>
-                    <a:p>
-                      <a:pPr>
-                        <a:defRPr sz="1000"/>
-                      </a:pPr>
-                      <a:r>
-                        <a:t>24.5%</a:t>
-                      </a:r>
-                    </a:p>
-                  </a:txBody>
-                  <a:tcPr/>
-                </a:tc>
-              </a:tr>
-              <a:tr h="548640">
-                <a:tc>
-                  <a:txBody>
-                    <a:bodyPr/>
-                    <a:lstStyle/>
-                    <a:p>
-                      <a:pPr>
-                        <a:defRPr sz="1000"/>
-                      </a:pPr>
-                      <a:r>
-                        <a:t>Continental Europe</a:t>
-                      </a:r>
-                    </a:p>
-                  </a:txBody>
-                  <a:tcPr/>
-                </a:tc>
-                <a:tc>
-                  <a:txBody>
-                    <a:bodyPr/>
-                    <a:lstStyle/>
-                    <a:p>
-                      <a:pPr>
-                        <a:defRPr sz="1000"/>
-                      </a:pPr>
-                      <a:r>
-                        <a:t>2.12</a:t>
-                      </a:r>
-                    </a:p>
-                  </a:txBody>
-                  <a:tcPr/>
-                </a:tc>
-                <a:tc>
-                  <a:txBody>
-                    <a:bodyPr/>
-                    <a:lstStyle/>
-                    <a:p>
-                      <a:pPr>
-                        <a:defRPr sz="1000"/>
-                      </a:pPr>
-                      <a:r>
-                        <a:t>28.5%</a:t>
-                      </a:r>
-                    </a:p>
-                  </a:txBody>
-                  <a:tcPr/>
-                </a:tc>
-              </a:tr>
-              <a:tr h="548640">
-                <a:tc>
-                  <a:txBody>
-                    <a:bodyPr/>
-                    <a:lstStyle/>
-                    <a:p>
-                      <a:pPr>
-                        <a:defRPr sz="1000"/>
-                      </a:pPr>
-                      <a:r>
-                        <a:t>Hindu</a:t>
-                      </a:r>
-                    </a:p>
-                  </a:txBody>
-                  <a:tcPr/>
-                </a:tc>
-                <a:tc>
-                  <a:txBody>
-                    <a:bodyPr/>
-                    <a:lstStyle/>
-                    <a:p>
-                      <a:pPr>
-                        <a:defRPr sz="1000"/>
-                      </a:pPr>
-                      <a:r>
-                        <a:t>1.56</a:t>
-                      </a:r>
-                    </a:p>
-                  </a:txBody>
-                  <a:tcPr/>
-                </a:tc>
-                <a:tc>
-                  <a:txBody>
-                    <a:bodyPr/>
-                    <a:lstStyle/>
-                    <a:p>
-                      <a:pPr>
-                        <a:defRPr sz="1000"/>
-                      </a:pPr>
-                      <a:r>
-                        <a:t>30.5%</a:t>
-                      </a:r>
-                    </a:p>
-                  </a:txBody>
-                  <a:tcPr/>
-                </a:tc>
-              </a:tr>
-              <a:tr h="548640">
-                <a:tc>
-                  <a:txBody>
-                    <a:bodyPr/>
-                    <a:lstStyle/>
-                    <a:p>
-                      <a:pPr>
-                        <a:defRPr sz="1000"/>
-                      </a:pPr>
-                      <a:r>
-                        <a:t>Islamic</a:t>
-                      </a:r>
-                    </a:p>
-                  </a:txBody>
-                  <a:tcPr/>
-                </a:tc>
-                <a:tc>
-                  <a:txBody>
-                    <a:bodyPr/>
-                    <a:lstStyle/>
-                    <a:p>
-                      <a:pPr>
-                        <a:defRPr sz="1000"/>
-                      </a:pPr>
-                      <a:r>
-                        <a:t>3.05</a:t>
-                      </a:r>
-                    </a:p>
-                  </a:txBody>
-                  <a:tcPr/>
-                </a:tc>
-                <a:tc>
-                  <a:txBody>
-                    <a:bodyPr/>
-                    <a:lstStyle/>
-                    <a:p>
-                      <a:pPr>
-                        <a:defRPr sz="1000"/>
-                      </a:pPr>
-                      <a:r>
-                        <a:t>48.0%</a:t>
-                      </a:r>
-                    </a:p>
-                  </a:txBody>
-                  <a:tcPr/>
-                </a:tc>
-              </a:tr>
-              <a:tr h="548640">
-                <a:tc>
-                  <a:txBody>
-                    <a:bodyPr/>
-                    <a:lstStyle/>
-                    <a:p>
-                      <a:pPr>
-                        <a:defRPr sz="1000"/>
-                      </a:pPr>
-                      <a:r>
-                        <a:t>Japanese</a:t>
-                      </a:r>
-                    </a:p>
-                  </a:txBody>
-                  <a:tcPr/>
-                </a:tc>
-                <a:tc>
-                  <a:txBody>
-                    <a:bodyPr/>
-                    <a:lstStyle/>
-                    <a:p>
-                      <a:pPr>
-                        <a:defRPr sz="1000"/>
-                      </a:pPr>
-                      <a:r>
-                        <a:t>1.23</a:t>
-                      </a:r>
-                    </a:p>
-                  </a:txBody>
-                  <a:tcPr/>
-                </a:tc>
-                <a:tc>
-                  <a:txBody>
-                    <a:bodyPr/>
-                    <a:lstStyle/>
-                    <a:p>
-                      <a:pPr>
-                        <a:defRPr sz="1000"/>
-                      </a:pPr>
-                      <a:r>
-                        <a:t>32.3%</a:t>
-                      </a:r>
-                    </a:p>
-                  </a:txBody>
-                  <a:tcPr/>
-                </a:tc>
-              </a:tr>
-              <a:tr h="548640">
-                <a:tc>
-                  <a:txBody>
-                    <a:bodyPr/>
-                    <a:lstStyle/>
-                    <a:p>
-                      <a:pPr>
-                        <a:defRPr sz="1000"/>
-                      </a:pPr>
-                      <a:r>
-                        <a:t>Other Civilizations</a:t>
-                      </a:r>
-                    </a:p>
-                  </a:txBody>
-                  <a:tcPr/>
-                </a:tc>
-                <a:tc>
-                  <a:txBody>
-                    <a:bodyPr/>
-                    <a:lstStyle/>
-                    <a:p>
-                      <a:pPr>
-                        <a:defRPr sz="1000"/>
-                      </a:pPr>
-                      <a:r>
-                        <a:t>1.72</a:t>
-                      </a:r>
-                    </a:p>
-                  </a:txBody>
-                  <a:tcPr/>
-                </a:tc>
-                <a:tc>
-                  <a:txBody>
-                    <a:bodyPr/>
-                    <a:lstStyle/>
-                    <a:p>
-                      <a:pPr>
-                        <a:defRPr sz="1000"/>
-                      </a:pPr>
-                      <a:r>
-                        <a:t>36.7%</a:t>
-                      </a:r>
-                    </a:p>
-                  </a:txBody>
-                  <a:tcPr/>
-                </a:tc>
-              </a:tr>
-              <a:tr h="548640">
-                <a:tc>
-                  <a:txBody>
-                    <a:bodyPr/>
-                    <a:lstStyle/>
-                    <a:p>
-                      <a:pPr>
-                        <a:defRPr sz="1000"/>
-                      </a:pPr>
-                      <a:r>
-                        <a:t>Other Western</a:t>
-                      </a:r>
-                    </a:p>
-                  </a:txBody>
-                  <a:tcPr/>
-                </a:tc>
-                <a:tc>
-                  <a:txBody>
-                    <a:bodyPr/>
-                    <a:lstStyle/>
-                    <a:p>
-                      <a:pPr>
-                        <a:defRPr sz="1000"/>
-                      </a:pPr>
-                      <a:r>
-                        <a:t>2.22</a:t>
-                      </a:r>
-                    </a:p>
-                  </a:txBody>
-                  <a:tcPr/>
-                </a:tc>
-                <a:tc>
-                  <a:txBody>
-                    <a:bodyPr/>
-                    <a:lstStyle/>
-                    <a:p>
-                      <a:pPr>
-                        <a:defRPr sz="1000"/>
-                      </a:pPr>
-                      <a:r>
-                        <a:t>34.8%</a:t>
-                      </a:r>
-                    </a:p>
-                  </a:txBody>
-                  <a:tcPr/>
-                </a:tc>
-              </a:tr>
-              <a:tr h="548640">
-                <a:tc>
-                  <a:txBody>
-                    <a:bodyPr/>
-                    <a:lstStyle/>
-                    <a:p>
-                      <a:pPr>
-                        <a:defRPr sz="1000"/>
-                      </a:pPr>
-                      <a:r>
-                        <a:t>Sinic</a:t>
-                      </a:r>
-                    </a:p>
-                  </a:txBody>
-                  <a:tcPr/>
-                </a:tc>
-                <a:tc>
-                  <a:txBody>
-                    <a:bodyPr/>
-                    <a:lstStyle/>
-                    <a:p>
-                      <a:pPr>
-                        <a:defRPr sz="1000"/>
-                      </a:pPr>
-                      <a:r>
-                        <a:t>4.43</a:t>
-                      </a:r>
-                    </a:p>
-                  </a:txBody>
-                  <a:tcPr/>
-                </a:tc>
-                <a:tc>
-                  <a:txBody>
-                    <a:bodyPr/>
-                    <a:lstStyle/>
-                    <a:p>
-                      <a:pPr>
-                        <a:defRPr sz="1000"/>
-                      </a:pPr>
-                      <a:r>
-                        <a:t>54.5%</a:t>
-                      </a:r>
-                    </a:p>
-                  </a:txBody>
-                  <a:tcPr/>
-                </a:tc>
-              </a:tr>
-              <a:tr h="548640">
-                <a:tc>
-                  <a:txBody>
-                    <a:bodyPr/>
-                    <a:lstStyle/>
-                    <a:p>
-                      <a:pPr>
-                        <a:defRPr sz="1000"/>
-                      </a:pPr>
-                      <a:r>
-                        <a:t>United States</a:t>
-                      </a:r>
-                    </a:p>
-                  </a:txBody>
-                  <a:tcPr/>
-                </a:tc>
-                <a:tc>
-                  <a:txBody>
-                    <a:bodyPr/>
-                    <a:lstStyle/>
-                    <a:p>
-                      <a:pPr>
-                        <a:defRPr sz="1000"/>
-                      </a:pPr>
-                      <a:r>
-                        <a:t>3.87</a:t>
-                      </a:r>
-                    </a:p>
-                  </a:txBody>
-                  <a:tcPr/>
-                </a:tc>
-                <a:tc>
-                  <a:txBody>
-                    <a:bodyPr/>
-                    <a:lstStyle/>
-                    <a:p>
-                      <a:pPr>
-                        <a:defRPr sz="1000"/>
-                      </a:pPr>
-                      <a:r>
-                        <a:t>33.6%</a:t>
                       </a:r>
                     </a:p>
                   </a:txBody>
@@ -9182,6 +8271,1175 @@
 </file>
 
 <file path=ppt/slides/slide20.xml><?xml version="1.0" encoding="utf-8"?>
+<p:sld xmlns:a="http://schemas.openxmlformats.org/drawingml/2006/main" xmlns:p="http://schemas.openxmlformats.org/presentationml/2006/main" xmlns:r="http://schemas.openxmlformats.org/officeDocument/2006/relationships">
+  <p:cSld>
+    <p:spTree>
+      <p:nvGrpSpPr>
+        <p:cNvPr id="1" name=""/>
+        <p:cNvGrpSpPr/>
+        <p:nvPr/>
+      </p:nvGrpSpPr>
+      <p:grpSpPr/>
+      <p:sp>
+        <p:nvSpPr>
+          <p:cNvPr id="2" name="Title 1"/>
+          <p:cNvSpPr>
+            <a:spLocks noGrp="1"/>
+          </p:cNvSpPr>
+          <p:nvPr>
+            <p:ph type="title"/>
+          </p:nvPr>
+        </p:nvSpPr>
+        <p:spPr/>
+        <p:txBody>
+          <a:bodyPr/>
+          <a:lstStyle/>
+          <a:p>
+            <a:r>
+              <a:t>Table 10: Top origin-destination abroad author-year pairs</a:t>
+            </a:r>
+          </a:p>
+        </p:txBody>
+      </p:sp>
+      <p:sp>
+        <p:nvSpPr>
+          <p:cNvPr id="3" name="Content Placeholder 2"/>
+          <p:cNvSpPr>
+            <a:spLocks noGrp="1"/>
+          </p:cNvSpPr>
+          <p:nvPr>
+            <p:ph idx="1" sz="half"/>
+          </p:nvPr>
+        </p:nvSpPr>
+        <p:spPr/>
+        <p:txBody>
+          <a:bodyPr/>
+          <a:lstStyle/>
+          <a:p/>
+        </p:txBody>
+      </p:sp>
+      <p:sp>
+        <p:nvSpPr>
+          <p:cNvPr id="4" name="Content Placeholder 3"/>
+          <p:cNvSpPr>
+            <a:spLocks noGrp="1"/>
+          </p:cNvSpPr>
+          <p:nvPr>
+            <p:ph idx="2" sz="half"/>
+          </p:nvPr>
+        </p:nvSpPr>
+        <p:spPr/>
+        <p:txBody>
+          <a:bodyPr/>
+          <a:lstStyle/>
+          <a:p/>
+        </p:txBody>
+      </p:sp>
+      <p:graphicFrame>
+        <p:nvGraphicFramePr>
+          <p:cNvPr id="5" name="Table 4"/>
+          <p:cNvGraphicFramePr>
+            <a:graphicFrameLocks noGrp="1"/>
+          </p:cNvGraphicFramePr>
+          <p:nvPr/>
+        </p:nvGraphicFramePr>
+        <p:xfrm>
+          <a:off x="457200" y="1097280"/>
+          <a:ext cx="5486400" cy="6035040"/>
+        </p:xfrm>
+        <a:graphic>
+          <a:graphicData uri="http://schemas.openxmlformats.org/drawingml/2006/table">
+            <a:tbl>
+              <a:tblPr firstRow="1" bandRow="1">
+                <a:tableStyleId>{5C22544A-7EE6-4342-B048-85BDC9FD1C3A}</a:tableStyleId>
+              </a:tblPr>
+              <a:tblGrid>
+                <a:gridCol w="1828800"/>
+                <a:gridCol w="1828800"/>
+                <a:gridCol w="1828800"/>
+              </a:tblGrid>
+              <a:tr h="548640">
+                <a:tc>
+                  <a:txBody>
+                    <a:bodyPr/>
+                    <a:lstStyle/>
+                    <a:p>
+                      <a:r>
+                        <a:t>Origin</a:t>
+                      </a:r>
+                    </a:p>
+                  </a:txBody>
+                  <a:tcPr/>
+                </a:tc>
+                <a:tc>
+                  <a:txBody>
+                    <a:bodyPr/>
+                    <a:lstStyle/>
+                    <a:p>
+                      <a:r>
+                        <a:t>Destination</a:t>
+                      </a:r>
+                    </a:p>
+                  </a:txBody>
+                  <a:tcPr/>
+                </a:tc>
+                <a:tc>
+                  <a:txBody>
+                    <a:bodyPr/>
+                    <a:lstStyle/>
+                    <a:p>
+                      <a:r>
+                        <a:t>Author-years</a:t>
+                      </a:r>
+                    </a:p>
+                  </a:txBody>
+                  <a:tcPr/>
+                </a:tc>
+              </a:tr>
+              <a:tr h="548640">
+                <a:tc>
+                  <a:txBody>
+                    <a:bodyPr/>
+                    <a:lstStyle/>
+                    <a:p>
+                      <a:pPr>
+                        <a:defRPr sz="1000"/>
+                      </a:pPr>
+                      <a:r>
+                        <a:t>Continental Europe</a:t>
+                      </a:r>
+                    </a:p>
+                  </a:txBody>
+                  <a:tcPr/>
+                </a:tc>
+                <a:tc>
+                  <a:txBody>
+                    <a:bodyPr/>
+                    <a:lstStyle/>
+                    <a:p>
+                      <a:pPr>
+                        <a:defRPr sz="1000"/>
+                      </a:pPr>
+                      <a:r>
+                        <a:t>Continental Europe</a:t>
+                      </a:r>
+                    </a:p>
+                  </a:txBody>
+                  <a:tcPr/>
+                </a:tc>
+                <a:tc>
+                  <a:txBody>
+                    <a:bodyPr/>
+                    <a:lstStyle/>
+                    <a:p>
+                      <a:pPr>
+                        <a:defRPr sz="1000"/>
+                      </a:pPr>
+                      <a:r>
+                        <a:t>80</a:t>
+                      </a:r>
+                    </a:p>
+                  </a:txBody>
+                  <a:tcPr/>
+                </a:tc>
+              </a:tr>
+              <a:tr h="548640">
+                <a:tc>
+                  <a:txBody>
+                    <a:bodyPr/>
+                    <a:lstStyle/>
+                    <a:p>
+                      <a:pPr>
+                        <a:defRPr sz="1000"/>
+                      </a:pPr>
+                      <a:r>
+                        <a:t>Sinic</a:t>
+                      </a:r>
+                    </a:p>
+                  </a:txBody>
+                  <a:tcPr/>
+                </a:tc>
+                <a:tc>
+                  <a:txBody>
+                    <a:bodyPr/>
+                    <a:lstStyle/>
+                    <a:p>
+                      <a:pPr>
+                        <a:defRPr sz="1000"/>
+                      </a:pPr>
+                      <a:r>
+                        <a:t>Sinic</a:t>
+                      </a:r>
+                    </a:p>
+                  </a:txBody>
+                  <a:tcPr/>
+                </a:tc>
+                <a:tc>
+                  <a:txBody>
+                    <a:bodyPr/>
+                    <a:lstStyle/>
+                    <a:p>
+                      <a:pPr>
+                        <a:defRPr sz="1000"/>
+                      </a:pPr>
+                      <a:r>
+                        <a:t>78</a:t>
+                      </a:r>
+                    </a:p>
+                  </a:txBody>
+                  <a:tcPr/>
+                </a:tc>
+              </a:tr>
+              <a:tr h="548640">
+                <a:tc>
+                  <a:txBody>
+                    <a:bodyPr/>
+                    <a:lstStyle/>
+                    <a:p>
+                      <a:pPr>
+                        <a:defRPr sz="1000"/>
+                      </a:pPr>
+                      <a:r>
+                        <a:t>Anglosphere ex-US</a:t>
+                      </a:r>
+                    </a:p>
+                  </a:txBody>
+                  <a:tcPr/>
+                </a:tc>
+                <a:tc>
+                  <a:txBody>
+                    <a:bodyPr/>
+                    <a:lstStyle/>
+                    <a:p>
+                      <a:pPr>
+                        <a:defRPr sz="1000"/>
+                      </a:pPr>
+                      <a:r>
+                        <a:t>Continental Europe</a:t>
+                      </a:r>
+                    </a:p>
+                  </a:txBody>
+                  <a:tcPr/>
+                </a:tc>
+                <a:tc>
+                  <a:txBody>
+                    <a:bodyPr/>
+                    <a:lstStyle/>
+                    <a:p>
+                      <a:pPr>
+                        <a:defRPr sz="1000"/>
+                      </a:pPr>
+                      <a:r>
+                        <a:t>61</a:t>
+                      </a:r>
+                    </a:p>
+                  </a:txBody>
+                  <a:tcPr/>
+                </a:tc>
+              </a:tr>
+              <a:tr h="548640">
+                <a:tc>
+                  <a:txBody>
+                    <a:bodyPr/>
+                    <a:lstStyle/>
+                    <a:p>
+                      <a:pPr>
+                        <a:defRPr sz="1000"/>
+                      </a:pPr>
+                      <a:r>
+                        <a:t>Continental Europe</a:t>
+                      </a:r>
+                    </a:p>
+                  </a:txBody>
+                  <a:tcPr/>
+                </a:tc>
+                <a:tc>
+                  <a:txBody>
+                    <a:bodyPr/>
+                    <a:lstStyle/>
+                    <a:p>
+                      <a:pPr>
+                        <a:defRPr sz="1000"/>
+                      </a:pPr>
+                      <a:r>
+                        <a:t>Anglosphere ex-US</a:t>
+                      </a:r>
+                    </a:p>
+                  </a:txBody>
+                  <a:tcPr/>
+                </a:tc>
+                <a:tc>
+                  <a:txBody>
+                    <a:bodyPr/>
+                    <a:lstStyle/>
+                    <a:p>
+                      <a:pPr>
+                        <a:defRPr sz="1000"/>
+                      </a:pPr>
+                      <a:r>
+                        <a:t>60</a:t>
+                      </a:r>
+                    </a:p>
+                  </a:txBody>
+                  <a:tcPr/>
+                </a:tc>
+              </a:tr>
+              <a:tr h="548640">
+                <a:tc>
+                  <a:txBody>
+                    <a:bodyPr/>
+                    <a:lstStyle/>
+                    <a:p>
+                      <a:pPr>
+                        <a:defRPr sz="1000"/>
+                      </a:pPr>
+                      <a:r>
+                        <a:t>Anglosphere ex-US</a:t>
+                      </a:r>
+                    </a:p>
+                  </a:txBody>
+                  <a:tcPr/>
+                </a:tc>
+                <a:tc>
+                  <a:txBody>
+                    <a:bodyPr/>
+                    <a:lstStyle/>
+                    <a:p>
+                      <a:pPr>
+                        <a:defRPr sz="1000"/>
+                      </a:pPr>
+                      <a:r>
+                        <a:t>Anglosphere ex-US</a:t>
+                      </a:r>
+                    </a:p>
+                  </a:txBody>
+                  <a:tcPr/>
+                </a:tc>
+                <a:tc>
+                  <a:txBody>
+                    <a:bodyPr/>
+                    <a:lstStyle/>
+                    <a:p>
+                      <a:pPr>
+                        <a:defRPr sz="1000"/>
+                      </a:pPr>
+                      <a:r>
+                        <a:t>59</a:t>
+                      </a:r>
+                    </a:p>
+                  </a:txBody>
+                  <a:tcPr/>
+                </a:tc>
+              </a:tr>
+              <a:tr h="548640">
+                <a:tc>
+                  <a:txBody>
+                    <a:bodyPr/>
+                    <a:lstStyle/>
+                    <a:p>
+                      <a:pPr>
+                        <a:defRPr sz="1000"/>
+                      </a:pPr>
+                      <a:r>
+                        <a:t>United States</a:t>
+                      </a:r>
+                    </a:p>
+                  </a:txBody>
+                  <a:tcPr/>
+                </a:tc>
+                <a:tc>
+                  <a:txBody>
+                    <a:bodyPr/>
+                    <a:lstStyle/>
+                    <a:p>
+                      <a:pPr>
+                        <a:defRPr sz="1000"/>
+                      </a:pPr>
+                      <a:r>
+                        <a:t>Other Western</a:t>
+                      </a:r>
+                    </a:p>
+                  </a:txBody>
+                  <a:tcPr/>
+                </a:tc>
+                <a:tc>
+                  <a:txBody>
+                    <a:bodyPr/>
+                    <a:lstStyle/>
+                    <a:p>
+                      <a:pPr>
+                        <a:defRPr sz="1000"/>
+                      </a:pPr>
+                      <a:r>
+                        <a:t>52</a:t>
+                      </a:r>
+                    </a:p>
+                  </a:txBody>
+                  <a:tcPr/>
+                </a:tc>
+              </a:tr>
+              <a:tr h="548640">
+                <a:tc>
+                  <a:txBody>
+                    <a:bodyPr/>
+                    <a:lstStyle/>
+                    <a:p>
+                      <a:pPr>
+                        <a:defRPr sz="1000"/>
+                      </a:pPr>
+                      <a:r>
+                        <a:t>Hindu</a:t>
+                      </a:r>
+                    </a:p>
+                  </a:txBody>
+                  <a:tcPr/>
+                </a:tc>
+                <a:tc>
+                  <a:txBody>
+                    <a:bodyPr/>
+                    <a:lstStyle/>
+                    <a:p>
+                      <a:pPr>
+                        <a:defRPr sz="1000"/>
+                      </a:pPr>
+                      <a:r>
+                        <a:t>Hindu</a:t>
+                      </a:r>
+                    </a:p>
+                  </a:txBody>
+                  <a:tcPr/>
+                </a:tc>
+                <a:tc>
+                  <a:txBody>
+                    <a:bodyPr/>
+                    <a:lstStyle/>
+                    <a:p>
+                      <a:pPr>
+                        <a:defRPr sz="1000"/>
+                      </a:pPr>
+                      <a:r>
+                        <a:t>48</a:t>
+                      </a:r>
+                    </a:p>
+                  </a:txBody>
+                  <a:tcPr/>
+                </a:tc>
+              </a:tr>
+              <a:tr h="548640">
+                <a:tc>
+                  <a:txBody>
+                    <a:bodyPr/>
+                    <a:lstStyle/>
+                    <a:p>
+                      <a:pPr>
+                        <a:defRPr sz="1000"/>
+                      </a:pPr>
+                      <a:r>
+                        <a:t>Other Western</a:t>
+                      </a:r>
+                    </a:p>
+                  </a:txBody>
+                  <a:tcPr/>
+                </a:tc>
+                <a:tc>
+                  <a:txBody>
+                    <a:bodyPr/>
+                    <a:lstStyle/>
+                    <a:p>
+                      <a:pPr>
+                        <a:defRPr sz="1000"/>
+                      </a:pPr>
+                      <a:r>
+                        <a:t>Other Western</a:t>
+                      </a:r>
+                    </a:p>
+                  </a:txBody>
+                  <a:tcPr/>
+                </a:tc>
+                <a:tc>
+                  <a:txBody>
+                    <a:bodyPr/>
+                    <a:lstStyle/>
+                    <a:p>
+                      <a:pPr>
+                        <a:defRPr sz="1000"/>
+                      </a:pPr>
+                      <a:r>
+                        <a:t>43</a:t>
+                      </a:r>
+                    </a:p>
+                  </a:txBody>
+                  <a:tcPr/>
+                </a:tc>
+              </a:tr>
+              <a:tr h="548640">
+                <a:tc>
+                  <a:txBody>
+                    <a:bodyPr/>
+                    <a:lstStyle/>
+                    <a:p>
+                      <a:pPr>
+                        <a:defRPr sz="1000"/>
+                      </a:pPr>
+                      <a:r>
+                        <a:t>Continental Europe</a:t>
+                      </a:r>
+                    </a:p>
+                  </a:txBody>
+                  <a:tcPr/>
+                </a:tc>
+                <a:tc>
+                  <a:txBody>
+                    <a:bodyPr/>
+                    <a:lstStyle/>
+                    <a:p>
+                      <a:pPr>
+                        <a:defRPr sz="1000"/>
+                      </a:pPr>
+                      <a:r>
+                        <a:t>Other Western</a:t>
+                      </a:r>
+                    </a:p>
+                  </a:txBody>
+                  <a:tcPr/>
+                </a:tc>
+                <a:tc>
+                  <a:txBody>
+                    <a:bodyPr/>
+                    <a:lstStyle/>
+                    <a:p>
+                      <a:pPr>
+                        <a:defRPr sz="1000"/>
+                      </a:pPr>
+                      <a:r>
+                        <a:t>40</a:t>
+                      </a:r>
+                    </a:p>
+                  </a:txBody>
+                  <a:tcPr/>
+                </a:tc>
+              </a:tr>
+              <a:tr h="548640">
+                <a:tc>
+                  <a:txBody>
+                    <a:bodyPr/>
+                    <a:lstStyle/>
+                    <a:p>
+                      <a:pPr>
+                        <a:defRPr sz="1000"/>
+                      </a:pPr>
+                      <a:r>
+                        <a:t>United States</a:t>
+                      </a:r>
+                    </a:p>
+                  </a:txBody>
+                  <a:tcPr/>
+                </a:tc>
+                <a:tc>
+                  <a:txBody>
+                    <a:bodyPr/>
+                    <a:lstStyle/>
+                    <a:p>
+                      <a:pPr>
+                        <a:defRPr sz="1000"/>
+                      </a:pPr>
+                      <a:r>
+                        <a:t>Continental Europe</a:t>
+                      </a:r>
+                    </a:p>
+                  </a:txBody>
+                  <a:tcPr/>
+                </a:tc>
+                <a:tc>
+                  <a:txBody>
+                    <a:bodyPr/>
+                    <a:lstStyle/>
+                    <a:p>
+                      <a:pPr>
+                        <a:defRPr sz="1000"/>
+                      </a:pPr>
+                      <a:r>
+                        <a:t>38</a:t>
+                      </a:r>
+                    </a:p>
+                  </a:txBody>
+                  <a:tcPr/>
+                </a:tc>
+              </a:tr>
+            </a:tbl>
+          </a:graphicData>
+        </a:graphic>
+      </p:graphicFrame>
+    </p:spTree>
+  </p:cSld>
+  <p:clrMapOvr>
+    <a:masterClrMapping/>
+  </p:clrMapOvr>
+</p:sld>
+</file>
+
+<file path=ppt/slides/slide21.xml><?xml version="1.0" encoding="utf-8"?>
+<p:sld xmlns:a="http://schemas.openxmlformats.org/drawingml/2006/main" xmlns:p="http://schemas.openxmlformats.org/presentationml/2006/main" xmlns:r="http://schemas.openxmlformats.org/officeDocument/2006/relationships">
+  <p:cSld>
+    <p:spTree>
+      <p:nvGrpSpPr>
+        <p:cNvPr id="1" name=""/>
+        <p:cNvGrpSpPr/>
+        <p:nvPr/>
+      </p:nvGrpSpPr>
+      <p:grpSpPr/>
+      <p:sp>
+        <p:nvSpPr>
+          <p:cNvPr id="2" name="Title 1"/>
+          <p:cNvSpPr>
+            <a:spLocks noGrp="1"/>
+          </p:cNvSpPr>
+          <p:nvPr>
+            <p:ph type="title"/>
+          </p:nvPr>
+        </p:nvSpPr>
+        <p:spPr/>
+        <p:txBody>
+          <a:bodyPr/>
+          <a:lstStyle/>
+          <a:p>
+            <a:r>
+              <a:t>Table 11: Projection accuracy by civilisation, 2017-2023</a:t>
+            </a:r>
+          </a:p>
+        </p:txBody>
+      </p:sp>
+      <p:sp>
+        <p:nvSpPr>
+          <p:cNvPr id="3" name="Content Placeholder 2"/>
+          <p:cNvSpPr>
+            <a:spLocks noGrp="1"/>
+          </p:cNvSpPr>
+          <p:nvPr>
+            <p:ph idx="1" sz="half"/>
+          </p:nvPr>
+        </p:nvSpPr>
+        <p:spPr/>
+        <p:txBody>
+          <a:bodyPr/>
+          <a:lstStyle/>
+          <a:p/>
+        </p:txBody>
+      </p:sp>
+      <p:sp>
+        <p:nvSpPr>
+          <p:cNvPr id="4" name="Content Placeholder 3"/>
+          <p:cNvSpPr>
+            <a:spLocks noGrp="1"/>
+          </p:cNvSpPr>
+          <p:nvPr>
+            <p:ph idx="2" sz="half"/>
+          </p:nvPr>
+        </p:nvSpPr>
+        <p:spPr/>
+        <p:txBody>
+          <a:bodyPr/>
+          <a:lstStyle/>
+          <a:p/>
+        </p:txBody>
+      </p:sp>
+      <p:graphicFrame>
+        <p:nvGraphicFramePr>
+          <p:cNvPr id="5" name="Table 4"/>
+          <p:cNvGraphicFramePr>
+            <a:graphicFrameLocks noGrp="1"/>
+          </p:cNvGraphicFramePr>
+          <p:nvPr/>
+        </p:nvGraphicFramePr>
+        <p:xfrm>
+          <a:off x="457200" y="1097280"/>
+          <a:ext cx="6035040" cy="5486400"/>
+        </p:xfrm>
+        <a:graphic>
+          <a:graphicData uri="http://schemas.openxmlformats.org/drawingml/2006/table">
+            <a:tbl>
+              <a:tblPr firstRow="1" bandRow="1">
+                <a:tableStyleId>{5C22544A-7EE6-4342-B048-85BDC9FD1C3A}</a:tableStyleId>
+              </a:tblPr>
+              <a:tblGrid>
+                <a:gridCol w="2011680"/>
+                <a:gridCol w="2011680"/>
+                <a:gridCol w="2011680"/>
+              </a:tblGrid>
+              <a:tr h="548640">
+                <a:tc>
+                  <a:txBody>
+                    <a:bodyPr/>
+                    <a:lstStyle/>
+                    <a:p>
+                      <a:r>
+                        <a:t>Group</a:t>
+                      </a:r>
+                    </a:p>
+                  </a:txBody>
+                  <a:tcPr/>
+                </a:tc>
+                <a:tc>
+                  <a:txBody>
+                    <a:bodyPr/>
+                    <a:lstStyle/>
+                    <a:p>
+                      <a:r>
+                        <a:t>RMSE</a:t>
+                      </a:r>
+                    </a:p>
+                  </a:txBody>
+                  <a:tcPr/>
+                </a:tc>
+                <a:tc>
+                  <a:txBody>
+                    <a:bodyPr/>
+                    <a:lstStyle/>
+                    <a:p>
+                      <a:r>
+                        <a:t>MAPE</a:t>
+                      </a:r>
+                    </a:p>
+                  </a:txBody>
+                  <a:tcPr/>
+                </a:tc>
+              </a:tr>
+              <a:tr h="548640">
+                <a:tc>
+                  <a:txBody>
+                    <a:bodyPr/>
+                    <a:lstStyle/>
+                    <a:p>
+                      <a:pPr>
+                        <a:defRPr sz="1000"/>
+                      </a:pPr>
+                      <a:r>
+                        <a:t>Anglosphere ex-US</a:t>
+                      </a:r>
+                    </a:p>
+                  </a:txBody>
+                  <a:tcPr/>
+                </a:tc>
+                <a:tc>
+                  <a:txBody>
+                    <a:bodyPr/>
+                    <a:lstStyle/>
+                    <a:p>
+                      <a:pPr>
+                        <a:defRPr sz="1000"/>
+                      </a:pPr>
+                      <a:r>
+                        <a:t>1.79</a:t>
+                      </a:r>
+                    </a:p>
+                  </a:txBody>
+                  <a:tcPr/>
+                </a:tc>
+                <a:tc>
+                  <a:txBody>
+                    <a:bodyPr/>
+                    <a:lstStyle/>
+                    <a:p>
+                      <a:pPr>
+                        <a:defRPr sz="1000"/>
+                      </a:pPr>
+                      <a:r>
+                        <a:t>24.5%</a:t>
+                      </a:r>
+                    </a:p>
+                  </a:txBody>
+                  <a:tcPr/>
+                </a:tc>
+              </a:tr>
+              <a:tr h="548640">
+                <a:tc>
+                  <a:txBody>
+                    <a:bodyPr/>
+                    <a:lstStyle/>
+                    <a:p>
+                      <a:pPr>
+                        <a:defRPr sz="1000"/>
+                      </a:pPr>
+                      <a:r>
+                        <a:t>Continental Europe</a:t>
+                      </a:r>
+                    </a:p>
+                  </a:txBody>
+                  <a:tcPr/>
+                </a:tc>
+                <a:tc>
+                  <a:txBody>
+                    <a:bodyPr/>
+                    <a:lstStyle/>
+                    <a:p>
+                      <a:pPr>
+                        <a:defRPr sz="1000"/>
+                      </a:pPr>
+                      <a:r>
+                        <a:t>2.12</a:t>
+                      </a:r>
+                    </a:p>
+                  </a:txBody>
+                  <a:tcPr/>
+                </a:tc>
+                <a:tc>
+                  <a:txBody>
+                    <a:bodyPr/>
+                    <a:lstStyle/>
+                    <a:p>
+                      <a:pPr>
+                        <a:defRPr sz="1000"/>
+                      </a:pPr>
+                      <a:r>
+                        <a:t>28.5%</a:t>
+                      </a:r>
+                    </a:p>
+                  </a:txBody>
+                  <a:tcPr/>
+                </a:tc>
+              </a:tr>
+              <a:tr h="548640">
+                <a:tc>
+                  <a:txBody>
+                    <a:bodyPr/>
+                    <a:lstStyle/>
+                    <a:p>
+                      <a:pPr>
+                        <a:defRPr sz="1000"/>
+                      </a:pPr>
+                      <a:r>
+                        <a:t>Hindu</a:t>
+                      </a:r>
+                    </a:p>
+                  </a:txBody>
+                  <a:tcPr/>
+                </a:tc>
+                <a:tc>
+                  <a:txBody>
+                    <a:bodyPr/>
+                    <a:lstStyle/>
+                    <a:p>
+                      <a:pPr>
+                        <a:defRPr sz="1000"/>
+                      </a:pPr>
+                      <a:r>
+                        <a:t>1.56</a:t>
+                      </a:r>
+                    </a:p>
+                  </a:txBody>
+                  <a:tcPr/>
+                </a:tc>
+                <a:tc>
+                  <a:txBody>
+                    <a:bodyPr/>
+                    <a:lstStyle/>
+                    <a:p>
+                      <a:pPr>
+                        <a:defRPr sz="1000"/>
+                      </a:pPr>
+                      <a:r>
+                        <a:t>30.5%</a:t>
+                      </a:r>
+                    </a:p>
+                  </a:txBody>
+                  <a:tcPr/>
+                </a:tc>
+              </a:tr>
+              <a:tr h="548640">
+                <a:tc>
+                  <a:txBody>
+                    <a:bodyPr/>
+                    <a:lstStyle/>
+                    <a:p>
+                      <a:pPr>
+                        <a:defRPr sz="1000"/>
+                      </a:pPr>
+                      <a:r>
+                        <a:t>Islamic</a:t>
+                      </a:r>
+                    </a:p>
+                  </a:txBody>
+                  <a:tcPr/>
+                </a:tc>
+                <a:tc>
+                  <a:txBody>
+                    <a:bodyPr/>
+                    <a:lstStyle/>
+                    <a:p>
+                      <a:pPr>
+                        <a:defRPr sz="1000"/>
+                      </a:pPr>
+                      <a:r>
+                        <a:t>3.05</a:t>
+                      </a:r>
+                    </a:p>
+                  </a:txBody>
+                  <a:tcPr/>
+                </a:tc>
+                <a:tc>
+                  <a:txBody>
+                    <a:bodyPr/>
+                    <a:lstStyle/>
+                    <a:p>
+                      <a:pPr>
+                        <a:defRPr sz="1000"/>
+                      </a:pPr>
+                      <a:r>
+                        <a:t>48.0%</a:t>
+                      </a:r>
+                    </a:p>
+                  </a:txBody>
+                  <a:tcPr/>
+                </a:tc>
+              </a:tr>
+              <a:tr h="548640">
+                <a:tc>
+                  <a:txBody>
+                    <a:bodyPr/>
+                    <a:lstStyle/>
+                    <a:p>
+                      <a:pPr>
+                        <a:defRPr sz="1000"/>
+                      </a:pPr>
+                      <a:r>
+                        <a:t>Japanese</a:t>
+                      </a:r>
+                    </a:p>
+                  </a:txBody>
+                  <a:tcPr/>
+                </a:tc>
+                <a:tc>
+                  <a:txBody>
+                    <a:bodyPr/>
+                    <a:lstStyle/>
+                    <a:p>
+                      <a:pPr>
+                        <a:defRPr sz="1000"/>
+                      </a:pPr>
+                      <a:r>
+                        <a:t>1.23</a:t>
+                      </a:r>
+                    </a:p>
+                  </a:txBody>
+                  <a:tcPr/>
+                </a:tc>
+                <a:tc>
+                  <a:txBody>
+                    <a:bodyPr/>
+                    <a:lstStyle/>
+                    <a:p>
+                      <a:pPr>
+                        <a:defRPr sz="1000"/>
+                      </a:pPr>
+                      <a:r>
+                        <a:t>32.3%</a:t>
+                      </a:r>
+                    </a:p>
+                  </a:txBody>
+                  <a:tcPr/>
+                </a:tc>
+              </a:tr>
+              <a:tr h="548640">
+                <a:tc>
+                  <a:txBody>
+                    <a:bodyPr/>
+                    <a:lstStyle/>
+                    <a:p>
+                      <a:pPr>
+                        <a:defRPr sz="1000"/>
+                      </a:pPr>
+                      <a:r>
+                        <a:t>Other Civilizations</a:t>
+                      </a:r>
+                    </a:p>
+                  </a:txBody>
+                  <a:tcPr/>
+                </a:tc>
+                <a:tc>
+                  <a:txBody>
+                    <a:bodyPr/>
+                    <a:lstStyle/>
+                    <a:p>
+                      <a:pPr>
+                        <a:defRPr sz="1000"/>
+                      </a:pPr>
+                      <a:r>
+                        <a:t>1.72</a:t>
+                      </a:r>
+                    </a:p>
+                  </a:txBody>
+                  <a:tcPr/>
+                </a:tc>
+                <a:tc>
+                  <a:txBody>
+                    <a:bodyPr/>
+                    <a:lstStyle/>
+                    <a:p>
+                      <a:pPr>
+                        <a:defRPr sz="1000"/>
+                      </a:pPr>
+                      <a:r>
+                        <a:t>36.7%</a:t>
+                      </a:r>
+                    </a:p>
+                  </a:txBody>
+                  <a:tcPr/>
+                </a:tc>
+              </a:tr>
+              <a:tr h="548640">
+                <a:tc>
+                  <a:txBody>
+                    <a:bodyPr/>
+                    <a:lstStyle/>
+                    <a:p>
+                      <a:pPr>
+                        <a:defRPr sz="1000"/>
+                      </a:pPr>
+                      <a:r>
+                        <a:t>Other Western</a:t>
+                      </a:r>
+                    </a:p>
+                  </a:txBody>
+                  <a:tcPr/>
+                </a:tc>
+                <a:tc>
+                  <a:txBody>
+                    <a:bodyPr/>
+                    <a:lstStyle/>
+                    <a:p>
+                      <a:pPr>
+                        <a:defRPr sz="1000"/>
+                      </a:pPr>
+                      <a:r>
+                        <a:t>2.22</a:t>
+                      </a:r>
+                    </a:p>
+                  </a:txBody>
+                  <a:tcPr/>
+                </a:tc>
+                <a:tc>
+                  <a:txBody>
+                    <a:bodyPr/>
+                    <a:lstStyle/>
+                    <a:p>
+                      <a:pPr>
+                        <a:defRPr sz="1000"/>
+                      </a:pPr>
+                      <a:r>
+                        <a:t>34.8%</a:t>
+                      </a:r>
+                    </a:p>
+                  </a:txBody>
+                  <a:tcPr/>
+                </a:tc>
+              </a:tr>
+              <a:tr h="548640">
+                <a:tc>
+                  <a:txBody>
+                    <a:bodyPr/>
+                    <a:lstStyle/>
+                    <a:p>
+                      <a:pPr>
+                        <a:defRPr sz="1000"/>
+                      </a:pPr>
+                      <a:r>
+                        <a:t>Sinic</a:t>
+                      </a:r>
+                    </a:p>
+                  </a:txBody>
+                  <a:tcPr/>
+                </a:tc>
+                <a:tc>
+                  <a:txBody>
+                    <a:bodyPr/>
+                    <a:lstStyle/>
+                    <a:p>
+                      <a:pPr>
+                        <a:defRPr sz="1000"/>
+                      </a:pPr>
+                      <a:r>
+                        <a:t>4.43</a:t>
+                      </a:r>
+                    </a:p>
+                  </a:txBody>
+                  <a:tcPr/>
+                </a:tc>
+                <a:tc>
+                  <a:txBody>
+                    <a:bodyPr/>
+                    <a:lstStyle/>
+                    <a:p>
+                      <a:pPr>
+                        <a:defRPr sz="1000"/>
+                      </a:pPr>
+                      <a:r>
+                        <a:t>54.5%</a:t>
+                      </a:r>
+                    </a:p>
+                  </a:txBody>
+                  <a:tcPr/>
+                </a:tc>
+              </a:tr>
+              <a:tr h="548640">
+                <a:tc>
+                  <a:txBody>
+                    <a:bodyPr/>
+                    <a:lstStyle/>
+                    <a:p>
+                      <a:pPr>
+                        <a:defRPr sz="1000"/>
+                      </a:pPr>
+                      <a:r>
+                        <a:t>United States</a:t>
+                      </a:r>
+                    </a:p>
+                  </a:txBody>
+                  <a:tcPr/>
+                </a:tc>
+                <a:tc>
+                  <a:txBody>
+                    <a:bodyPr/>
+                    <a:lstStyle/>
+                    <a:p>
+                      <a:pPr>
+                        <a:defRPr sz="1000"/>
+                      </a:pPr>
+                      <a:r>
+                        <a:t>3.87</a:t>
+                      </a:r>
+                    </a:p>
+                  </a:txBody>
+                  <a:tcPr/>
+                </a:tc>
+                <a:tc>
+                  <a:txBody>
+                    <a:bodyPr/>
+                    <a:lstStyle/>
+                    <a:p>
+                      <a:pPr>
+                        <a:defRPr sz="1000"/>
+                      </a:pPr>
+                      <a:r>
+                        <a:t>33.6%</a:t>
+                      </a:r>
+                    </a:p>
+                  </a:txBody>
+                  <a:tcPr/>
+                </a:tc>
+              </a:tr>
+            </a:tbl>
+          </a:graphicData>
+        </a:graphic>
+      </p:graphicFrame>
+    </p:spTree>
+  </p:cSld>
+  <p:clrMapOvr>
+    <a:masterClrMapping/>
+  </p:clrMapOvr>
+</p:sld>
+</file>
+
+<file path=ppt/slides/slide22.xml><?xml version="1.0" encoding="utf-8"?>
 <p:sld xmlns:a="http://schemas.openxmlformats.org/drawingml/2006/main" xmlns:p="http://schemas.openxmlformats.org/presentationml/2006/main" xmlns:r="http://schemas.openxmlformats.org/officeDocument/2006/relationships">
   <p:cSld>
     <p:spTree>

</xml_diff>

<commit_message>
fix(annual-projection): right-censor exits, fill zero-inflow years, train-period first-compartment shares, dashed/solid observed/projected split, pass fig_dir to annual plots; correct Methods text to match code; regenerate full-article docx/md/pptx/zip and review report
Co-Authored-By: Tatsuki Onishi <bougtoir@gmail.com>
</commit_message>
<xml_diff>
--- a/researcher_mobility_ode/docs/manuscript_full_article_figures.pptx
+++ b/researcher_mobility_ode/docs/manuscript_full_article_figures.pptx
@@ -6687,7 +6687,7 @@
         <p:spPr>
           <a:xfrm>
             <a:off x="1371600" y="1097280"/>
-            <a:ext cx="9144000" cy="5833374"/>
+            <a:ext cx="9144000" cy="5834597"/>
           </a:xfrm>
           <a:prstGeom prst="rect">
             <a:avLst/>
@@ -7252,22 +7252,22 @@
                         <a:defRPr sz="1000"/>
                       </a:pPr>
                       <a:r>
-                        <a:t>0.043972244494452827</a:t>
-                      </a:r>
-                    </a:p>
-                  </a:txBody>
-                  <a:tcPr/>
-                </a:tc>
-                <a:tc>
-                  <a:txBody>
-                    <a:bodyPr/>
-                    <a:lstStyle/>
-                    <a:p>
-                      <a:pPr>
-                        <a:defRPr sz="1000"/>
-                      </a:pPr>
-                      <a:r>
-                        <a:t>2.076923076923077</a:t>
+                        <a:t>0.041833207061297735</a:t>
+                      </a:r>
+                    </a:p>
+                  </a:txBody>
+                  <a:tcPr/>
+                </a:tc>
+                <a:tc>
+                  <a:txBody>
+                    <a:bodyPr/>
+                    <a:lstStyle/>
+                    <a:p>
+                      <a:pPr>
+                        <a:defRPr sz="1000"/>
+                      </a:pPr>
+                      <a:r>
+                        <a:t>1.588235294117647</a:t>
                       </a:r>
                     </a:p>
                   </a:txBody>
@@ -7359,22 +7359,22 @@
                         <a:defRPr sz="1000"/>
                       </a:pPr>
                       <a:r>
-                        <a:t>0.0300192911404828</a:t>
-                      </a:r>
-                    </a:p>
-                  </a:txBody>
-                  <a:tcPr/>
-                </a:tc>
-                <a:tc>
-                  <a:txBody>
-                    <a:bodyPr/>
-                    <a:lstStyle/>
-                    <a:p>
-                      <a:pPr>
-                        <a:defRPr sz="1000"/>
-                      </a:pPr>
-                      <a:r>
-                        <a:t>3.0625</a:t>
+                        <a:t>0.02681241691779005</a:t>
+                      </a:r>
+                    </a:p>
+                  </a:txBody>
+                  <a:tcPr/>
+                </a:tc>
+                <a:tc>
+                  <a:txBody>
+                    <a:bodyPr/>
+                    <a:lstStyle/>
+                    <a:p>
+                      <a:pPr>
+                        <a:defRPr sz="1000"/>
+                      </a:pPr>
+                      <a:r>
+                        <a:t>2.8823529411764706</a:t>
                       </a:r>
                     </a:p>
                   </a:txBody>
@@ -7481,7 +7481,7 @@
                         <a:defRPr sz="1000"/>
                       </a:pPr>
                       <a:r>
-                        <a:t>1.7333333333333334</a:t>
+                        <a:t>1.5294117647058822</a:t>
                       </a:r>
                     </a:p>
                   </a:txBody>
@@ -7588,7 +7588,7 @@
                         <a:defRPr sz="1000"/>
                       </a:pPr>
                       <a:r>
-                        <a:t>2.2222222222222223</a:t>
+                        <a:t>1.25</a:t>
                       </a:r>
                     </a:p>
                   </a:txBody>
@@ -7680,22 +7680,22 @@
                         <a:defRPr sz="1000"/>
                       </a:pPr>
                       <a:r>
-                        <a:t>0.05831801893653609</a:t>
-                      </a:r>
-                    </a:p>
-                  </a:txBody>
-                  <a:tcPr/>
-                </a:tc>
-                <a:tc>
-                  <a:txBody>
-                    <a:bodyPr/>
-                    <a:lstStyle/>
-                    <a:p>
-                      <a:pPr>
-                        <a:defRPr sz="1000"/>
-                      </a:pPr>
-                      <a:r>
-                        <a:t>2.0</a:t>
+                        <a:t>0.04921779348050002</a:t>
+                      </a:r>
+                    </a:p>
+                  </a:txBody>
+                  <a:tcPr/>
+                </a:tc>
+                <a:tc>
+                  <a:txBody>
+                    <a:bodyPr/>
+                    <a:lstStyle/>
+                    <a:p>
+                      <a:pPr>
+                        <a:defRPr sz="1000"/>
+                      </a:pPr>
+                      <a:r>
+                        <a:t>1.5294117647058822</a:t>
                       </a:r>
                     </a:p>
                   </a:txBody>
@@ -7787,22 +7787,22 @@
                         <a:defRPr sz="1000"/>
                       </a:pPr>
                       <a:r>
-                        <a:t>0.08593809508349504</a:t>
-                      </a:r>
-                    </a:p>
-                  </a:txBody>
-                  <a:tcPr/>
-                </a:tc>
-                <a:tc>
-                  <a:txBody>
-                    <a:bodyPr/>
-                    <a:lstStyle/>
-                    <a:p>
-                      <a:pPr>
-                        <a:defRPr sz="1000"/>
-                      </a:pPr>
-                      <a:r>
-                        <a:t>1.6666666666666667</a:t>
+                        <a:t>0.08033585418713651</a:t>
+                      </a:r>
+                    </a:p>
+                  </a:txBody>
+                  <a:tcPr/>
+                </a:tc>
+                <a:tc>
+                  <a:txBody>
+                    <a:bodyPr/>
+                    <a:lstStyle/>
+                    <a:p>
+                      <a:pPr>
+                        <a:defRPr sz="1000"/>
+                      </a:pPr>
+                      <a:r>
+                        <a:t>1.1764705882352942</a:t>
                       </a:r>
                     </a:p>
                   </a:txBody>
@@ -7909,7 +7909,7 @@
                         <a:defRPr sz="1000"/>
                       </a:pPr>
                       <a:r>
-                        <a:t>1.6666666666666667</a:t>
+                        <a:t>0.8823529411764706</a:t>
                       </a:r>
                     </a:p>
                   </a:txBody>
@@ -8016,7 +8016,7 @@
                         <a:defRPr sz="1000"/>
                       </a:pPr>
                       <a:r>
-                        <a:t>2.5625</a:t>
+                        <a:t>2.411764705882353</a:t>
                       </a:r>
                     </a:p>
                   </a:txBody>
@@ -8108,7 +8108,7 @@
                         <a:defRPr sz="1000"/>
                       </a:pPr>
                       <a:r>
-                        <a:t>0.027229516859262524</a:t>
+                        <a:t>0.02323216194912871</a:t>
                       </a:r>
                     </a:p>
                   </a:txBody>
@@ -9029,22 +9029,22 @@
                         <a:defRPr sz="1000"/>
                       </a:pPr>
                       <a:r>
-                        <a:t>1.79</a:t>
-                      </a:r>
-                    </a:p>
-                  </a:txBody>
-                  <a:tcPr/>
-                </a:tc>
-                <a:tc>
-                  <a:txBody>
-                    <a:bodyPr/>
-                    <a:lstStyle/>
-                    <a:p>
-                      <a:pPr>
-                        <a:defRPr sz="1000"/>
-                      </a:pPr>
-                      <a:r>
-                        <a:t>24.5%</a:t>
+                        <a:t>1.77</a:t>
+                      </a:r>
+                    </a:p>
+                  </a:txBody>
+                  <a:tcPr/>
+                </a:tc>
+                <a:tc>
+                  <a:txBody>
+                    <a:bodyPr/>
+                    <a:lstStyle/>
+                    <a:p>
+                      <a:pPr>
+                        <a:defRPr sz="1000"/>
+                      </a:pPr>
+                      <a:r>
+                        <a:t>25.2%</a:t>
                       </a:r>
                     </a:p>
                   </a:txBody>
@@ -9076,22 +9076,22 @@
                         <a:defRPr sz="1000"/>
                       </a:pPr>
                       <a:r>
-                        <a:t>2.12</a:t>
-                      </a:r>
-                    </a:p>
-                  </a:txBody>
-                  <a:tcPr/>
-                </a:tc>
-                <a:tc>
-                  <a:txBody>
-                    <a:bodyPr/>
-                    <a:lstStyle/>
-                    <a:p>
-                      <a:pPr>
-                        <a:defRPr sz="1000"/>
-                      </a:pPr>
-                      <a:r>
-                        <a:t>28.5%</a:t>
+                        <a:t>1.97</a:t>
+                      </a:r>
+                    </a:p>
+                  </a:txBody>
+                  <a:tcPr/>
+                </a:tc>
+                <a:tc>
+                  <a:txBody>
+                    <a:bodyPr/>
+                    <a:lstStyle/>
+                    <a:p>
+                      <a:pPr>
+                        <a:defRPr sz="1000"/>
+                      </a:pPr>
+                      <a:r>
+                        <a:t>27.2%</a:t>
                       </a:r>
                     </a:p>
                   </a:txBody>
@@ -9123,22 +9123,22 @@
                         <a:defRPr sz="1000"/>
                       </a:pPr>
                       <a:r>
-                        <a:t>1.56</a:t>
-                      </a:r>
-                    </a:p>
-                  </a:txBody>
-                  <a:tcPr/>
-                </a:tc>
-                <a:tc>
-                  <a:txBody>
-                    <a:bodyPr/>
-                    <a:lstStyle/>
-                    <a:p>
-                      <a:pPr>
-                        <a:defRPr sz="1000"/>
-                      </a:pPr>
-                      <a:r>
-                        <a:t>30.5%</a:t>
+                        <a:t>2.44</a:t>
+                      </a:r>
+                    </a:p>
+                  </a:txBody>
+                  <a:tcPr/>
+                </a:tc>
+                <a:tc>
+                  <a:txBody>
+                    <a:bodyPr/>
+                    <a:lstStyle/>
+                    <a:p>
+                      <a:pPr>
+                        <a:defRPr sz="1000"/>
+                      </a:pPr>
+                      <a:r>
+                        <a:t>39.4%</a:t>
                       </a:r>
                     </a:p>
                   </a:txBody>
@@ -9170,22 +9170,22 @@
                         <a:defRPr sz="1000"/>
                       </a:pPr>
                       <a:r>
-                        <a:t>3.05</a:t>
-                      </a:r>
-                    </a:p>
-                  </a:txBody>
-                  <a:tcPr/>
-                </a:tc>
-                <a:tc>
-                  <a:txBody>
-                    <a:bodyPr/>
-                    <a:lstStyle/>
-                    <a:p>
-                      <a:pPr>
-                        <a:defRPr sz="1000"/>
-                      </a:pPr>
-                      <a:r>
-                        <a:t>48.0%</a:t>
+                        <a:t>4.99</a:t>
+                      </a:r>
+                    </a:p>
+                  </a:txBody>
+                  <a:tcPr/>
+                </a:tc>
+                <a:tc>
+                  <a:txBody>
+                    <a:bodyPr/>
+                    <a:lstStyle/>
+                    <a:p>
+                      <a:pPr>
+                        <a:defRPr sz="1000"/>
+                      </a:pPr>
+                      <a:r>
+                        <a:t>68.9%</a:t>
                       </a:r>
                     </a:p>
                   </a:txBody>
@@ -9232,7 +9232,7 @@
                         <a:defRPr sz="1000"/>
                       </a:pPr>
                       <a:r>
-                        <a:t>32.3%</a:t>
+                        <a:t>32.1%</a:t>
                       </a:r>
                     </a:p>
                   </a:txBody>
@@ -9264,22 +9264,22 @@
                         <a:defRPr sz="1000"/>
                       </a:pPr>
                       <a:r>
-                        <a:t>1.72</a:t>
-                      </a:r>
-                    </a:p>
-                  </a:txBody>
-                  <a:tcPr/>
-                </a:tc>
-                <a:tc>
-                  <a:txBody>
-                    <a:bodyPr/>
-                    <a:lstStyle/>
-                    <a:p>
-                      <a:pPr>
-                        <a:defRPr sz="1000"/>
-                      </a:pPr>
-                      <a:r>
-                        <a:t>36.7%</a:t>
+                        <a:t>1.83</a:t>
+                      </a:r>
+                    </a:p>
+                  </a:txBody>
+                  <a:tcPr/>
+                </a:tc>
+                <a:tc>
+                  <a:txBody>
+                    <a:bodyPr/>
+                    <a:lstStyle/>
+                    <a:p>
+                      <a:pPr>
+                        <a:defRPr sz="1000"/>
+                      </a:pPr>
+                      <a:r>
+                        <a:t>37.6%</a:t>
                       </a:r>
                     </a:p>
                   </a:txBody>
@@ -9311,22 +9311,22 @@
                         <a:defRPr sz="1000"/>
                       </a:pPr>
                       <a:r>
-                        <a:t>2.22</a:t>
-                      </a:r>
-                    </a:p>
-                  </a:txBody>
-                  <a:tcPr/>
-                </a:tc>
-                <a:tc>
-                  <a:txBody>
-                    <a:bodyPr/>
-                    <a:lstStyle/>
-                    <a:p>
-                      <a:pPr>
-                        <a:defRPr sz="1000"/>
-                      </a:pPr>
-                      <a:r>
-                        <a:t>34.8%</a:t>
+                        <a:t>2.74</a:t>
+                      </a:r>
+                    </a:p>
+                  </a:txBody>
+                  <a:tcPr/>
+                </a:tc>
+                <a:tc>
+                  <a:txBody>
+                    <a:bodyPr/>
+                    <a:lstStyle/>
+                    <a:p>
+                      <a:pPr>
+                        <a:defRPr sz="1000"/>
+                      </a:pPr>
+                      <a:r>
+                        <a:t>42.9%</a:t>
                       </a:r>
                     </a:p>
                   </a:txBody>
@@ -9358,22 +9358,22 @@
                         <a:defRPr sz="1000"/>
                       </a:pPr>
                       <a:r>
-                        <a:t>4.43</a:t>
-                      </a:r>
-                    </a:p>
-                  </a:txBody>
-                  <a:tcPr/>
-                </a:tc>
-                <a:tc>
-                  <a:txBody>
-                    <a:bodyPr/>
-                    <a:lstStyle/>
-                    <a:p>
-                      <a:pPr>
-                        <a:defRPr sz="1000"/>
-                      </a:pPr>
-                      <a:r>
-                        <a:t>54.5%</a:t>
+                        <a:t>5.30</a:t>
+                      </a:r>
+                    </a:p>
+                  </a:txBody>
+                  <a:tcPr/>
+                </a:tc>
+                <a:tc>
+                  <a:txBody>
+                    <a:bodyPr/>
+                    <a:lstStyle/>
+                    <a:p>
+                      <a:pPr>
+                        <a:defRPr sz="1000"/>
+                      </a:pPr>
+                      <a:r>
+                        <a:t>70.9%</a:t>
                       </a:r>
                     </a:p>
                   </a:txBody>
@@ -9405,22 +9405,22 @@
                         <a:defRPr sz="1000"/>
                       </a:pPr>
                       <a:r>
-                        <a:t>3.87</a:t>
-                      </a:r>
-                    </a:p>
-                  </a:txBody>
-                  <a:tcPr/>
-                </a:tc>
-                <a:tc>
-                  <a:txBody>
-                    <a:bodyPr/>
-                    <a:lstStyle/>
-                    <a:p>
-                      <a:pPr>
-                        <a:defRPr sz="1000"/>
-                      </a:pPr>
-                      <a:r>
-                        <a:t>33.6%</a:t>
+                        <a:t>4.79</a:t>
+                      </a:r>
+                    </a:p>
+                  </a:txBody>
+                  <a:tcPr/>
+                </a:tc>
+                <a:tc>
+                  <a:txBody>
+                    <a:bodyPr/>
+                    <a:lstStyle/>
+                    <a:p>
+                      <a:pPr>
+                        <a:defRPr sz="1000"/>
+                      </a:pPr>
+                      <a:r>
+                        <a:t>38.2%</a:t>
                       </a:r>
                     </a:p>
                   </a:txBody>
@@ -9590,22 +9590,22 @@
                         <a:defRPr sz="1000"/>
                       </a:pPr>
                       <a:r>
-                        <a:t>0.86</a:t>
-                      </a:r>
-                    </a:p>
-                  </a:txBody>
-                  <a:tcPr/>
-                </a:tc>
-                <a:tc>
-                  <a:txBody>
-                    <a:bodyPr/>
-                    <a:lstStyle/>
-                    <a:p>
-                      <a:pPr>
-                        <a:defRPr sz="1000"/>
-                      </a:pPr>
-                      <a:r>
-                        <a:t>55.0%</a:t>
+                        <a:t>1.15</a:t>
+                      </a:r>
+                    </a:p>
+                  </a:txBody>
+                  <a:tcPr/>
+                </a:tc>
+                <a:tc>
+                  <a:txBody>
+                    <a:bodyPr/>
+                    <a:lstStyle/>
+                    <a:p>
+                      <a:pPr>
+                        <a:defRPr sz="1000"/>
+                      </a:pPr>
+                      <a:r>
+                        <a:t>72.1%</a:t>
                       </a:r>
                     </a:p>
                   </a:txBody>
@@ -9637,22 +9637,22 @@
                         <a:defRPr sz="1000"/>
                       </a:pPr>
                       <a:r>
-                        <a:t>1.51</a:t>
-                      </a:r>
-                    </a:p>
-                  </a:txBody>
-                  <a:tcPr/>
-                </a:tc>
-                <a:tc>
-                  <a:txBody>
-                    <a:bodyPr/>
-                    <a:lstStyle/>
-                    <a:p>
-                      <a:pPr>
-                        <a:defRPr sz="1000"/>
-                      </a:pPr>
-                      <a:r>
-                        <a:t>21.1%</a:t>
+                        <a:t>2.42</a:t>
+                      </a:r>
+                    </a:p>
+                  </a:txBody>
+                  <a:tcPr/>
+                </a:tc>
+                <a:tc>
+                  <a:txBody>
+                    <a:bodyPr/>
+                    <a:lstStyle/>
+                    <a:p>
+                      <a:pPr>
+                        <a:defRPr sz="1000"/>
+                      </a:pPr>
+                      <a:r>
+                        <a:t>29.4%</a:t>
                       </a:r>
                     </a:p>
                   </a:txBody>
@@ -9684,22 +9684,22 @@
                         <a:defRPr sz="1000"/>
                       </a:pPr>
                       <a:r>
-                        <a:t>1.52</a:t>
-                      </a:r>
-                    </a:p>
-                  </a:txBody>
-                  <a:tcPr/>
-                </a:tc>
-                <a:tc>
-                  <a:txBody>
-                    <a:bodyPr/>
-                    <a:lstStyle/>
-                    <a:p>
-                      <a:pPr>
-                        <a:defRPr sz="1000"/>
-                      </a:pPr>
-                      <a:r>
-                        <a:t>27.6%</a:t>
+                        <a:t>1.63</a:t>
+                      </a:r>
+                    </a:p>
+                  </a:txBody>
+                  <a:tcPr/>
+                </a:tc>
+                <a:tc>
+                  <a:txBody>
+                    <a:bodyPr/>
+                    <a:lstStyle/>
+                    <a:p>
+                      <a:pPr>
+                        <a:defRPr sz="1000"/>
+                      </a:pPr>
+                      <a:r>
+                        <a:t>28.9%</a:t>
                       </a:r>
                     </a:p>
                   </a:txBody>
@@ -9731,22 +9731,22 @@
                         <a:defRPr sz="1000"/>
                       </a:pPr>
                       <a:r>
-                        <a:t>4.68</a:t>
-                      </a:r>
-                    </a:p>
-                  </a:txBody>
-                  <a:tcPr/>
-                </a:tc>
-                <a:tc>
-                  <a:txBody>
-                    <a:bodyPr/>
-                    <a:lstStyle/>
-                    <a:p>
-                      <a:pPr>
-                        <a:defRPr sz="1000"/>
-                      </a:pPr>
-                      <a:r>
-                        <a:t>32.3%</a:t>
+                        <a:t>6.54</a:t>
+                      </a:r>
+                    </a:p>
+                  </a:txBody>
+                  <a:tcPr/>
+                </a:tc>
+                <a:tc>
+                  <a:txBody>
+                    <a:bodyPr/>
+                    <a:lstStyle/>
+                    <a:p>
+                      <a:pPr>
+                        <a:defRPr sz="1000"/>
+                      </a:pPr>
+                      <a:r>
+                        <a:t>44.2%</a:t>
                       </a:r>
                     </a:p>
                   </a:txBody>
@@ -9778,22 +9778,22 @@
                         <a:defRPr sz="1000"/>
                       </a:pPr>
                       <a:r>
-                        <a:t>1.99</a:t>
-                      </a:r>
-                    </a:p>
-                  </a:txBody>
-                  <a:tcPr/>
-                </a:tc>
-                <a:tc>
-                  <a:txBody>
-                    <a:bodyPr/>
-                    <a:lstStyle/>
-                    <a:p>
-                      <a:pPr>
-                        <a:defRPr sz="1000"/>
-                      </a:pPr>
-                      <a:r>
-                        <a:t>46.9%</a:t>
+                        <a:t>1.98</a:t>
+                      </a:r>
+                    </a:p>
+                  </a:txBody>
+                  <a:tcPr/>
+                </a:tc>
+                <a:tc>
+                  <a:txBody>
+                    <a:bodyPr/>
+                    <a:lstStyle/>
+                    <a:p>
+                      <a:pPr>
+                        <a:defRPr sz="1000"/>
+                      </a:pPr>
+                      <a:r>
+                        <a:t>47.0%</a:t>
                       </a:r>
                     </a:p>
                   </a:txBody>
@@ -9825,22 +9825,22 @@
                         <a:defRPr sz="1000"/>
                       </a:pPr>
                       <a:r>
-                        <a:t>3.33</a:t>
-                      </a:r>
-                    </a:p>
-                  </a:txBody>
-                  <a:tcPr/>
-                </a:tc>
-                <a:tc>
-                  <a:txBody>
-                    <a:bodyPr/>
-                    <a:lstStyle/>
-                    <a:p>
-                      <a:pPr>
-                        <a:defRPr sz="1000"/>
-                      </a:pPr>
-                      <a:r>
-                        <a:t>32.7%</a:t>
+                        <a:t>3.32</a:t>
+                      </a:r>
+                    </a:p>
+                  </a:txBody>
+                  <a:tcPr/>
+                </a:tc>
+                <a:tc>
+                  <a:txBody>
+                    <a:bodyPr/>
+                    <a:lstStyle/>
+                    <a:p>
+                      <a:pPr>
+                        <a:defRPr sz="1000"/>
+                      </a:pPr>
+                      <a:r>
+                        <a:t>33.3%</a:t>
                       </a:r>
                     </a:p>
                   </a:txBody>

</xml_diff>

<commit_message>
fix(annual,manuscript): anchor annual dropout to cohort hazard, exclude self/Unknown inter-civ flows, update captions and Methods text
Co-Authored-By: Tatsuki Onishi <bougtoir@gmail.com>
</commit_message>
<xml_diff>
--- a/researcher_mobility_ode/docs/manuscript_full_article_figures.pptx
+++ b/researcher_mobility_ode/docs/manuscript_full_article_figures.pptx
@@ -7777,7 +7777,7 @@
           <a:lstStyle/>
           <a:p>
             <a:r>
-              <a:t>Figure 6: Inter-civilisation abroad author-years</a:t>
+              <a:t>Figure 6: Cross-civilisation abroad author-years</a:t>
             </a:r>
           </a:p>
         </p:txBody>
@@ -7833,7 +7833,7 @@
         <p:spPr>
           <a:xfrm>
             <a:off x="1371600" y="1097280"/>
-            <a:ext cx="9144000" cy="7367469"/>
+            <a:ext cx="9144000" cy="7433228"/>
           </a:xfrm>
           <a:prstGeom prst="rect">
             <a:avLst/>
@@ -7866,7 +7866,7 @@
               <a:defRPr sz="1400"/>
             </a:pPr>
             <a:r>
-              <a:t>Rows are origin civilisations; columns are destination civilisations approximated by recent_group.</a:t>
+              <a:t>Rows are origin civilisations; columns are destination civilisations approximated by recent_group. Same-civilisation cells and Unknown destinations are excluded.</a:t>
             </a:r>
           </a:p>
         </p:txBody>
@@ -8526,7 +8526,7 @@
                         <a:defRPr sz="1000"/>
                       </a:pPr>
                       <a:r>
-                        <a:t>2.3993559341492728e-05</a:t>
+                        <a:t>0.0456012888273175</a:t>
                       </a:r>
                     </a:p>
                   </a:txBody>
@@ -8633,7 +8633,7 @@
                         <a:defRPr sz="1000"/>
                       </a:pPr>
                       <a:r>
-                        <a:t>1.023603938867775e-05</a:t>
+                        <a:t>0.0458472850546197</a:t>
                       </a:r>
                     </a:p>
                   </a:txBody>
@@ -8740,7 +8740,7 @@
                         <a:defRPr sz="1000"/>
                       </a:pPr>
                       <a:r>
-                        <a:t>0.00017661680145375047</a:t>
+                        <a:t>0.0277057844536427</a:t>
                       </a:r>
                     </a:p>
                   </a:txBody>
@@ -8847,7 +8847,7 @@
                         <a:defRPr sz="1000"/>
                       </a:pPr>
                       <a:r>
-                        <a:t>0.00012802714302895973</a:t>
+                        <a:t>0.0300792155414555</a:t>
                       </a:r>
                     </a:p>
                   </a:txBody>
@@ -8954,7 +8954,7 @@
                         <a:defRPr sz="1000"/>
                       </a:pPr>
                       <a:r>
-                        <a:t>4.669479559562741e-05</a:t>
+                        <a:t>0.0552190245713187</a:t>
                       </a:r>
                     </a:p>
                   </a:txBody>
@@ -9061,7 +9061,7 @@
                         <a:defRPr sz="1000"/>
                       </a:pPr>
                       <a:r>
-                        <a:t>4.804844701600728e-05</a:t>
+                        <a:t>0.0418088008437154</a:t>
                       </a:r>
                     </a:p>
                   </a:txBody>
@@ -9168,7 +9168,7 @@
                         <a:defRPr sz="1000"/>
                       </a:pPr>
                       <a:r>
-                        <a:t>0.0003401825985208706</a:t>
+                        <a:t>0.0442928225810436</a:t>
                       </a:r>
                     </a:p>
                   </a:txBody>
@@ -9275,7 +9275,7 @@
                         <a:defRPr sz="1000"/>
                       </a:pPr>
                       <a:r>
-                        <a:t>1.899934220568275e-05</a:t>
+                        <a:t>0.0336695344484046</a:t>
                       </a:r>
                     </a:p>
                   </a:txBody>
@@ -9382,7 +9382,7 @@
                         <a:defRPr sz="1000"/>
                       </a:pPr>
                       <a:r>
-                        <a:t>1.1618201219453924e-05</a:t>
+                        <a:t>0.0459350067675392</a:t>
                       </a:r>
                     </a:p>
                   </a:txBody>
@@ -9680,6 +9680,21 @@
                         <a:defRPr sz="1000"/>
                       </a:pPr>
                       <a:r>
+                        <a:t>United States</a:t>
+                      </a:r>
+                    </a:p>
+                  </a:txBody>
+                  <a:tcPr/>
+                </a:tc>
+                <a:tc>
+                  <a:txBody>
+                    <a:bodyPr/>
+                    <a:lstStyle/>
+                    <a:p>
+                      <a:pPr>
+                        <a:defRPr sz="1000"/>
+                      </a:pPr>
+                      <a:r>
                         <a:t>Sinic</a:t>
                       </a:r>
                     </a:p>
@@ -9695,22 +9710,7 @@
                         <a:defRPr sz="1000"/>
                       </a:pPr>
                       <a:r>
-                        <a:t>Sinic</a:t>
-                      </a:r>
-                    </a:p>
-                  </a:txBody>
-                  <a:tcPr/>
-                </a:tc>
-                <a:tc>
-                  <a:txBody>
-                    <a:bodyPr/>
-                    <a:lstStyle/>
-                    <a:p>
-                      <a:pPr>
-                        <a:defRPr sz="1000"/>
-                      </a:pPr>
-                      <a:r>
-                        <a:t>111609</a:t>
+                        <a:t>52689</a:t>
                       </a:r>
                     </a:p>
                   </a:txBody>
@@ -9727,6 +9727,21 @@
                         <a:defRPr sz="1000"/>
                       </a:pPr>
                       <a:r>
+                        <a:t>United States</a:t>
+                      </a:r>
+                    </a:p>
+                  </a:txBody>
+                  <a:tcPr/>
+                </a:tc>
+                <a:tc>
+                  <a:txBody>
+                    <a:bodyPr/>
+                    <a:lstStyle/>
+                    <a:p>
+                      <a:pPr>
+                        <a:defRPr sz="1000"/>
+                      </a:pPr>
+                      <a:r>
                         <a:t>Continental Europe</a:t>
                       </a:r>
                     </a:p>
@@ -9742,22 +9757,7 @@
                         <a:defRPr sz="1000"/>
                       </a:pPr>
                       <a:r>
-                        <a:t>Continental Europe</a:t>
-                      </a:r>
-                    </a:p>
-                  </a:txBody>
-                  <a:tcPr/>
-                </a:tc>
-                <a:tc>
-                  <a:txBody>
-                    <a:bodyPr/>
-                    <a:lstStyle/>
-                    <a:p>
-                      <a:pPr>
-                        <a:defRPr sz="1000"/>
-                      </a:pPr>
-                      <a:r>
-                        <a:t>86447</a:t>
+                        <a:t>21968</a:t>
                       </a:r>
                     </a:p>
                   </a:txBody>
@@ -9774,37 +9774,37 @@
                         <a:defRPr sz="1000"/>
                       </a:pPr>
                       <a:r>
-                        <a:t>United States</a:t>
-                      </a:r>
-                    </a:p>
-                  </a:txBody>
-                  <a:tcPr/>
-                </a:tc>
-                <a:tc>
-                  <a:txBody>
-                    <a:bodyPr/>
-                    <a:lstStyle/>
-                    <a:p>
-                      <a:pPr>
-                        <a:defRPr sz="1000"/>
-                      </a:pPr>
-                      <a:r>
-                        <a:t>Unknown</a:t>
-                      </a:r>
-                    </a:p>
-                  </a:txBody>
-                  <a:tcPr/>
-                </a:tc>
-                <a:tc>
-                  <a:txBody>
-                    <a:bodyPr/>
-                    <a:lstStyle/>
-                    <a:p>
-                      <a:pPr>
-                        <a:defRPr sz="1000"/>
-                      </a:pPr>
-                      <a:r>
-                        <a:t>65558</a:t>
+                        <a:t>Anglosphere ex-US</a:t>
+                      </a:r>
+                    </a:p>
+                  </a:txBody>
+                  <a:tcPr/>
+                </a:tc>
+                <a:tc>
+                  <a:txBody>
+                    <a:bodyPr/>
+                    <a:lstStyle/>
+                    <a:p>
+                      <a:pPr>
+                        <a:defRPr sz="1000"/>
+                      </a:pPr>
+                      <a:r>
+                        <a:t>Sinic</a:t>
+                      </a:r>
+                    </a:p>
+                  </a:txBody>
+                  <a:tcPr/>
+                </a:tc>
+                <a:tc>
+                  <a:txBody>
+                    <a:bodyPr/>
+                    <a:lstStyle/>
+                    <a:p>
+                      <a:pPr>
+                        <a:defRPr sz="1000"/>
+                      </a:pPr>
+                      <a:r>
+                        <a:t>20534</a:t>
                       </a:r>
                     </a:p>
                   </a:txBody>
@@ -9821,37 +9821,37 @@
                         <a:defRPr sz="1000"/>
                       </a:pPr>
                       <a:r>
-                        <a:t>Continental Europe</a:t>
-                      </a:r>
-                    </a:p>
-                  </a:txBody>
-                  <a:tcPr/>
-                </a:tc>
-                <a:tc>
-                  <a:txBody>
-                    <a:bodyPr/>
-                    <a:lstStyle/>
-                    <a:p>
-                      <a:pPr>
-                        <a:defRPr sz="1000"/>
-                      </a:pPr>
-                      <a:r>
-                        <a:t>Unknown</a:t>
-                      </a:r>
-                    </a:p>
-                  </a:txBody>
-                  <a:tcPr/>
-                </a:tc>
-                <a:tc>
-                  <a:txBody>
-                    <a:bodyPr/>
-                    <a:lstStyle/>
-                    <a:p>
-                      <a:pPr>
-                        <a:defRPr sz="1000"/>
-                      </a:pPr>
-                      <a:r>
-                        <a:t>58313</a:t>
+                        <a:t>Sinic</a:t>
+                      </a:r>
+                    </a:p>
+                  </a:txBody>
+                  <a:tcPr/>
+                </a:tc>
+                <a:tc>
+                  <a:txBody>
+                    <a:bodyPr/>
+                    <a:lstStyle/>
+                    <a:p>
+                      <a:pPr>
+                        <a:defRPr sz="1000"/>
+                      </a:pPr>
+                      <a:r>
+                        <a:t>United States</a:t>
+                      </a:r>
+                    </a:p>
+                  </a:txBody>
+                  <a:tcPr/>
+                </a:tc>
+                <a:tc>
+                  <a:txBody>
+                    <a:bodyPr/>
+                    <a:lstStyle/>
+                    <a:p>
+                      <a:pPr>
+                        <a:defRPr sz="1000"/>
+                      </a:pPr>
+                      <a:r>
+                        <a:t>18505</a:t>
                       </a:r>
                     </a:p>
                   </a:txBody>
@@ -9868,37 +9868,37 @@
                         <a:defRPr sz="1000"/>
                       </a:pPr>
                       <a:r>
-                        <a:t>United States</a:t>
-                      </a:r>
-                    </a:p>
-                  </a:txBody>
-                  <a:tcPr/>
-                </a:tc>
-                <a:tc>
-                  <a:txBody>
-                    <a:bodyPr/>
-                    <a:lstStyle/>
-                    <a:p>
-                      <a:pPr>
-                        <a:defRPr sz="1000"/>
-                      </a:pPr>
-                      <a:r>
-                        <a:t>United States</a:t>
-                      </a:r>
-                    </a:p>
-                  </a:txBody>
-                  <a:tcPr/>
-                </a:tc>
-                <a:tc>
-                  <a:txBody>
-                    <a:bodyPr/>
-                    <a:lstStyle/>
-                    <a:p>
-                      <a:pPr>
-                        <a:defRPr sz="1000"/>
-                      </a:pPr>
-                      <a:r>
-                        <a:t>57712</a:t>
+                        <a:t>Continental Europe</a:t>
+                      </a:r>
+                    </a:p>
+                  </a:txBody>
+                  <a:tcPr/>
+                </a:tc>
+                <a:tc>
+                  <a:txBody>
+                    <a:bodyPr/>
+                    <a:lstStyle/>
+                    <a:p>
+                      <a:pPr>
+                        <a:defRPr sz="1000"/>
+                      </a:pPr>
+                      <a:r>
+                        <a:t>Anglosphere ex-US</a:t>
+                      </a:r>
+                    </a:p>
+                  </a:txBody>
+                  <a:tcPr/>
+                </a:tc>
+                <a:tc>
+                  <a:txBody>
+                    <a:bodyPr/>
+                    <a:lstStyle/>
+                    <a:p>
+                      <a:pPr>
+                        <a:defRPr sz="1000"/>
+                      </a:pPr>
+                      <a:r>
+                        <a:t>18156</a:t>
                       </a:r>
                     </a:p>
                   </a:txBody>
@@ -9930,22 +9930,22 @@
                         <a:defRPr sz="1000"/>
                       </a:pPr>
                       <a:r>
-                        <a:t>Sinic</a:t>
-                      </a:r>
-                    </a:p>
-                  </a:txBody>
-                  <a:tcPr/>
-                </a:tc>
-                <a:tc>
-                  <a:txBody>
-                    <a:bodyPr/>
-                    <a:lstStyle/>
-                    <a:p>
-                      <a:pPr>
-                        <a:defRPr sz="1000"/>
-                      </a:pPr>
-                      <a:r>
-                        <a:t>52689</a:t>
+                        <a:t>Anglosphere ex-US</a:t>
+                      </a:r>
+                    </a:p>
+                  </a:txBody>
+                  <a:tcPr/>
+                </a:tc>
+                <a:tc>
+                  <a:txBody>
+                    <a:bodyPr/>
+                    <a:lstStyle/>
+                    <a:p>
+                      <a:pPr>
+                        <a:defRPr sz="1000"/>
+                      </a:pPr>
+                      <a:r>
+                        <a:t>17719</a:t>
                       </a:r>
                     </a:p>
                   </a:txBody>
@@ -9962,37 +9962,37 @@
                         <a:defRPr sz="1000"/>
                       </a:pPr>
                       <a:r>
-                        <a:t>Anglosphere ex-US</a:t>
-                      </a:r>
-                    </a:p>
-                  </a:txBody>
-                  <a:tcPr/>
-                </a:tc>
-                <a:tc>
-                  <a:txBody>
-                    <a:bodyPr/>
-                    <a:lstStyle/>
-                    <a:p>
-                      <a:pPr>
-                        <a:defRPr sz="1000"/>
-                      </a:pPr>
-                      <a:r>
-                        <a:t>Anglosphere ex-US</a:t>
-                      </a:r>
-                    </a:p>
-                  </a:txBody>
-                  <a:tcPr/>
-                </a:tc>
-                <a:tc>
-                  <a:txBody>
-                    <a:bodyPr/>
-                    <a:lstStyle/>
-                    <a:p>
-                      <a:pPr>
-                        <a:defRPr sz="1000"/>
-                      </a:pPr>
-                      <a:r>
-                        <a:t>38063</a:t>
+                        <a:t>Continental Europe</a:t>
+                      </a:r>
+                    </a:p>
+                  </a:txBody>
+                  <a:tcPr/>
+                </a:tc>
+                <a:tc>
+                  <a:txBody>
+                    <a:bodyPr/>
+                    <a:lstStyle/>
+                    <a:p>
+                      <a:pPr>
+                        <a:defRPr sz="1000"/>
+                      </a:pPr>
+                      <a:r>
+                        <a:t>United States</a:t>
+                      </a:r>
+                    </a:p>
+                  </a:txBody>
+                  <a:tcPr/>
+                </a:tc>
+                <a:tc>
+                  <a:txBody>
+                    <a:bodyPr/>
+                    <a:lstStyle/>
+                    <a:p>
+                      <a:pPr>
+                        <a:defRPr sz="1000"/>
+                      </a:pPr>
+                      <a:r>
+                        <a:t>15459</a:t>
                       </a:r>
                     </a:p>
                   </a:txBody>
@@ -10009,37 +10009,37 @@
                         <a:defRPr sz="1000"/>
                       </a:pPr>
                       <a:r>
-                        <a:t>Sinic</a:t>
-                      </a:r>
-                    </a:p>
-                  </a:txBody>
-                  <a:tcPr/>
-                </a:tc>
-                <a:tc>
-                  <a:txBody>
-                    <a:bodyPr/>
-                    <a:lstStyle/>
-                    <a:p>
-                      <a:pPr>
-                        <a:defRPr sz="1000"/>
-                      </a:pPr>
-                      <a:r>
-                        <a:t>Unknown</a:t>
-                      </a:r>
-                    </a:p>
-                  </a:txBody>
-                  <a:tcPr/>
-                </a:tc>
-                <a:tc>
-                  <a:txBody>
-                    <a:bodyPr/>
-                    <a:lstStyle/>
-                    <a:p>
-                      <a:pPr>
-                        <a:defRPr sz="1000"/>
-                      </a:pPr>
-                      <a:r>
-                        <a:t>37254</a:t>
+                        <a:t>Anglosphere ex-US</a:t>
+                      </a:r>
+                    </a:p>
+                  </a:txBody>
+                  <a:tcPr/>
+                </a:tc>
+                <a:tc>
+                  <a:txBody>
+                    <a:bodyPr/>
+                    <a:lstStyle/>
+                    <a:p>
+                      <a:pPr>
+                        <a:defRPr sz="1000"/>
+                      </a:pPr>
+                      <a:r>
+                        <a:t>Continental Europe</a:t>
+                      </a:r>
+                    </a:p>
+                  </a:txBody>
+                  <a:tcPr/>
+                </a:tc>
+                <a:tc>
+                  <a:txBody>
+                    <a:bodyPr/>
+                    <a:lstStyle/>
+                    <a:p>
+                      <a:pPr>
+                        <a:defRPr sz="1000"/>
+                      </a:pPr>
+                      <a:r>
+                        <a:t>15003</a:t>
                       </a:r>
                     </a:p>
                   </a:txBody>
@@ -10071,22 +10071,22 @@
                         <a:defRPr sz="1000"/>
                       </a:pPr>
                       <a:r>
-                        <a:t>Unknown</a:t>
-                      </a:r>
-                    </a:p>
-                  </a:txBody>
-                  <a:tcPr/>
-                </a:tc>
-                <a:tc>
-                  <a:txBody>
-                    <a:bodyPr/>
-                    <a:lstStyle/>
-                    <a:p>
-                      <a:pPr>
-                        <a:defRPr sz="1000"/>
-                      </a:pPr>
-                      <a:r>
-                        <a:t>36460</a:t>
+                        <a:t>United States</a:t>
+                      </a:r>
+                    </a:p>
+                  </a:txBody>
+                  <a:tcPr/>
+                </a:tc>
+                <a:tc>
+                  <a:txBody>
+                    <a:bodyPr/>
+                    <a:lstStyle/>
+                    <a:p>
+                      <a:pPr>
+                        <a:defRPr sz="1000"/>
+                      </a:pPr>
+                      <a:r>
+                        <a:t>14422</a:t>
                       </a:r>
                     </a:p>
                   </a:txBody>
@@ -10103,37 +10103,37 @@
                         <a:defRPr sz="1000"/>
                       </a:pPr>
                       <a:r>
-                        <a:t>Other Civilizations</a:t>
-                      </a:r>
-                    </a:p>
-                  </a:txBody>
-                  <a:tcPr/>
-                </a:tc>
-                <a:tc>
-                  <a:txBody>
-                    <a:bodyPr/>
-                    <a:lstStyle/>
-                    <a:p>
-                      <a:pPr>
-                        <a:defRPr sz="1000"/>
-                      </a:pPr>
-                      <a:r>
-                        <a:t>Other Civilizations</a:t>
-                      </a:r>
-                    </a:p>
-                  </a:txBody>
-                  <a:tcPr/>
-                </a:tc>
-                <a:tc>
-                  <a:txBody>
-                    <a:bodyPr/>
-                    <a:lstStyle/>
-                    <a:p>
-                      <a:pPr>
-                        <a:defRPr sz="1000"/>
-                      </a:pPr>
-                      <a:r>
-                        <a:t>28095</a:t>
+                        <a:t>Continental Europe</a:t>
+                      </a:r>
+                    </a:p>
+                  </a:txBody>
+                  <a:tcPr/>
+                </a:tc>
+                <a:tc>
+                  <a:txBody>
+                    <a:bodyPr/>
+                    <a:lstStyle/>
+                    <a:p>
+                      <a:pPr>
+                        <a:defRPr sz="1000"/>
+                      </a:pPr>
+                      <a:r>
+                        <a:t>Sinic</a:t>
+                      </a:r>
+                    </a:p>
+                  </a:txBody>
+                  <a:tcPr/>
+                </a:tc>
+                <a:tc>
+                  <a:txBody>
+                    <a:bodyPr/>
+                    <a:lstStyle/>
+                    <a:p>
+                      <a:pPr>
+                        <a:defRPr sz="1000"/>
+                      </a:pPr>
+                      <a:r>
+                        <a:t>10535</a:t>
                       </a:r>
                     </a:p>
                   </a:txBody>
@@ -10303,22 +10303,22 @@
                         <a:defRPr sz="1000"/>
                       </a:pPr>
                       <a:r>
-                        <a:t>5045.95</a:t>
-                      </a:r>
-                    </a:p>
-                  </a:txBody>
-                  <a:tcPr/>
-                </a:tc>
-                <a:tc>
-                  <a:txBody>
-                    <a:bodyPr/>
-                    <a:lstStyle/>
-                    <a:p>
-                      <a:pPr>
-                        <a:defRPr sz="1000"/>
-                      </a:pPr>
-                      <a:r>
-                        <a:t>117.0%</a:t>
+                        <a:t>3545.91</a:t>
+                      </a:r>
+                    </a:p>
+                  </a:txBody>
+                  <a:tcPr/>
+                </a:tc>
+                <a:tc>
+                  <a:txBody>
+                    <a:bodyPr/>
+                    <a:lstStyle/>
+                    <a:p>
+                      <a:pPr>
+                        <a:defRPr sz="1000"/>
+                      </a:pPr>
+                      <a:r>
+                        <a:t>86.3%</a:t>
                       </a:r>
                     </a:p>
                   </a:txBody>
@@ -10350,22 +10350,22 @@
                         <a:defRPr sz="1000"/>
                       </a:pPr>
                       <a:r>
-                        <a:t>16427.90</a:t>
-                      </a:r>
-                    </a:p>
-                  </a:txBody>
-                  <a:tcPr/>
-                </a:tc>
-                <a:tc>
-                  <a:txBody>
-                    <a:bodyPr/>
-                    <a:lstStyle/>
-                    <a:p>
-                      <a:pPr>
-                        <a:defRPr sz="1000"/>
-                      </a:pPr>
-                      <a:r>
-                        <a:t>137.3%</a:t>
+                        <a:t>11675.98</a:t>
+                      </a:r>
+                    </a:p>
+                  </a:txBody>
+                  <a:tcPr/>
+                </a:tc>
+                <a:tc>
+                  <a:txBody>
+                    <a:bodyPr/>
+                    <a:lstStyle/>
+                    <a:p>
+                      <a:pPr>
+                        <a:defRPr sz="1000"/>
+                      </a:pPr>
+                      <a:r>
+                        <a:t>103.1%</a:t>
                       </a:r>
                     </a:p>
                   </a:txBody>
@@ -10397,22 +10397,22 @@
                         <a:defRPr sz="1000"/>
                       </a:pPr>
                       <a:r>
-                        <a:t>8871.05</a:t>
-                      </a:r>
-                    </a:p>
-                  </a:txBody>
-                  <a:tcPr/>
-                </a:tc>
-                <a:tc>
-                  <a:txBody>
-                    <a:bodyPr/>
-                    <a:lstStyle/>
-                    <a:p>
-                      <a:pPr>
-                        <a:defRPr sz="1000"/>
-                      </a:pPr>
-                      <a:r>
-                        <a:t>223.3%</a:t>
+                        <a:t>7893.85</a:t>
+                      </a:r>
+                    </a:p>
+                  </a:txBody>
+                  <a:tcPr/>
+                </a:tc>
+                <a:tc>
+                  <a:txBody>
+                    <a:bodyPr/>
+                    <a:lstStyle/>
+                    <a:p>
+                      <a:pPr>
+                        <a:defRPr sz="1000"/>
+                      </a:pPr>
+                      <a:r>
+                        <a:t>199.3%</a:t>
                       </a:r>
                     </a:p>
                   </a:txBody>
@@ -10444,22 +10444,22 @@
                         <a:defRPr sz="1000"/>
                       </a:pPr>
                       <a:r>
-                        <a:t>18803.07</a:t>
-                      </a:r>
-                    </a:p>
-                  </a:txBody>
-                  <a:tcPr/>
-                </a:tc>
-                <a:tc>
-                  <a:txBody>
-                    <a:bodyPr/>
-                    <a:lstStyle/>
-                    <a:p>
-                      <a:pPr>
-                        <a:defRPr sz="1000"/>
-                      </a:pPr>
-                      <a:r>
-                        <a:t>307.7%</a:t>
+                        <a:t>16747.65</a:t>
+                      </a:r>
+                    </a:p>
+                  </a:txBody>
+                  <a:tcPr/>
+                </a:tc>
+                <a:tc>
+                  <a:txBody>
+                    <a:bodyPr/>
+                    <a:lstStyle/>
+                    <a:p>
+                      <a:pPr>
+                        <a:defRPr sz="1000"/>
+                      </a:pPr>
+                      <a:r>
+                        <a:t>275.2%</a:t>
                       </a:r>
                     </a:p>
                   </a:txBody>
@@ -10491,22 +10491,22 @@
                         <a:defRPr sz="1000"/>
                       </a:pPr>
                       <a:r>
-                        <a:t>2487.82</a:t>
-                      </a:r>
-                    </a:p>
-                  </a:txBody>
-                  <a:tcPr/>
-                </a:tc>
-                <a:tc>
-                  <a:txBody>
-                    <a:bodyPr/>
-                    <a:lstStyle/>
-                    <a:p>
-                      <a:pPr>
-                        <a:defRPr sz="1000"/>
-                      </a:pPr>
-                      <a:r>
-                        <a:t>106.6%</a:t>
+                        <a:t>1677.51</a:t>
+                      </a:r>
+                    </a:p>
+                  </a:txBody>
+                  <a:tcPr/>
+                </a:tc>
+                <a:tc>
+                  <a:txBody>
+                    <a:bodyPr/>
+                    <a:lstStyle/>
+                    <a:p>
+                      <a:pPr>
+                        <a:defRPr sz="1000"/>
+                      </a:pPr>
+                      <a:r>
+                        <a:t>70.1%</a:t>
                       </a:r>
                     </a:p>
                   </a:txBody>
@@ -10538,22 +10538,22 @@
                         <a:defRPr sz="1000"/>
                       </a:pPr>
                       <a:r>
-                        <a:t>7835.00</a:t>
-                      </a:r>
-                    </a:p>
-                  </a:txBody>
-                  <a:tcPr/>
-                </a:tc>
-                <a:tc>
-                  <a:txBody>
-                    <a:bodyPr/>
-                    <a:lstStyle/>
-                    <a:p>
-                      <a:pPr>
-                        <a:defRPr sz="1000"/>
-                      </a:pPr>
-                      <a:r>
-                        <a:t>167.1%</a:t>
+                        <a:t>6151.05</a:t>
+                      </a:r>
+                    </a:p>
+                  </a:txBody>
+                  <a:tcPr/>
+                </a:tc>
+                <a:tc>
+                  <a:txBody>
+                    <a:bodyPr/>
+                    <a:lstStyle/>
+                    <a:p>
+                      <a:pPr>
+                        <a:defRPr sz="1000"/>
+                      </a:pPr>
+                      <a:r>
+                        <a:t>132.5%</a:t>
                       </a:r>
                     </a:p>
                   </a:txBody>
@@ -10585,22 +10585,22 @@
                         <a:defRPr sz="1000"/>
                       </a:pPr>
                       <a:r>
-                        <a:t>351.16</a:t>
-                      </a:r>
-                    </a:p>
-                  </a:txBody>
-                  <a:tcPr/>
-                </a:tc>
-                <a:tc>
-                  <a:txBody>
-                    <a:bodyPr/>
-                    <a:lstStyle/>
-                    <a:p>
-                      <a:pPr>
-                        <a:defRPr sz="1000"/>
-                      </a:pPr>
-                      <a:r>
-                        <a:t>131.6%</a:t>
+                        <a:t>259.88</a:t>
+                      </a:r>
+                    </a:p>
+                  </a:txBody>
+                  <a:tcPr/>
+                </a:tc>
+                <a:tc>
+                  <a:txBody>
+                    <a:bodyPr/>
+                    <a:lstStyle/>
+                    <a:p>
+                      <a:pPr>
+                        <a:defRPr sz="1000"/>
+                      </a:pPr>
+                      <a:r>
+                        <a:t>97.8%</a:t>
                       </a:r>
                     </a:p>
                   </a:txBody>
@@ -10632,22 +10632,22 @@
                         <a:defRPr sz="1000"/>
                       </a:pPr>
                       <a:r>
-                        <a:t>24182.04</a:t>
-                      </a:r>
-                    </a:p>
-                  </a:txBody>
-                  <a:tcPr/>
-                </a:tc>
-                <a:tc>
-                  <a:txBody>
-                    <a:bodyPr/>
-                    <a:lstStyle/>
-                    <a:p>
-                      <a:pPr>
-                        <a:defRPr sz="1000"/>
-                      </a:pPr>
-                      <a:r>
-                        <a:t>160.1%</a:t>
+                        <a:t>18773.11</a:t>
+                      </a:r>
+                    </a:p>
+                  </a:txBody>
+                  <a:tcPr/>
+                </a:tc>
+                <a:tc>
+                  <a:txBody>
+                    <a:bodyPr/>
+                    <a:lstStyle/>
+                    <a:p>
+                      <a:pPr>
+                        <a:defRPr sz="1000"/>
+                      </a:pPr>
+                      <a:r>
+                        <a:t>131.6%</a:t>
                       </a:r>
                     </a:p>
                   </a:txBody>
@@ -10679,22 +10679,22 @@
                         <a:defRPr sz="1000"/>
                       </a:pPr>
                       <a:r>
-                        <a:t>10293.03</a:t>
-                      </a:r>
-                    </a:p>
-                  </a:txBody>
-                  <a:tcPr/>
-                </a:tc>
-                <a:tc>
-                  <a:txBody>
-                    <a:bodyPr/>
-                    <a:lstStyle/>
-                    <a:p>
-                      <a:pPr>
-                        <a:defRPr sz="1000"/>
-                      </a:pPr>
-                      <a:r>
-                        <a:t>106.9%</a:t>
+                        <a:t>7014.93</a:t>
+                      </a:r>
+                    </a:p>
+                  </a:txBody>
+                  <a:tcPr/>
+                </a:tc>
+                <a:tc>
+                  <a:txBody>
+                    <a:bodyPr/>
+                    <a:lstStyle/>
+                    <a:p>
+                      <a:pPr>
+                        <a:defRPr sz="1000"/>
+                      </a:pPr>
+                      <a:r>
+                        <a:t>77.4%</a:t>
                       </a:r>
                     </a:p>
                   </a:txBody>
@@ -10864,22 +10864,22 @@
                         <a:defRPr sz="1000"/>
                       </a:pPr>
                       <a:r>
-                        <a:t>1043.17</a:t>
-                      </a:r>
-                    </a:p>
-                  </a:txBody>
-                  <a:tcPr/>
-                </a:tc>
-                <a:tc>
-                  <a:txBody>
-                    <a:bodyPr/>
-                    <a:lstStyle/>
-                    <a:p>
-                      <a:pPr>
-                        <a:defRPr sz="1000"/>
-                      </a:pPr>
-                      <a:r>
-                        <a:t>275.6%</a:t>
+                        <a:t>860.78</a:t>
+                      </a:r>
+                    </a:p>
+                  </a:txBody>
+                  <a:tcPr/>
+                </a:tc>
+                <a:tc>
+                  <a:txBody>
+                    <a:bodyPr/>
+                    <a:lstStyle/>
+                    <a:p>
+                      <a:pPr>
+                        <a:defRPr sz="1000"/>
+                      </a:pPr>
+                      <a:r>
+                        <a:t>224.2%</a:t>
                       </a:r>
                     </a:p>
                   </a:txBody>
@@ -10911,22 +10911,22 @@
                         <a:defRPr sz="1000"/>
                       </a:pPr>
                       <a:r>
-                        <a:t>23067.25</a:t>
-                      </a:r>
-                    </a:p>
-                  </a:txBody>
-                  <a:tcPr/>
-                </a:tc>
-                <a:tc>
-                  <a:txBody>
-                    <a:bodyPr/>
-                    <a:lstStyle/>
-                    <a:p>
-                      <a:pPr>
-                        <a:defRPr sz="1000"/>
-                      </a:pPr>
-                      <a:r>
-                        <a:t>311.6%</a:t>
+                        <a:t>19772.90</a:t>
+                      </a:r>
+                    </a:p>
+                  </a:txBody>
+                  <a:tcPr/>
+                </a:tc>
+                <a:tc>
+                  <a:txBody>
+                    <a:bodyPr/>
+                    <a:lstStyle/>
+                    <a:p>
+                      <a:pPr>
+                        <a:defRPr sz="1000"/>
+                      </a:pPr>
+                      <a:r>
+                        <a:t>262.8%</a:t>
                       </a:r>
                     </a:p>
                   </a:txBody>
@@ -10958,22 +10958,22 @@
                         <a:defRPr sz="1000"/>
                       </a:pPr>
                       <a:r>
-                        <a:t>552.28</a:t>
-                      </a:r>
-                    </a:p>
-                  </a:txBody>
-                  <a:tcPr/>
-                </a:tc>
-                <a:tc>
-                  <a:txBody>
-                    <a:bodyPr/>
-                    <a:lstStyle/>
-                    <a:p>
-                      <a:pPr>
-                        <a:defRPr sz="1000"/>
-                      </a:pPr>
-                      <a:r>
-                        <a:t>69.8%</a:t>
+                        <a:t>406.05</a:t>
+                      </a:r>
+                    </a:p>
+                  </a:txBody>
+                  <a:tcPr/>
+                </a:tc>
+                <a:tc>
+                  <a:txBody>
+                    <a:bodyPr/>
+                    <a:lstStyle/>
+                    <a:p>
+                      <a:pPr>
+                        <a:defRPr sz="1000"/>
+                      </a:pPr>
+                      <a:r>
+                        <a:t>50.9%</a:t>
                       </a:r>
                     </a:p>
                   </a:txBody>
@@ -11005,22 +11005,22 @@
                         <a:defRPr sz="1000"/>
                       </a:pPr>
                       <a:r>
-                        <a:t>10318.58</a:t>
-                      </a:r>
-                    </a:p>
-                  </a:txBody>
-                  <a:tcPr/>
-                </a:tc>
-                <a:tc>
-                  <a:txBody>
-                    <a:bodyPr/>
-                    <a:lstStyle/>
-                    <a:p>
-                      <a:pPr>
-                        <a:defRPr sz="1000"/>
-                      </a:pPr>
-                      <a:r>
-                        <a:t>211.2%</a:t>
+                        <a:t>8086.06</a:t>
+                      </a:r>
+                    </a:p>
+                  </a:txBody>
+                  <a:tcPr/>
+                </a:tc>
+                <a:tc>
+                  <a:txBody>
+                    <a:bodyPr/>
+                    <a:lstStyle/>
+                    <a:p>
+                      <a:pPr>
+                        <a:defRPr sz="1000"/>
+                      </a:pPr>
+                      <a:r>
+                        <a:t>170.7%</a:t>
                       </a:r>
                     </a:p>
                   </a:txBody>
@@ -11052,22 +11052,22 @@
                         <a:defRPr sz="1000"/>
                       </a:pPr>
                       <a:r>
-                        <a:t>2056.79</a:t>
-                      </a:r>
-                    </a:p>
-                  </a:txBody>
-                  <a:tcPr/>
-                </a:tc>
-                <a:tc>
-                  <a:txBody>
-                    <a:bodyPr/>
-                    <a:lstStyle/>
-                    <a:p>
-                      <a:pPr>
-                        <a:defRPr sz="1000"/>
-                      </a:pPr>
-                      <a:r>
-                        <a:t>46.7%</a:t>
+                        <a:t>1738.38</a:t>
+                      </a:r>
+                    </a:p>
+                  </a:txBody>
+                  <a:tcPr/>
+                </a:tc>
+                <a:tc>
+                  <a:txBody>
+                    <a:bodyPr/>
+                    <a:lstStyle/>
+                    <a:p>
+                      <a:pPr>
+                        <a:defRPr sz="1000"/>
+                      </a:pPr>
+                      <a:r>
+                        <a:t>35.5%</a:t>
                       </a:r>
                     </a:p>
                   </a:txBody>
@@ -11099,22 +11099,22 @@
                         <a:defRPr sz="1000"/>
                       </a:pPr>
                       <a:r>
-                        <a:t>18613.86</a:t>
-                      </a:r>
-                    </a:p>
-                  </a:txBody>
-                  <a:tcPr/>
-                </a:tc>
-                <a:tc>
-                  <a:txBody>
-                    <a:bodyPr/>
-                    <a:lstStyle/>
-                    <a:p>
-                      <a:pPr>
-                        <a:defRPr sz="1000"/>
-                      </a:pPr>
-                      <a:r>
-                        <a:t>56.8%</a:t>
+                        <a:t>12744.52</a:t>
+                      </a:r>
+                    </a:p>
+                  </a:txBody>
+                  <a:tcPr/>
+                </a:tc>
+                <a:tc>
+                  <a:txBody>
+                    <a:bodyPr/>
+                    <a:lstStyle/>
+                    <a:p>
+                      <a:pPr>
+                        <a:defRPr sz="1000"/>
+                      </a:pPr>
+                      <a:r>
+                        <a:t>38.0%</a:t>
                       </a:r>
                     </a:p>
                   </a:txBody>

</xml_diff>

<commit_message>
C1/C2: move detailed annual rate/interciv tables to supplementary, add direction-agreement and threshold-alarm metrics to annual projection and manuscript
Co-Authored-By: Tatsuki Onishi <bougtoir@gmail.com>
</commit_message>
<xml_diff>
--- a/researcher_mobility_ode/docs/manuscript_full_article_figures.pptx
+++ b/researcher_mobility_ode/docs/manuscript_full_article_figures.pptx
@@ -27,6 +27,7 @@
     <p:sldId id="275" r:id="rId26"/>
     <p:sldId id="276" r:id="rId27"/>
     <p:sldId id="277" r:id="rId28"/>
+    <p:sldId id="278" r:id="rId29"/>
   </p:sldIdLst>
   <p:sldSz cx="12191695" cy="6858000" type="screen4x3"/>
   <p:notesSz cx="6858000" cy="9144000"/>
@@ -6792,6 +6793,379 @@
           <a:lstStyle/>
           <a:p>
             <a:r>
+              <a:t>Table 9: Transition levers, policy instruments, and management actions</a:t>
+            </a:r>
+          </a:p>
+        </p:txBody>
+      </p:sp>
+      <p:sp>
+        <p:nvSpPr>
+          <p:cNvPr id="3" name="Content Placeholder 2"/>
+          <p:cNvSpPr>
+            <a:spLocks noGrp="1"/>
+          </p:cNvSpPr>
+          <p:nvPr>
+            <p:ph idx="1" sz="half"/>
+          </p:nvPr>
+        </p:nvSpPr>
+        <p:spPr/>
+        <p:txBody>
+          <a:bodyPr/>
+          <a:lstStyle/>
+          <a:p/>
+        </p:txBody>
+      </p:sp>
+      <p:sp>
+        <p:nvSpPr>
+          <p:cNvPr id="4" name="Content Placeholder 3"/>
+          <p:cNvSpPr>
+            <a:spLocks noGrp="1"/>
+          </p:cNvSpPr>
+          <p:nvPr>
+            <p:ph idx="2" sz="half"/>
+          </p:nvPr>
+        </p:nvSpPr>
+        <p:spPr/>
+        <p:txBody>
+          <a:bodyPr/>
+          <a:lstStyle/>
+          <a:p/>
+        </p:txBody>
+      </p:sp>
+      <p:graphicFrame>
+        <p:nvGraphicFramePr>
+          <p:cNvPr id="5" name="Table 4"/>
+          <p:cNvGraphicFramePr>
+            <a:graphicFrameLocks noGrp="1"/>
+          </p:cNvGraphicFramePr>
+          <p:nvPr/>
+        </p:nvGraphicFramePr>
+        <p:xfrm>
+          <a:off x="457200" y="1097280"/>
+          <a:ext cx="6035040" cy="3291839"/>
+        </p:xfrm>
+        <a:graphic>
+          <a:graphicData uri="http://schemas.openxmlformats.org/drawingml/2006/table">
+            <a:tbl>
+              <a:tblPr firstRow="1" bandRow="1">
+                <a:tableStyleId>{5C22544A-7EE6-4342-B048-85BDC9FD1C3A}</a:tableStyleId>
+              </a:tblPr>
+              <a:tblGrid>
+                <a:gridCol w="2011680"/>
+                <a:gridCol w="2011680"/>
+                <a:gridCol w="2011680"/>
+              </a:tblGrid>
+              <a:tr h="548639">
+                <a:tc>
+                  <a:txBody>
+                    <a:bodyPr/>
+                    <a:lstStyle/>
+                    <a:p>
+                      <a:r>
+                        <a:t>Lever</a:t>
+                      </a:r>
+                    </a:p>
+                  </a:txBody>
+                  <a:tcPr/>
+                </a:tc>
+                <a:tc>
+                  <a:txBody>
+                    <a:bodyPr/>
+                    <a:lstStyle/>
+                    <a:p>
+                      <a:r>
+                        <a:t>Policy instrument</a:t>
+                      </a:r>
+                    </a:p>
+                  </a:txBody>
+                  <a:tcPr/>
+                </a:tc>
+                <a:tc>
+                  <a:txBody>
+                    <a:bodyPr/>
+                    <a:lstStyle/>
+                    <a:p>
+                      <a:r>
+                        <a:t>Management action</a:t>
+                      </a:r>
+                    </a:p>
+                  </a:txBody>
+                  <a:tcPr/>
+                </a:tc>
+              </a:tr>
+              <a:tr h="548639">
+                <a:tc>
+                  <a:txBody>
+                    <a:bodyPr/>
+                    <a:lstStyle/>
+                    <a:p>
+                      <a:pPr>
+                        <a:defRPr sz="1000"/>
+                      </a:pPr>
+                      <a:r>
+                        <a:t>Dropout (d)</a:t>
+                      </a:r>
+                    </a:p>
+                  </a:txBody>
+                  <a:tcPr/>
+                </a:tc>
+                <a:tc>
+                  <a:txBody>
+                    <a:bodyPr/>
+                    <a:lstStyle/>
+                    <a:p>
+                      <a:pPr>
+                        <a:defRPr sz="1000"/>
+                      </a:pPr>
+                      <a:r>
+                        <a:t>Early-career fellowships, childcare and dual-career support, stable non-tenure tracks</a:t>
+                      </a:r>
+                    </a:p>
+                  </a:txBody>
+                  <a:tcPr/>
+                </a:tc>
+                <a:tc>
+                  <a:txBody>
+                    <a:bodyPr/>
+                    <a:lstStyle/>
+                    <a:p>
+                      <a:pPr>
+                        <a:defRPr sz="1000"/>
+                      </a:pPr>
+                      <a:r>
+                        <a:t>Retain researchers in the domestic pipeline beyond the first career years</a:t>
+                      </a:r>
+                    </a:p>
+                  </a:txBody>
+                  <a:tcPr/>
+                </a:tc>
+              </a:tr>
+              <a:tr h="548639">
+                <a:tc>
+                  <a:txBody>
+                    <a:bodyPr/>
+                    <a:lstStyle/>
+                    <a:p>
+                      <a:pPr>
+                        <a:defRPr sz="1000"/>
+                      </a:pPr>
+                      <a:r>
+                        <a:t>Exogenous entry (I0)</a:t>
+                      </a:r>
+                    </a:p>
+                  </a:txBody>
+                  <a:tcPr/>
+                </a:tc>
+                <a:tc>
+                  <a:txBody>
+                    <a:bodyPr/>
+                    <a:lstStyle/>
+                    <a:p>
+                      <a:pPr>
+                        <a:defRPr sz="1000"/>
+                      </a:pPr>
+                      <a:r>
+                        <a:t>Research-master and undergraduate pipelines, doctoral fellowships, recruitment visas</a:t>
+                      </a:r>
+                    </a:p>
+                  </a:txBody>
+                  <a:tcPr/>
+                </a:tc>
+                <a:tc>
+                  <a:txBody>
+                    <a:bodyPr/>
+                    <a:lstStyle/>
+                    <a:p>
+                      <a:pPr>
+                        <a:defRPr sz="1000"/>
+                      </a:pPr>
+                      <a:r>
+                        <a:t>Widen the base of incoming researchers before they select a field or location</a:t>
+                      </a:r>
+                    </a:p>
+                  </a:txBody>
+                  <a:tcPr/>
+                </a:tc>
+              </a:tr>
+              <a:tr h="548639">
+                <a:tc>
+                  <a:txBody>
+                    <a:bodyPr/>
+                    <a:lstStyle/>
+                    <a:p>
+                      <a:pPr>
+                        <a:defRPr sz="1000"/>
+                      </a:pPr>
+                      <a:r>
+                        <a:t>Return from abroad (β)</a:t>
+                      </a:r>
+                    </a:p>
+                  </a:txBody>
+                  <a:tcPr/>
+                </a:tc>
+                <a:tc>
+                  <a:txBody>
+                    <a:bodyPr/>
+                    <a:lstStyle/>
+                    <a:p>
+                      <a:pPr>
+                        <a:defRPr sz="1000"/>
+                      </a:pPr>
+                      <a:r>
+                        <a:t>Return grants, diaspora networks, dual appointments, overseas-experience recognition</a:t>
+                      </a:r>
+                    </a:p>
+                  </a:txBody>
+                  <a:tcPr/>
+                </a:tc>
+                <a:tc>
+                  <a:txBody>
+                    <a:bodyPr/>
+                    <a:lstStyle/>
+                    <a:p>
+                      <a:pPr>
+                        <a:defRPr sz="1000"/>
+                      </a:pPr>
+                      <a:r>
+                        <a:t>Encourage mobile researchers to re-establish domestic research groups</a:t>
+                      </a:r>
+                    </a:p>
+                  </a:txBody>
+                  <a:tcPr/>
+                </a:tc>
+              </a:tr>
+              <a:tr h="548639">
+                <a:tc>
+                  <a:txBody>
+                    <a:bodyPr/>
+                    <a:lstStyle/>
+                    <a:p>
+                      <a:pPr>
+                        <a:defRPr sz="1000"/>
+                      </a:pPr>
+                      <a:r>
+                        <a:t>Domestic hit generation (h_D)</a:t>
+                      </a:r>
+                    </a:p>
+                  </a:txBody>
+                  <a:tcPr/>
+                </a:tc>
+                <a:tc>
+                  <a:txBody>
+                    <a:bodyPr/>
+                    <a:lstStyle/>
+                    <a:p>
+                      <a:pPr>
+                        <a:defRPr sz="1000"/>
+                      </a:pPr>
+                      <a:r>
+                        <a:t>Independent-lab programmes (e.g. SPREAD-style), doctoral/postdoctoral training, compute access</a:t>
+                      </a:r>
+                    </a:p>
+                  </a:txBody>
+                  <a:tcPr/>
+                </a:tc>
+                <a:tc>
+                  <a:txBody>
+                    <a:bodyPr/>
+                    <a:lstStyle/>
+                    <a:p>
+                      <a:pPr>
+                        <a:defRPr sz="1000"/>
+                      </a:pPr>
+                      <a:r>
+                        <a:t>Translate junior capacity into visible, high-impact work and independent research lines</a:t>
+                      </a:r>
+                    </a:p>
+                  </a:txBody>
+                  <a:tcPr/>
+                </a:tc>
+              </a:tr>
+              <a:tr h="548644">
+                <a:tc>
+                  <a:txBody>
+                    <a:bodyPr/>
+                    <a:lstStyle/>
+                    <a:p>
+                      <a:pPr>
+                        <a:defRPr sz="1000"/>
+                      </a:pPr>
+                      <a:r>
+                        <a:t>PI promotion (p_D)</a:t>
+                      </a:r>
+                    </a:p>
+                  </a:txBody>
+                  <a:tcPr/>
+                </a:tc>
+                <a:tc>
+                  <a:txBody>
+                    <a:bodyPr/>
+                    <a:lstStyle/>
+                    <a:p>
+                      <a:pPr>
+                        <a:defRPr sz="1000"/>
+                      </a:pPr>
+                      <a:r>
+                        <a:t>Tenure-track conversion, startup packages, project-based PI status</a:t>
+                      </a:r>
+                    </a:p>
+                  </a:txBody>
+                  <a:tcPr/>
+                </a:tc>
+                <a:tc>
+                  <a:txBody>
+                    <a:bodyPr/>
+                    <a:lstStyle/>
+                    <a:p>
+                      <a:pPr>
+                        <a:defRPr sz="1000"/>
+                      </a:pPr>
+                      <a:r>
+                        <a:t>Create durable principal-investigator positions that train the next cohort</a:t>
+                      </a:r>
+                    </a:p>
+                  </a:txBody>
+                  <a:tcPr/>
+                </a:tc>
+              </a:tr>
+            </a:tbl>
+          </a:graphicData>
+        </a:graphic>
+      </p:graphicFrame>
+    </p:spTree>
+  </p:cSld>
+  <p:clrMapOvr>
+    <a:masterClrMapping/>
+  </p:clrMapOvr>
+</p:sld>
+</file>
+
+<file path=ppt/slides/slide14.xml><?xml version="1.0" encoding="utf-8"?>
+<p:sld xmlns:a="http://schemas.openxmlformats.org/drawingml/2006/main" xmlns:p="http://schemas.openxmlformats.org/presentationml/2006/main" xmlns:r="http://schemas.openxmlformats.org/officeDocument/2006/relationships">
+  <p:cSld>
+    <p:spTree>
+      <p:nvGrpSpPr>
+        <p:cNvPr id="1" name=""/>
+        <p:cNvGrpSpPr/>
+        <p:nvPr/>
+      </p:nvGrpSpPr>
+      <p:grpSpPr/>
+      <p:sp>
+        <p:nvSpPr>
+          <p:cNvPr id="2" name="Title 1"/>
+          <p:cNvSpPr>
+            <a:spLocks noGrp="1"/>
+          </p:cNvSpPr>
+          <p:nvPr>
+            <p:ph type="title"/>
+          </p:nvPr>
+        </p:nvSpPr>
+        <p:spPr/>
+        <p:txBody>
+          <a:bodyPr/>
+          <a:lstStyle/>
+          <a:p>
+            <a:r>
               <a:t>Table 8: Bootstrap 95% CI</a:t>
             </a:r>
           </a:p>
@@ -7623,7 +7997,7 @@
 </p:sld>
 </file>
 
-<file path=ppt/slides/slide14.xml><?xml version="1.0" encoding="utf-8"?>
+<file path=ppt/slides/slide15.xml><?xml version="1.0" encoding="utf-8"?>
 <p:sld xmlns:a="http://schemas.openxmlformats.org/drawingml/2006/main" xmlns:p="http://schemas.openxmlformats.org/presentationml/2006/main" xmlns:r="http://schemas.openxmlformats.org/officeDocument/2006/relationships">
   <p:cSld>
     <p:spTree>
@@ -7751,7 +8125,7 @@
 </p:sld>
 </file>
 
-<file path=ppt/slides/slide15.xml><?xml version="1.0" encoding="utf-8"?>
+<file path=ppt/slides/slide16.xml><?xml version="1.0" encoding="utf-8"?>
 <p:sld xmlns:a="http://schemas.openxmlformats.org/drawingml/2006/main" xmlns:p="http://schemas.openxmlformats.org/presentationml/2006/main" xmlns:r="http://schemas.openxmlformats.org/officeDocument/2006/relationships">
   <p:cSld>
     <p:spTree>
@@ -7879,7 +8253,7 @@
 </p:sld>
 </file>
 
-<file path=ppt/slides/slide16.xml><?xml version="1.0" encoding="utf-8"?>
+<file path=ppt/slides/slide17.xml><?xml version="1.0" encoding="utf-8"?>
 <p:sld xmlns:a="http://schemas.openxmlformats.org/drawingml/2006/main" xmlns:p="http://schemas.openxmlformats.org/presentationml/2006/main" xmlns:r="http://schemas.openxmlformats.org/officeDocument/2006/relationships">
   <p:cSld>
     <p:spTree>
@@ -8007,7 +8381,7 @@
 </p:sld>
 </file>
 
-<file path=ppt/slides/slide17.xml><?xml version="1.0" encoding="utf-8"?>
+<file path=ppt/slides/slide18.xml><?xml version="1.0" encoding="utf-8"?>
 <p:sld xmlns:a="http://schemas.openxmlformats.org/drawingml/2006/main" xmlns:p="http://schemas.openxmlformats.org/presentationml/2006/main" xmlns:r="http://schemas.openxmlformats.org/officeDocument/2006/relationships">
   <p:cSld>
     <p:spTree>
@@ -8135,7 +8509,7 @@
 </p:sld>
 </file>
 
-<file path=ppt/slides/slide18.xml><?xml version="1.0" encoding="utf-8"?>
+<file path=ppt/slides/slide19.xml><?xml version="1.0" encoding="utf-8"?>
 <p:sld xmlns:a="http://schemas.openxmlformats.org/drawingml/2006/main" xmlns:p="http://schemas.openxmlformats.org/presentationml/2006/main" xmlns:r="http://schemas.openxmlformats.org/officeDocument/2006/relationships">
   <p:cSld>
     <p:spTree>
@@ -8255,1159 +8629,6 @@
           </a:p>
         </p:txBody>
       </p:sp>
-    </p:spTree>
-  </p:cSld>
-  <p:clrMapOvr>
-    <a:masterClrMapping/>
-  </p:clrMapOvr>
-</p:sld>
-</file>
-
-<file path=ppt/slides/slide19.xml><?xml version="1.0" encoding="utf-8"?>
-<p:sld xmlns:a="http://schemas.openxmlformats.org/drawingml/2006/main" xmlns:p="http://schemas.openxmlformats.org/presentationml/2006/main" xmlns:r="http://schemas.openxmlformats.org/officeDocument/2006/relationships">
-  <p:cSld>
-    <p:spTree>
-      <p:nvGrpSpPr>
-        <p:cNvPr id="1" name=""/>
-        <p:cNvGrpSpPr/>
-        <p:nvPr/>
-      </p:nvGrpSpPr>
-      <p:grpSpPr/>
-      <p:sp>
-        <p:nvSpPr>
-          <p:cNvPr id="2" name="Title 1"/>
-          <p:cNvSpPr>
-            <a:spLocks noGrp="1"/>
-          </p:cNvSpPr>
-          <p:nvPr>
-            <p:ph type="title"/>
-          </p:nvPr>
-        </p:nvSpPr>
-        <p:spPr/>
-        <p:txBody>
-          <a:bodyPr/>
-          <a:lstStyle/>
-          <a:p>
-            <a:r>
-              <a:t>Table 9: Mean observed annual transition rates, 2000-2016</a:t>
-            </a:r>
-          </a:p>
-        </p:txBody>
-      </p:sp>
-      <p:sp>
-        <p:nvSpPr>
-          <p:cNvPr id="3" name="Content Placeholder 2"/>
-          <p:cNvSpPr>
-            <a:spLocks noGrp="1"/>
-          </p:cNvSpPr>
-          <p:nvPr>
-            <p:ph idx="1" sz="half"/>
-          </p:nvPr>
-        </p:nvSpPr>
-        <p:spPr/>
-        <p:txBody>
-          <a:bodyPr/>
-          <a:lstStyle/>
-          <a:p/>
-        </p:txBody>
-      </p:sp>
-      <p:sp>
-        <p:nvSpPr>
-          <p:cNvPr id="4" name="Content Placeholder 3"/>
-          <p:cNvSpPr>
-            <a:spLocks noGrp="1"/>
-          </p:cNvSpPr>
-          <p:nvPr>
-            <p:ph idx="2" sz="half"/>
-          </p:nvPr>
-        </p:nvSpPr>
-        <p:spPr/>
-        <p:txBody>
-          <a:bodyPr/>
-          <a:lstStyle/>
-          <a:p/>
-        </p:txBody>
-      </p:sp>
-      <p:graphicFrame>
-        <p:nvGraphicFramePr>
-          <p:cNvPr id="5" name="Table 4"/>
-          <p:cNvGraphicFramePr>
-            <a:graphicFrameLocks noGrp="1"/>
-          </p:cNvGraphicFramePr>
-          <p:nvPr/>
-        </p:nvGraphicFramePr>
-        <p:xfrm>
-          <a:off x="457200" y="1097280"/>
-          <a:ext cx="8961119" cy="5486400"/>
-        </p:xfrm>
-        <a:graphic>
-          <a:graphicData uri="http://schemas.openxmlformats.org/drawingml/2006/table">
-            <a:tbl>
-              <a:tblPr firstRow="1" bandRow="1">
-                <a:tableStyleId>{5C22544A-7EE6-4342-B048-85BDC9FD1C3A}</a:tableStyleId>
-              </a:tblPr>
-              <a:tblGrid>
-                <a:gridCol w="1280159"/>
-                <a:gridCol w="1280159"/>
-                <a:gridCol w="1280159"/>
-                <a:gridCol w="1280159"/>
-                <a:gridCol w="1280159"/>
-                <a:gridCol w="1280159"/>
-                <a:gridCol w="1280165"/>
-              </a:tblGrid>
-              <a:tr h="548640">
-                <a:tc>
-                  <a:txBody>
-                    <a:bodyPr/>
-                    <a:lstStyle/>
-                    <a:p>
-                      <a:r>
-                        <a:t>Group</a:t>
-                      </a:r>
-                    </a:p>
-                  </a:txBody>
-                  <a:tcPr/>
-                </a:tc>
-                <a:tc>
-                  <a:txBody>
-                    <a:bodyPr/>
-                    <a:lstStyle/>
-                    <a:p>
-                      <a:r>
-                        <a:t>α</a:t>
-                      </a:r>
-                    </a:p>
-                  </a:txBody>
-                  <a:tcPr/>
-                </a:tc>
-                <a:tc>
-                  <a:txBody>
-                    <a:bodyPr/>
-                    <a:lstStyle/>
-                    <a:p>
-                      <a:r>
-                        <a:t>β</a:t>
-                      </a:r>
-                    </a:p>
-                  </a:txBody>
-                  <a:tcPr/>
-                </a:tc>
-                <a:tc>
-                  <a:txBody>
-                    <a:bodyPr/>
-                    <a:lstStyle/>
-                    <a:p>
-                      <a:r>
-                        <a:t>h_D</a:t>
-                      </a:r>
-                    </a:p>
-                  </a:txBody>
-                  <a:tcPr/>
-                </a:tc>
-                <a:tc>
-                  <a:txBody>
-                    <a:bodyPr/>
-                    <a:lstStyle/>
-                    <a:p>
-                      <a:r>
-                        <a:t>p_D</a:t>
-                      </a:r>
-                    </a:p>
-                  </a:txBody>
-                  <a:tcPr/>
-                </a:tc>
-                <a:tc>
-                  <a:txBody>
-                    <a:bodyPr/>
-                    <a:lstStyle/>
-                    <a:p>
-                      <a:r>
-                        <a:t>d</a:t>
-                      </a:r>
-                    </a:p>
-                  </a:txBody>
-                  <a:tcPr/>
-                </a:tc>
-                <a:tc>
-                  <a:txBody>
-                    <a:bodyPr/>
-                    <a:lstStyle/>
-                    <a:p>
-                      <a:r>
-                        <a:t>I_total</a:t>
-                      </a:r>
-                    </a:p>
-                  </a:txBody>
-                  <a:tcPr/>
-                </a:tc>
-              </a:tr>
-              <a:tr h="548640">
-                <a:tc>
-                  <a:txBody>
-                    <a:bodyPr/>
-                    <a:lstStyle/>
-                    <a:p>
-                      <a:pPr>
-                        <a:defRPr sz="1000"/>
-                      </a:pPr>
-                      <a:r>
-                        <a:t>Anglosphere ex-US</a:t>
-                      </a:r>
-                    </a:p>
-                  </a:txBody>
-                  <a:tcPr/>
-                </a:tc>
-                <a:tc>
-                  <a:txBody>
-                    <a:bodyPr/>
-                    <a:lstStyle/>
-                    <a:p>
-                      <a:pPr>
-                        <a:defRPr sz="1000"/>
-                      </a:pPr>
-                      <a:r>
-                        <a:t>0.01153982905868697</a:t>
-                      </a:r>
-                    </a:p>
-                  </a:txBody>
-                  <a:tcPr/>
-                </a:tc>
-                <a:tc>
-                  <a:txBody>
-                    <a:bodyPr/>
-                    <a:lstStyle/>
-                    <a:p>
-                      <a:pPr>
-                        <a:defRPr sz="1000"/>
-                      </a:pPr>
-                      <a:r>
-                        <a:t>0.03392610062985291</a:t>
-                      </a:r>
-                    </a:p>
-                  </a:txBody>
-                  <a:tcPr/>
-                </a:tc>
-                <a:tc>
-                  <a:txBody>
-                    <a:bodyPr/>
-                    <a:lstStyle/>
-                    <a:p>
-                      <a:pPr>
-                        <a:defRPr sz="1000"/>
-                      </a:pPr>
-                      <a:r>
-                        <a:t>0.046100674305792344</a:t>
-                      </a:r>
-                    </a:p>
-                  </a:txBody>
-                  <a:tcPr/>
-                </a:tc>
-                <a:tc>
-                  <a:txBody>
-                    <a:bodyPr/>
-                    <a:lstStyle/>
-                    <a:p>
-                      <a:pPr>
-                        <a:defRPr sz="1000"/>
-                      </a:pPr>
-                      <a:r>
-                        <a:t>0.08726928947875359</a:t>
-                      </a:r>
-                    </a:p>
-                  </a:txBody>
-                  <a:tcPr/>
-                </a:tc>
-                <a:tc>
-                  <a:txBody>
-                    <a:bodyPr/>
-                    <a:lstStyle/>
-                    <a:p>
-                      <a:pPr>
-                        <a:defRPr sz="1000"/>
-                      </a:pPr>
-                      <a:r>
-                        <a:t>0.0456012888273175</a:t>
-                      </a:r>
-                    </a:p>
-                  </a:txBody>
-                  <a:tcPr/>
-                </a:tc>
-                <a:tc>
-                  <a:txBody>
-                    <a:bodyPr/>
-                    <a:lstStyle/>
-                    <a:p>
-                      <a:pPr>
-                        <a:defRPr sz="1000"/>
-                      </a:pPr>
-                      <a:r>
-                        <a:t>3771.8823529411766</a:t>
-                      </a:r>
-                    </a:p>
-                  </a:txBody>
-                  <a:tcPr/>
-                </a:tc>
-              </a:tr>
-              <a:tr h="548640">
-                <a:tc>
-                  <a:txBody>
-                    <a:bodyPr/>
-                    <a:lstStyle/>
-                    <a:p>
-                      <a:pPr>
-                        <a:defRPr sz="1000"/>
-                      </a:pPr>
-                      <a:r>
-                        <a:t>Continental Europe</a:t>
-                      </a:r>
-                    </a:p>
-                  </a:txBody>
-                  <a:tcPr/>
-                </a:tc>
-                <a:tc>
-                  <a:txBody>
-                    <a:bodyPr/>
-                    <a:lstStyle/>
-                    <a:p>
-                      <a:pPr>
-                        <a:defRPr sz="1000"/>
-                      </a:pPr>
-                      <a:r>
-                        <a:t>0.006729238959531435</a:t>
-                      </a:r>
-                    </a:p>
-                  </a:txBody>
-                  <a:tcPr/>
-                </a:tc>
-                <a:tc>
-                  <a:txBody>
-                    <a:bodyPr/>
-                    <a:lstStyle/>
-                    <a:p>
-                      <a:pPr>
-                        <a:defRPr sz="1000"/>
-                      </a:pPr>
-                      <a:r>
-                        <a:t>0.035675615265306694</a:t>
-                      </a:r>
-                    </a:p>
-                  </a:txBody>
-                  <a:tcPr/>
-                </a:tc>
-                <a:tc>
-                  <a:txBody>
-                    <a:bodyPr/>
-                    <a:lstStyle/>
-                    <a:p>
-                      <a:pPr>
-                        <a:defRPr sz="1000"/>
-                      </a:pPr>
-                      <a:r>
-                        <a:t>0.05092163895711743</a:t>
-                      </a:r>
-                    </a:p>
-                  </a:txBody>
-                  <a:tcPr/>
-                </a:tc>
-                <a:tc>
-                  <a:txBody>
-                    <a:bodyPr/>
-                    <a:lstStyle/>
-                    <a:p>
-                      <a:pPr>
-                        <a:defRPr sz="1000"/>
-                      </a:pPr>
-                      <a:r>
-                        <a:t>0.09421365429270316</a:t>
-                      </a:r>
-                    </a:p>
-                  </a:txBody>
-                  <a:tcPr/>
-                </a:tc>
-                <a:tc>
-                  <a:txBody>
-                    <a:bodyPr/>
-                    <a:lstStyle/>
-                    <a:p>
-                      <a:pPr>
-                        <a:defRPr sz="1000"/>
-                      </a:pPr>
-                      <a:r>
-                        <a:t>0.0458472850546197</a:t>
-                      </a:r>
-                    </a:p>
-                  </a:txBody>
-                  <a:tcPr/>
-                </a:tc>
-                <a:tc>
-                  <a:txBody>
-                    <a:bodyPr/>
-                    <a:lstStyle/>
-                    <a:p>
-                      <a:pPr>
-                        <a:defRPr sz="1000"/>
-                      </a:pPr>
-                      <a:r>
-                        <a:t>9935.941176470587</a:t>
-                      </a:r>
-                    </a:p>
-                  </a:txBody>
-                  <a:tcPr/>
-                </a:tc>
-              </a:tr>
-              <a:tr h="548640">
-                <a:tc>
-                  <a:txBody>
-                    <a:bodyPr/>
-                    <a:lstStyle/>
-                    <a:p>
-                      <a:pPr>
-                        <a:defRPr sz="1000"/>
-                      </a:pPr>
-                      <a:r>
-                        <a:t>Hindu</a:t>
-                      </a:r>
-                    </a:p>
-                  </a:txBody>
-                  <a:tcPr/>
-                </a:tc>
-                <a:tc>
-                  <a:txBody>
-                    <a:bodyPr/>
-                    <a:lstStyle/>
-                    <a:p>
-                      <a:pPr>
-                        <a:defRPr sz="1000"/>
-                      </a:pPr>
-                      <a:r>
-                        <a:t>0.008226712242474519</a:t>
-                      </a:r>
-                    </a:p>
-                  </a:txBody>
-                  <a:tcPr/>
-                </a:tc>
-                <a:tc>
-                  <a:txBody>
-                    <a:bodyPr/>
-                    <a:lstStyle/>
-                    <a:p>
-                      <a:pPr>
-                        <a:defRPr sz="1000"/>
-                      </a:pPr>
-                      <a:r>
-                        <a:t>0.030279250458970227</a:t>
-                      </a:r>
-                    </a:p>
-                  </a:txBody>
-                  <a:tcPr/>
-                </a:tc>
-                <a:tc>
-                  <a:txBody>
-                    <a:bodyPr/>
-                    <a:lstStyle/>
-                    <a:p>
-                      <a:pPr>
-                        <a:defRPr sz="1000"/>
-                      </a:pPr>
-                      <a:r>
-                        <a:t>0.026557199723339326</a:t>
-                      </a:r>
-                    </a:p>
-                  </a:txBody>
-                  <a:tcPr/>
-                </a:tc>
-                <a:tc>
-                  <a:txBody>
-                    <a:bodyPr/>
-                    <a:lstStyle/>
-                    <a:p>
-                      <a:pPr>
-                        <a:defRPr sz="1000"/>
-                      </a:pPr>
-                      <a:r>
-                        <a:t>0.08171692434949991</a:t>
-                      </a:r>
-                    </a:p>
-                  </a:txBody>
-                  <a:tcPr/>
-                </a:tc>
-                <a:tc>
-                  <a:txBody>
-                    <a:bodyPr/>
-                    <a:lstStyle/>
-                    <a:p>
-                      <a:pPr>
-                        <a:defRPr sz="1000"/>
-                      </a:pPr>
-                      <a:r>
-                        <a:t>0.0277057844536427</a:t>
-                      </a:r>
-                    </a:p>
-                  </a:txBody>
-                  <a:tcPr/>
-                </a:tc>
-                <a:tc>
-                  <a:txBody>
-                    <a:bodyPr/>
-                    <a:lstStyle/>
-                    <a:p>
-                      <a:pPr>
-                        <a:defRPr sz="1000"/>
-                      </a:pPr>
-                      <a:r>
-                        <a:t>1651.1176470588234</a:t>
-                      </a:r>
-                    </a:p>
-                  </a:txBody>
-                  <a:tcPr/>
-                </a:tc>
-              </a:tr>
-              <a:tr h="548640">
-                <a:tc>
-                  <a:txBody>
-                    <a:bodyPr/>
-                    <a:lstStyle/>
-                    <a:p>
-                      <a:pPr>
-                        <a:defRPr sz="1000"/>
-                      </a:pPr>
-                      <a:r>
-                        <a:t>Islamic</a:t>
-                      </a:r>
-                    </a:p>
-                  </a:txBody>
-                  <a:tcPr/>
-                </a:tc>
-                <a:tc>
-                  <a:txBody>
-                    <a:bodyPr/>
-                    <a:lstStyle/>
-                    <a:p>
-                      <a:pPr>
-                        <a:defRPr sz="1000"/>
-                      </a:pPr>
-                      <a:r>
-                        <a:t>0.012389331071774071</a:t>
-                      </a:r>
-                    </a:p>
-                  </a:txBody>
-                  <a:tcPr/>
-                </a:tc>
-                <a:tc>
-                  <a:txBody>
-                    <a:bodyPr/>
-                    <a:lstStyle/>
-                    <a:p>
-                      <a:pPr>
-                        <a:defRPr sz="1000"/>
-                      </a:pPr>
-                      <a:r>
-                        <a:t>0.03689413571699145</a:t>
-                      </a:r>
-                    </a:p>
-                  </a:txBody>
-                  <a:tcPr/>
-                </a:tc>
-                <a:tc>
-                  <a:txBody>
-                    <a:bodyPr/>
-                    <a:lstStyle/>
-                    <a:p>
-                      <a:pPr>
-                        <a:defRPr sz="1000"/>
-                      </a:pPr>
-                      <a:r>
-                        <a:t>0.025186713119533095</a:t>
-                      </a:r>
-                    </a:p>
-                  </a:txBody>
-                  <a:tcPr/>
-                </a:tc>
-                <a:tc>
-                  <a:txBody>
-                    <a:bodyPr/>
-                    <a:lstStyle/>
-                    <a:p>
-                      <a:pPr>
-                        <a:defRPr sz="1000"/>
-                      </a:pPr>
-                      <a:r>
-                        <a:t>0.09451679349006414</a:t>
-                      </a:r>
-                    </a:p>
-                  </a:txBody>
-                  <a:tcPr/>
-                </a:tc>
-                <a:tc>
-                  <a:txBody>
-                    <a:bodyPr/>
-                    <a:lstStyle/>
-                    <a:p>
-                      <a:pPr>
-                        <a:defRPr sz="1000"/>
-                      </a:pPr>
-                      <a:r>
-                        <a:t>0.0300792155414555</a:t>
-                      </a:r>
-                    </a:p>
-                  </a:txBody>
-                  <a:tcPr/>
-                </a:tc>
-                <a:tc>
-                  <a:txBody>
-                    <a:bodyPr/>
-                    <a:lstStyle/>
-                    <a:p>
-                      <a:pPr>
-                        <a:defRPr sz="1000"/>
-                      </a:pPr>
-                      <a:r>
-                        <a:t>3002.529411764706</a:t>
-                      </a:r>
-                    </a:p>
-                  </a:txBody>
-                  <a:tcPr/>
-                </a:tc>
-              </a:tr>
-              <a:tr h="548640">
-                <a:tc>
-                  <a:txBody>
-                    <a:bodyPr/>
-                    <a:lstStyle/>
-                    <a:p>
-                      <a:pPr>
-                        <a:defRPr sz="1000"/>
-                      </a:pPr>
-                      <a:r>
-                        <a:t>Japanese</a:t>
-                      </a:r>
-                    </a:p>
-                  </a:txBody>
-                  <a:tcPr/>
-                </a:tc>
-                <a:tc>
-                  <a:txBody>
-                    <a:bodyPr/>
-                    <a:lstStyle/>
-                    <a:p>
-                      <a:pPr>
-                        <a:defRPr sz="1000"/>
-                      </a:pPr>
-                      <a:r>
-                        <a:t>0.006813925283901347</a:t>
-                      </a:r>
-                    </a:p>
-                  </a:txBody>
-                  <a:tcPr/>
-                </a:tc>
-                <a:tc>
-                  <a:txBody>
-                    <a:bodyPr/>
-                    <a:lstStyle/>
-                    <a:p>
-                      <a:pPr>
-                        <a:defRPr sz="1000"/>
-                      </a:pPr>
-                      <a:r>
-                        <a:t>0.03707504315767071</a:t>
-                      </a:r>
-                    </a:p>
-                  </a:txBody>
-                  <a:tcPr/>
-                </a:tc>
-                <a:tc>
-                  <a:txBody>
-                    <a:bodyPr/>
-                    <a:lstStyle/>
-                    <a:p>
-                      <a:pPr>
-                        <a:defRPr sz="1000"/>
-                      </a:pPr>
-                      <a:r>
-                        <a:t>0.023589752718372055</a:t>
-                      </a:r>
-                    </a:p>
-                  </a:txBody>
-                  <a:tcPr/>
-                </a:tc>
-                <a:tc>
-                  <a:txBody>
-                    <a:bodyPr/>
-                    <a:lstStyle/>
-                    <a:p>
-                      <a:pPr>
-                        <a:defRPr sz="1000"/>
-                      </a:pPr>
-                      <a:r>
-                        <a:t>0.06939410367989353</a:t>
-                      </a:r>
-                    </a:p>
-                  </a:txBody>
-                  <a:tcPr/>
-                </a:tc>
-                <a:tc>
-                  <a:txBody>
-                    <a:bodyPr/>
-                    <a:lstStyle/>
-                    <a:p>
-                      <a:pPr>
-                        <a:defRPr sz="1000"/>
-                      </a:pPr>
-                      <a:r>
-                        <a:t>0.0552190245713187</a:t>
-                      </a:r>
-                    </a:p>
-                  </a:txBody>
-                  <a:tcPr/>
-                </a:tc>
-                <a:tc>
-                  <a:txBody>
-                    <a:bodyPr/>
-                    <a:lstStyle/>
-                    <a:p>
-                      <a:pPr>
-                        <a:defRPr sz="1000"/>
-                      </a:pPr>
-                      <a:r>
-                        <a:t>1882.764705882353</a:t>
-                      </a:r>
-                    </a:p>
-                  </a:txBody>
-                  <a:tcPr/>
-                </a:tc>
-              </a:tr>
-              <a:tr h="548640">
-                <a:tc>
-                  <a:txBody>
-                    <a:bodyPr/>
-                    <a:lstStyle/>
-                    <a:p>
-                      <a:pPr>
-                        <a:defRPr sz="1000"/>
-                      </a:pPr>
-                      <a:r>
-                        <a:t>Other Civilizations</a:t>
-                      </a:r>
-                    </a:p>
-                  </a:txBody>
-                  <a:tcPr/>
-                </a:tc>
-                <a:tc>
-                  <a:txBody>
-                    <a:bodyPr/>
-                    <a:lstStyle/>
-                    <a:p>
-                      <a:pPr>
-                        <a:defRPr sz="1000"/>
-                      </a:pPr>
-                      <a:r>
-                        <a:t>0.009056448138388542</a:t>
-                      </a:r>
-                    </a:p>
-                  </a:txBody>
-                  <a:tcPr/>
-                </a:tc>
-                <a:tc>
-                  <a:txBody>
-                    <a:bodyPr/>
-                    <a:lstStyle/>
-                    <a:p>
-                      <a:pPr>
-                        <a:defRPr sz="1000"/>
-                      </a:pPr>
-                      <a:r>
-                        <a:t>0.034508343392236136</a:t>
-                      </a:r>
-                    </a:p>
-                  </a:txBody>
-                  <a:tcPr/>
-                </a:tc>
-                <a:tc>
-                  <a:txBody>
-                    <a:bodyPr/>
-                    <a:lstStyle/>
-                    <a:p>
-                      <a:pPr>
-                        <a:defRPr sz="1000"/>
-                      </a:pPr>
-                      <a:r>
-                        <a:t>0.02568915937776914</a:t>
-                      </a:r>
-                    </a:p>
-                  </a:txBody>
-                  <a:tcPr/>
-                </a:tc>
-                <a:tc>
-                  <a:txBody>
-                    <a:bodyPr/>
-                    <a:lstStyle/>
-                    <a:p>
-                      <a:pPr>
-                        <a:defRPr sz="1000"/>
-                      </a:pPr>
-                      <a:r>
-                        <a:t>0.07757096199241675</a:t>
-                      </a:r>
-                    </a:p>
-                  </a:txBody>
-                  <a:tcPr/>
-                </a:tc>
-                <a:tc>
-                  <a:txBody>
-                    <a:bodyPr/>
-                    <a:lstStyle/>
-                    <a:p>
-                      <a:pPr>
-                        <a:defRPr sz="1000"/>
-                      </a:pPr>
-                      <a:r>
-                        <a:t>0.0418088008437154</a:t>
-                      </a:r>
-                    </a:p>
-                  </a:txBody>
-                  <a:tcPr/>
-                </a:tc>
-                <a:tc>
-                  <a:txBody>
-                    <a:bodyPr/>
-                    <a:lstStyle/>
-                    <a:p>
-                      <a:pPr>
-                        <a:defRPr sz="1000"/>
-                      </a:pPr>
-                      <a:r>
-                        <a:t>2955.294117647059</a:t>
-                      </a:r>
-                    </a:p>
-                  </a:txBody>
-                  <a:tcPr/>
-                </a:tc>
-              </a:tr>
-              <a:tr h="548640">
-                <a:tc>
-                  <a:txBody>
-                    <a:bodyPr/>
-                    <a:lstStyle/>
-                    <a:p>
-                      <a:pPr>
-                        <a:defRPr sz="1000"/>
-                      </a:pPr>
-                      <a:r>
-                        <a:t>Other Western</a:t>
-                      </a:r>
-                    </a:p>
-                  </a:txBody>
-                  <a:tcPr/>
-                </a:tc>
-                <a:tc>
-                  <a:txBody>
-                    <a:bodyPr/>
-                    <a:lstStyle/>
-                    <a:p>
-                      <a:pPr>
-                        <a:defRPr sz="1000"/>
-                      </a:pPr>
-                      <a:r>
-                        <a:t>0.013521943556706347</a:t>
-                      </a:r>
-                    </a:p>
-                  </a:txBody>
-                  <a:tcPr/>
-                </a:tc>
-                <a:tc>
-                  <a:txBody>
-                    <a:bodyPr/>
-                    <a:lstStyle/>
-                    <a:p>
-                      <a:pPr>
-                        <a:defRPr sz="1000"/>
-                      </a:pPr>
-                      <a:r>
-                        <a:t>0.031869406157243534</a:t>
-                      </a:r>
-                    </a:p>
-                  </a:txBody>
-                  <a:tcPr/>
-                </a:tc>
-                <a:tc>
-                  <a:txBody>
-                    <a:bodyPr/>
-                    <a:lstStyle/>
-                    <a:p>
-                      <a:pPr>
-                        <a:defRPr sz="1000"/>
-                      </a:pPr>
-                      <a:r>
-                        <a:t>0.058099157893367795</a:t>
-                      </a:r>
-                    </a:p>
-                  </a:txBody>
-                  <a:tcPr/>
-                </a:tc>
-                <a:tc>
-                  <a:txBody>
-                    <a:bodyPr/>
-                    <a:lstStyle/>
-                    <a:p>
-                      <a:pPr>
-                        <a:defRPr sz="1000"/>
-                      </a:pPr>
-                      <a:r>
-                        <a:t>0.0671873401266947</a:t>
-                      </a:r>
-                    </a:p>
-                  </a:txBody>
-                  <a:tcPr/>
-                </a:tc>
-                <a:tc>
-                  <a:txBody>
-                    <a:bodyPr/>
-                    <a:lstStyle/>
-                    <a:p>
-                      <a:pPr>
-                        <a:defRPr sz="1000"/>
-                      </a:pPr>
-                      <a:r>
-                        <a:t>0.0442928225810436</a:t>
-                      </a:r>
-                    </a:p>
-                  </a:txBody>
-                  <a:tcPr/>
-                </a:tc>
-                <a:tc>
-                  <a:txBody>
-                    <a:bodyPr/>
-                    <a:lstStyle/>
-                    <a:p>
-                      <a:pPr>
-                        <a:defRPr sz="1000"/>
-                      </a:pPr>
-                      <a:r>
-                        <a:t>258.6470588235294</a:t>
-                      </a:r>
-                    </a:p>
-                  </a:txBody>
-                  <a:tcPr/>
-                </a:tc>
-              </a:tr>
-              <a:tr h="548640">
-                <a:tc>
-                  <a:txBody>
-                    <a:bodyPr/>
-                    <a:lstStyle/>
-                    <a:p>
-                      <a:pPr>
-                        <a:defRPr sz="1000"/>
-                      </a:pPr>
-                      <a:r>
-                        <a:t>Sinic</a:t>
-                      </a:r>
-                    </a:p>
-                  </a:txBody>
-                  <a:tcPr/>
-                </a:tc>
-                <a:tc>
-                  <a:txBody>
-                    <a:bodyPr/>
-                    <a:lstStyle/>
-                    <a:p>
-                      <a:pPr>
-                        <a:defRPr sz="1000"/>
-                      </a:pPr>
-                      <a:r>
-                        <a:t>0.006891999181649188</a:t>
-                      </a:r>
-                    </a:p>
-                  </a:txBody>
-                  <a:tcPr/>
-                </a:tc>
-                <a:tc>
-                  <a:txBody>
-                    <a:bodyPr/>
-                    <a:lstStyle/>
-                    <a:p>
-                      <a:pPr>
-                        <a:defRPr sz="1000"/>
-                      </a:pPr>
-                      <a:r>
-                        <a:t>0.026959051414237076</a:t>
-                      </a:r>
-                    </a:p>
-                  </a:txBody>
-                  <a:tcPr/>
-                </a:tc>
-                <a:tc>
-                  <a:txBody>
-                    <a:bodyPr/>
-                    <a:lstStyle/>
-                    <a:p>
-                      <a:pPr>
-                        <a:defRPr sz="1000"/>
-                      </a:pPr>
-                      <a:r>
-                        <a:t>0.025929464772427302</a:t>
-                      </a:r>
-                    </a:p>
-                  </a:txBody>
-                  <a:tcPr/>
-                </a:tc>
-                <a:tc>
-                  <a:txBody>
-                    <a:bodyPr/>
-                    <a:lstStyle/>
-                    <a:p>
-                      <a:pPr>
-                        <a:defRPr sz="1000"/>
-                      </a:pPr>
-                      <a:r>
-                        <a:t>0.09080689682278584</a:t>
-                      </a:r>
-                    </a:p>
-                  </a:txBody>
-                  <a:tcPr/>
-                </a:tc>
-                <a:tc>
-                  <a:txBody>
-                    <a:bodyPr/>
-                    <a:lstStyle/>
-                    <a:p>
-                      <a:pPr>
-                        <a:defRPr sz="1000"/>
-                      </a:pPr>
-                      <a:r>
-                        <a:t>0.0336695344484046</a:t>
-                      </a:r>
-                    </a:p>
-                  </a:txBody>
-                  <a:tcPr/>
-                </a:tc>
-                <a:tc>
-                  <a:txBody>
-                    <a:bodyPr/>
-                    <a:lstStyle/>
-                    <a:p>
-                      <a:pPr>
-                        <a:defRPr sz="1000"/>
-                      </a:pPr>
-                      <a:r>
-                        <a:t>11179.470588235294</a:t>
-                      </a:r>
-                    </a:p>
-                  </a:txBody>
-                  <a:tcPr/>
-                </a:tc>
-              </a:tr>
-              <a:tr h="548640">
-                <a:tc>
-                  <a:txBody>
-                    <a:bodyPr/>
-                    <a:lstStyle/>
-                    <a:p>
-                      <a:pPr>
-                        <a:defRPr sz="1000"/>
-                      </a:pPr>
-                      <a:r>
-                        <a:t>United States</a:t>
-                      </a:r>
-                    </a:p>
-                  </a:txBody>
-                  <a:tcPr/>
-                </a:tc>
-                <a:tc>
-                  <a:txBody>
-                    <a:bodyPr/>
-                    <a:lstStyle/>
-                    <a:p>
-                      <a:pPr>
-                        <a:defRPr sz="1000"/>
-                      </a:pPr>
-                      <a:r>
-                        <a:t>0.008485370848193771</a:t>
-                      </a:r>
-                    </a:p>
-                  </a:txBody>
-                  <a:tcPr/>
-                </a:tc>
-                <a:tc>
-                  <a:txBody>
-                    <a:bodyPr/>
-                    <a:lstStyle/>
-                    <a:p>
-                      <a:pPr>
-                        <a:defRPr sz="1000"/>
-                      </a:pPr>
-                      <a:r>
-                        <a:t>0.03323197711785264</a:t>
-                      </a:r>
-                    </a:p>
-                  </a:txBody>
-                  <a:tcPr/>
-                </a:tc>
-                <a:tc>
-                  <a:txBody>
-                    <a:bodyPr/>
-                    <a:lstStyle/>
-                    <a:p>
-                      <a:pPr>
-                        <a:defRPr sz="1000"/>
-                      </a:pPr>
-                      <a:r>
-                        <a:t>0.046601807299749005</a:t>
-                      </a:r>
-                    </a:p>
-                  </a:txBody>
-                  <a:tcPr/>
-                </a:tc>
-                <a:tc>
-                  <a:txBody>
-                    <a:bodyPr/>
-                    <a:lstStyle/>
-                    <a:p>
-                      <a:pPr>
-                        <a:defRPr sz="1000"/>
-                      </a:pPr>
-                      <a:r>
-                        <a:t>0.08643858355385259</a:t>
-                      </a:r>
-                    </a:p>
-                  </a:txBody>
-                  <a:tcPr/>
-                </a:tc>
-                <a:tc>
-                  <a:txBody>
-                    <a:bodyPr/>
-                    <a:lstStyle/>
-                    <a:p>
-                      <a:pPr>
-                        <a:defRPr sz="1000"/>
-                      </a:pPr>
-                      <a:r>
-                        <a:t>0.0459350067675392</a:t>
-                      </a:r>
-                    </a:p>
-                  </a:txBody>
-                  <a:tcPr/>
-                </a:tc>
-                <a:tc>
-                  <a:txBody>
-                    <a:bodyPr/>
-                    <a:lstStyle/>
-                    <a:p>
-                      <a:pPr>
-                        <a:defRPr sz="1000"/>
-                      </a:pPr>
-                      <a:r>
-                        <a:t>7929.823529411765</a:t>
-                      </a:r>
-                    </a:p>
-                  </a:txBody>
-                  <a:tcPr/>
-                </a:tc>
-              </a:tr>
-            </a:tbl>
-          </a:graphicData>
-        </a:graphic>
-      </p:graphicFrame>
     </p:spTree>
   </p:cSld>
   <p:clrMapOvr>
@@ -9570,7 +8791,1160 @@
           <a:lstStyle/>
           <a:p>
             <a:r>
-              <a:t>Table 10: Top origin-destination abroad author-year pairs</a:t>
+              <a:t>Supplementary Table 3: Mean observed annual transition rates, 2000-2016</a:t>
+            </a:r>
+          </a:p>
+        </p:txBody>
+      </p:sp>
+      <p:sp>
+        <p:nvSpPr>
+          <p:cNvPr id="3" name="Content Placeholder 2"/>
+          <p:cNvSpPr>
+            <a:spLocks noGrp="1"/>
+          </p:cNvSpPr>
+          <p:nvPr>
+            <p:ph idx="1" sz="half"/>
+          </p:nvPr>
+        </p:nvSpPr>
+        <p:spPr/>
+        <p:txBody>
+          <a:bodyPr/>
+          <a:lstStyle/>
+          <a:p/>
+        </p:txBody>
+      </p:sp>
+      <p:sp>
+        <p:nvSpPr>
+          <p:cNvPr id="4" name="Content Placeholder 3"/>
+          <p:cNvSpPr>
+            <a:spLocks noGrp="1"/>
+          </p:cNvSpPr>
+          <p:nvPr>
+            <p:ph idx="2" sz="half"/>
+          </p:nvPr>
+        </p:nvSpPr>
+        <p:spPr/>
+        <p:txBody>
+          <a:bodyPr/>
+          <a:lstStyle/>
+          <a:p/>
+        </p:txBody>
+      </p:sp>
+      <p:graphicFrame>
+        <p:nvGraphicFramePr>
+          <p:cNvPr id="5" name="Table 4"/>
+          <p:cNvGraphicFramePr>
+            <a:graphicFrameLocks noGrp="1"/>
+          </p:cNvGraphicFramePr>
+          <p:nvPr/>
+        </p:nvGraphicFramePr>
+        <p:xfrm>
+          <a:off x="457200" y="1097280"/>
+          <a:ext cx="8961119" cy="5486400"/>
+        </p:xfrm>
+        <a:graphic>
+          <a:graphicData uri="http://schemas.openxmlformats.org/drawingml/2006/table">
+            <a:tbl>
+              <a:tblPr firstRow="1" bandRow="1">
+                <a:tableStyleId>{5C22544A-7EE6-4342-B048-85BDC9FD1C3A}</a:tableStyleId>
+              </a:tblPr>
+              <a:tblGrid>
+                <a:gridCol w="1280159"/>
+                <a:gridCol w="1280159"/>
+                <a:gridCol w="1280159"/>
+                <a:gridCol w="1280159"/>
+                <a:gridCol w="1280159"/>
+                <a:gridCol w="1280159"/>
+                <a:gridCol w="1280165"/>
+              </a:tblGrid>
+              <a:tr h="548640">
+                <a:tc>
+                  <a:txBody>
+                    <a:bodyPr/>
+                    <a:lstStyle/>
+                    <a:p>
+                      <a:r>
+                        <a:t>Group</a:t>
+                      </a:r>
+                    </a:p>
+                  </a:txBody>
+                  <a:tcPr/>
+                </a:tc>
+                <a:tc>
+                  <a:txBody>
+                    <a:bodyPr/>
+                    <a:lstStyle/>
+                    <a:p>
+                      <a:r>
+                        <a:t>α</a:t>
+                      </a:r>
+                    </a:p>
+                  </a:txBody>
+                  <a:tcPr/>
+                </a:tc>
+                <a:tc>
+                  <a:txBody>
+                    <a:bodyPr/>
+                    <a:lstStyle/>
+                    <a:p>
+                      <a:r>
+                        <a:t>β</a:t>
+                      </a:r>
+                    </a:p>
+                  </a:txBody>
+                  <a:tcPr/>
+                </a:tc>
+                <a:tc>
+                  <a:txBody>
+                    <a:bodyPr/>
+                    <a:lstStyle/>
+                    <a:p>
+                      <a:r>
+                        <a:t>h_D</a:t>
+                      </a:r>
+                    </a:p>
+                  </a:txBody>
+                  <a:tcPr/>
+                </a:tc>
+                <a:tc>
+                  <a:txBody>
+                    <a:bodyPr/>
+                    <a:lstStyle/>
+                    <a:p>
+                      <a:r>
+                        <a:t>p_D</a:t>
+                      </a:r>
+                    </a:p>
+                  </a:txBody>
+                  <a:tcPr/>
+                </a:tc>
+                <a:tc>
+                  <a:txBody>
+                    <a:bodyPr/>
+                    <a:lstStyle/>
+                    <a:p>
+                      <a:r>
+                        <a:t>d</a:t>
+                      </a:r>
+                    </a:p>
+                  </a:txBody>
+                  <a:tcPr/>
+                </a:tc>
+                <a:tc>
+                  <a:txBody>
+                    <a:bodyPr/>
+                    <a:lstStyle/>
+                    <a:p>
+                      <a:r>
+                        <a:t>I_total</a:t>
+                      </a:r>
+                    </a:p>
+                  </a:txBody>
+                  <a:tcPr/>
+                </a:tc>
+              </a:tr>
+              <a:tr h="548640">
+                <a:tc>
+                  <a:txBody>
+                    <a:bodyPr/>
+                    <a:lstStyle/>
+                    <a:p>
+                      <a:pPr>
+                        <a:defRPr sz="1000"/>
+                      </a:pPr>
+                      <a:r>
+                        <a:t>Anglosphere ex-US</a:t>
+                      </a:r>
+                    </a:p>
+                  </a:txBody>
+                  <a:tcPr/>
+                </a:tc>
+                <a:tc>
+                  <a:txBody>
+                    <a:bodyPr/>
+                    <a:lstStyle/>
+                    <a:p>
+                      <a:pPr>
+                        <a:defRPr sz="1000"/>
+                      </a:pPr>
+                      <a:r>
+                        <a:t>0.01153982905868697</a:t>
+                      </a:r>
+                    </a:p>
+                  </a:txBody>
+                  <a:tcPr/>
+                </a:tc>
+                <a:tc>
+                  <a:txBody>
+                    <a:bodyPr/>
+                    <a:lstStyle/>
+                    <a:p>
+                      <a:pPr>
+                        <a:defRPr sz="1000"/>
+                      </a:pPr>
+                      <a:r>
+                        <a:t>0.03392610062985291</a:t>
+                      </a:r>
+                    </a:p>
+                  </a:txBody>
+                  <a:tcPr/>
+                </a:tc>
+                <a:tc>
+                  <a:txBody>
+                    <a:bodyPr/>
+                    <a:lstStyle/>
+                    <a:p>
+                      <a:pPr>
+                        <a:defRPr sz="1000"/>
+                      </a:pPr>
+                      <a:r>
+                        <a:t>0.046100674305792344</a:t>
+                      </a:r>
+                    </a:p>
+                  </a:txBody>
+                  <a:tcPr/>
+                </a:tc>
+                <a:tc>
+                  <a:txBody>
+                    <a:bodyPr/>
+                    <a:lstStyle/>
+                    <a:p>
+                      <a:pPr>
+                        <a:defRPr sz="1000"/>
+                      </a:pPr>
+                      <a:r>
+                        <a:t>0.08726928947875359</a:t>
+                      </a:r>
+                    </a:p>
+                  </a:txBody>
+                  <a:tcPr/>
+                </a:tc>
+                <a:tc>
+                  <a:txBody>
+                    <a:bodyPr/>
+                    <a:lstStyle/>
+                    <a:p>
+                      <a:pPr>
+                        <a:defRPr sz="1000"/>
+                      </a:pPr>
+                      <a:r>
+                        <a:t>0.0456012888273175</a:t>
+                      </a:r>
+                    </a:p>
+                  </a:txBody>
+                  <a:tcPr/>
+                </a:tc>
+                <a:tc>
+                  <a:txBody>
+                    <a:bodyPr/>
+                    <a:lstStyle/>
+                    <a:p>
+                      <a:pPr>
+                        <a:defRPr sz="1000"/>
+                      </a:pPr>
+                      <a:r>
+                        <a:t>3771.8823529411766</a:t>
+                      </a:r>
+                    </a:p>
+                  </a:txBody>
+                  <a:tcPr/>
+                </a:tc>
+              </a:tr>
+              <a:tr h="548640">
+                <a:tc>
+                  <a:txBody>
+                    <a:bodyPr/>
+                    <a:lstStyle/>
+                    <a:p>
+                      <a:pPr>
+                        <a:defRPr sz="1000"/>
+                      </a:pPr>
+                      <a:r>
+                        <a:t>Continental Europe</a:t>
+                      </a:r>
+                    </a:p>
+                  </a:txBody>
+                  <a:tcPr/>
+                </a:tc>
+                <a:tc>
+                  <a:txBody>
+                    <a:bodyPr/>
+                    <a:lstStyle/>
+                    <a:p>
+                      <a:pPr>
+                        <a:defRPr sz="1000"/>
+                      </a:pPr>
+                      <a:r>
+                        <a:t>0.006729238959531435</a:t>
+                      </a:r>
+                    </a:p>
+                  </a:txBody>
+                  <a:tcPr/>
+                </a:tc>
+                <a:tc>
+                  <a:txBody>
+                    <a:bodyPr/>
+                    <a:lstStyle/>
+                    <a:p>
+                      <a:pPr>
+                        <a:defRPr sz="1000"/>
+                      </a:pPr>
+                      <a:r>
+                        <a:t>0.035675615265306694</a:t>
+                      </a:r>
+                    </a:p>
+                  </a:txBody>
+                  <a:tcPr/>
+                </a:tc>
+                <a:tc>
+                  <a:txBody>
+                    <a:bodyPr/>
+                    <a:lstStyle/>
+                    <a:p>
+                      <a:pPr>
+                        <a:defRPr sz="1000"/>
+                      </a:pPr>
+                      <a:r>
+                        <a:t>0.05092163895711743</a:t>
+                      </a:r>
+                    </a:p>
+                  </a:txBody>
+                  <a:tcPr/>
+                </a:tc>
+                <a:tc>
+                  <a:txBody>
+                    <a:bodyPr/>
+                    <a:lstStyle/>
+                    <a:p>
+                      <a:pPr>
+                        <a:defRPr sz="1000"/>
+                      </a:pPr>
+                      <a:r>
+                        <a:t>0.09421365429270316</a:t>
+                      </a:r>
+                    </a:p>
+                  </a:txBody>
+                  <a:tcPr/>
+                </a:tc>
+                <a:tc>
+                  <a:txBody>
+                    <a:bodyPr/>
+                    <a:lstStyle/>
+                    <a:p>
+                      <a:pPr>
+                        <a:defRPr sz="1000"/>
+                      </a:pPr>
+                      <a:r>
+                        <a:t>0.0458472850546197</a:t>
+                      </a:r>
+                    </a:p>
+                  </a:txBody>
+                  <a:tcPr/>
+                </a:tc>
+                <a:tc>
+                  <a:txBody>
+                    <a:bodyPr/>
+                    <a:lstStyle/>
+                    <a:p>
+                      <a:pPr>
+                        <a:defRPr sz="1000"/>
+                      </a:pPr>
+                      <a:r>
+                        <a:t>9935.941176470587</a:t>
+                      </a:r>
+                    </a:p>
+                  </a:txBody>
+                  <a:tcPr/>
+                </a:tc>
+              </a:tr>
+              <a:tr h="548640">
+                <a:tc>
+                  <a:txBody>
+                    <a:bodyPr/>
+                    <a:lstStyle/>
+                    <a:p>
+                      <a:pPr>
+                        <a:defRPr sz="1000"/>
+                      </a:pPr>
+                      <a:r>
+                        <a:t>Hindu</a:t>
+                      </a:r>
+                    </a:p>
+                  </a:txBody>
+                  <a:tcPr/>
+                </a:tc>
+                <a:tc>
+                  <a:txBody>
+                    <a:bodyPr/>
+                    <a:lstStyle/>
+                    <a:p>
+                      <a:pPr>
+                        <a:defRPr sz="1000"/>
+                      </a:pPr>
+                      <a:r>
+                        <a:t>0.008226712242474519</a:t>
+                      </a:r>
+                    </a:p>
+                  </a:txBody>
+                  <a:tcPr/>
+                </a:tc>
+                <a:tc>
+                  <a:txBody>
+                    <a:bodyPr/>
+                    <a:lstStyle/>
+                    <a:p>
+                      <a:pPr>
+                        <a:defRPr sz="1000"/>
+                      </a:pPr>
+                      <a:r>
+                        <a:t>0.030279250458970227</a:t>
+                      </a:r>
+                    </a:p>
+                  </a:txBody>
+                  <a:tcPr/>
+                </a:tc>
+                <a:tc>
+                  <a:txBody>
+                    <a:bodyPr/>
+                    <a:lstStyle/>
+                    <a:p>
+                      <a:pPr>
+                        <a:defRPr sz="1000"/>
+                      </a:pPr>
+                      <a:r>
+                        <a:t>0.026557199723339326</a:t>
+                      </a:r>
+                    </a:p>
+                  </a:txBody>
+                  <a:tcPr/>
+                </a:tc>
+                <a:tc>
+                  <a:txBody>
+                    <a:bodyPr/>
+                    <a:lstStyle/>
+                    <a:p>
+                      <a:pPr>
+                        <a:defRPr sz="1000"/>
+                      </a:pPr>
+                      <a:r>
+                        <a:t>0.08171692434949991</a:t>
+                      </a:r>
+                    </a:p>
+                  </a:txBody>
+                  <a:tcPr/>
+                </a:tc>
+                <a:tc>
+                  <a:txBody>
+                    <a:bodyPr/>
+                    <a:lstStyle/>
+                    <a:p>
+                      <a:pPr>
+                        <a:defRPr sz="1000"/>
+                      </a:pPr>
+                      <a:r>
+                        <a:t>0.0277057844536427</a:t>
+                      </a:r>
+                    </a:p>
+                  </a:txBody>
+                  <a:tcPr/>
+                </a:tc>
+                <a:tc>
+                  <a:txBody>
+                    <a:bodyPr/>
+                    <a:lstStyle/>
+                    <a:p>
+                      <a:pPr>
+                        <a:defRPr sz="1000"/>
+                      </a:pPr>
+                      <a:r>
+                        <a:t>1651.1176470588234</a:t>
+                      </a:r>
+                    </a:p>
+                  </a:txBody>
+                  <a:tcPr/>
+                </a:tc>
+              </a:tr>
+              <a:tr h="548640">
+                <a:tc>
+                  <a:txBody>
+                    <a:bodyPr/>
+                    <a:lstStyle/>
+                    <a:p>
+                      <a:pPr>
+                        <a:defRPr sz="1000"/>
+                      </a:pPr>
+                      <a:r>
+                        <a:t>Islamic</a:t>
+                      </a:r>
+                    </a:p>
+                  </a:txBody>
+                  <a:tcPr/>
+                </a:tc>
+                <a:tc>
+                  <a:txBody>
+                    <a:bodyPr/>
+                    <a:lstStyle/>
+                    <a:p>
+                      <a:pPr>
+                        <a:defRPr sz="1000"/>
+                      </a:pPr>
+                      <a:r>
+                        <a:t>0.012389331071774071</a:t>
+                      </a:r>
+                    </a:p>
+                  </a:txBody>
+                  <a:tcPr/>
+                </a:tc>
+                <a:tc>
+                  <a:txBody>
+                    <a:bodyPr/>
+                    <a:lstStyle/>
+                    <a:p>
+                      <a:pPr>
+                        <a:defRPr sz="1000"/>
+                      </a:pPr>
+                      <a:r>
+                        <a:t>0.03689413571699145</a:t>
+                      </a:r>
+                    </a:p>
+                  </a:txBody>
+                  <a:tcPr/>
+                </a:tc>
+                <a:tc>
+                  <a:txBody>
+                    <a:bodyPr/>
+                    <a:lstStyle/>
+                    <a:p>
+                      <a:pPr>
+                        <a:defRPr sz="1000"/>
+                      </a:pPr>
+                      <a:r>
+                        <a:t>0.025186713119533095</a:t>
+                      </a:r>
+                    </a:p>
+                  </a:txBody>
+                  <a:tcPr/>
+                </a:tc>
+                <a:tc>
+                  <a:txBody>
+                    <a:bodyPr/>
+                    <a:lstStyle/>
+                    <a:p>
+                      <a:pPr>
+                        <a:defRPr sz="1000"/>
+                      </a:pPr>
+                      <a:r>
+                        <a:t>0.09451679349006414</a:t>
+                      </a:r>
+                    </a:p>
+                  </a:txBody>
+                  <a:tcPr/>
+                </a:tc>
+                <a:tc>
+                  <a:txBody>
+                    <a:bodyPr/>
+                    <a:lstStyle/>
+                    <a:p>
+                      <a:pPr>
+                        <a:defRPr sz="1000"/>
+                      </a:pPr>
+                      <a:r>
+                        <a:t>0.0300792155414555</a:t>
+                      </a:r>
+                    </a:p>
+                  </a:txBody>
+                  <a:tcPr/>
+                </a:tc>
+                <a:tc>
+                  <a:txBody>
+                    <a:bodyPr/>
+                    <a:lstStyle/>
+                    <a:p>
+                      <a:pPr>
+                        <a:defRPr sz="1000"/>
+                      </a:pPr>
+                      <a:r>
+                        <a:t>3002.529411764706</a:t>
+                      </a:r>
+                    </a:p>
+                  </a:txBody>
+                  <a:tcPr/>
+                </a:tc>
+              </a:tr>
+              <a:tr h="548640">
+                <a:tc>
+                  <a:txBody>
+                    <a:bodyPr/>
+                    <a:lstStyle/>
+                    <a:p>
+                      <a:pPr>
+                        <a:defRPr sz="1000"/>
+                      </a:pPr>
+                      <a:r>
+                        <a:t>Japanese</a:t>
+                      </a:r>
+                    </a:p>
+                  </a:txBody>
+                  <a:tcPr/>
+                </a:tc>
+                <a:tc>
+                  <a:txBody>
+                    <a:bodyPr/>
+                    <a:lstStyle/>
+                    <a:p>
+                      <a:pPr>
+                        <a:defRPr sz="1000"/>
+                      </a:pPr>
+                      <a:r>
+                        <a:t>0.006813925283901347</a:t>
+                      </a:r>
+                    </a:p>
+                  </a:txBody>
+                  <a:tcPr/>
+                </a:tc>
+                <a:tc>
+                  <a:txBody>
+                    <a:bodyPr/>
+                    <a:lstStyle/>
+                    <a:p>
+                      <a:pPr>
+                        <a:defRPr sz="1000"/>
+                      </a:pPr>
+                      <a:r>
+                        <a:t>0.03707504315767071</a:t>
+                      </a:r>
+                    </a:p>
+                  </a:txBody>
+                  <a:tcPr/>
+                </a:tc>
+                <a:tc>
+                  <a:txBody>
+                    <a:bodyPr/>
+                    <a:lstStyle/>
+                    <a:p>
+                      <a:pPr>
+                        <a:defRPr sz="1000"/>
+                      </a:pPr>
+                      <a:r>
+                        <a:t>0.023589752718372055</a:t>
+                      </a:r>
+                    </a:p>
+                  </a:txBody>
+                  <a:tcPr/>
+                </a:tc>
+                <a:tc>
+                  <a:txBody>
+                    <a:bodyPr/>
+                    <a:lstStyle/>
+                    <a:p>
+                      <a:pPr>
+                        <a:defRPr sz="1000"/>
+                      </a:pPr>
+                      <a:r>
+                        <a:t>0.06939410367989353</a:t>
+                      </a:r>
+                    </a:p>
+                  </a:txBody>
+                  <a:tcPr/>
+                </a:tc>
+                <a:tc>
+                  <a:txBody>
+                    <a:bodyPr/>
+                    <a:lstStyle/>
+                    <a:p>
+                      <a:pPr>
+                        <a:defRPr sz="1000"/>
+                      </a:pPr>
+                      <a:r>
+                        <a:t>0.0552190245713187</a:t>
+                      </a:r>
+                    </a:p>
+                  </a:txBody>
+                  <a:tcPr/>
+                </a:tc>
+                <a:tc>
+                  <a:txBody>
+                    <a:bodyPr/>
+                    <a:lstStyle/>
+                    <a:p>
+                      <a:pPr>
+                        <a:defRPr sz="1000"/>
+                      </a:pPr>
+                      <a:r>
+                        <a:t>1882.764705882353</a:t>
+                      </a:r>
+                    </a:p>
+                  </a:txBody>
+                  <a:tcPr/>
+                </a:tc>
+              </a:tr>
+              <a:tr h="548640">
+                <a:tc>
+                  <a:txBody>
+                    <a:bodyPr/>
+                    <a:lstStyle/>
+                    <a:p>
+                      <a:pPr>
+                        <a:defRPr sz="1000"/>
+                      </a:pPr>
+                      <a:r>
+                        <a:t>Other Civilizations</a:t>
+                      </a:r>
+                    </a:p>
+                  </a:txBody>
+                  <a:tcPr/>
+                </a:tc>
+                <a:tc>
+                  <a:txBody>
+                    <a:bodyPr/>
+                    <a:lstStyle/>
+                    <a:p>
+                      <a:pPr>
+                        <a:defRPr sz="1000"/>
+                      </a:pPr>
+                      <a:r>
+                        <a:t>0.009056448138388542</a:t>
+                      </a:r>
+                    </a:p>
+                  </a:txBody>
+                  <a:tcPr/>
+                </a:tc>
+                <a:tc>
+                  <a:txBody>
+                    <a:bodyPr/>
+                    <a:lstStyle/>
+                    <a:p>
+                      <a:pPr>
+                        <a:defRPr sz="1000"/>
+                      </a:pPr>
+                      <a:r>
+                        <a:t>0.034508343392236136</a:t>
+                      </a:r>
+                    </a:p>
+                  </a:txBody>
+                  <a:tcPr/>
+                </a:tc>
+                <a:tc>
+                  <a:txBody>
+                    <a:bodyPr/>
+                    <a:lstStyle/>
+                    <a:p>
+                      <a:pPr>
+                        <a:defRPr sz="1000"/>
+                      </a:pPr>
+                      <a:r>
+                        <a:t>0.02568915937776914</a:t>
+                      </a:r>
+                    </a:p>
+                  </a:txBody>
+                  <a:tcPr/>
+                </a:tc>
+                <a:tc>
+                  <a:txBody>
+                    <a:bodyPr/>
+                    <a:lstStyle/>
+                    <a:p>
+                      <a:pPr>
+                        <a:defRPr sz="1000"/>
+                      </a:pPr>
+                      <a:r>
+                        <a:t>0.07757096199241675</a:t>
+                      </a:r>
+                    </a:p>
+                  </a:txBody>
+                  <a:tcPr/>
+                </a:tc>
+                <a:tc>
+                  <a:txBody>
+                    <a:bodyPr/>
+                    <a:lstStyle/>
+                    <a:p>
+                      <a:pPr>
+                        <a:defRPr sz="1000"/>
+                      </a:pPr>
+                      <a:r>
+                        <a:t>0.0418088008437154</a:t>
+                      </a:r>
+                    </a:p>
+                  </a:txBody>
+                  <a:tcPr/>
+                </a:tc>
+                <a:tc>
+                  <a:txBody>
+                    <a:bodyPr/>
+                    <a:lstStyle/>
+                    <a:p>
+                      <a:pPr>
+                        <a:defRPr sz="1000"/>
+                      </a:pPr>
+                      <a:r>
+                        <a:t>2955.294117647059</a:t>
+                      </a:r>
+                    </a:p>
+                  </a:txBody>
+                  <a:tcPr/>
+                </a:tc>
+              </a:tr>
+              <a:tr h="548640">
+                <a:tc>
+                  <a:txBody>
+                    <a:bodyPr/>
+                    <a:lstStyle/>
+                    <a:p>
+                      <a:pPr>
+                        <a:defRPr sz="1000"/>
+                      </a:pPr>
+                      <a:r>
+                        <a:t>Other Western</a:t>
+                      </a:r>
+                    </a:p>
+                  </a:txBody>
+                  <a:tcPr/>
+                </a:tc>
+                <a:tc>
+                  <a:txBody>
+                    <a:bodyPr/>
+                    <a:lstStyle/>
+                    <a:p>
+                      <a:pPr>
+                        <a:defRPr sz="1000"/>
+                      </a:pPr>
+                      <a:r>
+                        <a:t>0.013521943556706347</a:t>
+                      </a:r>
+                    </a:p>
+                  </a:txBody>
+                  <a:tcPr/>
+                </a:tc>
+                <a:tc>
+                  <a:txBody>
+                    <a:bodyPr/>
+                    <a:lstStyle/>
+                    <a:p>
+                      <a:pPr>
+                        <a:defRPr sz="1000"/>
+                      </a:pPr>
+                      <a:r>
+                        <a:t>0.031869406157243534</a:t>
+                      </a:r>
+                    </a:p>
+                  </a:txBody>
+                  <a:tcPr/>
+                </a:tc>
+                <a:tc>
+                  <a:txBody>
+                    <a:bodyPr/>
+                    <a:lstStyle/>
+                    <a:p>
+                      <a:pPr>
+                        <a:defRPr sz="1000"/>
+                      </a:pPr>
+                      <a:r>
+                        <a:t>0.058099157893367795</a:t>
+                      </a:r>
+                    </a:p>
+                  </a:txBody>
+                  <a:tcPr/>
+                </a:tc>
+                <a:tc>
+                  <a:txBody>
+                    <a:bodyPr/>
+                    <a:lstStyle/>
+                    <a:p>
+                      <a:pPr>
+                        <a:defRPr sz="1000"/>
+                      </a:pPr>
+                      <a:r>
+                        <a:t>0.0671873401266947</a:t>
+                      </a:r>
+                    </a:p>
+                  </a:txBody>
+                  <a:tcPr/>
+                </a:tc>
+                <a:tc>
+                  <a:txBody>
+                    <a:bodyPr/>
+                    <a:lstStyle/>
+                    <a:p>
+                      <a:pPr>
+                        <a:defRPr sz="1000"/>
+                      </a:pPr>
+                      <a:r>
+                        <a:t>0.0442928225810436</a:t>
+                      </a:r>
+                    </a:p>
+                  </a:txBody>
+                  <a:tcPr/>
+                </a:tc>
+                <a:tc>
+                  <a:txBody>
+                    <a:bodyPr/>
+                    <a:lstStyle/>
+                    <a:p>
+                      <a:pPr>
+                        <a:defRPr sz="1000"/>
+                      </a:pPr>
+                      <a:r>
+                        <a:t>258.6470588235294</a:t>
+                      </a:r>
+                    </a:p>
+                  </a:txBody>
+                  <a:tcPr/>
+                </a:tc>
+              </a:tr>
+              <a:tr h="548640">
+                <a:tc>
+                  <a:txBody>
+                    <a:bodyPr/>
+                    <a:lstStyle/>
+                    <a:p>
+                      <a:pPr>
+                        <a:defRPr sz="1000"/>
+                      </a:pPr>
+                      <a:r>
+                        <a:t>Sinic</a:t>
+                      </a:r>
+                    </a:p>
+                  </a:txBody>
+                  <a:tcPr/>
+                </a:tc>
+                <a:tc>
+                  <a:txBody>
+                    <a:bodyPr/>
+                    <a:lstStyle/>
+                    <a:p>
+                      <a:pPr>
+                        <a:defRPr sz="1000"/>
+                      </a:pPr>
+                      <a:r>
+                        <a:t>0.006891999181649188</a:t>
+                      </a:r>
+                    </a:p>
+                  </a:txBody>
+                  <a:tcPr/>
+                </a:tc>
+                <a:tc>
+                  <a:txBody>
+                    <a:bodyPr/>
+                    <a:lstStyle/>
+                    <a:p>
+                      <a:pPr>
+                        <a:defRPr sz="1000"/>
+                      </a:pPr>
+                      <a:r>
+                        <a:t>0.026959051414237076</a:t>
+                      </a:r>
+                    </a:p>
+                  </a:txBody>
+                  <a:tcPr/>
+                </a:tc>
+                <a:tc>
+                  <a:txBody>
+                    <a:bodyPr/>
+                    <a:lstStyle/>
+                    <a:p>
+                      <a:pPr>
+                        <a:defRPr sz="1000"/>
+                      </a:pPr>
+                      <a:r>
+                        <a:t>0.025929464772427302</a:t>
+                      </a:r>
+                    </a:p>
+                  </a:txBody>
+                  <a:tcPr/>
+                </a:tc>
+                <a:tc>
+                  <a:txBody>
+                    <a:bodyPr/>
+                    <a:lstStyle/>
+                    <a:p>
+                      <a:pPr>
+                        <a:defRPr sz="1000"/>
+                      </a:pPr>
+                      <a:r>
+                        <a:t>0.09080689682278584</a:t>
+                      </a:r>
+                    </a:p>
+                  </a:txBody>
+                  <a:tcPr/>
+                </a:tc>
+                <a:tc>
+                  <a:txBody>
+                    <a:bodyPr/>
+                    <a:lstStyle/>
+                    <a:p>
+                      <a:pPr>
+                        <a:defRPr sz="1000"/>
+                      </a:pPr>
+                      <a:r>
+                        <a:t>0.0336695344484046</a:t>
+                      </a:r>
+                    </a:p>
+                  </a:txBody>
+                  <a:tcPr/>
+                </a:tc>
+                <a:tc>
+                  <a:txBody>
+                    <a:bodyPr/>
+                    <a:lstStyle/>
+                    <a:p>
+                      <a:pPr>
+                        <a:defRPr sz="1000"/>
+                      </a:pPr>
+                      <a:r>
+                        <a:t>11179.470588235294</a:t>
+                      </a:r>
+                    </a:p>
+                  </a:txBody>
+                  <a:tcPr/>
+                </a:tc>
+              </a:tr>
+              <a:tr h="548640">
+                <a:tc>
+                  <a:txBody>
+                    <a:bodyPr/>
+                    <a:lstStyle/>
+                    <a:p>
+                      <a:pPr>
+                        <a:defRPr sz="1000"/>
+                      </a:pPr>
+                      <a:r>
+                        <a:t>United States</a:t>
+                      </a:r>
+                    </a:p>
+                  </a:txBody>
+                  <a:tcPr/>
+                </a:tc>
+                <a:tc>
+                  <a:txBody>
+                    <a:bodyPr/>
+                    <a:lstStyle/>
+                    <a:p>
+                      <a:pPr>
+                        <a:defRPr sz="1000"/>
+                      </a:pPr>
+                      <a:r>
+                        <a:t>0.008485370848193771</a:t>
+                      </a:r>
+                    </a:p>
+                  </a:txBody>
+                  <a:tcPr/>
+                </a:tc>
+                <a:tc>
+                  <a:txBody>
+                    <a:bodyPr/>
+                    <a:lstStyle/>
+                    <a:p>
+                      <a:pPr>
+                        <a:defRPr sz="1000"/>
+                      </a:pPr>
+                      <a:r>
+                        <a:t>0.03323197711785264</a:t>
+                      </a:r>
+                    </a:p>
+                  </a:txBody>
+                  <a:tcPr/>
+                </a:tc>
+                <a:tc>
+                  <a:txBody>
+                    <a:bodyPr/>
+                    <a:lstStyle/>
+                    <a:p>
+                      <a:pPr>
+                        <a:defRPr sz="1000"/>
+                      </a:pPr>
+                      <a:r>
+                        <a:t>0.046601807299749005</a:t>
+                      </a:r>
+                    </a:p>
+                  </a:txBody>
+                  <a:tcPr/>
+                </a:tc>
+                <a:tc>
+                  <a:txBody>
+                    <a:bodyPr/>
+                    <a:lstStyle/>
+                    <a:p>
+                      <a:pPr>
+                        <a:defRPr sz="1000"/>
+                      </a:pPr>
+                      <a:r>
+                        <a:t>0.08643858355385259</a:t>
+                      </a:r>
+                    </a:p>
+                  </a:txBody>
+                  <a:tcPr/>
+                </a:tc>
+                <a:tc>
+                  <a:txBody>
+                    <a:bodyPr/>
+                    <a:lstStyle/>
+                    <a:p>
+                      <a:pPr>
+                        <a:defRPr sz="1000"/>
+                      </a:pPr>
+                      <a:r>
+                        <a:t>0.0459350067675392</a:t>
+                      </a:r>
+                    </a:p>
+                  </a:txBody>
+                  <a:tcPr/>
+                </a:tc>
+                <a:tc>
+                  <a:txBody>
+                    <a:bodyPr/>
+                    <a:lstStyle/>
+                    <a:p>
+                      <a:pPr>
+                        <a:defRPr sz="1000"/>
+                      </a:pPr>
+                      <a:r>
+                        <a:t>7929.823529411765</a:t>
+                      </a:r>
+                    </a:p>
+                  </a:txBody>
+                  <a:tcPr/>
+                </a:tc>
+              </a:tr>
+            </a:tbl>
+          </a:graphicData>
+        </a:graphic>
+      </p:graphicFrame>
+    </p:spTree>
+  </p:cSld>
+  <p:clrMapOvr>
+    <a:masterClrMapping/>
+  </p:clrMapOvr>
+</p:sld>
+</file>
+
+<file path=ppt/slides/slide21.xml><?xml version="1.0" encoding="utf-8"?>
+<p:sld xmlns:a="http://schemas.openxmlformats.org/drawingml/2006/main" xmlns:p="http://schemas.openxmlformats.org/presentationml/2006/main" xmlns:r="http://schemas.openxmlformats.org/officeDocument/2006/relationships">
+  <p:cSld>
+    <p:spTree>
+      <p:nvGrpSpPr>
+        <p:cNvPr id="1" name=""/>
+        <p:cNvGrpSpPr/>
+        <p:nvPr/>
+      </p:nvGrpSpPr>
+      <p:grpSpPr/>
+      <p:sp>
+        <p:nvSpPr>
+          <p:cNvPr id="2" name="Title 1"/>
+          <p:cNvSpPr>
+            <a:spLocks noGrp="1"/>
+          </p:cNvSpPr>
+          <p:nvPr>
+            <p:ph type="title"/>
+          </p:nvPr>
+        </p:nvSpPr>
+        <p:spPr/>
+        <p:txBody>
+          <a:bodyPr/>
+          <a:lstStyle/>
+          <a:p>
+            <a:r>
+              <a:t>Supplementary Table 4: Top origin-destination abroad author-year pairs</a:t>
             </a:r>
           </a:p>
         </p:txBody>
@@ -10152,7 +10526,7 @@
 </p:sld>
 </file>
 
-<file path=ppt/slides/slide21.xml><?xml version="1.0" encoding="utf-8"?>
+<file path=ppt/slides/slide22.xml><?xml version="1.0" encoding="utf-8"?>
 <p:sld xmlns:a="http://schemas.openxmlformats.org/drawingml/2006/main" xmlns:p="http://schemas.openxmlformats.org/presentationml/2006/main" xmlns:r="http://schemas.openxmlformats.org/officeDocument/2006/relationships">
   <p:cSld>
     <p:spTree>
@@ -10178,7 +10552,7 @@
           <a:lstStyle/>
           <a:p>
             <a:r>
-              <a:t>Table 11: Projection accuracy by civilisation, 2017-2023</a:t>
+              <a:t>Supplementary Table 1: Projection accuracy by civilisation, 2017-2023</a:t>
             </a:r>
           </a:p>
         </p:txBody>
@@ -10227,7 +10601,7 @@
         </p:nvGraphicFramePr>
         <p:xfrm>
           <a:off x="457200" y="1097280"/>
-          <a:ext cx="6035040" cy="5486400"/>
+          <a:ext cx="20116800" cy="5486400"/>
         </p:xfrm>
         <a:graphic>
           <a:graphicData uri="http://schemas.openxmlformats.org/drawingml/2006/table">
@@ -10239,6 +10613,13 @@
                 <a:gridCol w="2011680"/>
                 <a:gridCol w="2011680"/>
                 <a:gridCol w="2011680"/>
+                <a:gridCol w="2011680"/>
+                <a:gridCol w="2011680"/>
+                <a:gridCol w="2011680"/>
+                <a:gridCol w="2011680"/>
+                <a:gridCol w="2011680"/>
+                <a:gridCol w="2011680"/>
+                <a:gridCol w="2011680"/>
               </a:tblGrid>
               <a:tr h="548640">
                 <a:tc>
@@ -10277,6 +10658,90 @@
                   </a:txBody>
                   <a:tcPr/>
                 </a:tc>
+                <a:tc>
+                  <a:txBody>
+                    <a:bodyPr/>
+                    <a:lstStyle/>
+                    <a:p>
+                      <a:r>
+                        <a:t>direction_agreement</a:t>
+                      </a:r>
+                    </a:p>
+                  </a:txBody>
+                  <a:tcPr/>
+                </a:tc>
+                <a:tc>
+                  <a:txBody>
+                    <a:bodyPr/>
+                    <a:lstStyle/>
+                    <a:p>
+                      <a:r>
+                        <a:t>threshold_alarm_accuracy</a:t>
+                      </a:r>
+                    </a:p>
+                  </a:txBody>
+                  <a:tcPr/>
+                </a:tc>
+                <a:tc>
+                  <a:txBody>
+                    <a:bodyPr/>
+                    <a:lstStyle/>
+                    <a:p>
+                      <a:r>
+                        <a:t>threshold_alarm_sensitivity</a:t>
+                      </a:r>
+                    </a:p>
+                  </a:txBody>
+                  <a:tcPr/>
+                </a:tc>
+                <a:tc>
+                  <a:txBody>
+                    <a:bodyPr/>
+                    <a:lstStyle/>
+                    <a:p>
+                      <a:r>
+                        <a:t>threshold_alarm_specificity</a:t>
+                      </a:r>
+                    </a:p>
+                  </a:txBody>
+                  <a:tcPr/>
+                </a:tc>
+                <a:tc>
+                  <a:txBody>
+                    <a:bodyPr/>
+                    <a:lstStyle/>
+                    <a:p>
+                      <a:r>
+                        <a:t>threshold_alarm_precision</a:t>
+                      </a:r>
+                    </a:p>
+                  </a:txBody>
+                  <a:tcPr/>
+                </a:tc>
+                <a:tc>
+                  <a:txBody>
+                    <a:bodyPr/>
+                    <a:lstStyle/>
+                    <a:p>
+                      <a:r>
+                        <a:t>threshold_alarms_obs</a:t>
+                      </a:r>
+                    </a:p>
+                  </a:txBody>
+                  <a:tcPr/>
+                </a:tc>
+                <a:tc>
+                  <a:txBody>
+                    <a:bodyPr/>
+                    <a:lstStyle/>
+                    <a:p>
+                      <a:r>
+                        <a:t>threshold_alarms_proj</a:t>
+                      </a:r>
+                    </a:p>
+                  </a:txBody>
+                  <a:tcPr/>
+                </a:tc>
               </a:tr>
               <a:tr h="548640">
                 <a:tc>
@@ -10324,6 +10789,111 @@
                   </a:txBody>
                   <a:tcPr/>
                 </a:tc>
+                <a:tc>
+                  <a:txBody>
+                    <a:bodyPr/>
+                    <a:lstStyle/>
+                    <a:p>
+                      <a:pPr>
+                        <a:defRPr sz="1000"/>
+                      </a:pPr>
+                      <a:r>
+                        <a:t>0.1944444444444444</a:t>
+                      </a:r>
+                    </a:p>
+                  </a:txBody>
+                  <a:tcPr/>
+                </a:tc>
+                <a:tc>
+                  <a:txBody>
+                    <a:bodyPr/>
+                    <a:lstStyle/>
+                    <a:p>
+                      <a:pPr>
+                        <a:defRPr sz="1000"/>
+                      </a:pPr>
+                      <a:r>
+                        <a:t>1.0</a:t>
+                      </a:r>
+                    </a:p>
+                  </a:txBody>
+                  <a:tcPr/>
+                </a:tc>
+                <a:tc>
+                  <a:txBody>
+                    <a:bodyPr/>
+                    <a:lstStyle/>
+                    <a:p>
+                      <a:pPr>
+                        <a:defRPr sz="1000"/>
+                      </a:pPr>
+                      <a:r>
+                        <a:t>nan</a:t>
+                      </a:r>
+                    </a:p>
+                  </a:txBody>
+                  <a:tcPr/>
+                </a:tc>
+                <a:tc>
+                  <a:txBody>
+                    <a:bodyPr/>
+                    <a:lstStyle/>
+                    <a:p>
+                      <a:pPr>
+                        <a:defRPr sz="1000"/>
+                      </a:pPr>
+                      <a:r>
+                        <a:t>1.0</a:t>
+                      </a:r>
+                    </a:p>
+                  </a:txBody>
+                  <a:tcPr/>
+                </a:tc>
+                <a:tc>
+                  <a:txBody>
+                    <a:bodyPr/>
+                    <a:lstStyle/>
+                    <a:p>
+                      <a:pPr>
+                        <a:defRPr sz="1000"/>
+                      </a:pPr>
+                      <a:r>
+                        <a:t>nan</a:t>
+                      </a:r>
+                    </a:p>
+                  </a:txBody>
+                  <a:tcPr/>
+                </a:tc>
+                <a:tc>
+                  <a:txBody>
+                    <a:bodyPr/>
+                    <a:lstStyle/>
+                    <a:p>
+                      <a:pPr>
+                        <a:defRPr sz="1000"/>
+                      </a:pPr>
+                      <a:r>
+                        <a:t>0.0</a:t>
+                      </a:r>
+                    </a:p>
+                  </a:txBody>
+                  <a:tcPr/>
+                </a:tc>
+                <a:tc>
+                  <a:txBody>
+                    <a:bodyPr/>
+                    <a:lstStyle/>
+                    <a:p>
+                      <a:pPr>
+                        <a:defRPr sz="1000"/>
+                      </a:pPr>
+                      <a:r>
+                        <a:t>0.0</a:t>
+                      </a:r>
+                    </a:p>
+                  </a:txBody>
+                  <a:tcPr/>
+                </a:tc>
               </a:tr>
               <a:tr h="548640">
                 <a:tc>
@@ -10371,6 +10941,111 @@
                   </a:txBody>
                   <a:tcPr/>
                 </a:tc>
+                <a:tc>
+                  <a:txBody>
+                    <a:bodyPr/>
+                    <a:lstStyle/>
+                    <a:p>
+                      <a:pPr>
+                        <a:defRPr sz="1000"/>
+                      </a:pPr>
+                      <a:r>
+                        <a:t>0.1944444444444444</a:t>
+                      </a:r>
+                    </a:p>
+                  </a:txBody>
+                  <a:tcPr/>
+                </a:tc>
+                <a:tc>
+                  <a:txBody>
+                    <a:bodyPr/>
+                    <a:lstStyle/>
+                    <a:p>
+                      <a:pPr>
+                        <a:defRPr sz="1000"/>
+                      </a:pPr>
+                      <a:r>
+                        <a:t>1.0</a:t>
+                      </a:r>
+                    </a:p>
+                  </a:txBody>
+                  <a:tcPr/>
+                </a:tc>
+                <a:tc>
+                  <a:txBody>
+                    <a:bodyPr/>
+                    <a:lstStyle/>
+                    <a:p>
+                      <a:pPr>
+                        <a:defRPr sz="1000"/>
+                      </a:pPr>
+                      <a:r>
+                        <a:t>nan</a:t>
+                      </a:r>
+                    </a:p>
+                  </a:txBody>
+                  <a:tcPr/>
+                </a:tc>
+                <a:tc>
+                  <a:txBody>
+                    <a:bodyPr/>
+                    <a:lstStyle/>
+                    <a:p>
+                      <a:pPr>
+                        <a:defRPr sz="1000"/>
+                      </a:pPr>
+                      <a:r>
+                        <a:t>1.0</a:t>
+                      </a:r>
+                    </a:p>
+                  </a:txBody>
+                  <a:tcPr/>
+                </a:tc>
+                <a:tc>
+                  <a:txBody>
+                    <a:bodyPr/>
+                    <a:lstStyle/>
+                    <a:p>
+                      <a:pPr>
+                        <a:defRPr sz="1000"/>
+                      </a:pPr>
+                      <a:r>
+                        <a:t>nan</a:t>
+                      </a:r>
+                    </a:p>
+                  </a:txBody>
+                  <a:tcPr/>
+                </a:tc>
+                <a:tc>
+                  <a:txBody>
+                    <a:bodyPr/>
+                    <a:lstStyle/>
+                    <a:p>
+                      <a:pPr>
+                        <a:defRPr sz="1000"/>
+                      </a:pPr>
+                      <a:r>
+                        <a:t>0.0</a:t>
+                      </a:r>
+                    </a:p>
+                  </a:txBody>
+                  <a:tcPr/>
+                </a:tc>
+                <a:tc>
+                  <a:txBody>
+                    <a:bodyPr/>
+                    <a:lstStyle/>
+                    <a:p>
+                      <a:pPr>
+                        <a:defRPr sz="1000"/>
+                      </a:pPr>
+                      <a:r>
+                        <a:t>0.0</a:t>
+                      </a:r>
+                    </a:p>
+                  </a:txBody>
+                  <a:tcPr/>
+                </a:tc>
               </a:tr>
               <a:tr h="548640">
                 <a:tc>
@@ -10418,6 +11093,111 @@
                   </a:txBody>
                   <a:tcPr/>
                 </a:tc>
+                <a:tc>
+                  <a:txBody>
+                    <a:bodyPr/>
+                    <a:lstStyle/>
+                    <a:p>
+                      <a:pPr>
+                        <a:defRPr sz="1000"/>
+                      </a:pPr>
+                      <a:r>
+                        <a:t>0.1666666666666666</a:t>
+                      </a:r>
+                    </a:p>
+                  </a:txBody>
+                  <a:tcPr/>
+                </a:tc>
+                <a:tc>
+                  <a:txBody>
+                    <a:bodyPr/>
+                    <a:lstStyle/>
+                    <a:p>
+                      <a:pPr>
+                        <a:defRPr sz="1000"/>
+                      </a:pPr>
+                      <a:r>
+                        <a:t>1.0</a:t>
+                      </a:r>
+                    </a:p>
+                  </a:txBody>
+                  <a:tcPr/>
+                </a:tc>
+                <a:tc>
+                  <a:txBody>
+                    <a:bodyPr/>
+                    <a:lstStyle/>
+                    <a:p>
+                      <a:pPr>
+                        <a:defRPr sz="1000"/>
+                      </a:pPr>
+                      <a:r>
+                        <a:t>nan</a:t>
+                      </a:r>
+                    </a:p>
+                  </a:txBody>
+                  <a:tcPr/>
+                </a:tc>
+                <a:tc>
+                  <a:txBody>
+                    <a:bodyPr/>
+                    <a:lstStyle/>
+                    <a:p>
+                      <a:pPr>
+                        <a:defRPr sz="1000"/>
+                      </a:pPr>
+                      <a:r>
+                        <a:t>1.0</a:t>
+                      </a:r>
+                    </a:p>
+                  </a:txBody>
+                  <a:tcPr/>
+                </a:tc>
+                <a:tc>
+                  <a:txBody>
+                    <a:bodyPr/>
+                    <a:lstStyle/>
+                    <a:p>
+                      <a:pPr>
+                        <a:defRPr sz="1000"/>
+                      </a:pPr>
+                      <a:r>
+                        <a:t>nan</a:t>
+                      </a:r>
+                    </a:p>
+                  </a:txBody>
+                  <a:tcPr/>
+                </a:tc>
+                <a:tc>
+                  <a:txBody>
+                    <a:bodyPr/>
+                    <a:lstStyle/>
+                    <a:p>
+                      <a:pPr>
+                        <a:defRPr sz="1000"/>
+                      </a:pPr>
+                      <a:r>
+                        <a:t>0.0</a:t>
+                      </a:r>
+                    </a:p>
+                  </a:txBody>
+                  <a:tcPr/>
+                </a:tc>
+                <a:tc>
+                  <a:txBody>
+                    <a:bodyPr/>
+                    <a:lstStyle/>
+                    <a:p>
+                      <a:pPr>
+                        <a:defRPr sz="1000"/>
+                      </a:pPr>
+                      <a:r>
+                        <a:t>0.0</a:t>
+                      </a:r>
+                    </a:p>
+                  </a:txBody>
+                  <a:tcPr/>
+                </a:tc>
               </a:tr>
               <a:tr h="548640">
                 <a:tc>
@@ -10465,6 +11245,111 @@
                   </a:txBody>
                   <a:tcPr/>
                 </a:tc>
+                <a:tc>
+                  <a:txBody>
+                    <a:bodyPr/>
+                    <a:lstStyle/>
+                    <a:p>
+                      <a:pPr>
+                        <a:defRPr sz="1000"/>
+                      </a:pPr>
+                      <a:r>
+                        <a:t>0.2222222222222222</a:t>
+                      </a:r>
+                    </a:p>
+                  </a:txBody>
+                  <a:tcPr/>
+                </a:tc>
+                <a:tc>
+                  <a:txBody>
+                    <a:bodyPr/>
+                    <a:lstStyle/>
+                    <a:p>
+                      <a:pPr>
+                        <a:defRPr sz="1000"/>
+                      </a:pPr>
+                      <a:r>
+                        <a:t>1.0</a:t>
+                      </a:r>
+                    </a:p>
+                  </a:txBody>
+                  <a:tcPr/>
+                </a:tc>
+                <a:tc>
+                  <a:txBody>
+                    <a:bodyPr/>
+                    <a:lstStyle/>
+                    <a:p>
+                      <a:pPr>
+                        <a:defRPr sz="1000"/>
+                      </a:pPr>
+                      <a:r>
+                        <a:t>nan</a:t>
+                      </a:r>
+                    </a:p>
+                  </a:txBody>
+                  <a:tcPr/>
+                </a:tc>
+                <a:tc>
+                  <a:txBody>
+                    <a:bodyPr/>
+                    <a:lstStyle/>
+                    <a:p>
+                      <a:pPr>
+                        <a:defRPr sz="1000"/>
+                      </a:pPr>
+                      <a:r>
+                        <a:t>1.0</a:t>
+                      </a:r>
+                    </a:p>
+                  </a:txBody>
+                  <a:tcPr/>
+                </a:tc>
+                <a:tc>
+                  <a:txBody>
+                    <a:bodyPr/>
+                    <a:lstStyle/>
+                    <a:p>
+                      <a:pPr>
+                        <a:defRPr sz="1000"/>
+                      </a:pPr>
+                      <a:r>
+                        <a:t>nan</a:t>
+                      </a:r>
+                    </a:p>
+                  </a:txBody>
+                  <a:tcPr/>
+                </a:tc>
+                <a:tc>
+                  <a:txBody>
+                    <a:bodyPr/>
+                    <a:lstStyle/>
+                    <a:p>
+                      <a:pPr>
+                        <a:defRPr sz="1000"/>
+                      </a:pPr>
+                      <a:r>
+                        <a:t>0.0</a:t>
+                      </a:r>
+                    </a:p>
+                  </a:txBody>
+                  <a:tcPr/>
+                </a:tc>
+                <a:tc>
+                  <a:txBody>
+                    <a:bodyPr/>
+                    <a:lstStyle/>
+                    <a:p>
+                      <a:pPr>
+                        <a:defRPr sz="1000"/>
+                      </a:pPr>
+                      <a:r>
+                        <a:t>0.0</a:t>
+                      </a:r>
+                    </a:p>
+                  </a:txBody>
+                  <a:tcPr/>
+                </a:tc>
               </a:tr>
               <a:tr h="548640">
                 <a:tc>
@@ -10512,6 +11397,111 @@
                   </a:txBody>
                   <a:tcPr/>
                 </a:tc>
+                <a:tc>
+                  <a:txBody>
+                    <a:bodyPr/>
+                    <a:lstStyle/>
+                    <a:p>
+                      <a:pPr>
+                        <a:defRPr sz="1000"/>
+                      </a:pPr>
+                      <a:r>
+                        <a:t>0.2777777777777778</a:t>
+                      </a:r>
+                    </a:p>
+                  </a:txBody>
+                  <a:tcPr/>
+                </a:tc>
+                <a:tc>
+                  <a:txBody>
+                    <a:bodyPr/>
+                    <a:lstStyle/>
+                    <a:p>
+                      <a:pPr>
+                        <a:defRPr sz="1000"/>
+                      </a:pPr>
+                      <a:r>
+                        <a:t>1.0</a:t>
+                      </a:r>
+                    </a:p>
+                  </a:txBody>
+                  <a:tcPr/>
+                </a:tc>
+                <a:tc>
+                  <a:txBody>
+                    <a:bodyPr/>
+                    <a:lstStyle/>
+                    <a:p>
+                      <a:pPr>
+                        <a:defRPr sz="1000"/>
+                      </a:pPr>
+                      <a:r>
+                        <a:t>nan</a:t>
+                      </a:r>
+                    </a:p>
+                  </a:txBody>
+                  <a:tcPr/>
+                </a:tc>
+                <a:tc>
+                  <a:txBody>
+                    <a:bodyPr/>
+                    <a:lstStyle/>
+                    <a:p>
+                      <a:pPr>
+                        <a:defRPr sz="1000"/>
+                      </a:pPr>
+                      <a:r>
+                        <a:t>1.0</a:t>
+                      </a:r>
+                    </a:p>
+                  </a:txBody>
+                  <a:tcPr/>
+                </a:tc>
+                <a:tc>
+                  <a:txBody>
+                    <a:bodyPr/>
+                    <a:lstStyle/>
+                    <a:p>
+                      <a:pPr>
+                        <a:defRPr sz="1000"/>
+                      </a:pPr>
+                      <a:r>
+                        <a:t>nan</a:t>
+                      </a:r>
+                    </a:p>
+                  </a:txBody>
+                  <a:tcPr/>
+                </a:tc>
+                <a:tc>
+                  <a:txBody>
+                    <a:bodyPr/>
+                    <a:lstStyle/>
+                    <a:p>
+                      <a:pPr>
+                        <a:defRPr sz="1000"/>
+                      </a:pPr>
+                      <a:r>
+                        <a:t>0.0</a:t>
+                      </a:r>
+                    </a:p>
+                  </a:txBody>
+                  <a:tcPr/>
+                </a:tc>
+                <a:tc>
+                  <a:txBody>
+                    <a:bodyPr/>
+                    <a:lstStyle/>
+                    <a:p>
+                      <a:pPr>
+                        <a:defRPr sz="1000"/>
+                      </a:pPr>
+                      <a:r>
+                        <a:t>0.0</a:t>
+                      </a:r>
+                    </a:p>
+                  </a:txBody>
+                  <a:tcPr/>
+                </a:tc>
               </a:tr>
               <a:tr h="548640">
                 <a:tc>
@@ -10559,6 +11549,111 @@
                   </a:txBody>
                   <a:tcPr/>
                 </a:tc>
+                <a:tc>
+                  <a:txBody>
+                    <a:bodyPr/>
+                    <a:lstStyle/>
+                    <a:p>
+                      <a:pPr>
+                        <a:defRPr sz="1000"/>
+                      </a:pPr>
+                      <a:r>
+                        <a:t>0.1666666666666666</a:t>
+                      </a:r>
+                    </a:p>
+                  </a:txBody>
+                  <a:tcPr/>
+                </a:tc>
+                <a:tc>
+                  <a:txBody>
+                    <a:bodyPr/>
+                    <a:lstStyle/>
+                    <a:p>
+                      <a:pPr>
+                        <a:defRPr sz="1000"/>
+                      </a:pPr>
+                      <a:r>
+                        <a:t>1.0</a:t>
+                      </a:r>
+                    </a:p>
+                  </a:txBody>
+                  <a:tcPr/>
+                </a:tc>
+                <a:tc>
+                  <a:txBody>
+                    <a:bodyPr/>
+                    <a:lstStyle/>
+                    <a:p>
+                      <a:pPr>
+                        <a:defRPr sz="1000"/>
+                      </a:pPr>
+                      <a:r>
+                        <a:t>nan</a:t>
+                      </a:r>
+                    </a:p>
+                  </a:txBody>
+                  <a:tcPr/>
+                </a:tc>
+                <a:tc>
+                  <a:txBody>
+                    <a:bodyPr/>
+                    <a:lstStyle/>
+                    <a:p>
+                      <a:pPr>
+                        <a:defRPr sz="1000"/>
+                      </a:pPr>
+                      <a:r>
+                        <a:t>1.0</a:t>
+                      </a:r>
+                    </a:p>
+                  </a:txBody>
+                  <a:tcPr/>
+                </a:tc>
+                <a:tc>
+                  <a:txBody>
+                    <a:bodyPr/>
+                    <a:lstStyle/>
+                    <a:p>
+                      <a:pPr>
+                        <a:defRPr sz="1000"/>
+                      </a:pPr>
+                      <a:r>
+                        <a:t>nan</a:t>
+                      </a:r>
+                    </a:p>
+                  </a:txBody>
+                  <a:tcPr/>
+                </a:tc>
+                <a:tc>
+                  <a:txBody>
+                    <a:bodyPr/>
+                    <a:lstStyle/>
+                    <a:p>
+                      <a:pPr>
+                        <a:defRPr sz="1000"/>
+                      </a:pPr>
+                      <a:r>
+                        <a:t>0.0</a:t>
+                      </a:r>
+                    </a:p>
+                  </a:txBody>
+                  <a:tcPr/>
+                </a:tc>
+                <a:tc>
+                  <a:txBody>
+                    <a:bodyPr/>
+                    <a:lstStyle/>
+                    <a:p>
+                      <a:pPr>
+                        <a:defRPr sz="1000"/>
+                      </a:pPr>
+                      <a:r>
+                        <a:t>0.0</a:t>
+                      </a:r>
+                    </a:p>
+                  </a:txBody>
+                  <a:tcPr/>
+                </a:tc>
               </a:tr>
               <a:tr h="548640">
                 <a:tc>
@@ -10606,6 +11701,111 @@
                   </a:txBody>
                   <a:tcPr/>
                 </a:tc>
+                <a:tc>
+                  <a:txBody>
+                    <a:bodyPr/>
+                    <a:lstStyle/>
+                    <a:p>
+                      <a:pPr>
+                        <a:defRPr sz="1000"/>
+                      </a:pPr>
+                      <a:r>
+                        <a:t>0.25</a:t>
+                      </a:r>
+                    </a:p>
+                  </a:txBody>
+                  <a:tcPr/>
+                </a:tc>
+                <a:tc>
+                  <a:txBody>
+                    <a:bodyPr/>
+                    <a:lstStyle/>
+                    <a:p>
+                      <a:pPr>
+                        <a:defRPr sz="1000"/>
+                      </a:pPr>
+                      <a:r>
+                        <a:t>0.2857142857142857</a:t>
+                      </a:r>
+                    </a:p>
+                  </a:txBody>
+                  <a:tcPr/>
+                </a:tc>
+                <a:tc>
+                  <a:txBody>
+                    <a:bodyPr/>
+                    <a:lstStyle/>
+                    <a:p>
+                      <a:pPr>
+                        <a:defRPr sz="1000"/>
+                      </a:pPr>
+                      <a:r>
+                        <a:t>0.0</a:t>
+                      </a:r>
+                    </a:p>
+                  </a:txBody>
+                  <a:tcPr/>
+                </a:tc>
+                <a:tc>
+                  <a:txBody>
+                    <a:bodyPr/>
+                    <a:lstStyle/>
+                    <a:p>
+                      <a:pPr>
+                        <a:defRPr sz="1000"/>
+                      </a:pPr>
+                      <a:r>
+                        <a:t>1.0</a:t>
+                      </a:r>
+                    </a:p>
+                  </a:txBody>
+                  <a:tcPr/>
+                </a:tc>
+                <a:tc>
+                  <a:txBody>
+                    <a:bodyPr/>
+                    <a:lstStyle/>
+                    <a:p>
+                      <a:pPr>
+                        <a:defRPr sz="1000"/>
+                      </a:pPr>
+                      <a:r>
+                        <a:t>nan</a:t>
+                      </a:r>
+                    </a:p>
+                  </a:txBody>
+                  <a:tcPr/>
+                </a:tc>
+                <a:tc>
+                  <a:txBody>
+                    <a:bodyPr/>
+                    <a:lstStyle/>
+                    <a:p>
+                      <a:pPr>
+                        <a:defRPr sz="1000"/>
+                      </a:pPr>
+                      <a:r>
+                        <a:t>5.0</a:t>
+                      </a:r>
+                    </a:p>
+                  </a:txBody>
+                  <a:tcPr/>
+                </a:tc>
+                <a:tc>
+                  <a:txBody>
+                    <a:bodyPr/>
+                    <a:lstStyle/>
+                    <a:p>
+                      <a:pPr>
+                        <a:defRPr sz="1000"/>
+                      </a:pPr>
+                      <a:r>
+                        <a:t>0.0</a:t>
+                      </a:r>
+                    </a:p>
+                  </a:txBody>
+                  <a:tcPr/>
+                </a:tc>
               </a:tr>
               <a:tr h="548640">
                 <a:tc>
@@ -10653,6 +11853,111 @@
                   </a:txBody>
                   <a:tcPr/>
                 </a:tc>
+                <a:tc>
+                  <a:txBody>
+                    <a:bodyPr/>
+                    <a:lstStyle/>
+                    <a:p>
+                      <a:pPr>
+                        <a:defRPr sz="1000"/>
+                      </a:pPr>
+                      <a:r>
+                        <a:t>0.2222222222222222</a:t>
+                      </a:r>
+                    </a:p>
+                  </a:txBody>
+                  <a:tcPr/>
+                </a:tc>
+                <a:tc>
+                  <a:txBody>
+                    <a:bodyPr/>
+                    <a:lstStyle/>
+                    <a:p>
+                      <a:pPr>
+                        <a:defRPr sz="1000"/>
+                      </a:pPr>
+                      <a:r>
+                        <a:t>1.0</a:t>
+                      </a:r>
+                    </a:p>
+                  </a:txBody>
+                  <a:tcPr/>
+                </a:tc>
+                <a:tc>
+                  <a:txBody>
+                    <a:bodyPr/>
+                    <a:lstStyle/>
+                    <a:p>
+                      <a:pPr>
+                        <a:defRPr sz="1000"/>
+                      </a:pPr>
+                      <a:r>
+                        <a:t>nan</a:t>
+                      </a:r>
+                    </a:p>
+                  </a:txBody>
+                  <a:tcPr/>
+                </a:tc>
+                <a:tc>
+                  <a:txBody>
+                    <a:bodyPr/>
+                    <a:lstStyle/>
+                    <a:p>
+                      <a:pPr>
+                        <a:defRPr sz="1000"/>
+                      </a:pPr>
+                      <a:r>
+                        <a:t>1.0</a:t>
+                      </a:r>
+                    </a:p>
+                  </a:txBody>
+                  <a:tcPr/>
+                </a:tc>
+                <a:tc>
+                  <a:txBody>
+                    <a:bodyPr/>
+                    <a:lstStyle/>
+                    <a:p>
+                      <a:pPr>
+                        <a:defRPr sz="1000"/>
+                      </a:pPr>
+                      <a:r>
+                        <a:t>nan</a:t>
+                      </a:r>
+                    </a:p>
+                  </a:txBody>
+                  <a:tcPr/>
+                </a:tc>
+                <a:tc>
+                  <a:txBody>
+                    <a:bodyPr/>
+                    <a:lstStyle/>
+                    <a:p>
+                      <a:pPr>
+                        <a:defRPr sz="1000"/>
+                      </a:pPr>
+                      <a:r>
+                        <a:t>0.0</a:t>
+                      </a:r>
+                    </a:p>
+                  </a:txBody>
+                  <a:tcPr/>
+                </a:tc>
+                <a:tc>
+                  <a:txBody>
+                    <a:bodyPr/>
+                    <a:lstStyle/>
+                    <a:p>
+                      <a:pPr>
+                        <a:defRPr sz="1000"/>
+                      </a:pPr>
+                      <a:r>
+                        <a:t>0.0</a:t>
+                      </a:r>
+                    </a:p>
+                  </a:txBody>
+                  <a:tcPr/>
+                </a:tc>
               </a:tr>
               <a:tr h="548640">
                 <a:tc>
@@ -10695,6 +12000,111 @@
                       </a:pPr>
                       <a:r>
                         <a:t>77.4%</a:t>
+                      </a:r>
+                    </a:p>
+                  </a:txBody>
+                  <a:tcPr/>
+                </a:tc>
+                <a:tc>
+                  <a:txBody>
+                    <a:bodyPr/>
+                    <a:lstStyle/>
+                    <a:p>
+                      <a:pPr>
+                        <a:defRPr sz="1000"/>
+                      </a:pPr>
+                      <a:r>
+                        <a:t>0.25</a:t>
+                      </a:r>
+                    </a:p>
+                  </a:txBody>
+                  <a:tcPr/>
+                </a:tc>
+                <a:tc>
+                  <a:txBody>
+                    <a:bodyPr/>
+                    <a:lstStyle/>
+                    <a:p>
+                      <a:pPr>
+                        <a:defRPr sz="1000"/>
+                      </a:pPr>
+                      <a:r>
+                        <a:t>1.0</a:t>
+                      </a:r>
+                    </a:p>
+                  </a:txBody>
+                  <a:tcPr/>
+                </a:tc>
+                <a:tc>
+                  <a:txBody>
+                    <a:bodyPr/>
+                    <a:lstStyle/>
+                    <a:p>
+                      <a:pPr>
+                        <a:defRPr sz="1000"/>
+                      </a:pPr>
+                      <a:r>
+                        <a:t>nan</a:t>
+                      </a:r>
+                    </a:p>
+                  </a:txBody>
+                  <a:tcPr/>
+                </a:tc>
+                <a:tc>
+                  <a:txBody>
+                    <a:bodyPr/>
+                    <a:lstStyle/>
+                    <a:p>
+                      <a:pPr>
+                        <a:defRPr sz="1000"/>
+                      </a:pPr>
+                      <a:r>
+                        <a:t>1.0</a:t>
+                      </a:r>
+                    </a:p>
+                  </a:txBody>
+                  <a:tcPr/>
+                </a:tc>
+                <a:tc>
+                  <a:txBody>
+                    <a:bodyPr/>
+                    <a:lstStyle/>
+                    <a:p>
+                      <a:pPr>
+                        <a:defRPr sz="1000"/>
+                      </a:pPr>
+                      <a:r>
+                        <a:t>nan</a:t>
+                      </a:r>
+                    </a:p>
+                  </a:txBody>
+                  <a:tcPr/>
+                </a:tc>
+                <a:tc>
+                  <a:txBody>
+                    <a:bodyPr/>
+                    <a:lstStyle/>
+                    <a:p>
+                      <a:pPr>
+                        <a:defRPr sz="1000"/>
+                      </a:pPr>
+                      <a:r>
+                        <a:t>0.0</a:t>
+                      </a:r>
+                    </a:p>
+                  </a:txBody>
+                  <a:tcPr/>
+                </a:tc>
+                <a:tc>
+                  <a:txBody>
+                    <a:bodyPr/>
+                    <a:lstStyle/>
+                    <a:p>
+                      <a:pPr>
+                        <a:defRPr sz="1000"/>
+                      </a:pPr>
+                      <a:r>
+                        <a:t>0.0</a:t>
                       </a:r>
                     </a:p>
                   </a:txBody>
@@ -10713,7 +12123,7 @@
 </p:sld>
 </file>
 
-<file path=ppt/slides/slide22.xml><?xml version="1.0" encoding="utf-8"?>
+<file path=ppt/slides/slide23.xml><?xml version="1.0" encoding="utf-8"?>
 <p:sld xmlns:a="http://schemas.openxmlformats.org/drawingml/2006/main" xmlns:p="http://schemas.openxmlformats.org/presentationml/2006/main" xmlns:r="http://schemas.openxmlformats.org/officeDocument/2006/relationships">
   <p:cSld>
     <p:spTree>
@@ -10739,7 +12149,7 @@
           <a:lstStyle/>
           <a:p>
             <a:r>
-              <a:t>Table 12: Projection accuracy by compartment, 2017-2023</a:t>
+              <a:t>Supplementary Table 2: Projection accuracy by compartment, 2017-2023</a:t>
             </a:r>
           </a:p>
         </p:txBody>
@@ -10788,7 +12198,7 @@
         </p:nvGraphicFramePr>
         <p:xfrm>
           <a:off x="457200" y="1097280"/>
-          <a:ext cx="6035040" cy="3840480"/>
+          <a:ext cx="8046720" cy="3840480"/>
         </p:xfrm>
         <a:graphic>
           <a:graphicData uri="http://schemas.openxmlformats.org/drawingml/2006/table">
@@ -10800,6 +12210,7 @@
                 <a:gridCol w="2011680"/>
                 <a:gridCol w="2011680"/>
                 <a:gridCol w="2011680"/>
+                <a:gridCol w="2011680"/>
               </a:tblGrid>
               <a:tr h="548640">
                 <a:tc>
@@ -10838,6 +12249,18 @@
                   </a:txBody>
                   <a:tcPr/>
                 </a:tc>
+                <a:tc>
+                  <a:txBody>
+                    <a:bodyPr/>
+                    <a:lstStyle/>
+                    <a:p>
+                      <a:r>
+                        <a:t>direction_agreement</a:t>
+                      </a:r>
+                    </a:p>
+                  </a:txBody>
+                  <a:tcPr/>
+                </a:tc>
               </a:tr>
               <a:tr h="548640">
                 <a:tc>
@@ -10885,6 +12308,21 @@
                   </a:txBody>
                   <a:tcPr/>
                 </a:tc>
+                <a:tc>
+                  <a:txBody>
+                    <a:bodyPr/>
+                    <a:lstStyle/>
+                    <a:p>
+                      <a:pPr>
+                        <a:defRPr sz="1000"/>
+                      </a:pPr>
+                      <a:r>
+                        <a:t>0.0925925925925925</a:t>
+                      </a:r>
+                    </a:p>
+                  </a:txBody>
+                  <a:tcPr/>
+                </a:tc>
               </a:tr>
               <a:tr h="548640">
                 <a:tc>
@@ -10932,6 +12370,21 @@
                   </a:txBody>
                   <a:tcPr/>
                 </a:tc>
+                <a:tc>
+                  <a:txBody>
+                    <a:bodyPr/>
+                    <a:lstStyle/>
+                    <a:p>
+                      <a:pPr>
+                        <a:defRPr sz="1000"/>
+                      </a:pPr>
+                      <a:r>
+                        <a:t>0.0185185185185185</a:t>
+                      </a:r>
+                    </a:p>
+                  </a:txBody>
+                  <a:tcPr/>
+                </a:tc>
               </a:tr>
               <a:tr h="548640">
                 <a:tc>
@@ -10979,6 +12432,21 @@
                   </a:txBody>
                   <a:tcPr/>
                 </a:tc>
+                <a:tc>
+                  <a:txBody>
+                    <a:bodyPr/>
+                    <a:lstStyle/>
+                    <a:p>
+                      <a:pPr>
+                        <a:defRPr sz="1000"/>
+                      </a:pPr>
+                      <a:r>
+                        <a:t>0.3888888888888889</a:t>
+                      </a:r>
+                    </a:p>
+                  </a:txBody>
+                  <a:tcPr/>
+                </a:tc>
               </a:tr>
               <a:tr h="548640">
                 <a:tc>
@@ -11026,6 +12494,21 @@
                   </a:txBody>
                   <a:tcPr/>
                 </a:tc>
+                <a:tc>
+                  <a:txBody>
+                    <a:bodyPr/>
+                    <a:lstStyle/>
+                    <a:p>
+                      <a:pPr>
+                        <a:defRPr sz="1000"/>
+                      </a:pPr>
+                      <a:r>
+                        <a:t>0.0925925925925925</a:t>
+                      </a:r>
+                    </a:p>
+                  </a:txBody>
+                  <a:tcPr/>
+                </a:tc>
               </a:tr>
               <a:tr h="548640">
                 <a:tc>
@@ -11073,6 +12556,21 @@
                   </a:txBody>
                   <a:tcPr/>
                 </a:tc>
+                <a:tc>
+                  <a:txBody>
+                    <a:bodyPr/>
+                    <a:lstStyle/>
+                    <a:p>
+                      <a:pPr>
+                        <a:defRPr sz="1000"/>
+                      </a:pPr>
+                      <a:r>
+                        <a:t>0.2592592592592592</a:t>
+                      </a:r>
+                    </a:p>
+                  </a:txBody>
+                  <a:tcPr/>
+                </a:tc>
               </a:tr>
               <a:tr h="548640">
                 <a:tc>
@@ -11115,6 +12613,21 @@
                       </a:pPr>
                       <a:r>
                         <a:t>38.0%</a:t>
+                      </a:r>
+                    </a:p>
+                  </a:txBody>
+                  <a:tcPr/>
+                </a:tc>
+                <a:tc>
+                  <a:txBody>
+                    <a:bodyPr/>
+                    <a:lstStyle/>
+                    <a:p>
+                      <a:pPr>
+                        <a:defRPr sz="1000"/>
+                      </a:pPr>
+                      <a:r>
+                        <a:t>0.4444444444444444</a:t>
                       </a:r>
                     </a:p>
                   </a:txBody>

</xml_diff>

<commit_message>
Unify Laplace smoothing to pseudocount 1 per outcome; align Data Availability text with public repo
Co-Authored-By: Tatsuki Onishi <bougtoir@gmail.com>
</commit_message>
<xml_diff>
--- a/researcher_mobility_ode/docs/manuscript_full_article_figures.pptx
+++ b/researcher_mobility_ode/docs/manuscript_full_article_figures.pptx
@@ -8968,52 +8968,52 @@
                         <a:defRPr sz="1000"/>
                       </a:pPr>
                       <a:r>
-                        <a:t>0.01153982905868697</a:t>
-                      </a:r>
-                    </a:p>
-                  </a:txBody>
-                  <a:tcPr/>
-                </a:tc>
-                <a:tc>
-                  <a:txBody>
-                    <a:bodyPr/>
-                    <a:lstStyle/>
-                    <a:p>
-                      <a:pPr>
-                        <a:defRPr sz="1000"/>
-                      </a:pPr>
-                      <a:r>
-                        <a:t>0.03392610062985291</a:t>
-                      </a:r>
-                    </a:p>
-                  </a:txBody>
-                  <a:tcPr/>
-                </a:tc>
-                <a:tc>
-                  <a:txBody>
-                    <a:bodyPr/>
-                    <a:lstStyle/>
-                    <a:p>
-                      <a:pPr>
-                        <a:defRPr sz="1000"/>
-                      </a:pPr>
-                      <a:r>
-                        <a:t>0.046100674305792344</a:t>
-                      </a:r>
-                    </a:p>
-                  </a:txBody>
-                  <a:tcPr/>
-                </a:tc>
-                <a:tc>
-                  <a:txBody>
-                    <a:bodyPr/>
-                    <a:lstStyle/>
-                    <a:p>
-                      <a:pPr>
-                        <a:defRPr sz="1000"/>
-                      </a:pPr>
-                      <a:r>
-                        <a:t>0.08726928947875359</a:t>
+                        <a:t>0.011625124450015864</a:t>
+                      </a:r>
+                    </a:p>
+                  </a:txBody>
+                  <a:tcPr/>
+                </a:tc>
+                <a:tc>
+                  <a:txBody>
+                    <a:bodyPr/>
+                    <a:lstStyle/>
+                    <a:p>
+                      <a:pPr>
+                        <a:defRPr sz="1000"/>
+                      </a:pPr>
+                      <a:r>
+                        <a:t>0.03411253799743315</a:t>
+                      </a:r>
+                    </a:p>
+                  </a:txBody>
+                  <a:tcPr/>
+                </a:tc>
+                <a:tc>
+                  <a:txBody>
+                    <a:bodyPr/>
+                    <a:lstStyle/>
+                    <a:p>
+                      <a:pPr>
+                        <a:defRPr sz="1000"/>
+                      </a:pPr>
+                      <a:r>
+                        <a:t>0.04616211641533843</a:t>
+                      </a:r>
+                    </a:p>
+                  </a:txBody>
+                  <a:tcPr/>
+                </a:tc>
+                <a:tc>
+                  <a:txBody>
+                    <a:bodyPr/>
+                    <a:lstStyle/>
+                    <a:p>
+                      <a:pPr>
+                        <a:defRPr sz="1000"/>
+                      </a:pPr>
+                      <a:r>
+                        <a:t>0.0873092000485382</a:t>
                       </a:r>
                     </a:p>
                   </a:txBody>
@@ -9075,52 +9075,52 @@
                         <a:defRPr sz="1000"/>
                       </a:pPr>
                       <a:r>
-                        <a:t>0.006729238959531435</a:t>
-                      </a:r>
-                    </a:p>
-                  </a:txBody>
-                  <a:tcPr/>
-                </a:tc>
-                <a:tc>
-                  <a:txBody>
-                    <a:bodyPr/>
-                    <a:lstStyle/>
-                    <a:p>
-                      <a:pPr>
-                        <a:defRPr sz="1000"/>
-                      </a:pPr>
-                      <a:r>
-                        <a:t>0.035675615265306694</a:t>
-                      </a:r>
-                    </a:p>
-                  </a:txBody>
-                  <a:tcPr/>
-                </a:tc>
-                <a:tc>
-                  <a:txBody>
-                    <a:bodyPr/>
-                    <a:lstStyle/>
-                    <a:p>
-                      <a:pPr>
-                        <a:defRPr sz="1000"/>
-                      </a:pPr>
-                      <a:r>
-                        <a:t>0.05092163895711743</a:t>
-                      </a:r>
-                    </a:p>
-                  </a:txBody>
-                  <a:tcPr/>
-                </a:tc>
-                <a:tc>
-                  <a:txBody>
-                    <a:bodyPr/>
-                    <a:lstStyle/>
-                    <a:p>
-                      <a:pPr>
-                        <a:defRPr sz="1000"/>
-                      </a:pPr>
-                      <a:r>
-                        <a:t>0.09421365429270316</a:t>
+                        <a:t>0.006761991119387412</a:t>
+                      </a:r>
+                    </a:p>
+                  </a:txBody>
+                  <a:tcPr/>
+                </a:tc>
+                <a:tc>
+                  <a:txBody>
+                    <a:bodyPr/>
+                    <a:lstStyle/>
+                    <a:p>
+                      <a:pPr>
+                        <a:defRPr sz="1000"/>
+                      </a:pPr>
+                      <a:r>
+                        <a:t>0.035799512585035644</a:t>
+                      </a:r>
+                    </a:p>
+                  </a:txBody>
+                  <a:tcPr/>
+                </a:tc>
+                <a:tc>
+                  <a:txBody>
+                    <a:bodyPr/>
+                    <a:lstStyle/>
+                    <a:p>
+                      <a:pPr>
+                        <a:defRPr sz="1000"/>
+                      </a:pPr>
+                      <a:r>
+                        <a:t>0.05094340242156166</a:t>
+                      </a:r>
+                    </a:p>
+                  </a:txBody>
+                  <a:tcPr/>
+                </a:tc>
+                <a:tc>
+                  <a:txBody>
+                    <a:bodyPr/>
+                    <a:lstStyle/>
+                    <a:p>
+                      <a:pPr>
+                        <a:defRPr sz="1000"/>
+                      </a:pPr>
+                      <a:r>
+                        <a:t>0.09422625853124332</a:t>
                       </a:r>
                     </a:p>
                   </a:txBody>
@@ -9182,52 +9182,52 @@
                         <a:defRPr sz="1000"/>
                       </a:pPr>
                       <a:r>
-                        <a:t>0.008226712242474519</a:t>
-                      </a:r>
-                    </a:p>
-                  </a:txBody>
-                  <a:tcPr/>
-                </a:tc>
-                <a:tc>
-                  <a:txBody>
-                    <a:bodyPr/>
-                    <a:lstStyle/>
-                    <a:p>
-                      <a:pPr>
-                        <a:defRPr sz="1000"/>
-                      </a:pPr>
-                      <a:r>
-                        <a:t>0.030279250458970227</a:t>
-                      </a:r>
-                    </a:p>
-                  </a:txBody>
-                  <a:tcPr/>
-                </a:tc>
-                <a:tc>
-                  <a:txBody>
-                    <a:bodyPr/>
-                    <a:lstStyle/>
-                    <a:p>
-                      <a:pPr>
-                        <a:defRPr sz="1000"/>
-                      </a:pPr>
-                      <a:r>
-                        <a:t>0.026557199723339326</a:t>
-                      </a:r>
-                    </a:p>
-                  </a:txBody>
-                  <a:tcPr/>
-                </a:tc>
-                <a:tc>
-                  <a:txBody>
-                    <a:bodyPr/>
-                    <a:lstStyle/>
-                    <a:p>
-                      <a:pPr>
-                        <a:defRPr sz="1000"/>
-                      </a:pPr>
-                      <a:r>
-                        <a:t>0.08171692434949991</a:t>
+                        <a:t>0.008630402595531753</a:t>
+                      </a:r>
+                    </a:p>
+                  </a:txBody>
+                  <a:tcPr/>
+                </a:tc>
+                <a:tc>
+                  <a:txBody>
+                    <a:bodyPr/>
+                    <a:lstStyle/>
+                    <a:p>
+                      <a:pPr>
+                        <a:defRPr sz="1000"/>
+                      </a:pPr>
+                      <a:r>
+                        <a:t>0.03299680283228205</a:t>
+                      </a:r>
+                    </a:p>
+                  </a:txBody>
+                  <a:tcPr/>
+                </a:tc>
+                <a:tc>
+                  <a:txBody>
+                    <a:bodyPr/>
+                    <a:lstStyle/>
+                    <a:p>
+                      <a:pPr>
+                        <a:defRPr sz="1000"/>
+                      </a:pPr>
+                      <a:r>
+                        <a:t>0.02691431106611553</a:t>
+                      </a:r>
+                    </a:p>
+                  </a:txBody>
+                  <a:tcPr/>
+                </a:tc>
+                <a:tc>
+                  <a:txBody>
+                    <a:bodyPr/>
+                    <a:lstStyle/>
+                    <a:p>
+                      <a:pPr>
+                        <a:defRPr sz="1000"/>
+                      </a:pPr>
+                      <a:r>
+                        <a:t>0.08241584203083246</a:t>
                       </a:r>
                     </a:p>
                   </a:txBody>
@@ -9289,52 +9289,52 @@
                         <a:defRPr sz="1000"/>
                       </a:pPr>
                       <a:r>
-                        <a:t>0.012389331071774071</a:t>
-                      </a:r>
-                    </a:p>
-                  </a:txBody>
-                  <a:tcPr/>
-                </a:tc>
-                <a:tc>
-                  <a:txBody>
-                    <a:bodyPr/>
-                    <a:lstStyle/>
-                    <a:p>
-                      <a:pPr>
-                        <a:defRPr sz="1000"/>
-                      </a:pPr>
-                      <a:r>
-                        <a:t>0.03689413571699145</a:t>
-                      </a:r>
-                    </a:p>
-                  </a:txBody>
-                  <a:tcPr/>
-                </a:tc>
-                <a:tc>
-                  <a:txBody>
-                    <a:bodyPr/>
-                    <a:lstStyle/>
-                    <a:p>
-                      <a:pPr>
-                        <a:defRPr sz="1000"/>
-                      </a:pPr>
-                      <a:r>
-                        <a:t>0.025186713119533095</a:t>
-                      </a:r>
-                    </a:p>
-                  </a:txBody>
-                  <a:tcPr/>
-                </a:tc>
-                <a:tc>
-                  <a:txBody>
-                    <a:bodyPr/>
-                    <a:lstStyle/>
-                    <a:p>
-                      <a:pPr>
-                        <a:defRPr sz="1000"/>
-                      </a:pPr>
-                      <a:r>
-                        <a:t>0.09451679349006414</a:t>
+                        <a:t>0.012666046927368129</a:t>
+                      </a:r>
+                    </a:p>
+                  </a:txBody>
+                  <a:tcPr/>
+                </a:tc>
+                <a:tc>
+                  <a:txBody>
+                    <a:bodyPr/>
+                    <a:lstStyle/>
+                    <a:p>
+                      <a:pPr>
+                        <a:defRPr sz="1000"/>
+                      </a:pPr>
+                      <a:r>
+                        <a:t>0.038401582840796256</a:t>
+                      </a:r>
+                    </a:p>
+                  </a:txBody>
+                  <a:tcPr/>
+                </a:tc>
+                <a:tc>
+                  <a:txBody>
+                    <a:bodyPr/>
+                    <a:lstStyle/>
+                    <a:p>
+                      <a:pPr>
+                        <a:defRPr sz="1000"/>
+                      </a:pPr>
+                      <a:r>
+                        <a:t>0.025445116702978474</a:t>
+                      </a:r>
+                    </a:p>
+                  </a:txBody>
+                  <a:tcPr/>
+                </a:tc>
+                <a:tc>
+                  <a:txBody>
+                    <a:bodyPr/>
+                    <a:lstStyle/>
+                    <a:p>
+                      <a:pPr>
+                        <a:defRPr sz="1000"/>
+                      </a:pPr>
+                      <a:r>
+                        <a:t>0.09498790956874537</a:t>
                       </a:r>
                     </a:p>
                   </a:txBody>
@@ -9396,52 +9396,52 @@
                         <a:defRPr sz="1000"/>
                       </a:pPr>
                       <a:r>
-                        <a:t>0.006813925283901347</a:t>
-                      </a:r>
-                    </a:p>
-                  </a:txBody>
-                  <a:tcPr/>
-                </a:tc>
-                <a:tc>
-                  <a:txBody>
-                    <a:bodyPr/>
-                    <a:lstStyle/>
-                    <a:p>
-                      <a:pPr>
-                        <a:defRPr sz="1000"/>
-                      </a:pPr>
-                      <a:r>
-                        <a:t>0.03707504315767071</a:t>
-                      </a:r>
-                    </a:p>
-                  </a:txBody>
-                  <a:tcPr/>
-                </a:tc>
-                <a:tc>
-                  <a:txBody>
-                    <a:bodyPr/>
-                    <a:lstStyle/>
-                    <a:p>
-                      <a:pPr>
-                        <a:defRPr sz="1000"/>
-                      </a:pPr>
-                      <a:r>
-                        <a:t>0.023589752718372055</a:t>
-                      </a:r>
-                    </a:p>
-                  </a:txBody>
-                  <a:tcPr/>
-                </a:tc>
-                <a:tc>
-                  <a:txBody>
-                    <a:bodyPr/>
-                    <a:lstStyle/>
-                    <a:p>
-                      <a:pPr>
-                        <a:defRPr sz="1000"/>
-                      </a:pPr>
-                      <a:r>
-                        <a:t>0.06939410367989353</a:t>
+                        <a:t>0.006917679672886924</a:t>
+                      </a:r>
+                    </a:p>
+                  </a:txBody>
+                  <a:tcPr/>
+                </a:tc>
+                <a:tc>
+                  <a:txBody>
+                    <a:bodyPr/>
+                    <a:lstStyle/>
+                    <a:p>
+                      <a:pPr>
+                        <a:defRPr sz="1000"/>
+                      </a:pPr>
+                      <a:r>
+                        <a:t>0.037602085739115054</a:t>
+                      </a:r>
+                    </a:p>
+                  </a:txBody>
+                  <a:tcPr/>
+                </a:tc>
+                <a:tc>
+                  <a:txBody>
+                    <a:bodyPr/>
+                    <a:lstStyle/>
+                    <a:p>
+                      <a:pPr>
+                        <a:defRPr sz="1000"/>
+                      </a:pPr>
+                      <a:r>
+                        <a:t>0.02367889326887788</a:t>
+                      </a:r>
+                    </a:p>
+                  </a:txBody>
+                  <a:tcPr/>
+                </a:tc>
+                <a:tc>
+                  <a:txBody>
+                    <a:bodyPr/>
+                    <a:lstStyle/>
+                    <a:p>
+                      <a:pPr>
+                        <a:defRPr sz="1000"/>
+                      </a:pPr>
+                      <a:r>
+                        <a:t>0.06960468807321192</a:t>
                       </a:r>
                     </a:p>
                   </a:txBody>
@@ -9503,52 +9503,52 @@
                         <a:defRPr sz="1000"/>
                       </a:pPr>
                       <a:r>
-                        <a:t>0.009056448138388542</a:t>
-                      </a:r>
-                    </a:p>
-                  </a:txBody>
-                  <a:tcPr/>
-                </a:tc>
-                <a:tc>
-                  <a:txBody>
-                    <a:bodyPr/>
-                    <a:lstStyle/>
-                    <a:p>
-                      <a:pPr>
-                        <a:defRPr sz="1000"/>
-                      </a:pPr>
-                      <a:r>
-                        <a:t>0.034508343392236136</a:t>
-                      </a:r>
-                    </a:p>
-                  </a:txBody>
-                  <a:tcPr/>
-                </a:tc>
-                <a:tc>
-                  <a:txBody>
-                    <a:bodyPr/>
-                    <a:lstStyle/>
-                    <a:p>
-                      <a:pPr>
-                        <a:defRPr sz="1000"/>
-                      </a:pPr>
-                      <a:r>
-                        <a:t>0.02568915937776914</a:t>
-                      </a:r>
-                    </a:p>
-                  </a:txBody>
-                  <a:tcPr/>
-                </a:tc>
-                <a:tc>
-                  <a:txBody>
-                    <a:bodyPr/>
-                    <a:lstStyle/>
-                    <a:p>
-                      <a:pPr>
-                        <a:defRPr sz="1000"/>
-                      </a:pPr>
-                      <a:r>
-                        <a:t>0.07757096199241675</a:t>
+                        <a:t>0.009174917967806347</a:t>
+                      </a:r>
+                    </a:p>
+                  </a:txBody>
+                  <a:tcPr/>
+                </a:tc>
+                <a:tc>
+                  <a:txBody>
+                    <a:bodyPr/>
+                    <a:lstStyle/>
+                    <a:p>
+                      <a:pPr>
+                        <a:defRPr sz="1000"/>
+                      </a:pPr>
+                      <a:r>
+                        <a:t>0.034841303799186506</a:t>
+                      </a:r>
+                    </a:p>
+                  </a:txBody>
+                  <a:tcPr/>
+                </a:tc>
+                <a:tc>
+                  <a:txBody>
+                    <a:bodyPr/>
+                    <a:lstStyle/>
+                    <a:p>
+                      <a:pPr>
+                        <a:defRPr sz="1000"/>
+                      </a:pPr>
+                      <a:r>
+                        <a:t>0.025794413969593047</a:t>
+                      </a:r>
+                    </a:p>
+                  </a:txBody>
+                  <a:tcPr/>
+                </a:tc>
+                <a:tc>
+                  <a:txBody>
+                    <a:bodyPr/>
+                    <a:lstStyle/>
+                    <a:p>
+                      <a:pPr>
+                        <a:defRPr sz="1000"/>
+                      </a:pPr>
+                      <a:r>
+                        <a:t>0.07781467004902813</a:t>
                       </a:r>
                     </a:p>
                   </a:txBody>
@@ -9610,52 +9610,52 @@
                         <a:defRPr sz="1000"/>
                       </a:pPr>
                       <a:r>
-                        <a:t>0.013521943556706347</a:t>
-                      </a:r>
-                    </a:p>
-                  </a:txBody>
-                  <a:tcPr/>
-                </a:tc>
-                <a:tc>
-                  <a:txBody>
-                    <a:bodyPr/>
-                    <a:lstStyle/>
-                    <a:p>
-                      <a:pPr>
-                        <a:defRPr sz="1000"/>
-                      </a:pPr>
-                      <a:r>
-                        <a:t>0.031869406157243534</a:t>
-                      </a:r>
-                    </a:p>
-                  </a:txBody>
-                  <a:tcPr/>
-                </a:tc>
-                <a:tc>
-                  <a:txBody>
-                    <a:bodyPr/>
-                    <a:lstStyle/>
-                    <a:p>
-                      <a:pPr>
-                        <a:defRPr sz="1000"/>
-                      </a:pPr>
-                      <a:r>
-                        <a:t>0.058099157893367795</a:t>
-                      </a:r>
-                    </a:p>
-                  </a:txBody>
-                  <a:tcPr/>
-                </a:tc>
-                <a:tc>
-                  <a:txBody>
-                    <a:bodyPr/>
-                    <a:lstStyle/>
-                    <a:p>
-                      <a:pPr>
-                        <a:defRPr sz="1000"/>
-                      </a:pPr>
-                      <a:r>
-                        <a:t>0.0671873401266947</a:t>
+                        <a:t>0.014804380291716199</a:t>
+                      </a:r>
+                    </a:p>
+                  </a:txBody>
+                  <a:tcPr/>
+                </a:tc>
+                <a:tc>
+                  <a:txBody>
+                    <a:bodyPr/>
+                    <a:lstStyle/>
+                    <a:p>
+                      <a:pPr>
+                        <a:defRPr sz="1000"/>
+                      </a:pPr>
+                      <a:r>
+                        <a:t>0.033386940704236284</a:t>
+                      </a:r>
+                    </a:p>
+                  </a:txBody>
+                  <a:tcPr/>
+                </a:tc>
+                <a:tc>
+                  <a:txBody>
+                    <a:bodyPr/>
+                    <a:lstStyle/>
+                    <a:p>
+                      <a:pPr>
+                        <a:defRPr sz="1000"/>
+                      </a:pPr>
+                      <a:r>
+                        <a:t>0.05892906512509506</a:t>
+                      </a:r>
+                    </a:p>
+                  </a:txBody>
+                  <a:tcPr/>
+                </a:tc>
+                <a:tc>
+                  <a:txBody>
+                    <a:bodyPr/>
+                    <a:lstStyle/>
+                    <a:p>
+                      <a:pPr>
+                        <a:defRPr sz="1000"/>
+                      </a:pPr>
+                      <a:r>
+                        <a:t>0.06798731834845337</a:t>
                       </a:r>
                     </a:p>
                   </a:txBody>
@@ -9717,52 +9717,52 @@
                         <a:defRPr sz="1000"/>
                       </a:pPr>
                       <a:r>
-                        <a:t>0.006891999181649188</a:t>
-                      </a:r>
-                    </a:p>
-                  </a:txBody>
-                  <a:tcPr/>
-                </a:tc>
-                <a:tc>
-                  <a:txBody>
-                    <a:bodyPr/>
-                    <a:lstStyle/>
-                    <a:p>
-                      <a:pPr>
-                        <a:defRPr sz="1000"/>
-                      </a:pPr>
-                      <a:r>
-                        <a:t>0.026959051414237076</a:t>
-                      </a:r>
-                    </a:p>
-                  </a:txBody>
-                  <a:tcPr/>
-                </a:tc>
-                <a:tc>
-                  <a:txBody>
-                    <a:bodyPr/>
-                    <a:lstStyle/>
-                    <a:p>
-                      <a:pPr>
-                        <a:defRPr sz="1000"/>
-                      </a:pPr>
-                      <a:r>
-                        <a:t>0.025929464772427302</a:t>
-                      </a:r>
-                    </a:p>
-                  </a:txBody>
-                  <a:tcPr/>
-                </a:tc>
-                <a:tc>
-                  <a:txBody>
-                    <a:bodyPr/>
-                    <a:lstStyle/>
-                    <a:p>
-                      <a:pPr>
-                        <a:defRPr sz="1000"/>
-                      </a:pPr>
-                      <a:r>
-                        <a:t>0.09080689682278584</a:t>
+                        <a:t>0.0069463267399030824</a:t>
+                      </a:r>
+                    </a:p>
+                  </a:txBody>
+                  <a:tcPr/>
+                </a:tc>
+                <a:tc>
+                  <a:txBody>
+                    <a:bodyPr/>
+                    <a:lstStyle/>
+                    <a:p>
+                      <a:pPr>
+                        <a:defRPr sz="1000"/>
+                      </a:pPr>
+                      <a:r>
+                        <a:t>0.027227975340917476</a:t>
+                      </a:r>
+                    </a:p>
+                  </a:txBody>
+                  <a:tcPr/>
+                </a:tc>
+                <a:tc>
+                  <a:txBody>
+                    <a:bodyPr/>
+                    <a:lstStyle/>
+                    <a:p>
+                      <a:pPr>
+                        <a:defRPr sz="1000"/>
+                      </a:pPr>
+                      <a:r>
+                        <a:t>0.025975223591736964</a:t>
+                      </a:r>
+                    </a:p>
+                  </a:txBody>
+                  <a:tcPr/>
+                </a:tc>
+                <a:tc>
+                  <a:txBody>
+                    <a:bodyPr/>
+                    <a:lstStyle/>
+                    <a:p>
+                      <a:pPr>
+                        <a:defRPr sz="1000"/>
+                      </a:pPr>
+                      <a:r>
+                        <a:t>0.09085321057400796</a:t>
                       </a:r>
                     </a:p>
                   </a:txBody>
@@ -9824,52 +9824,52 @@
                         <a:defRPr sz="1000"/>
                       </a:pPr>
                       <a:r>
-                        <a:t>0.008485370848193771</a:t>
-                      </a:r>
-                    </a:p>
-                  </a:txBody>
-                  <a:tcPr/>
-                </a:tc>
-                <a:tc>
-                  <a:txBody>
-                    <a:bodyPr/>
-                    <a:lstStyle/>
-                    <a:p>
-                      <a:pPr>
-                        <a:defRPr sz="1000"/>
-                      </a:pPr>
-                      <a:r>
-                        <a:t>0.03323197711785264</a:t>
-                      </a:r>
-                    </a:p>
-                  </a:txBody>
-                  <a:tcPr/>
-                </a:tc>
-                <a:tc>
-                  <a:txBody>
-                    <a:bodyPr/>
-                    <a:lstStyle/>
-                    <a:p>
-                      <a:pPr>
-                        <a:defRPr sz="1000"/>
-                      </a:pPr>
-                      <a:r>
-                        <a:t>0.046601807299749005</a:t>
-                      </a:r>
-                    </a:p>
-                  </a:txBody>
-                  <a:tcPr/>
-                </a:tc>
-                <a:tc>
-                  <a:txBody>
-                    <a:bodyPr/>
-                    <a:lstStyle/>
-                    <a:p>
-                      <a:pPr>
-                        <a:defRPr sz="1000"/>
-                      </a:pPr>
-                      <a:r>
-                        <a:t>0.08643858355385259</a:t>
+                        <a:t>0.008529718608775006</a:t>
+                      </a:r>
+                    </a:p>
+                  </a:txBody>
+                  <a:tcPr/>
+                </a:tc>
+                <a:tc>
+                  <a:txBody>
+                    <a:bodyPr/>
+                    <a:lstStyle/>
+                    <a:p>
+                      <a:pPr>
+                        <a:defRPr sz="1000"/>
+                      </a:pPr>
+                      <a:r>
+                        <a:t>0.03333905686691644</a:t>
+                      </a:r>
+                    </a:p>
+                  </a:txBody>
+                  <a:tcPr/>
+                </a:tc>
+                <a:tc>
+                  <a:txBody>
+                    <a:bodyPr/>
+                    <a:lstStyle/>
+                    <a:p>
+                      <a:pPr>
+                        <a:defRPr sz="1000"/>
+                      </a:pPr>
+                      <a:r>
+                        <a:t>0.04663252635534043</a:t>
+                      </a:r>
+                    </a:p>
+                  </a:txBody>
+                  <a:tcPr/>
+                </a:tc>
+                <a:tc>
+                  <a:txBody>
+                    <a:bodyPr/>
+                    <a:lstStyle/>
+                    <a:p>
+                      <a:pPr>
+                        <a:defRPr sz="1000"/>
+                      </a:pPr>
+                      <a:r>
+                        <a:t>0.08645751258990873</a:t>
                       </a:r>
                     </a:p>
                   </a:txBody>
@@ -10768,22 +10768,22 @@
                         <a:defRPr sz="1000"/>
                       </a:pPr>
                       <a:r>
-                        <a:t>3545.91</a:t>
-                      </a:r>
-                    </a:p>
-                  </a:txBody>
-                  <a:tcPr/>
-                </a:tc>
-                <a:tc>
-                  <a:txBody>
-                    <a:bodyPr/>
-                    <a:lstStyle/>
-                    <a:p>
-                      <a:pPr>
-                        <a:defRPr sz="1000"/>
-                      </a:pPr>
-                      <a:r>
-                        <a:t>86.3%</a:t>
+                        <a:t>3544.26</a:t>
+                      </a:r>
+                    </a:p>
+                  </a:txBody>
+                  <a:tcPr/>
+                </a:tc>
+                <a:tc>
+                  <a:txBody>
+                    <a:bodyPr/>
+                    <a:lstStyle/>
+                    <a:p>
+                      <a:pPr>
+                        <a:defRPr sz="1000"/>
+                      </a:pPr>
+                      <a:r>
+                        <a:t>86.2%</a:t>
                       </a:r>
                     </a:p>
                   </a:txBody>
@@ -10920,7 +10920,7 @@
                         <a:defRPr sz="1000"/>
                       </a:pPr>
                       <a:r>
-                        <a:t>11675.98</a:t>
+                        <a:t>11674.84</a:t>
                       </a:r>
                     </a:p>
                   </a:txBody>
@@ -11072,22 +11072,22 @@
                         <a:defRPr sz="1000"/>
                       </a:pPr>
                       <a:r>
-                        <a:t>7893.85</a:t>
-                      </a:r>
-                    </a:p>
-                  </a:txBody>
-                  <a:tcPr/>
-                </a:tc>
-                <a:tc>
-                  <a:txBody>
-                    <a:bodyPr/>
-                    <a:lstStyle/>
-                    <a:p>
-                      <a:pPr>
-                        <a:defRPr sz="1000"/>
-                      </a:pPr>
-                      <a:r>
-                        <a:t>199.3%</a:t>
+                        <a:t>7915.72</a:t>
+                      </a:r>
+                    </a:p>
+                  </a:txBody>
+                  <a:tcPr/>
+                </a:tc>
+                <a:tc>
+                  <a:txBody>
+                    <a:bodyPr/>
+                    <a:lstStyle/>
+                    <a:p>
+                      <a:pPr>
+                        <a:defRPr sz="1000"/>
+                      </a:pPr>
+                      <a:r>
+                        <a:t>188.4%</a:t>
                       </a:r>
                     </a:p>
                   </a:txBody>
@@ -11224,22 +11224,22 @@
                         <a:defRPr sz="1000"/>
                       </a:pPr>
                       <a:r>
-                        <a:t>16747.65</a:t>
-                      </a:r>
-                    </a:p>
-                  </a:txBody>
-                  <a:tcPr/>
-                </a:tc>
-                <a:tc>
-                  <a:txBody>
-                    <a:bodyPr/>
-                    <a:lstStyle/>
-                    <a:p>
-                      <a:pPr>
-                        <a:defRPr sz="1000"/>
-                      </a:pPr>
-                      <a:r>
-                        <a:t>275.2%</a:t>
+                        <a:t>16757.46</a:t>
+                      </a:r>
+                    </a:p>
+                  </a:txBody>
+                  <a:tcPr/>
+                </a:tc>
+                <a:tc>
+                  <a:txBody>
+                    <a:bodyPr/>
+                    <a:lstStyle/>
+                    <a:p>
+                      <a:pPr>
+                        <a:defRPr sz="1000"/>
+                      </a:pPr>
+                      <a:r>
+                        <a:t>273.0%</a:t>
                       </a:r>
                     </a:p>
                   </a:txBody>
@@ -11376,22 +11376,22 @@
                         <a:defRPr sz="1000"/>
                       </a:pPr>
                       <a:r>
-                        <a:t>1677.51</a:t>
-                      </a:r>
-                    </a:p>
-                  </a:txBody>
-                  <a:tcPr/>
-                </a:tc>
-                <a:tc>
-                  <a:txBody>
-                    <a:bodyPr/>
-                    <a:lstStyle/>
-                    <a:p>
-                      <a:pPr>
-                        <a:defRPr sz="1000"/>
-                      </a:pPr>
-                      <a:r>
-                        <a:t>70.1%</a:t>
+                        <a:t>1677.63</a:t>
+                      </a:r>
+                    </a:p>
+                  </a:txBody>
+                  <a:tcPr/>
+                </a:tc>
+                <a:tc>
+                  <a:txBody>
+                    <a:bodyPr/>
+                    <a:lstStyle/>
+                    <a:p>
+                      <a:pPr>
+                        <a:defRPr sz="1000"/>
+                      </a:pPr>
+                      <a:r>
+                        <a:t>69.9%</a:t>
                       </a:r>
                     </a:p>
                   </a:txBody>
@@ -11528,22 +11528,22 @@
                         <a:defRPr sz="1000"/>
                       </a:pPr>
                       <a:r>
-                        <a:t>6151.05</a:t>
-                      </a:r>
-                    </a:p>
-                  </a:txBody>
-                  <a:tcPr/>
-                </a:tc>
-                <a:tc>
-                  <a:txBody>
-                    <a:bodyPr/>
-                    <a:lstStyle/>
-                    <a:p>
-                      <a:pPr>
-                        <a:defRPr sz="1000"/>
-                      </a:pPr>
-                      <a:r>
-                        <a:t>132.5%</a:t>
+                        <a:t>6149.73</a:t>
+                      </a:r>
+                    </a:p>
+                  </a:txBody>
+                  <a:tcPr/>
+                </a:tc>
+                <a:tc>
+                  <a:txBody>
+                    <a:bodyPr/>
+                    <a:lstStyle/>
+                    <a:p>
+                      <a:pPr>
+                        <a:defRPr sz="1000"/>
+                      </a:pPr>
+                      <a:r>
+                        <a:t>132.4%</a:t>
                       </a:r>
                     </a:p>
                   </a:txBody>
@@ -11680,37 +11680,37 @@
                         <a:defRPr sz="1000"/>
                       </a:pPr>
                       <a:r>
-                        <a:t>259.88</a:t>
-                      </a:r>
-                    </a:p>
-                  </a:txBody>
-                  <a:tcPr/>
-                </a:tc>
-                <a:tc>
-                  <a:txBody>
-                    <a:bodyPr/>
-                    <a:lstStyle/>
-                    <a:p>
-                      <a:pPr>
-                        <a:defRPr sz="1000"/>
-                      </a:pPr>
-                      <a:r>
-                        <a:t>97.8%</a:t>
-                      </a:r>
-                    </a:p>
-                  </a:txBody>
-                  <a:tcPr/>
-                </a:tc>
-                <a:tc>
-                  <a:txBody>
-                    <a:bodyPr/>
-                    <a:lstStyle/>
-                    <a:p>
-                      <a:pPr>
-                        <a:defRPr sz="1000"/>
-                      </a:pPr>
-                      <a:r>
-                        <a:t>0.25</a:t>
+                        <a:t>256.88</a:t>
+                      </a:r>
+                    </a:p>
+                  </a:txBody>
+                  <a:tcPr/>
+                </a:tc>
+                <a:tc>
+                  <a:txBody>
+                    <a:bodyPr/>
+                    <a:lstStyle/>
+                    <a:p>
+                      <a:pPr>
+                        <a:defRPr sz="1000"/>
+                      </a:pPr>
+                      <a:r>
+                        <a:t>98.7%</a:t>
+                      </a:r>
+                    </a:p>
+                  </a:txBody>
+                  <a:tcPr/>
+                </a:tc>
+                <a:tc>
+                  <a:txBody>
+                    <a:bodyPr/>
+                    <a:lstStyle/>
+                    <a:p>
+                      <a:pPr>
+                        <a:defRPr sz="1000"/>
+                      </a:pPr>
+                      <a:r>
+                        <a:t>0.2777777777777778</a:t>
                       </a:r>
                     </a:p>
                   </a:txBody>
@@ -11832,37 +11832,37 @@
                         <a:defRPr sz="1000"/>
                       </a:pPr>
                       <a:r>
-                        <a:t>18773.11</a:t>
-                      </a:r>
-                    </a:p>
-                  </a:txBody>
-                  <a:tcPr/>
-                </a:tc>
-                <a:tc>
-                  <a:txBody>
-                    <a:bodyPr/>
-                    <a:lstStyle/>
-                    <a:p>
-                      <a:pPr>
-                        <a:defRPr sz="1000"/>
-                      </a:pPr>
-                      <a:r>
-                        <a:t>131.6%</a:t>
-                      </a:r>
-                    </a:p>
-                  </a:txBody>
-                  <a:tcPr/>
-                </a:tc>
-                <a:tc>
-                  <a:txBody>
-                    <a:bodyPr/>
-                    <a:lstStyle/>
-                    <a:p>
-                      <a:pPr>
-                        <a:defRPr sz="1000"/>
-                      </a:pPr>
-                      <a:r>
-                        <a:t>0.2222222222222222</a:t>
+                        <a:t>18771.59</a:t>
+                      </a:r>
+                    </a:p>
+                  </a:txBody>
+                  <a:tcPr/>
+                </a:tc>
+                <a:tc>
+                  <a:txBody>
+                    <a:bodyPr/>
+                    <a:lstStyle/>
+                    <a:p>
+                      <a:pPr>
+                        <a:defRPr sz="1000"/>
+                      </a:pPr>
+                      <a:r>
+                        <a:t>132.3%</a:t>
+                      </a:r>
+                    </a:p>
+                  </a:txBody>
+                  <a:tcPr/>
+                </a:tc>
+                <a:tc>
+                  <a:txBody>
+                    <a:bodyPr/>
+                    <a:lstStyle/>
+                    <a:p>
+                      <a:pPr>
+                        <a:defRPr sz="1000"/>
+                      </a:pPr>
+                      <a:r>
+                        <a:t>0.1944444444444444</a:t>
                       </a:r>
                     </a:p>
                   </a:txBody>
@@ -11984,7 +11984,7 @@
                         <a:defRPr sz="1000"/>
                       </a:pPr>
                       <a:r>
-                        <a:t>7014.93</a:t>
+                        <a:t>7013.54</a:t>
                       </a:r>
                     </a:p>
                   </a:txBody>
@@ -12287,37 +12287,37 @@
                         <a:defRPr sz="1000"/>
                       </a:pPr>
                       <a:r>
-                        <a:t>860.78</a:t>
-                      </a:r>
-                    </a:p>
-                  </a:txBody>
-                  <a:tcPr/>
-                </a:tc>
-                <a:tc>
-                  <a:txBody>
-                    <a:bodyPr/>
-                    <a:lstStyle/>
-                    <a:p>
-                      <a:pPr>
-                        <a:defRPr sz="1000"/>
-                      </a:pPr>
-                      <a:r>
-                        <a:t>224.2%</a:t>
-                      </a:r>
-                    </a:p>
-                  </a:txBody>
-                  <a:tcPr/>
-                </a:tc>
-                <a:tc>
-                  <a:txBody>
-                    <a:bodyPr/>
-                    <a:lstStyle/>
-                    <a:p>
-                      <a:pPr>
-                        <a:defRPr sz="1000"/>
-                      </a:pPr>
-                      <a:r>
-                        <a:t>0.0925925925925925</a:t>
+                        <a:t>849.47</a:t>
+                      </a:r>
+                    </a:p>
+                  </a:txBody>
+                  <a:tcPr/>
+                </a:tc>
+                <a:tc>
+                  <a:txBody>
+                    <a:bodyPr/>
+                    <a:lstStyle/>
+                    <a:p>
+                      <a:pPr>
+                        <a:defRPr sz="1000"/>
+                      </a:pPr>
+                      <a:r>
+                        <a:t>215.1%</a:t>
+                      </a:r>
+                    </a:p>
+                  </a:txBody>
+                  <a:tcPr/>
+                </a:tc>
+                <a:tc>
+                  <a:txBody>
+                    <a:bodyPr/>
+                    <a:lstStyle/>
+                    <a:p>
+                      <a:pPr>
+                        <a:defRPr sz="1000"/>
+                      </a:pPr>
+                      <a:r>
+                        <a:t>0.074074074074074</a:t>
                       </a:r>
                     </a:p>
                   </a:txBody>
@@ -12349,22 +12349,22 @@
                         <a:defRPr sz="1000"/>
                       </a:pPr>
                       <a:r>
-                        <a:t>19772.90</a:t>
-                      </a:r>
-                    </a:p>
-                  </a:txBody>
-                  <a:tcPr/>
-                </a:tc>
-                <a:tc>
-                  <a:txBody>
-                    <a:bodyPr/>
-                    <a:lstStyle/>
-                    <a:p>
-                      <a:pPr>
-                        <a:defRPr sz="1000"/>
-                      </a:pPr>
-                      <a:r>
-                        <a:t>262.8%</a:t>
+                        <a:t>19801.25</a:t>
+                      </a:r>
+                    </a:p>
+                  </a:txBody>
+                  <a:tcPr/>
+                </a:tc>
+                <a:tc>
+                  <a:txBody>
+                    <a:bodyPr/>
+                    <a:lstStyle/>
+                    <a:p>
+                      <a:pPr>
+                        <a:defRPr sz="1000"/>
+                      </a:pPr>
+                      <a:r>
+                        <a:t>263.3%</a:t>
                       </a:r>
                     </a:p>
                   </a:txBody>
@@ -12411,22 +12411,22 @@
                         <a:defRPr sz="1000"/>
                       </a:pPr>
                       <a:r>
-                        <a:t>406.05</a:t>
-                      </a:r>
-                    </a:p>
-                  </a:txBody>
-                  <a:tcPr/>
-                </a:tc>
-                <a:tc>
-                  <a:txBody>
-                    <a:bodyPr/>
-                    <a:lstStyle/>
-                    <a:p>
-                      <a:pPr>
-                        <a:defRPr sz="1000"/>
-                      </a:pPr>
-                      <a:r>
-                        <a:t>50.9%</a:t>
+                        <a:t>394.83</a:t>
+                      </a:r>
+                    </a:p>
+                  </a:txBody>
+                  <a:tcPr/>
+                </a:tc>
+                <a:tc>
+                  <a:txBody>
+                    <a:bodyPr/>
+                    <a:lstStyle/>
+                    <a:p>
+                      <a:pPr>
+                        <a:defRPr sz="1000"/>
+                      </a:pPr>
+                      <a:r>
+                        <a:t>50.1%</a:t>
                       </a:r>
                     </a:p>
                   </a:txBody>
@@ -12473,22 +12473,22 @@
                         <a:defRPr sz="1000"/>
                       </a:pPr>
                       <a:r>
-                        <a:t>8086.06</a:t>
-                      </a:r>
-                    </a:p>
-                  </a:txBody>
-                  <a:tcPr/>
-                </a:tc>
-                <a:tc>
-                  <a:txBody>
-                    <a:bodyPr/>
-                    <a:lstStyle/>
-                    <a:p>
-                      <a:pPr>
-                        <a:defRPr sz="1000"/>
-                      </a:pPr>
-                      <a:r>
-                        <a:t>170.7%</a:t>
+                        <a:t>8094.10</a:t>
+                      </a:r>
+                    </a:p>
+                  </a:txBody>
+                  <a:tcPr/>
+                </a:tc>
+                <a:tc>
+                  <a:txBody>
+                    <a:bodyPr/>
+                    <a:lstStyle/>
+                    <a:p>
+                      <a:pPr>
+                        <a:defRPr sz="1000"/>
+                      </a:pPr>
+                      <a:r>
+                        <a:t>171.6%</a:t>
                       </a:r>
                     </a:p>
                   </a:txBody>
@@ -12535,22 +12535,22 @@
                         <a:defRPr sz="1000"/>
                       </a:pPr>
                       <a:r>
-                        <a:t>1738.38</a:t>
-                      </a:r>
-                    </a:p>
-                  </a:txBody>
-                  <a:tcPr/>
-                </a:tc>
-                <a:tc>
-                  <a:txBody>
-                    <a:bodyPr/>
-                    <a:lstStyle/>
-                    <a:p>
-                      <a:pPr>
-                        <a:defRPr sz="1000"/>
-                      </a:pPr>
-                      <a:r>
-                        <a:t>35.5%</a:t>
+                        <a:t>1744.50</a:t>
+                      </a:r>
+                    </a:p>
+                  </a:txBody>
+                  <a:tcPr/>
+                </a:tc>
+                <a:tc>
+                  <a:txBody>
+                    <a:bodyPr/>
+                    <a:lstStyle/>
+                    <a:p>
+                      <a:pPr>
+                        <a:defRPr sz="1000"/>
+                      </a:pPr>
+                      <a:r>
+                        <a:t>36.4%</a:t>
                       </a:r>
                     </a:p>
                   </a:txBody>
@@ -12597,37 +12597,37 @@
                         <a:defRPr sz="1000"/>
                       </a:pPr>
                       <a:r>
-                        <a:t>12744.52</a:t>
-                      </a:r>
-                    </a:p>
-                  </a:txBody>
-                  <a:tcPr/>
-                </a:tc>
-                <a:tc>
-                  <a:txBody>
-                    <a:bodyPr/>
-                    <a:lstStyle/>
-                    <a:p>
-                      <a:pPr>
-                        <a:defRPr sz="1000"/>
-                      </a:pPr>
-                      <a:r>
-                        <a:t>38.0%</a:t>
-                      </a:r>
-                    </a:p>
-                  </a:txBody>
-                  <a:tcPr/>
-                </a:tc>
-                <a:tc>
-                  <a:txBody>
-                    <a:bodyPr/>
-                    <a:lstStyle/>
-                    <a:p>
-                      <a:pPr>
-                        <a:defRPr sz="1000"/>
-                      </a:pPr>
-                      <a:r>
-                        <a:t>0.4444444444444444</a:t>
+                        <a:t>12709.83</a:t>
+                      </a:r>
+                    </a:p>
+                  </a:txBody>
+                  <a:tcPr/>
+                </a:tc>
+                <a:tc>
+                  <a:txBody>
+                    <a:bodyPr/>
+                    <a:lstStyle/>
+                    <a:p>
+                      <a:pPr>
+                        <a:defRPr sz="1000"/>
+                      </a:pPr>
+                      <a:r>
+                        <a:t>37.7%</a:t>
+                      </a:r>
+                    </a:p>
+                  </a:txBody>
+                  <a:tcPr/>
+                </a:tc>
+                <a:tc>
+                  <a:txBody>
+                    <a:bodyPr/>
+                    <a:lstStyle/>
+                    <a:p>
+                      <a:pPr>
+                        <a:defRPr sz="1000"/>
+                      </a:pPr>
+                      <a:r>
+                        <a:t>0.4629629629629629</a:t>
                       </a:r>
                     </a:p>
                   </a:txBody>

</xml_diff>

<commit_message>
Apply third-reviewer-report recommendations B1-B4 and C1-C4 (innovation framing, PNR sufficiency, projection purpose, policy actor mapping, Japan illustrative case, civilisation label note, Bootstrap CI moved to Supplementary Table 5, SQLite availability note)
Co-Authored-By: Tatsuki Onishi <bougtoir@gmail.com>
</commit_message>
<xml_diff>
--- a/researcher_mobility_ode/docs/manuscript_full_article_figures.pptx
+++ b/researcher_mobility_ode/docs/manuscript_full_article_figures.pptx
@@ -6793,7 +6793,7 @@
           <a:lstStyle/>
           <a:p>
             <a:r>
-              <a:t>Table 9: Transition levers, policy instruments, and management actions</a:t>
+              <a:t>Table 8: Transition levers, policy instruments, and management actions</a:t>
             </a:r>
           </a:p>
         </p:txBody>
@@ -7141,863 +7141,6 @@
 </file>
 
 <file path=ppt/slides/slide14.xml><?xml version="1.0" encoding="utf-8"?>
-<p:sld xmlns:a="http://schemas.openxmlformats.org/drawingml/2006/main" xmlns:p="http://schemas.openxmlformats.org/presentationml/2006/main" xmlns:r="http://schemas.openxmlformats.org/officeDocument/2006/relationships">
-  <p:cSld>
-    <p:spTree>
-      <p:nvGrpSpPr>
-        <p:cNvPr id="1" name=""/>
-        <p:cNvGrpSpPr/>
-        <p:nvPr/>
-      </p:nvGrpSpPr>
-      <p:grpSpPr/>
-      <p:sp>
-        <p:nvSpPr>
-          <p:cNvPr id="2" name="Title 1"/>
-          <p:cNvSpPr>
-            <a:spLocks noGrp="1"/>
-          </p:cNvSpPr>
-          <p:nvPr>
-            <p:ph type="title"/>
-          </p:nvPr>
-        </p:nvSpPr>
-        <p:spPr/>
-        <p:txBody>
-          <a:bodyPr/>
-          <a:lstStyle/>
-          <a:p>
-            <a:r>
-              <a:t>Table 8: Bootstrap 95% CI</a:t>
-            </a:r>
-          </a:p>
-        </p:txBody>
-      </p:sp>
-      <p:sp>
-        <p:nvSpPr>
-          <p:cNvPr id="3" name="Content Placeholder 2"/>
-          <p:cNvSpPr>
-            <a:spLocks noGrp="1"/>
-          </p:cNvSpPr>
-          <p:nvPr>
-            <p:ph idx="1" sz="half"/>
-          </p:nvPr>
-        </p:nvSpPr>
-        <p:spPr/>
-        <p:txBody>
-          <a:bodyPr/>
-          <a:lstStyle/>
-          <a:p/>
-        </p:txBody>
-      </p:sp>
-      <p:sp>
-        <p:nvSpPr>
-          <p:cNvPr id="4" name="Content Placeholder 3"/>
-          <p:cNvSpPr>
-            <a:spLocks noGrp="1"/>
-          </p:cNvSpPr>
-          <p:nvPr>
-            <p:ph idx="2" sz="half"/>
-          </p:nvPr>
-        </p:nvSpPr>
-        <p:spPr/>
-        <p:txBody>
-          <a:bodyPr/>
-          <a:lstStyle/>
-          <a:p/>
-        </p:txBody>
-      </p:sp>
-      <p:graphicFrame>
-        <p:nvGraphicFramePr>
-          <p:cNvPr id="5" name="Table 4"/>
-          <p:cNvGraphicFramePr>
-            <a:graphicFrameLocks noGrp="1"/>
-          </p:cNvGraphicFramePr>
-          <p:nvPr/>
-        </p:nvGraphicFramePr>
-        <p:xfrm>
-          <a:off x="457200" y="1097280"/>
-          <a:ext cx="10058400" cy="5486400"/>
-        </p:xfrm>
-        <a:graphic>
-          <a:graphicData uri="http://schemas.openxmlformats.org/drawingml/2006/table">
-            <a:tbl>
-              <a:tblPr firstRow="1" bandRow="1">
-                <a:tableStyleId>{5C22544A-7EE6-4342-B048-85BDC9FD1C3A}</a:tableStyleId>
-              </a:tblPr>
-              <a:tblGrid>
-                <a:gridCol w="2011680"/>
-                <a:gridCol w="2011680"/>
-                <a:gridCol w="2011680"/>
-                <a:gridCol w="2011680"/>
-                <a:gridCol w="2011680"/>
-              </a:tblGrid>
-              <a:tr h="548640">
-                <a:tc>
-                  <a:txBody>
-                    <a:bodyPr/>
-                    <a:lstStyle/>
-                    <a:p>
-                      <a:r>
-                        <a:t>Group</a:t>
-                      </a:r>
-                    </a:p>
-                  </a:txBody>
-                  <a:tcPr/>
-                </a:tc>
-                <a:tc>
-                  <a:txBody>
-                    <a:bodyPr/>
-                    <a:lstStyle/>
-                    <a:p>
-                      <a:r>
-                        <a:t>T median</a:t>
-                      </a:r>
-                    </a:p>
-                  </a:txBody>
-                  <a:tcPr/>
-                </a:tc>
-                <a:tc>
-                  <a:txBody>
-                    <a:bodyPr/>
-                    <a:lstStyle/>
-                    <a:p>
-                      <a:r>
-                        <a:t>T 95% CI</a:t>
-                      </a:r>
-                    </a:p>
-                  </a:txBody>
-                  <a:tcPr/>
-                </a:tc>
-                <a:tc>
-                  <a:txBody>
-                    <a:bodyPr/>
-                    <a:lstStyle/>
-                    <a:p>
-                      <a:r>
-                        <a:t>P_D mean</a:t>
-                      </a:r>
-                    </a:p>
-                  </a:txBody>
-                  <a:tcPr/>
-                </a:tc>
-                <a:tc>
-                  <a:txBody>
-                    <a:bodyPr/>
-                    <a:lstStyle/>
-                    <a:p>
-                      <a:r>
-                        <a:t>P_D 95% CI</a:t>
-                      </a:r>
-                    </a:p>
-                  </a:txBody>
-                  <a:tcPr/>
-                </a:tc>
-              </a:tr>
-              <a:tr h="548640">
-                <a:tc>
-                  <a:txBody>
-                    <a:bodyPr/>
-                    <a:lstStyle/>
-                    <a:p>
-                      <a:pPr>
-                        <a:defRPr sz="1000"/>
-                      </a:pPr>
-                      <a:r>
-                        <a:t>Anglosphere ex-US</a:t>
-                      </a:r>
-                    </a:p>
-                  </a:txBody>
-                  <a:tcPr/>
-                </a:tc>
-                <a:tc>
-                  <a:txBody>
-                    <a:bodyPr/>
-                    <a:lstStyle/>
-                    <a:p>
-                      <a:pPr>
-                        <a:defRPr sz="1000"/>
-                      </a:pPr>
-                      <a:r>
-                        <a:t>67546</a:t>
-                      </a:r>
-                    </a:p>
-                  </a:txBody>
-                  <a:tcPr/>
-                </a:tc>
-                <a:tc>
-                  <a:txBody>
-                    <a:bodyPr/>
-                    <a:lstStyle/>
-                    <a:p>
-                      <a:pPr>
-                        <a:defRPr sz="1000"/>
-                      </a:pPr>
-                      <a:r>
-                        <a:t>[66728, 68334]</a:t>
-                      </a:r>
-                    </a:p>
-                  </a:txBody>
-                  <a:tcPr/>
-                </a:tc>
-                <a:tc>
-                  <a:txBody>
-                    <a:bodyPr/>
-                    <a:lstStyle/>
-                    <a:p>
-                      <a:pPr>
-                        <a:defRPr sz="1000"/>
-                      </a:pPr>
-                      <a:r>
-                        <a:t>29814</a:t>
-                      </a:r>
-                    </a:p>
-                  </a:txBody>
-                  <a:tcPr/>
-                </a:tc>
-                <a:tc>
-                  <a:txBody>
-                    <a:bodyPr/>
-                    <a:lstStyle/>
-                    <a:p>
-                      <a:pPr>
-                        <a:defRPr sz="1000"/>
-                      </a:pPr>
-                      <a:r>
-                        <a:t>[29158, 30486]</a:t>
-                      </a:r>
-                    </a:p>
-                  </a:txBody>
-                  <a:tcPr/>
-                </a:tc>
-              </a:tr>
-              <a:tr h="548640">
-                <a:tc>
-                  <a:txBody>
-                    <a:bodyPr/>
-                    <a:lstStyle/>
-                    <a:p>
-                      <a:pPr>
-                        <a:defRPr sz="1000"/>
-                      </a:pPr>
-                      <a:r>
-                        <a:t>Continental Europe</a:t>
-                      </a:r>
-                    </a:p>
-                  </a:txBody>
-                  <a:tcPr/>
-                </a:tc>
-                <a:tc>
-                  <a:txBody>
-                    <a:bodyPr/>
-                    <a:lstStyle/>
-                    <a:p>
-                      <a:pPr>
-                        <a:defRPr sz="1000"/>
-                      </a:pPr>
-                      <a:r>
-                        <a:t>195077</a:t>
-                      </a:r>
-                    </a:p>
-                  </a:txBody>
-                  <a:tcPr/>
-                </a:tc>
-                <a:tc>
-                  <a:txBody>
-                    <a:bodyPr/>
-                    <a:lstStyle/>
-                    <a:p>
-                      <a:pPr>
-                        <a:defRPr sz="1000"/>
-                      </a:pPr>
-                      <a:r>
-                        <a:t>[193718, 196316]</a:t>
-                      </a:r>
-                    </a:p>
-                  </a:txBody>
-                  <a:tcPr/>
-                </a:tc>
-                <a:tc>
-                  <a:txBody>
-                    <a:bodyPr/>
-                    <a:lstStyle/>
-                    <a:p>
-                      <a:pPr>
-                        <a:defRPr sz="1000"/>
-                      </a:pPr>
-                      <a:r>
-                        <a:t>83476</a:t>
-                      </a:r>
-                    </a:p>
-                  </a:txBody>
-                  <a:tcPr/>
-                </a:tc>
-                <a:tc>
-                  <a:txBody>
-                    <a:bodyPr/>
-                    <a:lstStyle/>
-                    <a:p>
-                      <a:pPr>
-                        <a:defRPr sz="1000"/>
-                      </a:pPr>
-                      <a:r>
-                        <a:t>[82421, 84527]</a:t>
-                      </a:r>
-                    </a:p>
-                  </a:txBody>
-                  <a:tcPr/>
-                </a:tc>
-              </a:tr>
-              <a:tr h="548640">
-                <a:tc>
-                  <a:txBody>
-                    <a:bodyPr/>
-                    <a:lstStyle/>
-                    <a:p>
-                      <a:pPr>
-                        <a:defRPr sz="1000"/>
-                      </a:pPr>
-                      <a:r>
-                        <a:t>Hindu</a:t>
-                      </a:r>
-                    </a:p>
-                  </a:txBody>
-                  <a:tcPr/>
-                </a:tc>
-                <a:tc>
-                  <a:txBody>
-                    <a:bodyPr/>
-                    <a:lstStyle/>
-                    <a:p>
-                      <a:pPr>
-                        <a:defRPr sz="1000"/>
-                      </a:pPr>
-                      <a:r>
-                        <a:t>53407</a:t>
-                      </a:r>
-                    </a:p>
-                  </a:txBody>
-                  <a:tcPr/>
-                </a:tc>
-                <a:tc>
-                  <a:txBody>
-                    <a:bodyPr/>
-                    <a:lstStyle/>
-                    <a:p>
-                      <a:pPr>
-                        <a:defRPr sz="1000"/>
-                      </a:pPr>
-                      <a:r>
-                        <a:t>[52402, 54515]</a:t>
-                      </a:r>
-                    </a:p>
-                  </a:txBody>
-                  <a:tcPr/>
-                </a:tc>
-                <a:tc>
-                  <a:txBody>
-                    <a:bodyPr/>
-                    <a:lstStyle/>
-                    <a:p>
-                      <a:pPr>
-                        <a:defRPr sz="1000"/>
-                      </a:pPr>
-                      <a:r>
-                        <a:t>30277</a:t>
-                      </a:r>
-                    </a:p>
-                  </a:txBody>
-                  <a:tcPr/>
-                </a:tc>
-                <a:tc>
-                  <a:txBody>
-                    <a:bodyPr/>
-                    <a:lstStyle/>
-                    <a:p>
-                      <a:pPr>
-                        <a:defRPr sz="1000"/>
-                      </a:pPr>
-                      <a:r>
-                        <a:t>[29348, 31258]</a:t>
-                      </a:r>
-                    </a:p>
-                  </a:txBody>
-                  <a:tcPr/>
-                </a:tc>
-              </a:tr>
-              <a:tr h="548640">
-                <a:tc>
-                  <a:txBody>
-                    <a:bodyPr/>
-                    <a:lstStyle/>
-                    <a:p>
-                      <a:pPr>
-                        <a:defRPr sz="1000"/>
-                      </a:pPr>
-                      <a:r>
-                        <a:t>Islamic</a:t>
-                      </a:r>
-                    </a:p>
-                  </a:txBody>
-                  <a:tcPr/>
-                </a:tc>
-                <a:tc>
-                  <a:txBody>
-                    <a:bodyPr/>
-                    <a:lstStyle/>
-                    <a:p>
-                      <a:pPr>
-                        <a:defRPr sz="1000"/>
-                      </a:pPr>
-                      <a:r>
-                        <a:t>88428</a:t>
-                      </a:r>
-                    </a:p>
-                  </a:txBody>
-                  <a:tcPr/>
-                </a:tc>
-                <a:tc>
-                  <a:txBody>
-                    <a:bodyPr/>
-                    <a:lstStyle/>
-                    <a:p>
-                      <a:pPr>
-                        <a:defRPr sz="1000"/>
-                      </a:pPr>
-                      <a:r>
-                        <a:t>[87356, 89880]</a:t>
-                      </a:r>
-                    </a:p>
-                  </a:txBody>
-                  <a:tcPr/>
-                </a:tc>
-                <a:tc>
-                  <a:txBody>
-                    <a:bodyPr/>
-                    <a:lstStyle/>
-                    <a:p>
-                      <a:pPr>
-                        <a:defRPr sz="1000"/>
-                      </a:pPr>
-                      <a:r>
-                        <a:t>47264</a:t>
-                      </a:r>
-                    </a:p>
-                  </a:txBody>
-                  <a:tcPr/>
-                </a:tc>
-                <a:tc>
-                  <a:txBody>
-                    <a:bodyPr/>
-                    <a:lstStyle/>
-                    <a:p>
-                      <a:pPr>
-                        <a:defRPr sz="1000"/>
-                      </a:pPr>
-                      <a:r>
-                        <a:t>[46155, 48511]</a:t>
-                      </a:r>
-                    </a:p>
-                  </a:txBody>
-                  <a:tcPr/>
-                </a:tc>
-              </a:tr>
-              <a:tr h="548640">
-                <a:tc>
-                  <a:txBody>
-                    <a:bodyPr/>
-                    <a:lstStyle/>
-                    <a:p>
-                      <a:pPr>
-                        <a:defRPr sz="1000"/>
-                      </a:pPr>
-                      <a:r>
-                        <a:t>Japanese</a:t>
-                      </a:r>
-                    </a:p>
-                  </a:txBody>
-                  <a:tcPr/>
-                </a:tc>
-                <a:tc>
-                  <a:txBody>
-                    <a:bodyPr/>
-                    <a:lstStyle/>
-                    <a:p>
-                      <a:pPr>
-                        <a:defRPr sz="1000"/>
-                      </a:pPr>
-                      <a:r>
-                        <a:t>29372</a:t>
-                      </a:r>
-                    </a:p>
-                  </a:txBody>
-                  <a:tcPr/>
-                </a:tc>
-                <a:tc>
-                  <a:txBody>
-                    <a:bodyPr/>
-                    <a:lstStyle/>
-                    <a:p>
-                      <a:pPr>
-                        <a:defRPr sz="1000"/>
-                      </a:pPr>
-                      <a:r>
-                        <a:t>[28932, 29757]</a:t>
-                      </a:r>
-                    </a:p>
-                  </a:txBody>
-                  <a:tcPr/>
-                </a:tc>
-                <a:tc>
-                  <a:txBody>
-                    <a:bodyPr/>
-                    <a:lstStyle/>
-                    <a:p>
-                      <a:pPr>
-                        <a:defRPr sz="1000"/>
-                      </a:pPr>
-                      <a:r>
-                        <a:t>7387</a:t>
-                      </a:r>
-                    </a:p>
-                  </a:txBody>
-                  <a:tcPr/>
-                </a:tc>
-                <a:tc>
-                  <a:txBody>
-                    <a:bodyPr/>
-                    <a:lstStyle/>
-                    <a:p>
-                      <a:pPr>
-                        <a:defRPr sz="1000"/>
-                      </a:pPr>
-                      <a:r>
-                        <a:t>[7128, 7662]</a:t>
-                      </a:r>
-                    </a:p>
-                  </a:txBody>
-                  <a:tcPr/>
-                </a:tc>
-              </a:tr>
-              <a:tr h="548640">
-                <a:tc>
-                  <a:txBody>
-                    <a:bodyPr/>
-                    <a:lstStyle/>
-                    <a:p>
-                      <a:pPr>
-                        <a:defRPr sz="1000"/>
-                      </a:pPr>
-                      <a:r>
-                        <a:t>Other Civilizations</a:t>
-                      </a:r>
-                    </a:p>
-                  </a:txBody>
-                  <a:tcPr/>
-                </a:tc>
-                <a:tc>
-                  <a:txBody>
-                    <a:bodyPr/>
-                    <a:lstStyle/>
-                    <a:p>
-                      <a:pPr>
-                        <a:defRPr sz="1000"/>
-                      </a:pPr>
-                      <a:r>
-                        <a:t>59396</a:t>
-                      </a:r>
-                    </a:p>
-                  </a:txBody>
-                  <a:tcPr/>
-                </a:tc>
-                <a:tc>
-                  <a:txBody>
-                    <a:bodyPr/>
-                    <a:lstStyle/>
-                    <a:p>
-                      <a:pPr>
-                        <a:defRPr sz="1000"/>
-                      </a:pPr>
-                      <a:r>
-                        <a:t>[58590, 60178]</a:t>
-                      </a:r>
-                    </a:p>
-                  </a:txBody>
-                  <a:tcPr/>
-                </a:tc>
-                <a:tc>
-                  <a:txBody>
-                    <a:bodyPr/>
-                    <a:lstStyle/>
-                    <a:p>
-                      <a:pPr>
-                        <a:defRPr sz="1000"/>
-                      </a:pPr>
-                      <a:r>
-                        <a:t>22326</a:t>
-                      </a:r>
-                    </a:p>
-                  </a:txBody>
-                  <a:tcPr/>
-                </a:tc>
-                <a:tc>
-                  <a:txBody>
-                    <a:bodyPr/>
-                    <a:lstStyle/>
-                    <a:p>
-                      <a:pPr>
-                        <a:defRPr sz="1000"/>
-                      </a:pPr>
-                      <a:r>
-                        <a:t>[21715, 22975]</a:t>
-                      </a:r>
-                    </a:p>
-                  </a:txBody>
-                  <a:tcPr/>
-                </a:tc>
-              </a:tr>
-              <a:tr h="548640">
-                <a:tc>
-                  <a:txBody>
-                    <a:bodyPr/>
-                    <a:lstStyle/>
-                    <a:p>
-                      <a:pPr>
-                        <a:defRPr sz="1000"/>
-                      </a:pPr>
-                      <a:r>
-                        <a:t>Other Western</a:t>
-                      </a:r>
-                    </a:p>
-                  </a:txBody>
-                  <a:tcPr/>
-                </a:tc>
-                <a:tc>
-                  <a:txBody>
-                    <a:bodyPr/>
-                    <a:lstStyle/>
-                    <a:p>
-                      <a:pPr>
-                        <a:defRPr sz="1000"/>
-                      </a:pPr>
-                      <a:r>
-                        <a:t>4829</a:t>
-                      </a:r>
-                    </a:p>
-                  </a:txBody>
-                  <a:tcPr/>
-                </a:tc>
-                <a:tc>
-                  <a:txBody>
-                    <a:bodyPr/>
-                    <a:lstStyle/>
-                    <a:p>
-                      <a:pPr>
-                        <a:defRPr sz="1000"/>
-                      </a:pPr>
-                      <a:r>
-                        <a:t>[4602, 5077]</a:t>
-                      </a:r>
-                    </a:p>
-                  </a:txBody>
-                  <a:tcPr/>
-                </a:tc>
-                <a:tc>
-                  <a:txBody>
-                    <a:bodyPr/>
-                    <a:lstStyle/>
-                    <a:p>
-                      <a:pPr>
-                        <a:defRPr sz="1000"/>
-                      </a:pPr>
-                      <a:r>
-                        <a:t>2163</a:t>
-                      </a:r>
-                    </a:p>
-                  </a:txBody>
-                  <a:tcPr/>
-                </a:tc>
-                <a:tc>
-                  <a:txBody>
-                    <a:bodyPr/>
-                    <a:lstStyle/>
-                    <a:p>
-                      <a:pPr>
-                        <a:defRPr sz="1000"/>
-                      </a:pPr>
-                      <a:r>
-                        <a:t>[1981, 2370]</a:t>
-                      </a:r>
-                    </a:p>
-                  </a:txBody>
-                  <a:tcPr/>
-                </a:tc>
-              </a:tr>
-              <a:tr h="548640">
-                <a:tc>
-                  <a:txBody>
-                    <a:bodyPr/>
-                    <a:lstStyle/>
-                    <a:p>
-                      <a:pPr>
-                        <a:defRPr sz="1000"/>
-                      </a:pPr>
-                      <a:r>
-                        <a:t>Sinic</a:t>
-                      </a:r>
-                    </a:p>
-                  </a:txBody>
-                  <a:tcPr/>
-                </a:tc>
-                <a:tc>
-                  <a:txBody>
-                    <a:bodyPr/>
-                    <a:lstStyle/>
-                    <a:p>
-                      <a:pPr>
-                        <a:defRPr sz="1000"/>
-                      </a:pPr>
-                      <a:r>
-                        <a:t>303843</a:t>
-                      </a:r>
-                    </a:p>
-                  </a:txBody>
-                  <a:tcPr/>
-                </a:tc>
-                <a:tc>
-                  <a:txBody>
-                    <a:bodyPr/>
-                    <a:lstStyle/>
-                    <a:p>
-                      <a:pPr>
-                        <a:defRPr sz="1000"/>
-                      </a:pPr>
-                      <a:r>
-                        <a:t>[301809, 305720]</a:t>
-                      </a:r>
-                    </a:p>
-                  </a:txBody>
-                  <a:tcPr/>
-                </a:tc>
-                <a:tc>
-                  <a:txBody>
-                    <a:bodyPr/>
-                    <a:lstStyle/>
-                    <a:p>
-                      <a:pPr>
-                        <a:defRPr sz="1000"/>
-                      </a:pPr>
-                      <a:r>
-                        <a:t>133015</a:t>
-                      </a:r>
-                    </a:p>
-                  </a:txBody>
-                  <a:tcPr/>
-                </a:tc>
-                <a:tc>
-                  <a:txBody>
-                    <a:bodyPr/>
-                    <a:lstStyle/>
-                    <a:p>
-                      <a:pPr>
-                        <a:defRPr sz="1000"/>
-                      </a:pPr>
-                      <a:r>
-                        <a:t>[131418, 134567]</a:t>
-                      </a:r>
-                    </a:p>
-                  </a:txBody>
-                  <a:tcPr/>
-                </a:tc>
-              </a:tr>
-              <a:tr h="548640">
-                <a:tc>
-                  <a:txBody>
-                    <a:bodyPr/>
-                    <a:lstStyle/>
-                    <a:p>
-                      <a:pPr>
-                        <a:defRPr sz="1000"/>
-                      </a:pPr>
-                      <a:r>
-                        <a:t>United States</a:t>
-                      </a:r>
-                    </a:p>
-                  </a:txBody>
-                  <a:tcPr/>
-                </a:tc>
-                <a:tc>
-                  <a:txBody>
-                    <a:bodyPr/>
-                    <a:lstStyle/>
-                    <a:p>
-                      <a:pPr>
-                        <a:defRPr sz="1000"/>
-                      </a:pPr>
-                      <a:r>
-                        <a:t>146991</a:t>
-                      </a:r>
-                    </a:p>
-                  </a:txBody>
-                  <a:tcPr/>
-                </a:tc>
-                <a:tc>
-                  <a:txBody>
-                    <a:bodyPr/>
-                    <a:lstStyle/>
-                    <a:p>
-                      <a:pPr>
-                        <a:defRPr sz="1000"/>
-                      </a:pPr>
-                      <a:r>
-                        <a:t>[145947, 148235]</a:t>
-                      </a:r>
-                    </a:p>
-                  </a:txBody>
-                  <a:tcPr/>
-                </a:tc>
-                <a:tc>
-                  <a:txBody>
-                    <a:bodyPr/>
-                    <a:lstStyle/>
-                    <a:p>
-                      <a:pPr>
-                        <a:defRPr sz="1000"/>
-                      </a:pPr>
-                      <a:r>
-                        <a:t>63906</a:t>
-                      </a:r>
-                    </a:p>
-                  </a:txBody>
-                  <a:tcPr/>
-                </a:tc>
-                <a:tc>
-                  <a:txBody>
-                    <a:bodyPr/>
-                    <a:lstStyle/>
-                    <a:p>
-                      <a:pPr>
-                        <a:defRPr sz="1000"/>
-                      </a:pPr>
-                      <a:r>
-                        <a:t>[62994, 64906]</a:t>
-                      </a:r>
-                    </a:p>
-                  </a:txBody>
-                  <a:tcPr/>
-                </a:tc>
-              </a:tr>
-            </a:tbl>
-          </a:graphicData>
-        </a:graphic>
-      </p:graphicFrame>
-    </p:spTree>
-  </p:cSld>
-  <p:clrMapOvr>
-    <a:masterClrMapping/>
-  </p:clrMapOvr>
-</p:sld>
-</file>
-
-<file path=ppt/slides/slide15.xml><?xml version="1.0" encoding="utf-8"?>
 <p:sld xmlns:a="http://schemas.openxmlformats.org/drawingml/2006/main" xmlns:p="http://schemas.openxmlformats.org/presentationml/2006/main" xmlns:r="http://schemas.openxmlformats.org/officeDocument/2006/relationships">
   <p:cSld>
     <p:spTree>
@@ -8125,7 +7268,7 @@
 </p:sld>
 </file>
 
-<file path=ppt/slides/slide16.xml><?xml version="1.0" encoding="utf-8"?>
+<file path=ppt/slides/slide15.xml><?xml version="1.0" encoding="utf-8"?>
 <p:sld xmlns:a="http://schemas.openxmlformats.org/drawingml/2006/main" xmlns:p="http://schemas.openxmlformats.org/presentationml/2006/main" xmlns:r="http://schemas.openxmlformats.org/officeDocument/2006/relationships">
   <p:cSld>
     <p:spTree>
@@ -8253,7 +7396,7 @@
 </p:sld>
 </file>
 
-<file path=ppt/slides/slide17.xml><?xml version="1.0" encoding="utf-8"?>
+<file path=ppt/slides/slide16.xml><?xml version="1.0" encoding="utf-8"?>
 <p:sld xmlns:a="http://schemas.openxmlformats.org/drawingml/2006/main" xmlns:p="http://schemas.openxmlformats.org/presentationml/2006/main" xmlns:r="http://schemas.openxmlformats.org/officeDocument/2006/relationships">
   <p:cSld>
     <p:spTree>
@@ -8381,7 +7524,7 @@
 </p:sld>
 </file>
 
-<file path=ppt/slides/slide18.xml><?xml version="1.0" encoding="utf-8"?>
+<file path=ppt/slides/slide17.xml><?xml version="1.0" encoding="utf-8"?>
 <p:sld xmlns:a="http://schemas.openxmlformats.org/drawingml/2006/main" xmlns:p="http://schemas.openxmlformats.org/presentationml/2006/main" xmlns:r="http://schemas.openxmlformats.org/officeDocument/2006/relationships">
   <p:cSld>
     <p:spTree>
@@ -8509,7 +7652,7 @@
 </p:sld>
 </file>
 
-<file path=ppt/slides/slide19.xml><?xml version="1.0" encoding="utf-8"?>
+<file path=ppt/slides/slide18.xml><?xml version="1.0" encoding="utf-8"?>
 <p:sld xmlns:a="http://schemas.openxmlformats.org/drawingml/2006/main" xmlns:p="http://schemas.openxmlformats.org/presentationml/2006/main" xmlns:r="http://schemas.openxmlformats.org/officeDocument/2006/relationships">
   <p:cSld>
     <p:spTree>
@@ -8629,6 +7772,1159 @@
           </a:p>
         </p:txBody>
       </p:sp>
+    </p:spTree>
+  </p:cSld>
+  <p:clrMapOvr>
+    <a:masterClrMapping/>
+  </p:clrMapOvr>
+</p:sld>
+</file>
+
+<file path=ppt/slides/slide19.xml><?xml version="1.0" encoding="utf-8"?>
+<p:sld xmlns:a="http://schemas.openxmlformats.org/drawingml/2006/main" xmlns:p="http://schemas.openxmlformats.org/presentationml/2006/main" xmlns:r="http://schemas.openxmlformats.org/officeDocument/2006/relationships">
+  <p:cSld>
+    <p:spTree>
+      <p:nvGrpSpPr>
+        <p:cNvPr id="1" name=""/>
+        <p:cNvGrpSpPr/>
+        <p:nvPr/>
+      </p:nvGrpSpPr>
+      <p:grpSpPr/>
+      <p:sp>
+        <p:nvSpPr>
+          <p:cNvPr id="2" name="Title 1"/>
+          <p:cNvSpPr>
+            <a:spLocks noGrp="1"/>
+          </p:cNvSpPr>
+          <p:nvPr>
+            <p:ph type="title"/>
+          </p:nvPr>
+        </p:nvSpPr>
+        <p:spPr/>
+        <p:txBody>
+          <a:bodyPr/>
+          <a:lstStyle/>
+          <a:p>
+            <a:r>
+              <a:t>Supplementary Table 3: Mean observed annual transition rates, 2000-2016</a:t>
+            </a:r>
+          </a:p>
+        </p:txBody>
+      </p:sp>
+      <p:sp>
+        <p:nvSpPr>
+          <p:cNvPr id="3" name="Content Placeholder 2"/>
+          <p:cNvSpPr>
+            <a:spLocks noGrp="1"/>
+          </p:cNvSpPr>
+          <p:nvPr>
+            <p:ph idx="1" sz="half"/>
+          </p:nvPr>
+        </p:nvSpPr>
+        <p:spPr/>
+        <p:txBody>
+          <a:bodyPr/>
+          <a:lstStyle/>
+          <a:p/>
+        </p:txBody>
+      </p:sp>
+      <p:sp>
+        <p:nvSpPr>
+          <p:cNvPr id="4" name="Content Placeholder 3"/>
+          <p:cNvSpPr>
+            <a:spLocks noGrp="1"/>
+          </p:cNvSpPr>
+          <p:nvPr>
+            <p:ph idx="2" sz="half"/>
+          </p:nvPr>
+        </p:nvSpPr>
+        <p:spPr/>
+        <p:txBody>
+          <a:bodyPr/>
+          <a:lstStyle/>
+          <a:p/>
+        </p:txBody>
+      </p:sp>
+      <p:graphicFrame>
+        <p:nvGraphicFramePr>
+          <p:cNvPr id="5" name="Table 4"/>
+          <p:cNvGraphicFramePr>
+            <a:graphicFrameLocks noGrp="1"/>
+          </p:cNvGraphicFramePr>
+          <p:nvPr/>
+        </p:nvGraphicFramePr>
+        <p:xfrm>
+          <a:off x="457200" y="1097280"/>
+          <a:ext cx="8961119" cy="5486400"/>
+        </p:xfrm>
+        <a:graphic>
+          <a:graphicData uri="http://schemas.openxmlformats.org/drawingml/2006/table">
+            <a:tbl>
+              <a:tblPr firstRow="1" bandRow="1">
+                <a:tableStyleId>{5C22544A-7EE6-4342-B048-85BDC9FD1C3A}</a:tableStyleId>
+              </a:tblPr>
+              <a:tblGrid>
+                <a:gridCol w="1280159"/>
+                <a:gridCol w="1280159"/>
+                <a:gridCol w="1280159"/>
+                <a:gridCol w="1280159"/>
+                <a:gridCol w="1280159"/>
+                <a:gridCol w="1280159"/>
+                <a:gridCol w="1280165"/>
+              </a:tblGrid>
+              <a:tr h="548640">
+                <a:tc>
+                  <a:txBody>
+                    <a:bodyPr/>
+                    <a:lstStyle/>
+                    <a:p>
+                      <a:r>
+                        <a:t>Group</a:t>
+                      </a:r>
+                    </a:p>
+                  </a:txBody>
+                  <a:tcPr/>
+                </a:tc>
+                <a:tc>
+                  <a:txBody>
+                    <a:bodyPr/>
+                    <a:lstStyle/>
+                    <a:p>
+                      <a:r>
+                        <a:t>α</a:t>
+                      </a:r>
+                    </a:p>
+                  </a:txBody>
+                  <a:tcPr/>
+                </a:tc>
+                <a:tc>
+                  <a:txBody>
+                    <a:bodyPr/>
+                    <a:lstStyle/>
+                    <a:p>
+                      <a:r>
+                        <a:t>β</a:t>
+                      </a:r>
+                    </a:p>
+                  </a:txBody>
+                  <a:tcPr/>
+                </a:tc>
+                <a:tc>
+                  <a:txBody>
+                    <a:bodyPr/>
+                    <a:lstStyle/>
+                    <a:p>
+                      <a:r>
+                        <a:t>h_D</a:t>
+                      </a:r>
+                    </a:p>
+                  </a:txBody>
+                  <a:tcPr/>
+                </a:tc>
+                <a:tc>
+                  <a:txBody>
+                    <a:bodyPr/>
+                    <a:lstStyle/>
+                    <a:p>
+                      <a:r>
+                        <a:t>p_D</a:t>
+                      </a:r>
+                    </a:p>
+                  </a:txBody>
+                  <a:tcPr/>
+                </a:tc>
+                <a:tc>
+                  <a:txBody>
+                    <a:bodyPr/>
+                    <a:lstStyle/>
+                    <a:p>
+                      <a:r>
+                        <a:t>d</a:t>
+                      </a:r>
+                    </a:p>
+                  </a:txBody>
+                  <a:tcPr/>
+                </a:tc>
+                <a:tc>
+                  <a:txBody>
+                    <a:bodyPr/>
+                    <a:lstStyle/>
+                    <a:p>
+                      <a:r>
+                        <a:t>I_total</a:t>
+                      </a:r>
+                    </a:p>
+                  </a:txBody>
+                  <a:tcPr/>
+                </a:tc>
+              </a:tr>
+              <a:tr h="548640">
+                <a:tc>
+                  <a:txBody>
+                    <a:bodyPr/>
+                    <a:lstStyle/>
+                    <a:p>
+                      <a:pPr>
+                        <a:defRPr sz="1000"/>
+                      </a:pPr>
+                      <a:r>
+                        <a:t>Anglosphere ex-US</a:t>
+                      </a:r>
+                    </a:p>
+                  </a:txBody>
+                  <a:tcPr/>
+                </a:tc>
+                <a:tc>
+                  <a:txBody>
+                    <a:bodyPr/>
+                    <a:lstStyle/>
+                    <a:p>
+                      <a:pPr>
+                        <a:defRPr sz="1000"/>
+                      </a:pPr>
+                      <a:r>
+                        <a:t>0.011625124450015864</a:t>
+                      </a:r>
+                    </a:p>
+                  </a:txBody>
+                  <a:tcPr/>
+                </a:tc>
+                <a:tc>
+                  <a:txBody>
+                    <a:bodyPr/>
+                    <a:lstStyle/>
+                    <a:p>
+                      <a:pPr>
+                        <a:defRPr sz="1000"/>
+                      </a:pPr>
+                      <a:r>
+                        <a:t>0.03411253799743315</a:t>
+                      </a:r>
+                    </a:p>
+                  </a:txBody>
+                  <a:tcPr/>
+                </a:tc>
+                <a:tc>
+                  <a:txBody>
+                    <a:bodyPr/>
+                    <a:lstStyle/>
+                    <a:p>
+                      <a:pPr>
+                        <a:defRPr sz="1000"/>
+                      </a:pPr>
+                      <a:r>
+                        <a:t>0.04616211641533843</a:t>
+                      </a:r>
+                    </a:p>
+                  </a:txBody>
+                  <a:tcPr/>
+                </a:tc>
+                <a:tc>
+                  <a:txBody>
+                    <a:bodyPr/>
+                    <a:lstStyle/>
+                    <a:p>
+                      <a:pPr>
+                        <a:defRPr sz="1000"/>
+                      </a:pPr>
+                      <a:r>
+                        <a:t>0.0873092000485382</a:t>
+                      </a:r>
+                    </a:p>
+                  </a:txBody>
+                  <a:tcPr/>
+                </a:tc>
+                <a:tc>
+                  <a:txBody>
+                    <a:bodyPr/>
+                    <a:lstStyle/>
+                    <a:p>
+                      <a:pPr>
+                        <a:defRPr sz="1000"/>
+                      </a:pPr>
+                      <a:r>
+                        <a:t>0.0456012888273175</a:t>
+                      </a:r>
+                    </a:p>
+                  </a:txBody>
+                  <a:tcPr/>
+                </a:tc>
+                <a:tc>
+                  <a:txBody>
+                    <a:bodyPr/>
+                    <a:lstStyle/>
+                    <a:p>
+                      <a:pPr>
+                        <a:defRPr sz="1000"/>
+                      </a:pPr>
+                      <a:r>
+                        <a:t>3771.8823529411766</a:t>
+                      </a:r>
+                    </a:p>
+                  </a:txBody>
+                  <a:tcPr/>
+                </a:tc>
+              </a:tr>
+              <a:tr h="548640">
+                <a:tc>
+                  <a:txBody>
+                    <a:bodyPr/>
+                    <a:lstStyle/>
+                    <a:p>
+                      <a:pPr>
+                        <a:defRPr sz="1000"/>
+                      </a:pPr>
+                      <a:r>
+                        <a:t>Continental Europe</a:t>
+                      </a:r>
+                    </a:p>
+                  </a:txBody>
+                  <a:tcPr/>
+                </a:tc>
+                <a:tc>
+                  <a:txBody>
+                    <a:bodyPr/>
+                    <a:lstStyle/>
+                    <a:p>
+                      <a:pPr>
+                        <a:defRPr sz="1000"/>
+                      </a:pPr>
+                      <a:r>
+                        <a:t>0.006761991119387412</a:t>
+                      </a:r>
+                    </a:p>
+                  </a:txBody>
+                  <a:tcPr/>
+                </a:tc>
+                <a:tc>
+                  <a:txBody>
+                    <a:bodyPr/>
+                    <a:lstStyle/>
+                    <a:p>
+                      <a:pPr>
+                        <a:defRPr sz="1000"/>
+                      </a:pPr>
+                      <a:r>
+                        <a:t>0.035799512585035644</a:t>
+                      </a:r>
+                    </a:p>
+                  </a:txBody>
+                  <a:tcPr/>
+                </a:tc>
+                <a:tc>
+                  <a:txBody>
+                    <a:bodyPr/>
+                    <a:lstStyle/>
+                    <a:p>
+                      <a:pPr>
+                        <a:defRPr sz="1000"/>
+                      </a:pPr>
+                      <a:r>
+                        <a:t>0.05094340242156166</a:t>
+                      </a:r>
+                    </a:p>
+                  </a:txBody>
+                  <a:tcPr/>
+                </a:tc>
+                <a:tc>
+                  <a:txBody>
+                    <a:bodyPr/>
+                    <a:lstStyle/>
+                    <a:p>
+                      <a:pPr>
+                        <a:defRPr sz="1000"/>
+                      </a:pPr>
+                      <a:r>
+                        <a:t>0.09422625853124332</a:t>
+                      </a:r>
+                    </a:p>
+                  </a:txBody>
+                  <a:tcPr/>
+                </a:tc>
+                <a:tc>
+                  <a:txBody>
+                    <a:bodyPr/>
+                    <a:lstStyle/>
+                    <a:p>
+                      <a:pPr>
+                        <a:defRPr sz="1000"/>
+                      </a:pPr>
+                      <a:r>
+                        <a:t>0.0458472850546197</a:t>
+                      </a:r>
+                    </a:p>
+                  </a:txBody>
+                  <a:tcPr/>
+                </a:tc>
+                <a:tc>
+                  <a:txBody>
+                    <a:bodyPr/>
+                    <a:lstStyle/>
+                    <a:p>
+                      <a:pPr>
+                        <a:defRPr sz="1000"/>
+                      </a:pPr>
+                      <a:r>
+                        <a:t>9935.941176470587</a:t>
+                      </a:r>
+                    </a:p>
+                  </a:txBody>
+                  <a:tcPr/>
+                </a:tc>
+              </a:tr>
+              <a:tr h="548640">
+                <a:tc>
+                  <a:txBody>
+                    <a:bodyPr/>
+                    <a:lstStyle/>
+                    <a:p>
+                      <a:pPr>
+                        <a:defRPr sz="1000"/>
+                      </a:pPr>
+                      <a:r>
+                        <a:t>Hindu</a:t>
+                      </a:r>
+                    </a:p>
+                  </a:txBody>
+                  <a:tcPr/>
+                </a:tc>
+                <a:tc>
+                  <a:txBody>
+                    <a:bodyPr/>
+                    <a:lstStyle/>
+                    <a:p>
+                      <a:pPr>
+                        <a:defRPr sz="1000"/>
+                      </a:pPr>
+                      <a:r>
+                        <a:t>0.008630402595531753</a:t>
+                      </a:r>
+                    </a:p>
+                  </a:txBody>
+                  <a:tcPr/>
+                </a:tc>
+                <a:tc>
+                  <a:txBody>
+                    <a:bodyPr/>
+                    <a:lstStyle/>
+                    <a:p>
+                      <a:pPr>
+                        <a:defRPr sz="1000"/>
+                      </a:pPr>
+                      <a:r>
+                        <a:t>0.03299680283228205</a:t>
+                      </a:r>
+                    </a:p>
+                  </a:txBody>
+                  <a:tcPr/>
+                </a:tc>
+                <a:tc>
+                  <a:txBody>
+                    <a:bodyPr/>
+                    <a:lstStyle/>
+                    <a:p>
+                      <a:pPr>
+                        <a:defRPr sz="1000"/>
+                      </a:pPr>
+                      <a:r>
+                        <a:t>0.02691431106611553</a:t>
+                      </a:r>
+                    </a:p>
+                  </a:txBody>
+                  <a:tcPr/>
+                </a:tc>
+                <a:tc>
+                  <a:txBody>
+                    <a:bodyPr/>
+                    <a:lstStyle/>
+                    <a:p>
+                      <a:pPr>
+                        <a:defRPr sz="1000"/>
+                      </a:pPr>
+                      <a:r>
+                        <a:t>0.08241584203083246</a:t>
+                      </a:r>
+                    </a:p>
+                  </a:txBody>
+                  <a:tcPr/>
+                </a:tc>
+                <a:tc>
+                  <a:txBody>
+                    <a:bodyPr/>
+                    <a:lstStyle/>
+                    <a:p>
+                      <a:pPr>
+                        <a:defRPr sz="1000"/>
+                      </a:pPr>
+                      <a:r>
+                        <a:t>0.0277057844536427</a:t>
+                      </a:r>
+                    </a:p>
+                  </a:txBody>
+                  <a:tcPr/>
+                </a:tc>
+                <a:tc>
+                  <a:txBody>
+                    <a:bodyPr/>
+                    <a:lstStyle/>
+                    <a:p>
+                      <a:pPr>
+                        <a:defRPr sz="1000"/>
+                      </a:pPr>
+                      <a:r>
+                        <a:t>1651.1176470588234</a:t>
+                      </a:r>
+                    </a:p>
+                  </a:txBody>
+                  <a:tcPr/>
+                </a:tc>
+              </a:tr>
+              <a:tr h="548640">
+                <a:tc>
+                  <a:txBody>
+                    <a:bodyPr/>
+                    <a:lstStyle/>
+                    <a:p>
+                      <a:pPr>
+                        <a:defRPr sz="1000"/>
+                      </a:pPr>
+                      <a:r>
+                        <a:t>Islamic</a:t>
+                      </a:r>
+                    </a:p>
+                  </a:txBody>
+                  <a:tcPr/>
+                </a:tc>
+                <a:tc>
+                  <a:txBody>
+                    <a:bodyPr/>
+                    <a:lstStyle/>
+                    <a:p>
+                      <a:pPr>
+                        <a:defRPr sz="1000"/>
+                      </a:pPr>
+                      <a:r>
+                        <a:t>0.012666046927368129</a:t>
+                      </a:r>
+                    </a:p>
+                  </a:txBody>
+                  <a:tcPr/>
+                </a:tc>
+                <a:tc>
+                  <a:txBody>
+                    <a:bodyPr/>
+                    <a:lstStyle/>
+                    <a:p>
+                      <a:pPr>
+                        <a:defRPr sz="1000"/>
+                      </a:pPr>
+                      <a:r>
+                        <a:t>0.038401582840796256</a:t>
+                      </a:r>
+                    </a:p>
+                  </a:txBody>
+                  <a:tcPr/>
+                </a:tc>
+                <a:tc>
+                  <a:txBody>
+                    <a:bodyPr/>
+                    <a:lstStyle/>
+                    <a:p>
+                      <a:pPr>
+                        <a:defRPr sz="1000"/>
+                      </a:pPr>
+                      <a:r>
+                        <a:t>0.025445116702978474</a:t>
+                      </a:r>
+                    </a:p>
+                  </a:txBody>
+                  <a:tcPr/>
+                </a:tc>
+                <a:tc>
+                  <a:txBody>
+                    <a:bodyPr/>
+                    <a:lstStyle/>
+                    <a:p>
+                      <a:pPr>
+                        <a:defRPr sz="1000"/>
+                      </a:pPr>
+                      <a:r>
+                        <a:t>0.09498790956874537</a:t>
+                      </a:r>
+                    </a:p>
+                  </a:txBody>
+                  <a:tcPr/>
+                </a:tc>
+                <a:tc>
+                  <a:txBody>
+                    <a:bodyPr/>
+                    <a:lstStyle/>
+                    <a:p>
+                      <a:pPr>
+                        <a:defRPr sz="1000"/>
+                      </a:pPr>
+                      <a:r>
+                        <a:t>0.0300792155414555</a:t>
+                      </a:r>
+                    </a:p>
+                  </a:txBody>
+                  <a:tcPr/>
+                </a:tc>
+                <a:tc>
+                  <a:txBody>
+                    <a:bodyPr/>
+                    <a:lstStyle/>
+                    <a:p>
+                      <a:pPr>
+                        <a:defRPr sz="1000"/>
+                      </a:pPr>
+                      <a:r>
+                        <a:t>3002.529411764706</a:t>
+                      </a:r>
+                    </a:p>
+                  </a:txBody>
+                  <a:tcPr/>
+                </a:tc>
+              </a:tr>
+              <a:tr h="548640">
+                <a:tc>
+                  <a:txBody>
+                    <a:bodyPr/>
+                    <a:lstStyle/>
+                    <a:p>
+                      <a:pPr>
+                        <a:defRPr sz="1000"/>
+                      </a:pPr>
+                      <a:r>
+                        <a:t>Japanese</a:t>
+                      </a:r>
+                    </a:p>
+                  </a:txBody>
+                  <a:tcPr/>
+                </a:tc>
+                <a:tc>
+                  <a:txBody>
+                    <a:bodyPr/>
+                    <a:lstStyle/>
+                    <a:p>
+                      <a:pPr>
+                        <a:defRPr sz="1000"/>
+                      </a:pPr>
+                      <a:r>
+                        <a:t>0.006917679672886924</a:t>
+                      </a:r>
+                    </a:p>
+                  </a:txBody>
+                  <a:tcPr/>
+                </a:tc>
+                <a:tc>
+                  <a:txBody>
+                    <a:bodyPr/>
+                    <a:lstStyle/>
+                    <a:p>
+                      <a:pPr>
+                        <a:defRPr sz="1000"/>
+                      </a:pPr>
+                      <a:r>
+                        <a:t>0.037602085739115054</a:t>
+                      </a:r>
+                    </a:p>
+                  </a:txBody>
+                  <a:tcPr/>
+                </a:tc>
+                <a:tc>
+                  <a:txBody>
+                    <a:bodyPr/>
+                    <a:lstStyle/>
+                    <a:p>
+                      <a:pPr>
+                        <a:defRPr sz="1000"/>
+                      </a:pPr>
+                      <a:r>
+                        <a:t>0.02367889326887788</a:t>
+                      </a:r>
+                    </a:p>
+                  </a:txBody>
+                  <a:tcPr/>
+                </a:tc>
+                <a:tc>
+                  <a:txBody>
+                    <a:bodyPr/>
+                    <a:lstStyle/>
+                    <a:p>
+                      <a:pPr>
+                        <a:defRPr sz="1000"/>
+                      </a:pPr>
+                      <a:r>
+                        <a:t>0.06960468807321192</a:t>
+                      </a:r>
+                    </a:p>
+                  </a:txBody>
+                  <a:tcPr/>
+                </a:tc>
+                <a:tc>
+                  <a:txBody>
+                    <a:bodyPr/>
+                    <a:lstStyle/>
+                    <a:p>
+                      <a:pPr>
+                        <a:defRPr sz="1000"/>
+                      </a:pPr>
+                      <a:r>
+                        <a:t>0.0552190245713187</a:t>
+                      </a:r>
+                    </a:p>
+                  </a:txBody>
+                  <a:tcPr/>
+                </a:tc>
+                <a:tc>
+                  <a:txBody>
+                    <a:bodyPr/>
+                    <a:lstStyle/>
+                    <a:p>
+                      <a:pPr>
+                        <a:defRPr sz="1000"/>
+                      </a:pPr>
+                      <a:r>
+                        <a:t>1882.764705882353</a:t>
+                      </a:r>
+                    </a:p>
+                  </a:txBody>
+                  <a:tcPr/>
+                </a:tc>
+              </a:tr>
+              <a:tr h="548640">
+                <a:tc>
+                  <a:txBody>
+                    <a:bodyPr/>
+                    <a:lstStyle/>
+                    <a:p>
+                      <a:pPr>
+                        <a:defRPr sz="1000"/>
+                      </a:pPr>
+                      <a:r>
+                        <a:t>Other Civilizations</a:t>
+                      </a:r>
+                    </a:p>
+                  </a:txBody>
+                  <a:tcPr/>
+                </a:tc>
+                <a:tc>
+                  <a:txBody>
+                    <a:bodyPr/>
+                    <a:lstStyle/>
+                    <a:p>
+                      <a:pPr>
+                        <a:defRPr sz="1000"/>
+                      </a:pPr>
+                      <a:r>
+                        <a:t>0.009174917967806347</a:t>
+                      </a:r>
+                    </a:p>
+                  </a:txBody>
+                  <a:tcPr/>
+                </a:tc>
+                <a:tc>
+                  <a:txBody>
+                    <a:bodyPr/>
+                    <a:lstStyle/>
+                    <a:p>
+                      <a:pPr>
+                        <a:defRPr sz="1000"/>
+                      </a:pPr>
+                      <a:r>
+                        <a:t>0.034841303799186506</a:t>
+                      </a:r>
+                    </a:p>
+                  </a:txBody>
+                  <a:tcPr/>
+                </a:tc>
+                <a:tc>
+                  <a:txBody>
+                    <a:bodyPr/>
+                    <a:lstStyle/>
+                    <a:p>
+                      <a:pPr>
+                        <a:defRPr sz="1000"/>
+                      </a:pPr>
+                      <a:r>
+                        <a:t>0.025794413969593047</a:t>
+                      </a:r>
+                    </a:p>
+                  </a:txBody>
+                  <a:tcPr/>
+                </a:tc>
+                <a:tc>
+                  <a:txBody>
+                    <a:bodyPr/>
+                    <a:lstStyle/>
+                    <a:p>
+                      <a:pPr>
+                        <a:defRPr sz="1000"/>
+                      </a:pPr>
+                      <a:r>
+                        <a:t>0.07781467004902813</a:t>
+                      </a:r>
+                    </a:p>
+                  </a:txBody>
+                  <a:tcPr/>
+                </a:tc>
+                <a:tc>
+                  <a:txBody>
+                    <a:bodyPr/>
+                    <a:lstStyle/>
+                    <a:p>
+                      <a:pPr>
+                        <a:defRPr sz="1000"/>
+                      </a:pPr>
+                      <a:r>
+                        <a:t>0.0418088008437154</a:t>
+                      </a:r>
+                    </a:p>
+                  </a:txBody>
+                  <a:tcPr/>
+                </a:tc>
+                <a:tc>
+                  <a:txBody>
+                    <a:bodyPr/>
+                    <a:lstStyle/>
+                    <a:p>
+                      <a:pPr>
+                        <a:defRPr sz="1000"/>
+                      </a:pPr>
+                      <a:r>
+                        <a:t>2955.294117647059</a:t>
+                      </a:r>
+                    </a:p>
+                  </a:txBody>
+                  <a:tcPr/>
+                </a:tc>
+              </a:tr>
+              <a:tr h="548640">
+                <a:tc>
+                  <a:txBody>
+                    <a:bodyPr/>
+                    <a:lstStyle/>
+                    <a:p>
+                      <a:pPr>
+                        <a:defRPr sz="1000"/>
+                      </a:pPr>
+                      <a:r>
+                        <a:t>Other Western</a:t>
+                      </a:r>
+                    </a:p>
+                  </a:txBody>
+                  <a:tcPr/>
+                </a:tc>
+                <a:tc>
+                  <a:txBody>
+                    <a:bodyPr/>
+                    <a:lstStyle/>
+                    <a:p>
+                      <a:pPr>
+                        <a:defRPr sz="1000"/>
+                      </a:pPr>
+                      <a:r>
+                        <a:t>0.014804380291716199</a:t>
+                      </a:r>
+                    </a:p>
+                  </a:txBody>
+                  <a:tcPr/>
+                </a:tc>
+                <a:tc>
+                  <a:txBody>
+                    <a:bodyPr/>
+                    <a:lstStyle/>
+                    <a:p>
+                      <a:pPr>
+                        <a:defRPr sz="1000"/>
+                      </a:pPr>
+                      <a:r>
+                        <a:t>0.033386940704236284</a:t>
+                      </a:r>
+                    </a:p>
+                  </a:txBody>
+                  <a:tcPr/>
+                </a:tc>
+                <a:tc>
+                  <a:txBody>
+                    <a:bodyPr/>
+                    <a:lstStyle/>
+                    <a:p>
+                      <a:pPr>
+                        <a:defRPr sz="1000"/>
+                      </a:pPr>
+                      <a:r>
+                        <a:t>0.05892906512509506</a:t>
+                      </a:r>
+                    </a:p>
+                  </a:txBody>
+                  <a:tcPr/>
+                </a:tc>
+                <a:tc>
+                  <a:txBody>
+                    <a:bodyPr/>
+                    <a:lstStyle/>
+                    <a:p>
+                      <a:pPr>
+                        <a:defRPr sz="1000"/>
+                      </a:pPr>
+                      <a:r>
+                        <a:t>0.06798731834845337</a:t>
+                      </a:r>
+                    </a:p>
+                  </a:txBody>
+                  <a:tcPr/>
+                </a:tc>
+                <a:tc>
+                  <a:txBody>
+                    <a:bodyPr/>
+                    <a:lstStyle/>
+                    <a:p>
+                      <a:pPr>
+                        <a:defRPr sz="1000"/>
+                      </a:pPr>
+                      <a:r>
+                        <a:t>0.0442928225810436</a:t>
+                      </a:r>
+                    </a:p>
+                  </a:txBody>
+                  <a:tcPr/>
+                </a:tc>
+                <a:tc>
+                  <a:txBody>
+                    <a:bodyPr/>
+                    <a:lstStyle/>
+                    <a:p>
+                      <a:pPr>
+                        <a:defRPr sz="1000"/>
+                      </a:pPr>
+                      <a:r>
+                        <a:t>258.6470588235294</a:t>
+                      </a:r>
+                    </a:p>
+                  </a:txBody>
+                  <a:tcPr/>
+                </a:tc>
+              </a:tr>
+              <a:tr h="548640">
+                <a:tc>
+                  <a:txBody>
+                    <a:bodyPr/>
+                    <a:lstStyle/>
+                    <a:p>
+                      <a:pPr>
+                        <a:defRPr sz="1000"/>
+                      </a:pPr>
+                      <a:r>
+                        <a:t>Sinic</a:t>
+                      </a:r>
+                    </a:p>
+                  </a:txBody>
+                  <a:tcPr/>
+                </a:tc>
+                <a:tc>
+                  <a:txBody>
+                    <a:bodyPr/>
+                    <a:lstStyle/>
+                    <a:p>
+                      <a:pPr>
+                        <a:defRPr sz="1000"/>
+                      </a:pPr>
+                      <a:r>
+                        <a:t>0.0069463267399030824</a:t>
+                      </a:r>
+                    </a:p>
+                  </a:txBody>
+                  <a:tcPr/>
+                </a:tc>
+                <a:tc>
+                  <a:txBody>
+                    <a:bodyPr/>
+                    <a:lstStyle/>
+                    <a:p>
+                      <a:pPr>
+                        <a:defRPr sz="1000"/>
+                      </a:pPr>
+                      <a:r>
+                        <a:t>0.027227975340917476</a:t>
+                      </a:r>
+                    </a:p>
+                  </a:txBody>
+                  <a:tcPr/>
+                </a:tc>
+                <a:tc>
+                  <a:txBody>
+                    <a:bodyPr/>
+                    <a:lstStyle/>
+                    <a:p>
+                      <a:pPr>
+                        <a:defRPr sz="1000"/>
+                      </a:pPr>
+                      <a:r>
+                        <a:t>0.025975223591736964</a:t>
+                      </a:r>
+                    </a:p>
+                  </a:txBody>
+                  <a:tcPr/>
+                </a:tc>
+                <a:tc>
+                  <a:txBody>
+                    <a:bodyPr/>
+                    <a:lstStyle/>
+                    <a:p>
+                      <a:pPr>
+                        <a:defRPr sz="1000"/>
+                      </a:pPr>
+                      <a:r>
+                        <a:t>0.09085321057400796</a:t>
+                      </a:r>
+                    </a:p>
+                  </a:txBody>
+                  <a:tcPr/>
+                </a:tc>
+                <a:tc>
+                  <a:txBody>
+                    <a:bodyPr/>
+                    <a:lstStyle/>
+                    <a:p>
+                      <a:pPr>
+                        <a:defRPr sz="1000"/>
+                      </a:pPr>
+                      <a:r>
+                        <a:t>0.0336695344484046</a:t>
+                      </a:r>
+                    </a:p>
+                  </a:txBody>
+                  <a:tcPr/>
+                </a:tc>
+                <a:tc>
+                  <a:txBody>
+                    <a:bodyPr/>
+                    <a:lstStyle/>
+                    <a:p>
+                      <a:pPr>
+                        <a:defRPr sz="1000"/>
+                      </a:pPr>
+                      <a:r>
+                        <a:t>11179.470588235294</a:t>
+                      </a:r>
+                    </a:p>
+                  </a:txBody>
+                  <a:tcPr/>
+                </a:tc>
+              </a:tr>
+              <a:tr h="548640">
+                <a:tc>
+                  <a:txBody>
+                    <a:bodyPr/>
+                    <a:lstStyle/>
+                    <a:p>
+                      <a:pPr>
+                        <a:defRPr sz="1000"/>
+                      </a:pPr>
+                      <a:r>
+                        <a:t>United States</a:t>
+                      </a:r>
+                    </a:p>
+                  </a:txBody>
+                  <a:tcPr/>
+                </a:tc>
+                <a:tc>
+                  <a:txBody>
+                    <a:bodyPr/>
+                    <a:lstStyle/>
+                    <a:p>
+                      <a:pPr>
+                        <a:defRPr sz="1000"/>
+                      </a:pPr>
+                      <a:r>
+                        <a:t>0.008529718608775006</a:t>
+                      </a:r>
+                    </a:p>
+                  </a:txBody>
+                  <a:tcPr/>
+                </a:tc>
+                <a:tc>
+                  <a:txBody>
+                    <a:bodyPr/>
+                    <a:lstStyle/>
+                    <a:p>
+                      <a:pPr>
+                        <a:defRPr sz="1000"/>
+                      </a:pPr>
+                      <a:r>
+                        <a:t>0.03333905686691644</a:t>
+                      </a:r>
+                    </a:p>
+                  </a:txBody>
+                  <a:tcPr/>
+                </a:tc>
+                <a:tc>
+                  <a:txBody>
+                    <a:bodyPr/>
+                    <a:lstStyle/>
+                    <a:p>
+                      <a:pPr>
+                        <a:defRPr sz="1000"/>
+                      </a:pPr>
+                      <a:r>
+                        <a:t>0.04663252635534043</a:t>
+                      </a:r>
+                    </a:p>
+                  </a:txBody>
+                  <a:tcPr/>
+                </a:tc>
+                <a:tc>
+                  <a:txBody>
+                    <a:bodyPr/>
+                    <a:lstStyle/>
+                    <a:p>
+                      <a:pPr>
+                        <a:defRPr sz="1000"/>
+                      </a:pPr>
+                      <a:r>
+                        <a:t>0.08645751258990873</a:t>
+                      </a:r>
+                    </a:p>
+                  </a:txBody>
+                  <a:tcPr/>
+                </a:tc>
+                <a:tc>
+                  <a:txBody>
+                    <a:bodyPr/>
+                    <a:lstStyle/>
+                    <a:p>
+                      <a:pPr>
+                        <a:defRPr sz="1000"/>
+                      </a:pPr>
+                      <a:r>
+                        <a:t>0.0459350067675392</a:t>
+                      </a:r>
+                    </a:p>
+                  </a:txBody>
+                  <a:tcPr/>
+                </a:tc>
+                <a:tc>
+                  <a:txBody>
+                    <a:bodyPr/>
+                    <a:lstStyle/>
+                    <a:p>
+                      <a:pPr>
+                        <a:defRPr sz="1000"/>
+                      </a:pPr>
+                      <a:r>
+                        <a:t>7929.823529411765</a:t>
+                      </a:r>
+                    </a:p>
+                  </a:txBody>
+                  <a:tcPr/>
+                </a:tc>
+              </a:tr>
+            </a:tbl>
+          </a:graphicData>
+        </a:graphic>
+      </p:graphicFrame>
     </p:spTree>
   </p:cSld>
   <p:clrMapOvr>
@@ -8791,1159 +9087,6 @@
           <a:lstStyle/>
           <a:p>
             <a:r>
-              <a:t>Supplementary Table 3: Mean observed annual transition rates, 2000-2016</a:t>
-            </a:r>
-          </a:p>
-        </p:txBody>
-      </p:sp>
-      <p:sp>
-        <p:nvSpPr>
-          <p:cNvPr id="3" name="Content Placeholder 2"/>
-          <p:cNvSpPr>
-            <a:spLocks noGrp="1"/>
-          </p:cNvSpPr>
-          <p:nvPr>
-            <p:ph idx="1" sz="half"/>
-          </p:nvPr>
-        </p:nvSpPr>
-        <p:spPr/>
-        <p:txBody>
-          <a:bodyPr/>
-          <a:lstStyle/>
-          <a:p/>
-        </p:txBody>
-      </p:sp>
-      <p:sp>
-        <p:nvSpPr>
-          <p:cNvPr id="4" name="Content Placeholder 3"/>
-          <p:cNvSpPr>
-            <a:spLocks noGrp="1"/>
-          </p:cNvSpPr>
-          <p:nvPr>
-            <p:ph idx="2" sz="half"/>
-          </p:nvPr>
-        </p:nvSpPr>
-        <p:spPr/>
-        <p:txBody>
-          <a:bodyPr/>
-          <a:lstStyle/>
-          <a:p/>
-        </p:txBody>
-      </p:sp>
-      <p:graphicFrame>
-        <p:nvGraphicFramePr>
-          <p:cNvPr id="5" name="Table 4"/>
-          <p:cNvGraphicFramePr>
-            <a:graphicFrameLocks noGrp="1"/>
-          </p:cNvGraphicFramePr>
-          <p:nvPr/>
-        </p:nvGraphicFramePr>
-        <p:xfrm>
-          <a:off x="457200" y="1097280"/>
-          <a:ext cx="8961119" cy="5486400"/>
-        </p:xfrm>
-        <a:graphic>
-          <a:graphicData uri="http://schemas.openxmlformats.org/drawingml/2006/table">
-            <a:tbl>
-              <a:tblPr firstRow="1" bandRow="1">
-                <a:tableStyleId>{5C22544A-7EE6-4342-B048-85BDC9FD1C3A}</a:tableStyleId>
-              </a:tblPr>
-              <a:tblGrid>
-                <a:gridCol w="1280159"/>
-                <a:gridCol w="1280159"/>
-                <a:gridCol w="1280159"/>
-                <a:gridCol w="1280159"/>
-                <a:gridCol w="1280159"/>
-                <a:gridCol w="1280159"/>
-                <a:gridCol w="1280165"/>
-              </a:tblGrid>
-              <a:tr h="548640">
-                <a:tc>
-                  <a:txBody>
-                    <a:bodyPr/>
-                    <a:lstStyle/>
-                    <a:p>
-                      <a:r>
-                        <a:t>Group</a:t>
-                      </a:r>
-                    </a:p>
-                  </a:txBody>
-                  <a:tcPr/>
-                </a:tc>
-                <a:tc>
-                  <a:txBody>
-                    <a:bodyPr/>
-                    <a:lstStyle/>
-                    <a:p>
-                      <a:r>
-                        <a:t>α</a:t>
-                      </a:r>
-                    </a:p>
-                  </a:txBody>
-                  <a:tcPr/>
-                </a:tc>
-                <a:tc>
-                  <a:txBody>
-                    <a:bodyPr/>
-                    <a:lstStyle/>
-                    <a:p>
-                      <a:r>
-                        <a:t>β</a:t>
-                      </a:r>
-                    </a:p>
-                  </a:txBody>
-                  <a:tcPr/>
-                </a:tc>
-                <a:tc>
-                  <a:txBody>
-                    <a:bodyPr/>
-                    <a:lstStyle/>
-                    <a:p>
-                      <a:r>
-                        <a:t>h_D</a:t>
-                      </a:r>
-                    </a:p>
-                  </a:txBody>
-                  <a:tcPr/>
-                </a:tc>
-                <a:tc>
-                  <a:txBody>
-                    <a:bodyPr/>
-                    <a:lstStyle/>
-                    <a:p>
-                      <a:r>
-                        <a:t>p_D</a:t>
-                      </a:r>
-                    </a:p>
-                  </a:txBody>
-                  <a:tcPr/>
-                </a:tc>
-                <a:tc>
-                  <a:txBody>
-                    <a:bodyPr/>
-                    <a:lstStyle/>
-                    <a:p>
-                      <a:r>
-                        <a:t>d</a:t>
-                      </a:r>
-                    </a:p>
-                  </a:txBody>
-                  <a:tcPr/>
-                </a:tc>
-                <a:tc>
-                  <a:txBody>
-                    <a:bodyPr/>
-                    <a:lstStyle/>
-                    <a:p>
-                      <a:r>
-                        <a:t>I_total</a:t>
-                      </a:r>
-                    </a:p>
-                  </a:txBody>
-                  <a:tcPr/>
-                </a:tc>
-              </a:tr>
-              <a:tr h="548640">
-                <a:tc>
-                  <a:txBody>
-                    <a:bodyPr/>
-                    <a:lstStyle/>
-                    <a:p>
-                      <a:pPr>
-                        <a:defRPr sz="1000"/>
-                      </a:pPr>
-                      <a:r>
-                        <a:t>Anglosphere ex-US</a:t>
-                      </a:r>
-                    </a:p>
-                  </a:txBody>
-                  <a:tcPr/>
-                </a:tc>
-                <a:tc>
-                  <a:txBody>
-                    <a:bodyPr/>
-                    <a:lstStyle/>
-                    <a:p>
-                      <a:pPr>
-                        <a:defRPr sz="1000"/>
-                      </a:pPr>
-                      <a:r>
-                        <a:t>0.011625124450015864</a:t>
-                      </a:r>
-                    </a:p>
-                  </a:txBody>
-                  <a:tcPr/>
-                </a:tc>
-                <a:tc>
-                  <a:txBody>
-                    <a:bodyPr/>
-                    <a:lstStyle/>
-                    <a:p>
-                      <a:pPr>
-                        <a:defRPr sz="1000"/>
-                      </a:pPr>
-                      <a:r>
-                        <a:t>0.03411253799743315</a:t>
-                      </a:r>
-                    </a:p>
-                  </a:txBody>
-                  <a:tcPr/>
-                </a:tc>
-                <a:tc>
-                  <a:txBody>
-                    <a:bodyPr/>
-                    <a:lstStyle/>
-                    <a:p>
-                      <a:pPr>
-                        <a:defRPr sz="1000"/>
-                      </a:pPr>
-                      <a:r>
-                        <a:t>0.04616211641533843</a:t>
-                      </a:r>
-                    </a:p>
-                  </a:txBody>
-                  <a:tcPr/>
-                </a:tc>
-                <a:tc>
-                  <a:txBody>
-                    <a:bodyPr/>
-                    <a:lstStyle/>
-                    <a:p>
-                      <a:pPr>
-                        <a:defRPr sz="1000"/>
-                      </a:pPr>
-                      <a:r>
-                        <a:t>0.0873092000485382</a:t>
-                      </a:r>
-                    </a:p>
-                  </a:txBody>
-                  <a:tcPr/>
-                </a:tc>
-                <a:tc>
-                  <a:txBody>
-                    <a:bodyPr/>
-                    <a:lstStyle/>
-                    <a:p>
-                      <a:pPr>
-                        <a:defRPr sz="1000"/>
-                      </a:pPr>
-                      <a:r>
-                        <a:t>0.0456012888273175</a:t>
-                      </a:r>
-                    </a:p>
-                  </a:txBody>
-                  <a:tcPr/>
-                </a:tc>
-                <a:tc>
-                  <a:txBody>
-                    <a:bodyPr/>
-                    <a:lstStyle/>
-                    <a:p>
-                      <a:pPr>
-                        <a:defRPr sz="1000"/>
-                      </a:pPr>
-                      <a:r>
-                        <a:t>3771.8823529411766</a:t>
-                      </a:r>
-                    </a:p>
-                  </a:txBody>
-                  <a:tcPr/>
-                </a:tc>
-              </a:tr>
-              <a:tr h="548640">
-                <a:tc>
-                  <a:txBody>
-                    <a:bodyPr/>
-                    <a:lstStyle/>
-                    <a:p>
-                      <a:pPr>
-                        <a:defRPr sz="1000"/>
-                      </a:pPr>
-                      <a:r>
-                        <a:t>Continental Europe</a:t>
-                      </a:r>
-                    </a:p>
-                  </a:txBody>
-                  <a:tcPr/>
-                </a:tc>
-                <a:tc>
-                  <a:txBody>
-                    <a:bodyPr/>
-                    <a:lstStyle/>
-                    <a:p>
-                      <a:pPr>
-                        <a:defRPr sz="1000"/>
-                      </a:pPr>
-                      <a:r>
-                        <a:t>0.006761991119387412</a:t>
-                      </a:r>
-                    </a:p>
-                  </a:txBody>
-                  <a:tcPr/>
-                </a:tc>
-                <a:tc>
-                  <a:txBody>
-                    <a:bodyPr/>
-                    <a:lstStyle/>
-                    <a:p>
-                      <a:pPr>
-                        <a:defRPr sz="1000"/>
-                      </a:pPr>
-                      <a:r>
-                        <a:t>0.035799512585035644</a:t>
-                      </a:r>
-                    </a:p>
-                  </a:txBody>
-                  <a:tcPr/>
-                </a:tc>
-                <a:tc>
-                  <a:txBody>
-                    <a:bodyPr/>
-                    <a:lstStyle/>
-                    <a:p>
-                      <a:pPr>
-                        <a:defRPr sz="1000"/>
-                      </a:pPr>
-                      <a:r>
-                        <a:t>0.05094340242156166</a:t>
-                      </a:r>
-                    </a:p>
-                  </a:txBody>
-                  <a:tcPr/>
-                </a:tc>
-                <a:tc>
-                  <a:txBody>
-                    <a:bodyPr/>
-                    <a:lstStyle/>
-                    <a:p>
-                      <a:pPr>
-                        <a:defRPr sz="1000"/>
-                      </a:pPr>
-                      <a:r>
-                        <a:t>0.09422625853124332</a:t>
-                      </a:r>
-                    </a:p>
-                  </a:txBody>
-                  <a:tcPr/>
-                </a:tc>
-                <a:tc>
-                  <a:txBody>
-                    <a:bodyPr/>
-                    <a:lstStyle/>
-                    <a:p>
-                      <a:pPr>
-                        <a:defRPr sz="1000"/>
-                      </a:pPr>
-                      <a:r>
-                        <a:t>0.0458472850546197</a:t>
-                      </a:r>
-                    </a:p>
-                  </a:txBody>
-                  <a:tcPr/>
-                </a:tc>
-                <a:tc>
-                  <a:txBody>
-                    <a:bodyPr/>
-                    <a:lstStyle/>
-                    <a:p>
-                      <a:pPr>
-                        <a:defRPr sz="1000"/>
-                      </a:pPr>
-                      <a:r>
-                        <a:t>9935.941176470587</a:t>
-                      </a:r>
-                    </a:p>
-                  </a:txBody>
-                  <a:tcPr/>
-                </a:tc>
-              </a:tr>
-              <a:tr h="548640">
-                <a:tc>
-                  <a:txBody>
-                    <a:bodyPr/>
-                    <a:lstStyle/>
-                    <a:p>
-                      <a:pPr>
-                        <a:defRPr sz="1000"/>
-                      </a:pPr>
-                      <a:r>
-                        <a:t>Hindu</a:t>
-                      </a:r>
-                    </a:p>
-                  </a:txBody>
-                  <a:tcPr/>
-                </a:tc>
-                <a:tc>
-                  <a:txBody>
-                    <a:bodyPr/>
-                    <a:lstStyle/>
-                    <a:p>
-                      <a:pPr>
-                        <a:defRPr sz="1000"/>
-                      </a:pPr>
-                      <a:r>
-                        <a:t>0.008630402595531753</a:t>
-                      </a:r>
-                    </a:p>
-                  </a:txBody>
-                  <a:tcPr/>
-                </a:tc>
-                <a:tc>
-                  <a:txBody>
-                    <a:bodyPr/>
-                    <a:lstStyle/>
-                    <a:p>
-                      <a:pPr>
-                        <a:defRPr sz="1000"/>
-                      </a:pPr>
-                      <a:r>
-                        <a:t>0.03299680283228205</a:t>
-                      </a:r>
-                    </a:p>
-                  </a:txBody>
-                  <a:tcPr/>
-                </a:tc>
-                <a:tc>
-                  <a:txBody>
-                    <a:bodyPr/>
-                    <a:lstStyle/>
-                    <a:p>
-                      <a:pPr>
-                        <a:defRPr sz="1000"/>
-                      </a:pPr>
-                      <a:r>
-                        <a:t>0.02691431106611553</a:t>
-                      </a:r>
-                    </a:p>
-                  </a:txBody>
-                  <a:tcPr/>
-                </a:tc>
-                <a:tc>
-                  <a:txBody>
-                    <a:bodyPr/>
-                    <a:lstStyle/>
-                    <a:p>
-                      <a:pPr>
-                        <a:defRPr sz="1000"/>
-                      </a:pPr>
-                      <a:r>
-                        <a:t>0.08241584203083246</a:t>
-                      </a:r>
-                    </a:p>
-                  </a:txBody>
-                  <a:tcPr/>
-                </a:tc>
-                <a:tc>
-                  <a:txBody>
-                    <a:bodyPr/>
-                    <a:lstStyle/>
-                    <a:p>
-                      <a:pPr>
-                        <a:defRPr sz="1000"/>
-                      </a:pPr>
-                      <a:r>
-                        <a:t>0.0277057844536427</a:t>
-                      </a:r>
-                    </a:p>
-                  </a:txBody>
-                  <a:tcPr/>
-                </a:tc>
-                <a:tc>
-                  <a:txBody>
-                    <a:bodyPr/>
-                    <a:lstStyle/>
-                    <a:p>
-                      <a:pPr>
-                        <a:defRPr sz="1000"/>
-                      </a:pPr>
-                      <a:r>
-                        <a:t>1651.1176470588234</a:t>
-                      </a:r>
-                    </a:p>
-                  </a:txBody>
-                  <a:tcPr/>
-                </a:tc>
-              </a:tr>
-              <a:tr h="548640">
-                <a:tc>
-                  <a:txBody>
-                    <a:bodyPr/>
-                    <a:lstStyle/>
-                    <a:p>
-                      <a:pPr>
-                        <a:defRPr sz="1000"/>
-                      </a:pPr>
-                      <a:r>
-                        <a:t>Islamic</a:t>
-                      </a:r>
-                    </a:p>
-                  </a:txBody>
-                  <a:tcPr/>
-                </a:tc>
-                <a:tc>
-                  <a:txBody>
-                    <a:bodyPr/>
-                    <a:lstStyle/>
-                    <a:p>
-                      <a:pPr>
-                        <a:defRPr sz="1000"/>
-                      </a:pPr>
-                      <a:r>
-                        <a:t>0.012666046927368129</a:t>
-                      </a:r>
-                    </a:p>
-                  </a:txBody>
-                  <a:tcPr/>
-                </a:tc>
-                <a:tc>
-                  <a:txBody>
-                    <a:bodyPr/>
-                    <a:lstStyle/>
-                    <a:p>
-                      <a:pPr>
-                        <a:defRPr sz="1000"/>
-                      </a:pPr>
-                      <a:r>
-                        <a:t>0.038401582840796256</a:t>
-                      </a:r>
-                    </a:p>
-                  </a:txBody>
-                  <a:tcPr/>
-                </a:tc>
-                <a:tc>
-                  <a:txBody>
-                    <a:bodyPr/>
-                    <a:lstStyle/>
-                    <a:p>
-                      <a:pPr>
-                        <a:defRPr sz="1000"/>
-                      </a:pPr>
-                      <a:r>
-                        <a:t>0.025445116702978474</a:t>
-                      </a:r>
-                    </a:p>
-                  </a:txBody>
-                  <a:tcPr/>
-                </a:tc>
-                <a:tc>
-                  <a:txBody>
-                    <a:bodyPr/>
-                    <a:lstStyle/>
-                    <a:p>
-                      <a:pPr>
-                        <a:defRPr sz="1000"/>
-                      </a:pPr>
-                      <a:r>
-                        <a:t>0.09498790956874537</a:t>
-                      </a:r>
-                    </a:p>
-                  </a:txBody>
-                  <a:tcPr/>
-                </a:tc>
-                <a:tc>
-                  <a:txBody>
-                    <a:bodyPr/>
-                    <a:lstStyle/>
-                    <a:p>
-                      <a:pPr>
-                        <a:defRPr sz="1000"/>
-                      </a:pPr>
-                      <a:r>
-                        <a:t>0.0300792155414555</a:t>
-                      </a:r>
-                    </a:p>
-                  </a:txBody>
-                  <a:tcPr/>
-                </a:tc>
-                <a:tc>
-                  <a:txBody>
-                    <a:bodyPr/>
-                    <a:lstStyle/>
-                    <a:p>
-                      <a:pPr>
-                        <a:defRPr sz="1000"/>
-                      </a:pPr>
-                      <a:r>
-                        <a:t>3002.529411764706</a:t>
-                      </a:r>
-                    </a:p>
-                  </a:txBody>
-                  <a:tcPr/>
-                </a:tc>
-              </a:tr>
-              <a:tr h="548640">
-                <a:tc>
-                  <a:txBody>
-                    <a:bodyPr/>
-                    <a:lstStyle/>
-                    <a:p>
-                      <a:pPr>
-                        <a:defRPr sz="1000"/>
-                      </a:pPr>
-                      <a:r>
-                        <a:t>Japanese</a:t>
-                      </a:r>
-                    </a:p>
-                  </a:txBody>
-                  <a:tcPr/>
-                </a:tc>
-                <a:tc>
-                  <a:txBody>
-                    <a:bodyPr/>
-                    <a:lstStyle/>
-                    <a:p>
-                      <a:pPr>
-                        <a:defRPr sz="1000"/>
-                      </a:pPr>
-                      <a:r>
-                        <a:t>0.006917679672886924</a:t>
-                      </a:r>
-                    </a:p>
-                  </a:txBody>
-                  <a:tcPr/>
-                </a:tc>
-                <a:tc>
-                  <a:txBody>
-                    <a:bodyPr/>
-                    <a:lstStyle/>
-                    <a:p>
-                      <a:pPr>
-                        <a:defRPr sz="1000"/>
-                      </a:pPr>
-                      <a:r>
-                        <a:t>0.037602085739115054</a:t>
-                      </a:r>
-                    </a:p>
-                  </a:txBody>
-                  <a:tcPr/>
-                </a:tc>
-                <a:tc>
-                  <a:txBody>
-                    <a:bodyPr/>
-                    <a:lstStyle/>
-                    <a:p>
-                      <a:pPr>
-                        <a:defRPr sz="1000"/>
-                      </a:pPr>
-                      <a:r>
-                        <a:t>0.02367889326887788</a:t>
-                      </a:r>
-                    </a:p>
-                  </a:txBody>
-                  <a:tcPr/>
-                </a:tc>
-                <a:tc>
-                  <a:txBody>
-                    <a:bodyPr/>
-                    <a:lstStyle/>
-                    <a:p>
-                      <a:pPr>
-                        <a:defRPr sz="1000"/>
-                      </a:pPr>
-                      <a:r>
-                        <a:t>0.06960468807321192</a:t>
-                      </a:r>
-                    </a:p>
-                  </a:txBody>
-                  <a:tcPr/>
-                </a:tc>
-                <a:tc>
-                  <a:txBody>
-                    <a:bodyPr/>
-                    <a:lstStyle/>
-                    <a:p>
-                      <a:pPr>
-                        <a:defRPr sz="1000"/>
-                      </a:pPr>
-                      <a:r>
-                        <a:t>0.0552190245713187</a:t>
-                      </a:r>
-                    </a:p>
-                  </a:txBody>
-                  <a:tcPr/>
-                </a:tc>
-                <a:tc>
-                  <a:txBody>
-                    <a:bodyPr/>
-                    <a:lstStyle/>
-                    <a:p>
-                      <a:pPr>
-                        <a:defRPr sz="1000"/>
-                      </a:pPr>
-                      <a:r>
-                        <a:t>1882.764705882353</a:t>
-                      </a:r>
-                    </a:p>
-                  </a:txBody>
-                  <a:tcPr/>
-                </a:tc>
-              </a:tr>
-              <a:tr h="548640">
-                <a:tc>
-                  <a:txBody>
-                    <a:bodyPr/>
-                    <a:lstStyle/>
-                    <a:p>
-                      <a:pPr>
-                        <a:defRPr sz="1000"/>
-                      </a:pPr>
-                      <a:r>
-                        <a:t>Other Civilizations</a:t>
-                      </a:r>
-                    </a:p>
-                  </a:txBody>
-                  <a:tcPr/>
-                </a:tc>
-                <a:tc>
-                  <a:txBody>
-                    <a:bodyPr/>
-                    <a:lstStyle/>
-                    <a:p>
-                      <a:pPr>
-                        <a:defRPr sz="1000"/>
-                      </a:pPr>
-                      <a:r>
-                        <a:t>0.009174917967806347</a:t>
-                      </a:r>
-                    </a:p>
-                  </a:txBody>
-                  <a:tcPr/>
-                </a:tc>
-                <a:tc>
-                  <a:txBody>
-                    <a:bodyPr/>
-                    <a:lstStyle/>
-                    <a:p>
-                      <a:pPr>
-                        <a:defRPr sz="1000"/>
-                      </a:pPr>
-                      <a:r>
-                        <a:t>0.034841303799186506</a:t>
-                      </a:r>
-                    </a:p>
-                  </a:txBody>
-                  <a:tcPr/>
-                </a:tc>
-                <a:tc>
-                  <a:txBody>
-                    <a:bodyPr/>
-                    <a:lstStyle/>
-                    <a:p>
-                      <a:pPr>
-                        <a:defRPr sz="1000"/>
-                      </a:pPr>
-                      <a:r>
-                        <a:t>0.025794413969593047</a:t>
-                      </a:r>
-                    </a:p>
-                  </a:txBody>
-                  <a:tcPr/>
-                </a:tc>
-                <a:tc>
-                  <a:txBody>
-                    <a:bodyPr/>
-                    <a:lstStyle/>
-                    <a:p>
-                      <a:pPr>
-                        <a:defRPr sz="1000"/>
-                      </a:pPr>
-                      <a:r>
-                        <a:t>0.07781467004902813</a:t>
-                      </a:r>
-                    </a:p>
-                  </a:txBody>
-                  <a:tcPr/>
-                </a:tc>
-                <a:tc>
-                  <a:txBody>
-                    <a:bodyPr/>
-                    <a:lstStyle/>
-                    <a:p>
-                      <a:pPr>
-                        <a:defRPr sz="1000"/>
-                      </a:pPr>
-                      <a:r>
-                        <a:t>0.0418088008437154</a:t>
-                      </a:r>
-                    </a:p>
-                  </a:txBody>
-                  <a:tcPr/>
-                </a:tc>
-                <a:tc>
-                  <a:txBody>
-                    <a:bodyPr/>
-                    <a:lstStyle/>
-                    <a:p>
-                      <a:pPr>
-                        <a:defRPr sz="1000"/>
-                      </a:pPr>
-                      <a:r>
-                        <a:t>2955.294117647059</a:t>
-                      </a:r>
-                    </a:p>
-                  </a:txBody>
-                  <a:tcPr/>
-                </a:tc>
-              </a:tr>
-              <a:tr h="548640">
-                <a:tc>
-                  <a:txBody>
-                    <a:bodyPr/>
-                    <a:lstStyle/>
-                    <a:p>
-                      <a:pPr>
-                        <a:defRPr sz="1000"/>
-                      </a:pPr>
-                      <a:r>
-                        <a:t>Other Western</a:t>
-                      </a:r>
-                    </a:p>
-                  </a:txBody>
-                  <a:tcPr/>
-                </a:tc>
-                <a:tc>
-                  <a:txBody>
-                    <a:bodyPr/>
-                    <a:lstStyle/>
-                    <a:p>
-                      <a:pPr>
-                        <a:defRPr sz="1000"/>
-                      </a:pPr>
-                      <a:r>
-                        <a:t>0.014804380291716199</a:t>
-                      </a:r>
-                    </a:p>
-                  </a:txBody>
-                  <a:tcPr/>
-                </a:tc>
-                <a:tc>
-                  <a:txBody>
-                    <a:bodyPr/>
-                    <a:lstStyle/>
-                    <a:p>
-                      <a:pPr>
-                        <a:defRPr sz="1000"/>
-                      </a:pPr>
-                      <a:r>
-                        <a:t>0.033386940704236284</a:t>
-                      </a:r>
-                    </a:p>
-                  </a:txBody>
-                  <a:tcPr/>
-                </a:tc>
-                <a:tc>
-                  <a:txBody>
-                    <a:bodyPr/>
-                    <a:lstStyle/>
-                    <a:p>
-                      <a:pPr>
-                        <a:defRPr sz="1000"/>
-                      </a:pPr>
-                      <a:r>
-                        <a:t>0.05892906512509506</a:t>
-                      </a:r>
-                    </a:p>
-                  </a:txBody>
-                  <a:tcPr/>
-                </a:tc>
-                <a:tc>
-                  <a:txBody>
-                    <a:bodyPr/>
-                    <a:lstStyle/>
-                    <a:p>
-                      <a:pPr>
-                        <a:defRPr sz="1000"/>
-                      </a:pPr>
-                      <a:r>
-                        <a:t>0.06798731834845337</a:t>
-                      </a:r>
-                    </a:p>
-                  </a:txBody>
-                  <a:tcPr/>
-                </a:tc>
-                <a:tc>
-                  <a:txBody>
-                    <a:bodyPr/>
-                    <a:lstStyle/>
-                    <a:p>
-                      <a:pPr>
-                        <a:defRPr sz="1000"/>
-                      </a:pPr>
-                      <a:r>
-                        <a:t>0.0442928225810436</a:t>
-                      </a:r>
-                    </a:p>
-                  </a:txBody>
-                  <a:tcPr/>
-                </a:tc>
-                <a:tc>
-                  <a:txBody>
-                    <a:bodyPr/>
-                    <a:lstStyle/>
-                    <a:p>
-                      <a:pPr>
-                        <a:defRPr sz="1000"/>
-                      </a:pPr>
-                      <a:r>
-                        <a:t>258.6470588235294</a:t>
-                      </a:r>
-                    </a:p>
-                  </a:txBody>
-                  <a:tcPr/>
-                </a:tc>
-              </a:tr>
-              <a:tr h="548640">
-                <a:tc>
-                  <a:txBody>
-                    <a:bodyPr/>
-                    <a:lstStyle/>
-                    <a:p>
-                      <a:pPr>
-                        <a:defRPr sz="1000"/>
-                      </a:pPr>
-                      <a:r>
-                        <a:t>Sinic</a:t>
-                      </a:r>
-                    </a:p>
-                  </a:txBody>
-                  <a:tcPr/>
-                </a:tc>
-                <a:tc>
-                  <a:txBody>
-                    <a:bodyPr/>
-                    <a:lstStyle/>
-                    <a:p>
-                      <a:pPr>
-                        <a:defRPr sz="1000"/>
-                      </a:pPr>
-                      <a:r>
-                        <a:t>0.0069463267399030824</a:t>
-                      </a:r>
-                    </a:p>
-                  </a:txBody>
-                  <a:tcPr/>
-                </a:tc>
-                <a:tc>
-                  <a:txBody>
-                    <a:bodyPr/>
-                    <a:lstStyle/>
-                    <a:p>
-                      <a:pPr>
-                        <a:defRPr sz="1000"/>
-                      </a:pPr>
-                      <a:r>
-                        <a:t>0.027227975340917476</a:t>
-                      </a:r>
-                    </a:p>
-                  </a:txBody>
-                  <a:tcPr/>
-                </a:tc>
-                <a:tc>
-                  <a:txBody>
-                    <a:bodyPr/>
-                    <a:lstStyle/>
-                    <a:p>
-                      <a:pPr>
-                        <a:defRPr sz="1000"/>
-                      </a:pPr>
-                      <a:r>
-                        <a:t>0.025975223591736964</a:t>
-                      </a:r>
-                    </a:p>
-                  </a:txBody>
-                  <a:tcPr/>
-                </a:tc>
-                <a:tc>
-                  <a:txBody>
-                    <a:bodyPr/>
-                    <a:lstStyle/>
-                    <a:p>
-                      <a:pPr>
-                        <a:defRPr sz="1000"/>
-                      </a:pPr>
-                      <a:r>
-                        <a:t>0.09085321057400796</a:t>
-                      </a:r>
-                    </a:p>
-                  </a:txBody>
-                  <a:tcPr/>
-                </a:tc>
-                <a:tc>
-                  <a:txBody>
-                    <a:bodyPr/>
-                    <a:lstStyle/>
-                    <a:p>
-                      <a:pPr>
-                        <a:defRPr sz="1000"/>
-                      </a:pPr>
-                      <a:r>
-                        <a:t>0.0336695344484046</a:t>
-                      </a:r>
-                    </a:p>
-                  </a:txBody>
-                  <a:tcPr/>
-                </a:tc>
-                <a:tc>
-                  <a:txBody>
-                    <a:bodyPr/>
-                    <a:lstStyle/>
-                    <a:p>
-                      <a:pPr>
-                        <a:defRPr sz="1000"/>
-                      </a:pPr>
-                      <a:r>
-                        <a:t>11179.470588235294</a:t>
-                      </a:r>
-                    </a:p>
-                  </a:txBody>
-                  <a:tcPr/>
-                </a:tc>
-              </a:tr>
-              <a:tr h="548640">
-                <a:tc>
-                  <a:txBody>
-                    <a:bodyPr/>
-                    <a:lstStyle/>
-                    <a:p>
-                      <a:pPr>
-                        <a:defRPr sz="1000"/>
-                      </a:pPr>
-                      <a:r>
-                        <a:t>United States</a:t>
-                      </a:r>
-                    </a:p>
-                  </a:txBody>
-                  <a:tcPr/>
-                </a:tc>
-                <a:tc>
-                  <a:txBody>
-                    <a:bodyPr/>
-                    <a:lstStyle/>
-                    <a:p>
-                      <a:pPr>
-                        <a:defRPr sz="1000"/>
-                      </a:pPr>
-                      <a:r>
-                        <a:t>0.008529718608775006</a:t>
-                      </a:r>
-                    </a:p>
-                  </a:txBody>
-                  <a:tcPr/>
-                </a:tc>
-                <a:tc>
-                  <a:txBody>
-                    <a:bodyPr/>
-                    <a:lstStyle/>
-                    <a:p>
-                      <a:pPr>
-                        <a:defRPr sz="1000"/>
-                      </a:pPr>
-                      <a:r>
-                        <a:t>0.03333905686691644</a:t>
-                      </a:r>
-                    </a:p>
-                  </a:txBody>
-                  <a:tcPr/>
-                </a:tc>
-                <a:tc>
-                  <a:txBody>
-                    <a:bodyPr/>
-                    <a:lstStyle/>
-                    <a:p>
-                      <a:pPr>
-                        <a:defRPr sz="1000"/>
-                      </a:pPr>
-                      <a:r>
-                        <a:t>0.04663252635534043</a:t>
-                      </a:r>
-                    </a:p>
-                  </a:txBody>
-                  <a:tcPr/>
-                </a:tc>
-                <a:tc>
-                  <a:txBody>
-                    <a:bodyPr/>
-                    <a:lstStyle/>
-                    <a:p>
-                      <a:pPr>
-                        <a:defRPr sz="1000"/>
-                      </a:pPr>
-                      <a:r>
-                        <a:t>0.08645751258990873</a:t>
-                      </a:r>
-                    </a:p>
-                  </a:txBody>
-                  <a:tcPr/>
-                </a:tc>
-                <a:tc>
-                  <a:txBody>
-                    <a:bodyPr/>
-                    <a:lstStyle/>
-                    <a:p>
-                      <a:pPr>
-                        <a:defRPr sz="1000"/>
-                      </a:pPr>
-                      <a:r>
-                        <a:t>0.0459350067675392</a:t>
-                      </a:r>
-                    </a:p>
-                  </a:txBody>
-                  <a:tcPr/>
-                </a:tc>
-                <a:tc>
-                  <a:txBody>
-                    <a:bodyPr/>
-                    <a:lstStyle/>
-                    <a:p>
-                      <a:pPr>
-                        <a:defRPr sz="1000"/>
-                      </a:pPr>
-                      <a:r>
-                        <a:t>7929.823529411765</a:t>
-                      </a:r>
-                    </a:p>
-                  </a:txBody>
-                  <a:tcPr/>
-                </a:tc>
-              </a:tr>
-            </a:tbl>
-          </a:graphicData>
-        </a:graphic>
-      </p:graphicFrame>
-    </p:spTree>
-  </p:cSld>
-  <p:clrMapOvr>
-    <a:masterClrMapping/>
-  </p:clrMapOvr>
-</p:sld>
-</file>
-
-<file path=ppt/slides/slide21.xml><?xml version="1.0" encoding="utf-8"?>
-<p:sld xmlns:a="http://schemas.openxmlformats.org/drawingml/2006/main" xmlns:p="http://schemas.openxmlformats.org/presentationml/2006/main" xmlns:r="http://schemas.openxmlformats.org/officeDocument/2006/relationships">
-  <p:cSld>
-    <p:spTree>
-      <p:nvGrpSpPr>
-        <p:cNvPr id="1" name=""/>
-        <p:cNvGrpSpPr/>
-        <p:nvPr/>
-      </p:nvGrpSpPr>
-      <p:grpSpPr/>
-      <p:sp>
-        <p:nvSpPr>
-          <p:cNvPr id="2" name="Title 1"/>
-          <p:cNvSpPr>
-            <a:spLocks noGrp="1"/>
-          </p:cNvSpPr>
-          <p:nvPr>
-            <p:ph type="title"/>
-          </p:nvPr>
-        </p:nvSpPr>
-        <p:spPr/>
-        <p:txBody>
-          <a:bodyPr/>
-          <a:lstStyle/>
-          <a:p>
-            <a:r>
               <a:t>Supplementary Table 4: Top origin-destination abroad author-year pairs</a:t>
             </a:r>
           </a:p>
@@ -10526,7 +9669,7 @@
 </p:sld>
 </file>
 
-<file path=ppt/slides/slide22.xml><?xml version="1.0" encoding="utf-8"?>
+<file path=ppt/slides/slide21.xml><?xml version="1.0" encoding="utf-8"?>
 <p:sld xmlns:a="http://schemas.openxmlformats.org/drawingml/2006/main" xmlns:p="http://schemas.openxmlformats.org/presentationml/2006/main" xmlns:r="http://schemas.openxmlformats.org/officeDocument/2006/relationships">
   <p:cSld>
     <p:spTree>
@@ -12123,7 +11266,7 @@
 </p:sld>
 </file>
 
-<file path=ppt/slides/slide23.xml><?xml version="1.0" encoding="utf-8"?>
+<file path=ppt/slides/slide22.xml><?xml version="1.0" encoding="utf-8"?>
 <p:sld xmlns:a="http://schemas.openxmlformats.org/drawingml/2006/main" xmlns:p="http://schemas.openxmlformats.org/presentationml/2006/main" xmlns:r="http://schemas.openxmlformats.org/officeDocument/2006/relationships">
   <p:cSld>
     <p:spTree>
@@ -12628,6 +11771,863 @@
                       </a:pPr>
                       <a:r>
                         <a:t>0.4629629629629629</a:t>
+                      </a:r>
+                    </a:p>
+                  </a:txBody>
+                  <a:tcPr/>
+                </a:tc>
+              </a:tr>
+            </a:tbl>
+          </a:graphicData>
+        </a:graphic>
+      </p:graphicFrame>
+    </p:spTree>
+  </p:cSld>
+  <p:clrMapOvr>
+    <a:masterClrMapping/>
+  </p:clrMapOvr>
+</p:sld>
+</file>
+
+<file path=ppt/slides/slide23.xml><?xml version="1.0" encoding="utf-8"?>
+<p:sld xmlns:a="http://schemas.openxmlformats.org/drawingml/2006/main" xmlns:p="http://schemas.openxmlformats.org/presentationml/2006/main" xmlns:r="http://schemas.openxmlformats.org/officeDocument/2006/relationships">
+  <p:cSld>
+    <p:spTree>
+      <p:nvGrpSpPr>
+        <p:cNvPr id="1" name=""/>
+        <p:cNvGrpSpPr/>
+        <p:nvPr/>
+      </p:nvGrpSpPr>
+      <p:grpSpPr/>
+      <p:sp>
+        <p:nvSpPr>
+          <p:cNvPr id="2" name="Title 1"/>
+          <p:cNvSpPr>
+            <a:spLocks noGrp="1"/>
+          </p:cNvSpPr>
+          <p:nvPr>
+            <p:ph type="title"/>
+          </p:nvPr>
+        </p:nvSpPr>
+        <p:spPr/>
+        <p:txBody>
+          <a:bodyPr/>
+          <a:lstStyle/>
+          <a:p>
+            <a:r>
+              <a:t>Supplementary Table 5: Bootstrap 95% CI</a:t>
+            </a:r>
+          </a:p>
+        </p:txBody>
+      </p:sp>
+      <p:sp>
+        <p:nvSpPr>
+          <p:cNvPr id="3" name="Content Placeholder 2"/>
+          <p:cNvSpPr>
+            <a:spLocks noGrp="1"/>
+          </p:cNvSpPr>
+          <p:nvPr>
+            <p:ph idx="1" sz="half"/>
+          </p:nvPr>
+        </p:nvSpPr>
+        <p:spPr/>
+        <p:txBody>
+          <a:bodyPr/>
+          <a:lstStyle/>
+          <a:p/>
+        </p:txBody>
+      </p:sp>
+      <p:sp>
+        <p:nvSpPr>
+          <p:cNvPr id="4" name="Content Placeholder 3"/>
+          <p:cNvSpPr>
+            <a:spLocks noGrp="1"/>
+          </p:cNvSpPr>
+          <p:nvPr>
+            <p:ph idx="2" sz="half"/>
+          </p:nvPr>
+        </p:nvSpPr>
+        <p:spPr/>
+        <p:txBody>
+          <a:bodyPr/>
+          <a:lstStyle/>
+          <a:p/>
+        </p:txBody>
+      </p:sp>
+      <p:graphicFrame>
+        <p:nvGraphicFramePr>
+          <p:cNvPr id="5" name="Table 4"/>
+          <p:cNvGraphicFramePr>
+            <a:graphicFrameLocks noGrp="1"/>
+          </p:cNvGraphicFramePr>
+          <p:nvPr/>
+        </p:nvGraphicFramePr>
+        <p:xfrm>
+          <a:off x="457200" y="1097280"/>
+          <a:ext cx="10058400" cy="5486400"/>
+        </p:xfrm>
+        <a:graphic>
+          <a:graphicData uri="http://schemas.openxmlformats.org/drawingml/2006/table">
+            <a:tbl>
+              <a:tblPr firstRow="1" bandRow="1">
+                <a:tableStyleId>{5C22544A-7EE6-4342-B048-85BDC9FD1C3A}</a:tableStyleId>
+              </a:tblPr>
+              <a:tblGrid>
+                <a:gridCol w="2011680"/>
+                <a:gridCol w="2011680"/>
+                <a:gridCol w="2011680"/>
+                <a:gridCol w="2011680"/>
+                <a:gridCol w="2011680"/>
+              </a:tblGrid>
+              <a:tr h="548640">
+                <a:tc>
+                  <a:txBody>
+                    <a:bodyPr/>
+                    <a:lstStyle/>
+                    <a:p>
+                      <a:r>
+                        <a:t>Group</a:t>
+                      </a:r>
+                    </a:p>
+                  </a:txBody>
+                  <a:tcPr/>
+                </a:tc>
+                <a:tc>
+                  <a:txBody>
+                    <a:bodyPr/>
+                    <a:lstStyle/>
+                    <a:p>
+                      <a:r>
+                        <a:t>T median</a:t>
+                      </a:r>
+                    </a:p>
+                  </a:txBody>
+                  <a:tcPr/>
+                </a:tc>
+                <a:tc>
+                  <a:txBody>
+                    <a:bodyPr/>
+                    <a:lstStyle/>
+                    <a:p>
+                      <a:r>
+                        <a:t>T 95% CI</a:t>
+                      </a:r>
+                    </a:p>
+                  </a:txBody>
+                  <a:tcPr/>
+                </a:tc>
+                <a:tc>
+                  <a:txBody>
+                    <a:bodyPr/>
+                    <a:lstStyle/>
+                    <a:p>
+                      <a:r>
+                        <a:t>P_D mean</a:t>
+                      </a:r>
+                    </a:p>
+                  </a:txBody>
+                  <a:tcPr/>
+                </a:tc>
+                <a:tc>
+                  <a:txBody>
+                    <a:bodyPr/>
+                    <a:lstStyle/>
+                    <a:p>
+                      <a:r>
+                        <a:t>P_D 95% CI</a:t>
+                      </a:r>
+                    </a:p>
+                  </a:txBody>
+                  <a:tcPr/>
+                </a:tc>
+              </a:tr>
+              <a:tr h="548640">
+                <a:tc>
+                  <a:txBody>
+                    <a:bodyPr/>
+                    <a:lstStyle/>
+                    <a:p>
+                      <a:pPr>
+                        <a:defRPr sz="1000"/>
+                      </a:pPr>
+                      <a:r>
+                        <a:t>Anglosphere ex-US</a:t>
+                      </a:r>
+                    </a:p>
+                  </a:txBody>
+                  <a:tcPr/>
+                </a:tc>
+                <a:tc>
+                  <a:txBody>
+                    <a:bodyPr/>
+                    <a:lstStyle/>
+                    <a:p>
+                      <a:pPr>
+                        <a:defRPr sz="1000"/>
+                      </a:pPr>
+                      <a:r>
+                        <a:t>67546</a:t>
+                      </a:r>
+                    </a:p>
+                  </a:txBody>
+                  <a:tcPr/>
+                </a:tc>
+                <a:tc>
+                  <a:txBody>
+                    <a:bodyPr/>
+                    <a:lstStyle/>
+                    <a:p>
+                      <a:pPr>
+                        <a:defRPr sz="1000"/>
+                      </a:pPr>
+                      <a:r>
+                        <a:t>[66728, 68334]</a:t>
+                      </a:r>
+                    </a:p>
+                  </a:txBody>
+                  <a:tcPr/>
+                </a:tc>
+                <a:tc>
+                  <a:txBody>
+                    <a:bodyPr/>
+                    <a:lstStyle/>
+                    <a:p>
+                      <a:pPr>
+                        <a:defRPr sz="1000"/>
+                      </a:pPr>
+                      <a:r>
+                        <a:t>29814</a:t>
+                      </a:r>
+                    </a:p>
+                  </a:txBody>
+                  <a:tcPr/>
+                </a:tc>
+                <a:tc>
+                  <a:txBody>
+                    <a:bodyPr/>
+                    <a:lstStyle/>
+                    <a:p>
+                      <a:pPr>
+                        <a:defRPr sz="1000"/>
+                      </a:pPr>
+                      <a:r>
+                        <a:t>[29158, 30486]</a:t>
+                      </a:r>
+                    </a:p>
+                  </a:txBody>
+                  <a:tcPr/>
+                </a:tc>
+              </a:tr>
+              <a:tr h="548640">
+                <a:tc>
+                  <a:txBody>
+                    <a:bodyPr/>
+                    <a:lstStyle/>
+                    <a:p>
+                      <a:pPr>
+                        <a:defRPr sz="1000"/>
+                      </a:pPr>
+                      <a:r>
+                        <a:t>Continental Europe</a:t>
+                      </a:r>
+                    </a:p>
+                  </a:txBody>
+                  <a:tcPr/>
+                </a:tc>
+                <a:tc>
+                  <a:txBody>
+                    <a:bodyPr/>
+                    <a:lstStyle/>
+                    <a:p>
+                      <a:pPr>
+                        <a:defRPr sz="1000"/>
+                      </a:pPr>
+                      <a:r>
+                        <a:t>195077</a:t>
+                      </a:r>
+                    </a:p>
+                  </a:txBody>
+                  <a:tcPr/>
+                </a:tc>
+                <a:tc>
+                  <a:txBody>
+                    <a:bodyPr/>
+                    <a:lstStyle/>
+                    <a:p>
+                      <a:pPr>
+                        <a:defRPr sz="1000"/>
+                      </a:pPr>
+                      <a:r>
+                        <a:t>[193718, 196316]</a:t>
+                      </a:r>
+                    </a:p>
+                  </a:txBody>
+                  <a:tcPr/>
+                </a:tc>
+                <a:tc>
+                  <a:txBody>
+                    <a:bodyPr/>
+                    <a:lstStyle/>
+                    <a:p>
+                      <a:pPr>
+                        <a:defRPr sz="1000"/>
+                      </a:pPr>
+                      <a:r>
+                        <a:t>83476</a:t>
+                      </a:r>
+                    </a:p>
+                  </a:txBody>
+                  <a:tcPr/>
+                </a:tc>
+                <a:tc>
+                  <a:txBody>
+                    <a:bodyPr/>
+                    <a:lstStyle/>
+                    <a:p>
+                      <a:pPr>
+                        <a:defRPr sz="1000"/>
+                      </a:pPr>
+                      <a:r>
+                        <a:t>[82421, 84527]</a:t>
+                      </a:r>
+                    </a:p>
+                  </a:txBody>
+                  <a:tcPr/>
+                </a:tc>
+              </a:tr>
+              <a:tr h="548640">
+                <a:tc>
+                  <a:txBody>
+                    <a:bodyPr/>
+                    <a:lstStyle/>
+                    <a:p>
+                      <a:pPr>
+                        <a:defRPr sz="1000"/>
+                      </a:pPr>
+                      <a:r>
+                        <a:t>Hindu</a:t>
+                      </a:r>
+                    </a:p>
+                  </a:txBody>
+                  <a:tcPr/>
+                </a:tc>
+                <a:tc>
+                  <a:txBody>
+                    <a:bodyPr/>
+                    <a:lstStyle/>
+                    <a:p>
+                      <a:pPr>
+                        <a:defRPr sz="1000"/>
+                      </a:pPr>
+                      <a:r>
+                        <a:t>53407</a:t>
+                      </a:r>
+                    </a:p>
+                  </a:txBody>
+                  <a:tcPr/>
+                </a:tc>
+                <a:tc>
+                  <a:txBody>
+                    <a:bodyPr/>
+                    <a:lstStyle/>
+                    <a:p>
+                      <a:pPr>
+                        <a:defRPr sz="1000"/>
+                      </a:pPr>
+                      <a:r>
+                        <a:t>[52402, 54515]</a:t>
+                      </a:r>
+                    </a:p>
+                  </a:txBody>
+                  <a:tcPr/>
+                </a:tc>
+                <a:tc>
+                  <a:txBody>
+                    <a:bodyPr/>
+                    <a:lstStyle/>
+                    <a:p>
+                      <a:pPr>
+                        <a:defRPr sz="1000"/>
+                      </a:pPr>
+                      <a:r>
+                        <a:t>30277</a:t>
+                      </a:r>
+                    </a:p>
+                  </a:txBody>
+                  <a:tcPr/>
+                </a:tc>
+                <a:tc>
+                  <a:txBody>
+                    <a:bodyPr/>
+                    <a:lstStyle/>
+                    <a:p>
+                      <a:pPr>
+                        <a:defRPr sz="1000"/>
+                      </a:pPr>
+                      <a:r>
+                        <a:t>[29348, 31258]</a:t>
+                      </a:r>
+                    </a:p>
+                  </a:txBody>
+                  <a:tcPr/>
+                </a:tc>
+              </a:tr>
+              <a:tr h="548640">
+                <a:tc>
+                  <a:txBody>
+                    <a:bodyPr/>
+                    <a:lstStyle/>
+                    <a:p>
+                      <a:pPr>
+                        <a:defRPr sz="1000"/>
+                      </a:pPr>
+                      <a:r>
+                        <a:t>Islamic</a:t>
+                      </a:r>
+                    </a:p>
+                  </a:txBody>
+                  <a:tcPr/>
+                </a:tc>
+                <a:tc>
+                  <a:txBody>
+                    <a:bodyPr/>
+                    <a:lstStyle/>
+                    <a:p>
+                      <a:pPr>
+                        <a:defRPr sz="1000"/>
+                      </a:pPr>
+                      <a:r>
+                        <a:t>88428</a:t>
+                      </a:r>
+                    </a:p>
+                  </a:txBody>
+                  <a:tcPr/>
+                </a:tc>
+                <a:tc>
+                  <a:txBody>
+                    <a:bodyPr/>
+                    <a:lstStyle/>
+                    <a:p>
+                      <a:pPr>
+                        <a:defRPr sz="1000"/>
+                      </a:pPr>
+                      <a:r>
+                        <a:t>[87356, 89880]</a:t>
+                      </a:r>
+                    </a:p>
+                  </a:txBody>
+                  <a:tcPr/>
+                </a:tc>
+                <a:tc>
+                  <a:txBody>
+                    <a:bodyPr/>
+                    <a:lstStyle/>
+                    <a:p>
+                      <a:pPr>
+                        <a:defRPr sz="1000"/>
+                      </a:pPr>
+                      <a:r>
+                        <a:t>47264</a:t>
+                      </a:r>
+                    </a:p>
+                  </a:txBody>
+                  <a:tcPr/>
+                </a:tc>
+                <a:tc>
+                  <a:txBody>
+                    <a:bodyPr/>
+                    <a:lstStyle/>
+                    <a:p>
+                      <a:pPr>
+                        <a:defRPr sz="1000"/>
+                      </a:pPr>
+                      <a:r>
+                        <a:t>[46155, 48511]</a:t>
+                      </a:r>
+                    </a:p>
+                  </a:txBody>
+                  <a:tcPr/>
+                </a:tc>
+              </a:tr>
+              <a:tr h="548640">
+                <a:tc>
+                  <a:txBody>
+                    <a:bodyPr/>
+                    <a:lstStyle/>
+                    <a:p>
+                      <a:pPr>
+                        <a:defRPr sz="1000"/>
+                      </a:pPr>
+                      <a:r>
+                        <a:t>Japanese</a:t>
+                      </a:r>
+                    </a:p>
+                  </a:txBody>
+                  <a:tcPr/>
+                </a:tc>
+                <a:tc>
+                  <a:txBody>
+                    <a:bodyPr/>
+                    <a:lstStyle/>
+                    <a:p>
+                      <a:pPr>
+                        <a:defRPr sz="1000"/>
+                      </a:pPr>
+                      <a:r>
+                        <a:t>29372</a:t>
+                      </a:r>
+                    </a:p>
+                  </a:txBody>
+                  <a:tcPr/>
+                </a:tc>
+                <a:tc>
+                  <a:txBody>
+                    <a:bodyPr/>
+                    <a:lstStyle/>
+                    <a:p>
+                      <a:pPr>
+                        <a:defRPr sz="1000"/>
+                      </a:pPr>
+                      <a:r>
+                        <a:t>[28932, 29757]</a:t>
+                      </a:r>
+                    </a:p>
+                  </a:txBody>
+                  <a:tcPr/>
+                </a:tc>
+                <a:tc>
+                  <a:txBody>
+                    <a:bodyPr/>
+                    <a:lstStyle/>
+                    <a:p>
+                      <a:pPr>
+                        <a:defRPr sz="1000"/>
+                      </a:pPr>
+                      <a:r>
+                        <a:t>7387</a:t>
+                      </a:r>
+                    </a:p>
+                  </a:txBody>
+                  <a:tcPr/>
+                </a:tc>
+                <a:tc>
+                  <a:txBody>
+                    <a:bodyPr/>
+                    <a:lstStyle/>
+                    <a:p>
+                      <a:pPr>
+                        <a:defRPr sz="1000"/>
+                      </a:pPr>
+                      <a:r>
+                        <a:t>[7128, 7662]</a:t>
+                      </a:r>
+                    </a:p>
+                  </a:txBody>
+                  <a:tcPr/>
+                </a:tc>
+              </a:tr>
+              <a:tr h="548640">
+                <a:tc>
+                  <a:txBody>
+                    <a:bodyPr/>
+                    <a:lstStyle/>
+                    <a:p>
+                      <a:pPr>
+                        <a:defRPr sz="1000"/>
+                      </a:pPr>
+                      <a:r>
+                        <a:t>Other Civilizations</a:t>
+                      </a:r>
+                    </a:p>
+                  </a:txBody>
+                  <a:tcPr/>
+                </a:tc>
+                <a:tc>
+                  <a:txBody>
+                    <a:bodyPr/>
+                    <a:lstStyle/>
+                    <a:p>
+                      <a:pPr>
+                        <a:defRPr sz="1000"/>
+                      </a:pPr>
+                      <a:r>
+                        <a:t>59396</a:t>
+                      </a:r>
+                    </a:p>
+                  </a:txBody>
+                  <a:tcPr/>
+                </a:tc>
+                <a:tc>
+                  <a:txBody>
+                    <a:bodyPr/>
+                    <a:lstStyle/>
+                    <a:p>
+                      <a:pPr>
+                        <a:defRPr sz="1000"/>
+                      </a:pPr>
+                      <a:r>
+                        <a:t>[58590, 60178]</a:t>
+                      </a:r>
+                    </a:p>
+                  </a:txBody>
+                  <a:tcPr/>
+                </a:tc>
+                <a:tc>
+                  <a:txBody>
+                    <a:bodyPr/>
+                    <a:lstStyle/>
+                    <a:p>
+                      <a:pPr>
+                        <a:defRPr sz="1000"/>
+                      </a:pPr>
+                      <a:r>
+                        <a:t>22326</a:t>
+                      </a:r>
+                    </a:p>
+                  </a:txBody>
+                  <a:tcPr/>
+                </a:tc>
+                <a:tc>
+                  <a:txBody>
+                    <a:bodyPr/>
+                    <a:lstStyle/>
+                    <a:p>
+                      <a:pPr>
+                        <a:defRPr sz="1000"/>
+                      </a:pPr>
+                      <a:r>
+                        <a:t>[21715, 22975]</a:t>
+                      </a:r>
+                    </a:p>
+                  </a:txBody>
+                  <a:tcPr/>
+                </a:tc>
+              </a:tr>
+              <a:tr h="548640">
+                <a:tc>
+                  <a:txBody>
+                    <a:bodyPr/>
+                    <a:lstStyle/>
+                    <a:p>
+                      <a:pPr>
+                        <a:defRPr sz="1000"/>
+                      </a:pPr>
+                      <a:r>
+                        <a:t>Other Western</a:t>
+                      </a:r>
+                    </a:p>
+                  </a:txBody>
+                  <a:tcPr/>
+                </a:tc>
+                <a:tc>
+                  <a:txBody>
+                    <a:bodyPr/>
+                    <a:lstStyle/>
+                    <a:p>
+                      <a:pPr>
+                        <a:defRPr sz="1000"/>
+                      </a:pPr>
+                      <a:r>
+                        <a:t>4829</a:t>
+                      </a:r>
+                    </a:p>
+                  </a:txBody>
+                  <a:tcPr/>
+                </a:tc>
+                <a:tc>
+                  <a:txBody>
+                    <a:bodyPr/>
+                    <a:lstStyle/>
+                    <a:p>
+                      <a:pPr>
+                        <a:defRPr sz="1000"/>
+                      </a:pPr>
+                      <a:r>
+                        <a:t>[4602, 5077]</a:t>
+                      </a:r>
+                    </a:p>
+                  </a:txBody>
+                  <a:tcPr/>
+                </a:tc>
+                <a:tc>
+                  <a:txBody>
+                    <a:bodyPr/>
+                    <a:lstStyle/>
+                    <a:p>
+                      <a:pPr>
+                        <a:defRPr sz="1000"/>
+                      </a:pPr>
+                      <a:r>
+                        <a:t>2163</a:t>
+                      </a:r>
+                    </a:p>
+                  </a:txBody>
+                  <a:tcPr/>
+                </a:tc>
+                <a:tc>
+                  <a:txBody>
+                    <a:bodyPr/>
+                    <a:lstStyle/>
+                    <a:p>
+                      <a:pPr>
+                        <a:defRPr sz="1000"/>
+                      </a:pPr>
+                      <a:r>
+                        <a:t>[1981, 2370]</a:t>
+                      </a:r>
+                    </a:p>
+                  </a:txBody>
+                  <a:tcPr/>
+                </a:tc>
+              </a:tr>
+              <a:tr h="548640">
+                <a:tc>
+                  <a:txBody>
+                    <a:bodyPr/>
+                    <a:lstStyle/>
+                    <a:p>
+                      <a:pPr>
+                        <a:defRPr sz="1000"/>
+                      </a:pPr>
+                      <a:r>
+                        <a:t>Sinic</a:t>
+                      </a:r>
+                    </a:p>
+                  </a:txBody>
+                  <a:tcPr/>
+                </a:tc>
+                <a:tc>
+                  <a:txBody>
+                    <a:bodyPr/>
+                    <a:lstStyle/>
+                    <a:p>
+                      <a:pPr>
+                        <a:defRPr sz="1000"/>
+                      </a:pPr>
+                      <a:r>
+                        <a:t>303843</a:t>
+                      </a:r>
+                    </a:p>
+                  </a:txBody>
+                  <a:tcPr/>
+                </a:tc>
+                <a:tc>
+                  <a:txBody>
+                    <a:bodyPr/>
+                    <a:lstStyle/>
+                    <a:p>
+                      <a:pPr>
+                        <a:defRPr sz="1000"/>
+                      </a:pPr>
+                      <a:r>
+                        <a:t>[301809, 305720]</a:t>
+                      </a:r>
+                    </a:p>
+                  </a:txBody>
+                  <a:tcPr/>
+                </a:tc>
+                <a:tc>
+                  <a:txBody>
+                    <a:bodyPr/>
+                    <a:lstStyle/>
+                    <a:p>
+                      <a:pPr>
+                        <a:defRPr sz="1000"/>
+                      </a:pPr>
+                      <a:r>
+                        <a:t>133015</a:t>
+                      </a:r>
+                    </a:p>
+                  </a:txBody>
+                  <a:tcPr/>
+                </a:tc>
+                <a:tc>
+                  <a:txBody>
+                    <a:bodyPr/>
+                    <a:lstStyle/>
+                    <a:p>
+                      <a:pPr>
+                        <a:defRPr sz="1000"/>
+                      </a:pPr>
+                      <a:r>
+                        <a:t>[131418, 134567]</a:t>
+                      </a:r>
+                    </a:p>
+                  </a:txBody>
+                  <a:tcPr/>
+                </a:tc>
+              </a:tr>
+              <a:tr h="548640">
+                <a:tc>
+                  <a:txBody>
+                    <a:bodyPr/>
+                    <a:lstStyle/>
+                    <a:p>
+                      <a:pPr>
+                        <a:defRPr sz="1000"/>
+                      </a:pPr>
+                      <a:r>
+                        <a:t>United States</a:t>
+                      </a:r>
+                    </a:p>
+                  </a:txBody>
+                  <a:tcPr/>
+                </a:tc>
+                <a:tc>
+                  <a:txBody>
+                    <a:bodyPr/>
+                    <a:lstStyle/>
+                    <a:p>
+                      <a:pPr>
+                        <a:defRPr sz="1000"/>
+                      </a:pPr>
+                      <a:r>
+                        <a:t>146991</a:t>
+                      </a:r>
+                    </a:p>
+                  </a:txBody>
+                  <a:tcPr/>
+                </a:tc>
+                <a:tc>
+                  <a:txBody>
+                    <a:bodyPr/>
+                    <a:lstStyle/>
+                    <a:p>
+                      <a:pPr>
+                        <a:defRPr sz="1000"/>
+                      </a:pPr>
+                      <a:r>
+                        <a:t>[145947, 148235]</a:t>
+                      </a:r>
+                    </a:p>
+                  </a:txBody>
+                  <a:tcPr/>
+                </a:tc>
+                <a:tc>
+                  <a:txBody>
+                    <a:bodyPr/>
+                    <a:lstStyle/>
+                    <a:p>
+                      <a:pPr>
+                        <a:defRPr sz="1000"/>
+                      </a:pPr>
+                      <a:r>
+                        <a:t>63906</a:t>
+                      </a:r>
+                    </a:p>
+                  </a:txBody>
+                  <a:tcPr/>
+                </a:tc>
+                <a:tc>
+                  <a:txBody>
+                    <a:bodyPr/>
+                    <a:lstStyle/>
+                    <a:p>
+                      <a:pPr>
+                        <a:defRPr sz="1000"/>
+                      </a:pPr>
+                      <a:r>
+                        <a:t>[62994, 64906]</a:t>
                       </a:r>
                     </a:p>
                   </a:txBody>

</xml_diff>